<commit_message>
Future work: instance data across two tables (treatment, admission)
Card 1 shows treatment and admission in the slide-2 table style, joined on
admission_id, with P1-P3 / A1-A3 and no names. The candidate's provenance gains
treatment:drug (re-verified with the OWL API); speech updated.

Co-Authored-By: Claude Opus 5.5 <noreply@anthropic.com>
Claude-Session: https://claude.ai/code/session_01KcycczqUBG98FnzsgJYAW8
</commit_message>
<xml_diff>
--- a/presentation/RIGOR_future_work.pptx
+++ b/presentation/RIGOR_future_work.pptx
@@ -1775,19 +1775,6 @@
           </a:bodyPr>
           <a:lstStyle/>
           <a:p>
-            <a:pPr indent="-228600" lvl="0" marL="457200" marR="0" rtl="0" algn="l">
-              <a:lnSpc>
-                <a:spcPct val="100000"/>
-              </a:lnSpc>
-              <a:spcBef>
-                <a:spcPts val="0"/>
-              </a:spcBef>
-              <a:spcAft>
-                <a:spcPts val="0"/>
-              </a:spcAft>
-              <a:buSzPts val="1400"/>
-              <a:buNone/>
-            </a:pPr>
             <a:r>
               <a:rPr lang="en-US" sz="1200">
                 <a:solidFill>
@@ -1798,24 +1785,10 @@
                 <a:cs typeface="Calibri"/>
                 <a:sym typeface="Calibri"/>
               </a:rPr>
-              <a:t>[11:05–12:00]  SPOKEN SCRIPT (96 words)</a:t>
-            </a:r>
-            <a:endParaRPr/>
+              <a:t>[11:19–12:21]  SPOKEN SCRIPT (109 words)</a:t>
+            </a:r>
           </a:p>
           <a:p>
-            <a:pPr indent="-228600" lvl="0" marL="457200" marR="0" rtl="0" algn="l">
-              <a:lnSpc>
-                <a:spcPct val="100000"/>
-              </a:lnSpc>
-              <a:spcBef>
-                <a:spcPts val="0"/>
-              </a:spcBef>
-              <a:spcAft>
-                <a:spcPts val="0"/>
-              </a:spcAft>
-              <a:buSzPts val="1400"/>
-              <a:buNone/>
-            </a:pPr>
             <a:r>
               <a:rPr lang="en-US" sz="1200">
                 <a:solidFill>
@@ -1826,51 +1799,11 @@
                 <a:cs typeface="Calibri"/>
                 <a:sym typeface="Calibri"/>
               </a:rPr>
-              <a:t>Where next? Today RIGOR reads schemas and documentation. The next step is to let the data speak. Imagine several patients whose records show bone marrow depression after cisplatin cycles. The rows alone show a pattern. The drug label adds that bone-marrow suppression is a known adverse reaction of cisplatin. Together, they let RIGOR propose new knowledge: a candidate association between cisplatin and bone marrow depression, with provenance to both sources. Candidate, not cause. Gemcitabine, radiotherapy or cirrhosis could also explain it. So an expert reviews it. We also want validator and reasoner feedback inside the loop.</a:t>
-            </a:r>
-            <a:endParaRPr/>
+              <a:t>Where next? Today RIGOR reads schemas and documentation. The next step is to let the data speak. Here the data sits in two tables: treatment says which admissions received cisplatin, admission records bone marrow depression. Joined on the admission id, the rows show a pattern. The drug label adds that bone-marrow suppression is a known adverse reaction of cisplatin. Together, they let RIGOR propose new knowledge: a candidate association between cisplatin and bone marrow depression, with provenance to both tables and the label. Candidate, not cause. Gemcitabine, radiotherapy or cirrhosis could also explain it. So an expert reviews it. We also want validator and reasoner feedback inside the loop.</a:t>
+            </a:r>
           </a:p>
+          <a:p/>
           <a:p>
-            <a:pPr indent="-228600" lvl="0" marL="457200" marR="0" rtl="0" algn="l">
-              <a:lnSpc>
-                <a:spcPct val="100000"/>
-              </a:lnSpc>
-              <a:spcBef>
-                <a:spcPts val="0"/>
-              </a:spcBef>
-              <a:spcAft>
-                <a:spcPts val="0"/>
-              </a:spcAft>
-              <a:buSzPts val="1400"/>
-              <a:buNone/>
-            </a:pPr>
-            <a:r>
-              <a:t/>
-            </a:r>
-            <a:endParaRPr sz="1200">
-              <a:solidFill>
-                <a:schemeClr val="dk1"/>
-              </a:solidFill>
-              <a:latin typeface="Calibri"/>
-              <a:ea typeface="Calibri"/>
-              <a:cs typeface="Calibri"/>
-              <a:sym typeface="Calibri"/>
-            </a:endParaRPr>
-          </a:p>
-          <a:p>
-            <a:pPr indent="-228600" lvl="0" marL="457200" marR="0" rtl="0" algn="l">
-              <a:lnSpc>
-                <a:spcPct val="100000"/>
-              </a:lnSpc>
-              <a:spcBef>
-                <a:spcPts val="0"/>
-              </a:spcBef>
-              <a:spcAft>
-                <a:spcPts val="0"/>
-              </a:spcAft>
-              <a:buSzPts val="1400"/>
-              <a:buNone/>
-            </a:pPr>
             <a:r>
               <a:rPr lang="en-US" sz="1200">
                 <a:solidFill>
@@ -1881,24 +1814,10 @@
                 <a:cs typeface="Calibri"/>
                 <a:sym typeface="Calibri"/>
               </a:rPr>
-              <a:t>PRESENTER / POINTER: Rows, label, code, left to right. Say 'candidate' or 'may have contributed', never 'caused'.</a:t>
-            </a:r>
-            <a:endParaRPr/>
+              <a:t>PRESENTER / POINTER: Point at A1 and A3 in both tables, then the label, then the code. Say 'candidate', never 'caused'.</a:t>
+            </a:r>
           </a:p>
           <a:p>
-            <a:pPr indent="-228600" lvl="0" marL="457200" marR="0" rtl="0" algn="l">
-              <a:lnSpc>
-                <a:spcPct val="100000"/>
-              </a:lnSpc>
-              <a:spcBef>
-                <a:spcPts val="0"/>
-              </a:spcBef>
-              <a:spcAft>
-                <a:spcPts val="0"/>
-              </a:spcAft>
-              <a:buSzPts val="1400"/>
-              <a:buNone/>
-            </a:pPr>
             <a:r>
               <a:rPr lang="en-US" sz="1200">
                 <a:solidFill>
@@ -1911,22 +1830,8 @@
               </a:rPr>
               <a:t>AUDIENCE TAKEAWAY: Instances plus documentation can propose knowledge; experts confirm it.</a:t>
             </a:r>
-            <a:endParaRPr/>
           </a:p>
           <a:p>
-            <a:pPr indent="-228600" lvl="0" marL="457200" marR="0" rtl="0" algn="l">
-              <a:lnSpc>
-                <a:spcPct val="100000"/>
-              </a:lnSpc>
-              <a:spcBef>
-                <a:spcPts val="0"/>
-              </a:spcBef>
-              <a:spcAft>
-                <a:spcPts val="0"/>
-              </a:spcAft>
-              <a:buSzPts val="1400"/>
-              <a:buNone/>
-            </a:pPr>
             <a:r>
               <a:rPr lang="en-US" sz="1200">
                 <a:solidFill>
@@ -1939,22 +1844,8 @@
               </a:rPr>
               <a:t>SOURCE AND SCOPE: Paper Section 5. Rows are synthetic. OWL verified (presentation/excerpts/slide22_future_candidate.omn): a typed individual with provenance, no causal axiom.</a:t>
             </a:r>
-            <a:endParaRPr/>
           </a:p>
           <a:p>
-            <a:pPr indent="-228600" lvl="0" marL="457200" marR="0" rtl="0" algn="l">
-              <a:lnSpc>
-                <a:spcPct val="100000"/>
-              </a:lnSpc>
-              <a:spcBef>
-                <a:spcPts val="0"/>
-              </a:spcBef>
-              <a:spcAft>
-                <a:spcPts val="0"/>
-              </a:spcAft>
-              <a:buSzPts val="1400"/>
-              <a:buNone/>
-            </a:pPr>
             <a:r>
               <a:rPr lang="en-US" sz="1200">
                 <a:solidFill>
@@ -1967,49 +1858,9 @@
               </a:rPr>
               <a:t>IF RUNNING LATE, DROP: "We also want validator and reasoner feedback inside the loop."</a:t>
             </a:r>
-            <a:endParaRPr/>
           </a:p>
+          <a:p/>
           <a:p>
-            <a:pPr indent="-228600" lvl="0" marL="457200" marR="0" rtl="0" algn="l">
-              <a:lnSpc>
-                <a:spcPct val="100000"/>
-              </a:lnSpc>
-              <a:spcBef>
-                <a:spcPts val="0"/>
-              </a:spcBef>
-              <a:spcAft>
-                <a:spcPts val="0"/>
-              </a:spcAft>
-              <a:buSzPts val="1400"/>
-              <a:buNone/>
-            </a:pPr>
-            <a:r>
-              <a:t/>
-            </a:r>
-            <a:endParaRPr sz="1200">
-              <a:solidFill>
-                <a:schemeClr val="dk1"/>
-              </a:solidFill>
-              <a:latin typeface="Calibri"/>
-              <a:ea typeface="Calibri"/>
-              <a:cs typeface="Calibri"/>
-              <a:sym typeface="Calibri"/>
-            </a:endParaRPr>
-          </a:p>
-          <a:p>
-            <a:pPr indent="-228600" lvl="0" marL="457200" marR="0" rtl="0" algn="l">
-              <a:lnSpc>
-                <a:spcPct val="100000"/>
-              </a:lnSpc>
-              <a:spcBef>
-                <a:spcPts val="0"/>
-              </a:spcBef>
-              <a:spcAft>
-                <a:spcPts val="0"/>
-              </a:spcAft>
-              <a:buSzPts val="1400"/>
-              <a:buNone/>
-            </a:pPr>
             <a:r>
               <a:rPr lang="en-US" sz="1200">
                 <a:solidFill>
@@ -2022,7 +1873,6 @@
               </a:rPr>
               <a:t>IF ASKED WHY NOT AN OWL CAUSAL AXIOM: OWL reasoning is deductive and open-world; it cannot derive causation from statistics, and 'Cisplatin SubClassOf causes some BoneMarrowDepression' would wrongly claim it for every case.</a:t>
             </a:r>
-            <a:endParaRPr/>
           </a:p>
         </p:txBody>
       </p:sp>
@@ -4076,7 +3926,7 @@
         <p:spPr>
           <a:xfrm>
             <a:off x="822960" y="2194560"/>
-            <a:ext cx="3017400" cy="3127248"/>
+            <a:ext cx="3017400" cy="3218688"/>
           </a:xfrm>
           <a:prstGeom prst="roundRect">
             <a:avLst>
@@ -4138,7 +3988,7 @@
         <p:spPr>
           <a:xfrm>
             <a:off x="4224528" y="2194560"/>
-            <a:ext cx="2788800" cy="3127248"/>
+            <a:ext cx="2788800" cy="3218688"/>
           </a:xfrm>
           <a:prstGeom prst="roundRect">
             <a:avLst>
@@ -4200,7 +4050,7 @@
         <p:spPr>
           <a:xfrm>
             <a:off x="7397496" y="2194560"/>
-            <a:ext cx="3941100" cy="3127248"/>
+            <a:ext cx="3941100" cy="3218688"/>
           </a:xfrm>
           <a:prstGeom prst="roundRect">
             <a:avLst>
@@ -4261,7 +4111,7 @@
         </p:nvSpPr>
         <p:spPr>
           <a:xfrm>
-            <a:off x="3877048" y="3566184"/>
+            <a:off x="3877048" y="3611904"/>
             <a:ext cx="429600" cy="384000"/>
           </a:xfrm>
           <a:prstGeom prst="rightArrow">
@@ -4318,7 +4168,7 @@
         </p:nvSpPr>
         <p:spPr>
           <a:xfrm>
-            <a:off x="7050025" y="3566184"/>
+            <a:off x="7050025" y="3611904"/>
             <a:ext cx="429600" cy="384000"/>
           </a:xfrm>
           <a:prstGeom prst="rightArrow">
@@ -4458,67 +4308,14 @@
               <a:buNone/>
             </a:pPr>
             <a:r>
-              <a:rPr b="0" i="0" lang="en-US" sz="1300" u="none" cap="none" strike="noStrike">
-                <a:solidFill>
-                  <a:srgbClr val="5B6770"/>
-                </a:solidFill>
-                <a:latin typeface="Calibri"/>
-                <a:ea typeface="Calibri"/>
-                <a:cs typeface="Calibri"/>
-                <a:sym typeface="Calibri"/>
-              </a:rPr>
-              <a:t>What patient rows show</a:t>
-            </a:r>
-            <a:endParaRPr/>
-          </a:p>
-        </p:txBody>
-      </p:sp>
-      <p:sp>
-        <p:nvSpPr>
-          <p:cNvPr id="1305" name="Google Shape;1305;p22"/>
-          <p:cNvSpPr txBox="1"/>
-          <p:nvPr/>
-        </p:nvSpPr>
-        <p:spPr>
-          <a:xfrm>
-            <a:off x="1024128" y="4846320"/>
-            <a:ext cx="2651700" cy="384048"/>
-          </a:xfrm>
-          <a:prstGeom prst="rect">
-            <a:avLst/>
-          </a:prstGeom>
-          <a:noFill/>
-          <a:ln>
-            <a:noFill/>
-          </a:ln>
-        </p:spPr>
-        <p:txBody>
-          <a:bodyPr anchorCtr="0" anchor="t" bIns="0" lIns="0" spcFirstLastPara="1" rIns="0" wrap="square" tIns="0">
-            <a:noAutofit/>
-          </a:bodyPr>
-          <a:lstStyle/>
-          <a:p>
-            <a:pPr indent="0" lvl="0" marL="0" marR="0" rtl="0" algn="l">
-              <a:lnSpc>
-                <a:spcPct val="100000"/>
-              </a:lnSpc>
-              <a:spcBef>
-                <a:spcPts val="0"/>
-              </a:spcBef>
-              <a:spcAft>
-                <a:spcPts val="0"/>
-              </a:spcAft>
-              <a:buNone/>
-            </a:pPr>
-            <a:r>
-              <a:rPr lang="en-US" sz="1100" b="0" i="0" dirty="0">
+              <a:rPr lang="en-US" sz="1300" b="0" i="0" dirty="0">
                 <a:solidFill>
                   <a:srgbClr val="5B6770"/>
                 </a:solidFill>
                 <a:latin typeface="Calibri"/>
                 <a:cs typeface="Calibri"/>
               </a:rPr>
-              <a:t xml:space="preserve">Synthetic rows: patients given cisplatin show bone marrow depression (BM_DEP = 1).</a:t>
+              <a:t xml:space="preserve">What the rows show, across two tables</a:t>
             </a:r>
           </a:p>
         </p:txBody>
@@ -4853,7 +4650,7 @@
         </p:nvSpPr>
         <p:spPr>
           <a:xfrm>
-            <a:off x="7598664" y="4924044"/>
+            <a:off x="7598664" y="4974336"/>
             <a:ext cx="3575400" cy="384048"/>
           </a:xfrm>
           <a:prstGeom prst="rect">
@@ -4913,7 +4710,7 @@
         </p:nvSpPr>
         <p:spPr>
           <a:xfrm>
-            <a:off x="822960" y="5486400"/>
+            <a:off x="822960" y="5559552"/>
             <a:ext cx="10515600" cy="420600"/>
           </a:xfrm>
           <a:prstGeom prst="roundRect">
@@ -4982,7 +4779,7 @@
         </p:nvSpPr>
         <p:spPr>
           <a:xfrm>
-            <a:off x="850392" y="6053328"/>
+            <a:off x="850392" y="6108192"/>
             <a:ext cx="10488300" cy="237600"/>
           </a:xfrm>
           <a:prstGeom prst="rect">
@@ -5029,14 +4826,54 @@
       </p:sp>
       <p:sp>
         <p:nvSpPr>
-          <p:cNvPr id="1317" name="Table header"/>
+          <p:cNvPr id="1317" name="Table treatment"/>
+          <p:cNvSpPr/>
+          <p:nvPr/>
+        </p:nvSpPr>
+        <p:spPr>
+          <a:xfrm>
+            <a:off x="987552" y="2944368"/>
+            <a:ext cx="2688216" cy="1120140"/>
+          </a:xfrm>
+          <a:prstGeom prst="roundRect">
+            <a:avLst>
+              <a:gd name="adj" fmla="val 9000"/>
+            </a:avLst>
+          </a:prstGeom>
+          <a:solidFill>
+            <a:srgbClr val="E9EEEB"/>
+          </a:solidFill>
+          <a:ln>
+            <a:noFill/>
+          </a:ln>
+          <a:effectLst>
+            <a:outerShdw blurRad="76200" dist="25400" dir="5400000" algn="t" rotWithShape="0">
+              <a:srgbClr val="000000">
+                <a:alpha val="16000"/>
+              </a:srgbClr>
+            </a:outerShdw>
+          </a:effectLst>
+        </p:spPr>
+        <p:txBody>
+          <a:bodyPr wrap="square" lIns="0" tIns="0" rIns="0" bIns="0" anchor="ctr">
+            <a:noAutofit/>
+          </a:bodyPr>
+          <a:lstStyle/>
+          <a:p>
+            <a:endParaRPr lang="en-US"/>
+          </a:p>
+        </p:txBody>
+      </p:sp>
+      <p:sp>
+        <p:nvSpPr>
+          <p:cNvPr id="1318" name="Table name"/>
           <p:cNvSpPr txBox="1"/>
           <p:nvPr/>
         </p:nvSpPr>
         <p:spPr>
           <a:xfrm>
-            <a:off x="1024128" y="3035808"/>
-            <a:ext cx="914400" cy="237744"/>
+            <a:off x="1124712" y="2971800"/>
+            <a:ext cx="2413896" cy="246888"/>
           </a:xfrm>
           <a:prstGeom prst="rect">
             <a:avLst/>
@@ -5054,112 +4891,34 @@
           <a:p>
             <a:pPr algn="l"/>
             <a:r>
-              <a:rPr lang="en-US" sz="950" b="1" i="0" dirty="0">
-                <a:solidFill>
-                  <a:srgbClr val="5B6770"/>
-                </a:solidFill>
-                <a:latin typeface="Consolas"/>
-                <a:cs typeface="Consolas"/>
-              </a:rPr>
-              <a:t xml:space="preserve">PATIENT</a:t>
+              <a:rPr lang="en-US" sz="1450" b="1" i="0" dirty="0">
+                <a:solidFill>
+                  <a:srgbClr val="1F2328"/>
+                </a:solidFill>
+                <a:latin typeface="Calibri"/>
+                <a:cs typeface="Calibri"/>
+              </a:rPr>
+              <a:t xml:space="preserve">treatment</a:t>
             </a:r>
           </a:p>
         </p:txBody>
       </p:sp>
       <p:sp>
         <p:nvSpPr>
-          <p:cNvPr id="1318" name="Table header"/>
-          <p:cNvSpPr txBox="1"/>
-          <p:nvPr/>
-        </p:nvSpPr>
-        <p:spPr>
-          <a:xfrm>
-            <a:off x="1920240" y="3035808"/>
-            <a:ext cx="914400" cy="237744"/>
-          </a:xfrm>
-          <a:prstGeom prst="rect">
-            <a:avLst/>
-          </a:prstGeom>
-          <a:noFill/>
-          <a:ln>
-            <a:noFill/>
-          </a:ln>
-        </p:spPr>
-        <p:txBody>
-          <a:bodyPr wrap="square" lIns="0" tIns="0" rIns="0" bIns="0" anchor="ctr">
-            <a:noAutofit/>
-          </a:bodyPr>
-          <a:lstStyle/>
-          <a:p>
-            <a:pPr algn="l"/>
-            <a:r>
-              <a:rPr lang="en-US" sz="950" b="1" i="0" dirty="0">
-                <a:solidFill>
-                  <a:srgbClr val="5B6770"/>
-                </a:solidFill>
-                <a:latin typeface="Consolas"/>
-                <a:cs typeface="Consolas"/>
-              </a:rPr>
-              <a:t xml:space="preserve">CISPLATIN</a:t>
-            </a:r>
-          </a:p>
-        </p:txBody>
-      </p:sp>
-      <p:sp>
-        <p:nvSpPr>
-          <p:cNvPr id="1319" name="Table header"/>
-          <p:cNvSpPr txBox="1"/>
-          <p:nvPr/>
-        </p:nvSpPr>
-        <p:spPr>
-          <a:xfrm>
-            <a:off x="2926079" y="3035808"/>
-            <a:ext cx="914400" cy="237744"/>
-          </a:xfrm>
-          <a:prstGeom prst="rect">
-            <a:avLst/>
-          </a:prstGeom>
-          <a:noFill/>
-          <a:ln>
-            <a:noFill/>
-          </a:ln>
-        </p:spPr>
-        <p:txBody>
-          <a:bodyPr wrap="square" lIns="0" tIns="0" rIns="0" bIns="0" anchor="ctr">
-            <a:noAutofit/>
-          </a:bodyPr>
-          <a:lstStyle/>
-          <a:p>
-            <a:pPr algn="l"/>
-            <a:r>
-              <a:rPr lang="en-US" sz="950" b="1" i="0" dirty="0">
-                <a:solidFill>
-                  <a:srgbClr val="5B6770"/>
-                </a:solidFill>
-                <a:latin typeface="Consolas"/>
-                <a:cs typeface="Consolas"/>
-              </a:rPr>
-              <a:t xml:space="preserve">BM_DEP</a:t>
-            </a:r>
-          </a:p>
-        </p:txBody>
-      </p:sp>
-      <p:sp>
-        <p:nvSpPr>
-          <p:cNvPr id="1320" name="Row band"/>
+          <p:cNvPr id="1319" name="Rule"/>
           <p:cNvSpPr/>
           <p:nvPr/>
         </p:nvSpPr>
         <p:spPr>
           <a:xfrm>
-            <a:off x="960120" y="3328416"/>
-            <a:ext cx="2743080" cy="256032"/>
+            <a:off x="1124712" y="3236976"/>
+            <a:ext cx="2413896" cy="10972"/>
           </a:xfrm>
           <a:prstGeom prst="rect">
             <a:avLst/>
           </a:prstGeom>
           <a:solidFill>
-            <a:srgbClr val="E6F2EC"/>
+            <a:srgbClr val="9AA3A9"/>
           </a:solidFill>
           <a:ln>
             <a:noFill/>
@@ -5177,14 +4936,14 @@
       </p:sp>
       <p:sp>
         <p:nvSpPr>
-          <p:cNvPr id="1321" name="Cell"/>
+          <p:cNvPr id="1320" name="Column"/>
           <p:cNvSpPr txBox="1"/>
           <p:nvPr/>
         </p:nvSpPr>
         <p:spPr>
           <a:xfrm>
-            <a:off x="1024128" y="3328416"/>
-            <a:ext cx="914400" cy="256032"/>
+            <a:off x="1124712" y="3264408"/>
+            <a:ext cx="1051560" cy="182880"/>
           </a:xfrm>
           <a:prstGeom prst="rect">
             <a:avLst/>
@@ -5202,28 +4961,38 @@
           <a:p>
             <a:pPr algn="l"/>
             <a:r>
-              <a:rPr lang="en-US" sz="1150" b="0" i="0" dirty="0">
-                <a:solidFill>
-                  <a:srgbClr val="1F2328"/>
-                </a:solidFill>
-                <a:latin typeface="Consolas"/>
-                <a:cs typeface="Consolas"/>
-              </a:rPr>
-              <a:t xml:space="preserve">P01</a:t>
+              <a:rPr lang="en-US" sz="1050" b="1" i="0" dirty="0">
+                <a:solidFill>
+                  <a:srgbClr val="0B6E4F"/>
+                </a:solidFill>
+                <a:latin typeface="Calibri"/>
+                <a:cs typeface="Calibri"/>
+              </a:rPr>
+              <a:t xml:space="preserve">admission_id</a:t>
+            </a:r>
+            <a:r>
+              <a:rPr lang="en-US" sz="900" b="0" i="0" dirty="0">
+                <a:solidFill>
+                  <a:srgbClr val="5B6770"/>
+                </a:solidFill>
+                <a:latin typeface="Calibri"/>
+                <a:cs typeface="Calibri"/>
+              </a:rPr>
+              <a:t xml:space="preserve">  FK</a:t>
             </a:r>
           </a:p>
         </p:txBody>
       </p:sp>
       <p:sp>
         <p:nvSpPr>
-          <p:cNvPr id="1322" name="Cell"/>
+          <p:cNvPr id="1321" name="Column"/>
           <p:cNvSpPr txBox="1"/>
           <p:nvPr/>
         </p:nvSpPr>
         <p:spPr>
           <a:xfrm>
-            <a:off x="1920240" y="3328416"/>
-            <a:ext cx="914400" cy="256032"/>
+            <a:off x="2176272" y="3264408"/>
+            <a:ext cx="1508760" cy="182880"/>
           </a:xfrm>
           <a:prstGeom prst="rect">
             <a:avLst/>
@@ -5241,73 +5010,34 @@
           <a:p>
             <a:pPr algn="l"/>
             <a:r>
-              <a:rPr lang="en-US" sz="1150" b="0" i="0" dirty="0">
-                <a:solidFill>
-                  <a:srgbClr val="1F2328"/>
-                </a:solidFill>
-                <a:latin typeface="Consolas"/>
-                <a:cs typeface="Consolas"/>
-              </a:rPr>
-              <a:t xml:space="preserve">yes</a:t>
+              <a:rPr lang="en-US" sz="1050" b="1" i="0" dirty="0">
+                <a:solidFill>
+                  <a:srgbClr val="0B6E4F"/>
+                </a:solidFill>
+                <a:latin typeface="Calibri"/>
+                <a:cs typeface="Calibri"/>
+              </a:rPr>
+              <a:t xml:space="preserve">drug</a:t>
             </a:r>
           </a:p>
         </p:txBody>
       </p:sp>
       <p:sp>
         <p:nvSpPr>
-          <p:cNvPr id="1323" name="Cell"/>
-          <p:cNvSpPr txBox="1"/>
-          <p:nvPr/>
-        </p:nvSpPr>
-        <p:spPr>
-          <a:xfrm>
-            <a:off x="2926079" y="3328416"/>
-            <a:ext cx="914400" cy="256032"/>
-          </a:xfrm>
-          <a:prstGeom prst="rect">
-            <a:avLst/>
-          </a:prstGeom>
-          <a:noFill/>
-          <a:ln>
-            <a:noFill/>
-          </a:ln>
-        </p:spPr>
-        <p:txBody>
-          <a:bodyPr wrap="square" lIns="0" tIns="0" rIns="0" bIns="0" anchor="ctr">
-            <a:noAutofit/>
-          </a:bodyPr>
-          <a:lstStyle/>
-          <a:p>
-            <a:pPr algn="l"/>
-            <a:r>
-              <a:rPr lang="en-US" sz="1150" b="0" i="0" dirty="0">
-                <a:solidFill>
-                  <a:srgbClr val="1F2328"/>
-                </a:solidFill>
-                <a:latin typeface="Consolas"/>
-                <a:cs typeface="Consolas"/>
-              </a:rPr>
-              <a:t xml:space="preserve">1</a:t>
-            </a:r>
-          </a:p>
-        </p:txBody>
-      </p:sp>
-      <p:sp>
-        <p:nvSpPr>
-          <p:cNvPr id="1324" name="Row band"/>
+          <p:cNvPr id="1322" name="Row band"/>
           <p:cNvSpPr/>
           <p:nvPr/>
         </p:nvSpPr>
         <p:spPr>
           <a:xfrm>
-            <a:off x="960120" y="3621024"/>
-            <a:ext cx="2743080" cy="256032"/>
+            <a:off x="1060704" y="3456432"/>
+            <a:ext cx="2541912" cy="173736"/>
           </a:xfrm>
           <a:prstGeom prst="rect">
             <a:avLst/>
           </a:prstGeom>
           <a:solidFill>
-            <a:srgbClr val="E6F2EC"/>
+            <a:srgbClr val="D7EDE2"/>
           </a:solidFill>
           <a:ln>
             <a:noFill/>
@@ -5325,14 +5055,14 @@
       </p:sp>
       <p:sp>
         <p:nvSpPr>
-          <p:cNvPr id="1325" name="Cell"/>
+          <p:cNvPr id="1323" name="Cell"/>
           <p:cNvSpPr txBox="1"/>
           <p:nvPr/>
         </p:nvSpPr>
         <p:spPr>
           <a:xfrm>
-            <a:off x="1024128" y="3621024"/>
-            <a:ext cx="914400" cy="256032"/>
+            <a:off x="1124712" y="3456432"/>
+            <a:ext cx="1051560" cy="173736"/>
           </a:xfrm>
           <a:prstGeom prst="rect">
             <a:avLst/>
@@ -5350,28 +5080,28 @@
           <a:p>
             <a:pPr algn="l"/>
             <a:r>
-              <a:rPr lang="en-US" sz="1150" b="0" i="0" dirty="0">
+              <a:rPr lang="en-US" sz="1050" b="0" i="0" dirty="0">
                 <a:solidFill>
                   <a:srgbClr val="1F2328"/>
                 </a:solidFill>
                 <a:latin typeface="Consolas"/>
                 <a:cs typeface="Consolas"/>
               </a:rPr>
-              <a:t xml:space="preserve">P02</a:t>
+              <a:t xml:space="preserve">A1</a:t>
             </a:r>
           </a:p>
         </p:txBody>
       </p:sp>
       <p:sp>
         <p:nvSpPr>
-          <p:cNvPr id="1326" name="Cell"/>
+          <p:cNvPr id="1324" name="Cell"/>
           <p:cNvSpPr txBox="1"/>
           <p:nvPr/>
         </p:nvSpPr>
         <p:spPr>
           <a:xfrm>
-            <a:off x="1920240" y="3621024"/>
-            <a:ext cx="914400" cy="256032"/>
+            <a:off x="2176272" y="3456432"/>
+            <a:ext cx="1508760" cy="173736"/>
           </a:xfrm>
           <a:prstGeom prst="rect">
             <a:avLst/>
@@ -5389,28 +5119,28 @@
           <a:p>
             <a:pPr algn="l"/>
             <a:r>
-              <a:rPr lang="en-US" sz="1150" b="0" i="0" dirty="0">
+              <a:rPr lang="en-US" sz="1050" b="0" i="0" dirty="0">
                 <a:solidFill>
                   <a:srgbClr val="1F2328"/>
                 </a:solidFill>
                 <a:latin typeface="Consolas"/>
                 <a:cs typeface="Consolas"/>
               </a:rPr>
-              <a:t xml:space="preserve">yes</a:t>
+              <a:t xml:space="preserve">cisplatin</a:t>
             </a:r>
           </a:p>
         </p:txBody>
       </p:sp>
       <p:sp>
         <p:nvSpPr>
-          <p:cNvPr id="1327" name="Cell"/>
+          <p:cNvPr id="1325" name="Cell"/>
           <p:cNvSpPr txBox="1"/>
           <p:nvPr/>
         </p:nvSpPr>
         <p:spPr>
           <a:xfrm>
-            <a:off x="2926079" y="3621024"/>
-            <a:ext cx="914400" cy="256032"/>
+            <a:off x="1124712" y="3643884"/>
+            <a:ext cx="1051560" cy="173736"/>
           </a:xfrm>
           <a:prstGeom prst="rect">
             <a:avLst/>
@@ -5428,28 +5158,28 @@
           <a:p>
             <a:pPr algn="l"/>
             <a:r>
-              <a:rPr lang="en-US" sz="1150" b="0" i="0" dirty="0">
+              <a:rPr lang="en-US" sz="1050" b="0" i="0" dirty="0">
                 <a:solidFill>
                   <a:srgbClr val="1F2328"/>
                 </a:solidFill>
                 <a:latin typeface="Consolas"/>
                 <a:cs typeface="Consolas"/>
               </a:rPr>
-              <a:t xml:space="preserve">1</a:t>
+              <a:t xml:space="preserve">A2</a:t>
             </a:r>
           </a:p>
         </p:txBody>
       </p:sp>
       <p:sp>
         <p:nvSpPr>
-          <p:cNvPr id="1328" name="Cell"/>
+          <p:cNvPr id="1326" name="Cell"/>
           <p:cNvSpPr txBox="1"/>
           <p:nvPr/>
         </p:nvSpPr>
         <p:spPr>
           <a:xfrm>
-            <a:off x="1024128" y="3913632"/>
-            <a:ext cx="914400" cy="256032"/>
+            <a:off x="2176272" y="3643884"/>
+            <a:ext cx="1508760" cy="173736"/>
           </a:xfrm>
           <a:prstGeom prst="rect">
             <a:avLst/>
@@ -5467,112 +5197,34 @@
           <a:p>
             <a:pPr algn="l"/>
             <a:r>
-              <a:rPr lang="en-US" sz="1150" b="0" i="0" dirty="0">
+              <a:rPr lang="en-US" sz="1050" b="0" i="0" dirty="0">
                 <a:solidFill>
                   <a:srgbClr val="1F2328"/>
                 </a:solidFill>
                 <a:latin typeface="Consolas"/>
                 <a:cs typeface="Consolas"/>
               </a:rPr>
-              <a:t xml:space="preserve">P03</a:t>
+              <a:t xml:space="preserve">nivolumab</a:t>
             </a:r>
           </a:p>
         </p:txBody>
       </p:sp>
       <p:sp>
         <p:nvSpPr>
-          <p:cNvPr id="1329" name="Cell"/>
-          <p:cNvSpPr txBox="1"/>
-          <p:nvPr/>
-        </p:nvSpPr>
-        <p:spPr>
-          <a:xfrm>
-            <a:off x="1920240" y="3913632"/>
-            <a:ext cx="914400" cy="256032"/>
-          </a:xfrm>
-          <a:prstGeom prst="rect">
-            <a:avLst/>
-          </a:prstGeom>
-          <a:noFill/>
-          <a:ln>
-            <a:noFill/>
-          </a:ln>
-        </p:spPr>
-        <p:txBody>
-          <a:bodyPr wrap="square" lIns="0" tIns="0" rIns="0" bIns="0" anchor="ctr">
-            <a:noAutofit/>
-          </a:bodyPr>
-          <a:lstStyle/>
-          <a:p>
-            <a:pPr algn="l"/>
-            <a:r>
-              <a:rPr lang="en-US" sz="1150" b="0" i="0" dirty="0">
-                <a:solidFill>
-                  <a:srgbClr val="1F2328"/>
-                </a:solidFill>
-                <a:latin typeface="Consolas"/>
-                <a:cs typeface="Consolas"/>
-              </a:rPr>
-              <a:t xml:space="preserve">no</a:t>
-            </a:r>
-          </a:p>
-        </p:txBody>
-      </p:sp>
-      <p:sp>
-        <p:nvSpPr>
-          <p:cNvPr id="1330" name="Cell"/>
-          <p:cNvSpPr txBox="1"/>
-          <p:nvPr/>
-        </p:nvSpPr>
-        <p:spPr>
-          <a:xfrm>
-            <a:off x="2926079" y="3913632"/>
-            <a:ext cx="914400" cy="256032"/>
-          </a:xfrm>
-          <a:prstGeom prst="rect">
-            <a:avLst/>
-          </a:prstGeom>
-          <a:noFill/>
-          <a:ln>
-            <a:noFill/>
-          </a:ln>
-        </p:spPr>
-        <p:txBody>
-          <a:bodyPr wrap="square" lIns="0" tIns="0" rIns="0" bIns="0" anchor="ctr">
-            <a:noAutofit/>
-          </a:bodyPr>
-          <a:lstStyle/>
-          <a:p>
-            <a:pPr algn="l"/>
-            <a:r>
-              <a:rPr lang="en-US" sz="1150" b="0" i="0" dirty="0">
-                <a:solidFill>
-                  <a:srgbClr val="1F2328"/>
-                </a:solidFill>
-                <a:latin typeface="Consolas"/>
-                <a:cs typeface="Consolas"/>
-              </a:rPr>
-              <a:t xml:space="preserve">0</a:t>
-            </a:r>
-          </a:p>
-        </p:txBody>
-      </p:sp>
-      <p:sp>
-        <p:nvSpPr>
-          <p:cNvPr id="1331" name="Row band"/>
+          <p:cNvPr id="1327" name="Row band"/>
           <p:cNvSpPr/>
           <p:nvPr/>
         </p:nvSpPr>
         <p:spPr>
           <a:xfrm>
-            <a:off x="960120" y="4206240"/>
-            <a:ext cx="2743080" cy="256032"/>
+            <a:off x="1060704" y="3831336"/>
+            <a:ext cx="2541912" cy="173736"/>
           </a:xfrm>
           <a:prstGeom prst="rect">
             <a:avLst/>
           </a:prstGeom>
           <a:solidFill>
-            <a:srgbClr val="E6F2EC"/>
+            <a:srgbClr val="D7EDE2"/>
           </a:solidFill>
           <a:ln>
             <a:noFill/>
@@ -5590,14 +5242,14 @@
       </p:sp>
       <p:sp>
         <p:nvSpPr>
-          <p:cNvPr id="1332" name="Cell"/>
+          <p:cNvPr id="1328" name="Cell"/>
           <p:cNvSpPr txBox="1"/>
           <p:nvPr/>
         </p:nvSpPr>
         <p:spPr>
           <a:xfrm>
-            <a:off x="1024128" y="4206240"/>
-            <a:ext cx="914400" cy="256032"/>
+            <a:off x="1124712" y="3831336"/>
+            <a:ext cx="1051560" cy="173736"/>
           </a:xfrm>
           <a:prstGeom prst="rect">
             <a:avLst/>
@@ -5615,28 +5267,28 @@
           <a:p>
             <a:pPr algn="l"/>
             <a:r>
-              <a:rPr lang="en-US" sz="1150" b="0" i="0" dirty="0">
+              <a:rPr lang="en-US" sz="1050" b="0" i="0" dirty="0">
                 <a:solidFill>
                   <a:srgbClr val="1F2328"/>
                 </a:solidFill>
                 <a:latin typeface="Consolas"/>
                 <a:cs typeface="Consolas"/>
               </a:rPr>
-              <a:t xml:space="preserve">P04</a:t>
+              <a:t xml:space="preserve">A3</a:t>
             </a:r>
           </a:p>
         </p:txBody>
       </p:sp>
       <p:sp>
         <p:nvSpPr>
-          <p:cNvPr id="1333" name="Cell"/>
+          <p:cNvPr id="1329" name="Cell"/>
           <p:cNvSpPr txBox="1"/>
           <p:nvPr/>
         </p:nvSpPr>
         <p:spPr>
           <a:xfrm>
-            <a:off x="1920240" y="4206240"/>
-            <a:ext cx="914400" cy="256032"/>
+            <a:off x="2176272" y="3831336"/>
+            <a:ext cx="1508760" cy="173736"/>
           </a:xfrm>
           <a:prstGeom prst="rect">
             <a:avLst/>
@@ -5654,28 +5306,68 @@
           <a:p>
             <a:pPr algn="l"/>
             <a:r>
-              <a:rPr lang="en-US" sz="1150" b="0" i="0" dirty="0">
+              <a:rPr lang="en-US" sz="1050" b="0" i="0" dirty="0">
                 <a:solidFill>
                   <a:srgbClr val="1F2328"/>
                 </a:solidFill>
                 <a:latin typeface="Consolas"/>
                 <a:cs typeface="Consolas"/>
               </a:rPr>
-              <a:t xml:space="preserve">yes</a:t>
+              <a:t xml:space="preserve">cisplatin</a:t>
             </a:r>
           </a:p>
         </p:txBody>
       </p:sp>
       <p:sp>
         <p:nvSpPr>
-          <p:cNvPr id="1334" name="Cell"/>
+          <p:cNvPr id="1330" name="Table admission"/>
+          <p:cNvSpPr/>
+          <p:nvPr/>
+        </p:nvSpPr>
+        <p:spPr>
+          <a:xfrm>
+            <a:off x="987552" y="4155948"/>
+            <a:ext cx="2688216" cy="1120140"/>
+          </a:xfrm>
+          <a:prstGeom prst="roundRect">
+            <a:avLst>
+              <a:gd name="adj" fmla="val 9000"/>
+            </a:avLst>
+          </a:prstGeom>
+          <a:solidFill>
+            <a:srgbClr val="E9EEEB"/>
+          </a:solidFill>
+          <a:ln>
+            <a:noFill/>
+          </a:ln>
+          <a:effectLst>
+            <a:outerShdw blurRad="76200" dist="25400" dir="5400000" algn="t" rotWithShape="0">
+              <a:srgbClr val="000000">
+                <a:alpha val="16000"/>
+              </a:srgbClr>
+            </a:outerShdw>
+          </a:effectLst>
+        </p:spPr>
+        <p:txBody>
+          <a:bodyPr wrap="square" lIns="0" tIns="0" rIns="0" bIns="0" anchor="ctr">
+            <a:noAutofit/>
+          </a:bodyPr>
+          <a:lstStyle/>
+          <a:p>
+            <a:endParaRPr lang="en-US"/>
+          </a:p>
+        </p:txBody>
+      </p:sp>
+      <p:sp>
+        <p:nvSpPr>
+          <p:cNvPr id="1331" name="Table name"/>
           <p:cNvSpPr txBox="1"/>
           <p:nvPr/>
         </p:nvSpPr>
         <p:spPr>
           <a:xfrm>
-            <a:off x="2926079" y="4206240"/>
-            <a:ext cx="914400" cy="256032"/>
+            <a:off x="1124712" y="4183380"/>
+            <a:ext cx="2413896" cy="246888"/>
           </a:xfrm>
           <a:prstGeom prst="rect">
             <a:avLst/>
@@ -5693,28 +5385,59 @@
           <a:p>
             <a:pPr algn="l"/>
             <a:r>
-              <a:rPr lang="en-US" sz="1150" b="0" i="0" dirty="0">
+              <a:rPr lang="en-US" sz="1450" b="1" i="0" dirty="0">
                 <a:solidFill>
                   <a:srgbClr val="1F2328"/>
                 </a:solidFill>
-                <a:latin typeface="Consolas"/>
-                <a:cs typeface="Consolas"/>
-              </a:rPr>
-              <a:t xml:space="preserve">1</a:t>
+                <a:latin typeface="Calibri"/>
+                <a:cs typeface="Calibri"/>
+              </a:rPr>
+              <a:t xml:space="preserve">admission</a:t>
             </a:r>
           </a:p>
         </p:txBody>
       </p:sp>
       <p:sp>
         <p:nvSpPr>
-          <p:cNvPr id="1335" name="Cell"/>
+          <p:cNvPr id="1332" name="Rule"/>
+          <p:cNvSpPr/>
+          <p:nvPr/>
+        </p:nvSpPr>
+        <p:spPr>
+          <a:xfrm>
+            <a:off x="1124712" y="4448556"/>
+            <a:ext cx="2413896" cy="10972"/>
+          </a:xfrm>
+          <a:prstGeom prst="rect">
+            <a:avLst/>
+          </a:prstGeom>
+          <a:solidFill>
+            <a:srgbClr val="9AA3A9"/>
+          </a:solidFill>
+          <a:ln>
+            <a:noFill/>
+          </a:ln>
+        </p:spPr>
+        <p:txBody>
+          <a:bodyPr wrap="square" lIns="0" tIns="0" rIns="0" bIns="0" anchor="t">
+            <a:noAutofit/>
+          </a:bodyPr>
+          <a:lstStyle/>
+          <a:p>
+            <a:pPr algn="l"/>
+          </a:p>
+        </p:txBody>
+      </p:sp>
+      <p:sp>
+        <p:nvSpPr>
+          <p:cNvPr id="1333" name="Column"/>
           <p:cNvSpPr txBox="1"/>
           <p:nvPr/>
         </p:nvSpPr>
         <p:spPr>
           <a:xfrm>
-            <a:off x="1024128" y="4498848"/>
-            <a:ext cx="914400" cy="256032"/>
+            <a:off x="1124712" y="4475988"/>
+            <a:ext cx="1051560" cy="182880"/>
           </a:xfrm>
           <a:prstGeom prst="rect">
             <a:avLst/>
@@ -5732,28 +5455,28 @@
           <a:p>
             <a:pPr algn="l"/>
             <a:r>
-              <a:rPr lang="en-US" sz="1150" b="0" i="0" dirty="0">
-                <a:solidFill>
-                  <a:srgbClr val="1F2328"/>
-                </a:solidFill>
-                <a:latin typeface="Consolas"/>
-                <a:cs typeface="Consolas"/>
-              </a:rPr>
-              <a:t xml:space="preserve">P05</a:t>
+              <a:rPr lang="en-US" sz="1050" b="1" i="0" dirty="0">
+                <a:solidFill>
+                  <a:srgbClr val="0B6E4F"/>
+                </a:solidFill>
+                <a:latin typeface="Calibri"/>
+                <a:cs typeface="Calibri"/>
+              </a:rPr>
+              <a:t xml:space="preserve">admission_id</a:t>
             </a:r>
           </a:p>
         </p:txBody>
       </p:sp>
       <p:sp>
         <p:nvSpPr>
-          <p:cNvPr id="1336" name="Cell"/>
+          <p:cNvPr id="1334" name="Column"/>
           <p:cNvSpPr txBox="1"/>
           <p:nvPr/>
         </p:nvSpPr>
         <p:spPr>
           <a:xfrm>
-            <a:off x="1920240" y="4498848"/>
-            <a:ext cx="914400" cy="256032"/>
+            <a:off x="2176272" y="4475988"/>
+            <a:ext cx="868680" cy="182880"/>
           </a:xfrm>
           <a:prstGeom prst="rect">
             <a:avLst/>
@@ -5771,28 +5494,28 @@
           <a:p>
             <a:pPr algn="l"/>
             <a:r>
-              <a:rPr lang="en-US" sz="1150" b="0" i="0" dirty="0">
-                <a:solidFill>
-                  <a:srgbClr val="1F2328"/>
-                </a:solidFill>
-                <a:latin typeface="Consolas"/>
-                <a:cs typeface="Consolas"/>
-              </a:rPr>
-              <a:t xml:space="preserve">no</a:t>
+              <a:rPr lang="en-US" sz="1050" b="1" i="0" dirty="0">
+                <a:solidFill>
+                  <a:srgbClr val="0B6E4F"/>
+                </a:solidFill>
+                <a:latin typeface="Calibri"/>
+                <a:cs typeface="Calibri"/>
+              </a:rPr>
+              <a:t xml:space="preserve">patient_id</a:t>
             </a:r>
           </a:p>
         </p:txBody>
       </p:sp>
       <p:sp>
         <p:nvSpPr>
-          <p:cNvPr id="1337" name="Cell"/>
+          <p:cNvPr id="1335" name="Column"/>
           <p:cNvSpPr txBox="1"/>
           <p:nvPr/>
         </p:nvSpPr>
         <p:spPr>
           <a:xfrm>
-            <a:off x="2926079" y="4498848"/>
-            <a:ext cx="914400" cy="256032"/>
+            <a:off x="3044952" y="4475988"/>
+            <a:ext cx="640080" cy="182880"/>
           </a:xfrm>
           <a:prstGeom prst="rect">
             <a:avLst/>
@@ -5810,28 +5533,59 @@
           <a:p>
             <a:pPr algn="l"/>
             <a:r>
-              <a:rPr lang="en-US" sz="1150" b="0" i="0" dirty="0">
-                <a:solidFill>
-                  <a:srgbClr val="1F2328"/>
-                </a:solidFill>
-                <a:latin typeface="Consolas"/>
-                <a:cs typeface="Consolas"/>
-              </a:rPr>
-              <a:t xml:space="preserve">0</a:t>
+              <a:rPr lang="en-US" sz="1050" b="1" i="0" dirty="0">
+                <a:solidFill>
+                  <a:srgbClr val="0B6E4F"/>
+                </a:solidFill>
+                <a:latin typeface="Calibri"/>
+                <a:cs typeface="Calibri"/>
+              </a:rPr>
+              <a:t xml:space="preserve">BM_DEP</a:t>
             </a:r>
           </a:p>
         </p:txBody>
       </p:sp>
       <p:sp>
         <p:nvSpPr>
-          <p:cNvPr id="1338" name="Bridge"/>
+          <p:cNvPr id="1336" name="Row band"/>
+          <p:cNvSpPr/>
+          <p:nvPr/>
+        </p:nvSpPr>
+        <p:spPr>
+          <a:xfrm>
+            <a:off x="1060704" y="4668012"/>
+            <a:ext cx="2541912" cy="173736"/>
+          </a:xfrm>
+          <a:prstGeom prst="rect">
+            <a:avLst/>
+          </a:prstGeom>
+          <a:solidFill>
+            <a:srgbClr val="D7EDE2"/>
+          </a:solidFill>
+          <a:ln>
+            <a:noFill/>
+          </a:ln>
+        </p:spPr>
+        <p:txBody>
+          <a:bodyPr wrap="square" lIns="0" tIns="0" rIns="0" bIns="0" anchor="t">
+            <a:noAutofit/>
+          </a:bodyPr>
+          <a:lstStyle/>
+          <a:p>
+            <a:pPr algn="l"/>
+          </a:p>
+        </p:txBody>
+      </p:sp>
+      <p:sp>
+        <p:nvSpPr>
+          <p:cNvPr id="1337" name="Cell"/>
           <p:cNvSpPr txBox="1"/>
           <p:nvPr/>
         </p:nvSpPr>
         <p:spPr>
           <a:xfrm>
-            <a:off x="4425696" y="4526280"/>
-            <a:ext cx="2423040" cy="566928"/>
+            <a:off x="1124712" y="4668012"/>
+            <a:ext cx="1051560" cy="173736"/>
           </a:xfrm>
           <a:prstGeom prst="rect">
             <a:avLst/>
@@ -5842,12 +5596,394 @@
           </a:ln>
         </p:spPr>
         <p:txBody>
+          <a:bodyPr wrap="square" lIns="0" tIns="0" rIns="0" bIns="0" anchor="ctr">
+            <a:noAutofit/>
+          </a:bodyPr>
+          <a:lstStyle/>
+          <a:p>
+            <a:pPr algn="l"/>
+            <a:r>
+              <a:rPr lang="en-US" sz="1050" b="0" i="0" dirty="0">
+                <a:solidFill>
+                  <a:srgbClr val="1F2328"/>
+                </a:solidFill>
+                <a:latin typeface="Consolas"/>
+                <a:cs typeface="Consolas"/>
+              </a:rPr>
+              <a:t xml:space="preserve">A1</a:t>
+            </a:r>
+          </a:p>
+        </p:txBody>
+      </p:sp>
+      <p:sp>
+        <p:nvSpPr>
+          <p:cNvPr id="1338" name="Cell"/>
+          <p:cNvSpPr txBox="1"/>
+          <p:nvPr/>
+        </p:nvSpPr>
+        <p:spPr>
+          <a:xfrm>
+            <a:off x="2176272" y="4668012"/>
+            <a:ext cx="868680" cy="173736"/>
+          </a:xfrm>
+          <a:prstGeom prst="rect">
+            <a:avLst/>
+          </a:prstGeom>
+          <a:noFill/>
+          <a:ln>
+            <a:noFill/>
+          </a:ln>
+        </p:spPr>
+        <p:txBody>
+          <a:bodyPr wrap="square" lIns="0" tIns="0" rIns="0" bIns="0" anchor="ctr">
+            <a:noAutofit/>
+          </a:bodyPr>
+          <a:lstStyle/>
+          <a:p>
+            <a:pPr algn="l"/>
+            <a:r>
+              <a:rPr lang="en-US" sz="1050" b="0" i="0" dirty="0">
+                <a:solidFill>
+                  <a:srgbClr val="1F2328"/>
+                </a:solidFill>
+                <a:latin typeface="Consolas"/>
+                <a:cs typeface="Consolas"/>
+              </a:rPr>
+              <a:t xml:space="preserve">P1</a:t>
+            </a:r>
+          </a:p>
+        </p:txBody>
+      </p:sp>
+      <p:sp>
+        <p:nvSpPr>
+          <p:cNvPr id="1339" name="Cell"/>
+          <p:cNvSpPr txBox="1"/>
+          <p:nvPr/>
+        </p:nvSpPr>
+        <p:spPr>
+          <a:xfrm>
+            <a:off x="3044952" y="4668012"/>
+            <a:ext cx="640080" cy="173736"/>
+          </a:xfrm>
+          <a:prstGeom prst="rect">
+            <a:avLst/>
+          </a:prstGeom>
+          <a:noFill/>
+          <a:ln>
+            <a:noFill/>
+          </a:ln>
+        </p:spPr>
+        <p:txBody>
+          <a:bodyPr wrap="square" lIns="0" tIns="0" rIns="0" bIns="0" anchor="ctr">
+            <a:noAutofit/>
+          </a:bodyPr>
+          <a:lstStyle/>
+          <a:p>
+            <a:pPr algn="l"/>
+            <a:r>
+              <a:rPr lang="en-US" sz="1050" b="0" i="0" dirty="0">
+                <a:solidFill>
+                  <a:srgbClr val="1F2328"/>
+                </a:solidFill>
+                <a:latin typeface="Consolas"/>
+                <a:cs typeface="Consolas"/>
+              </a:rPr>
+              <a:t xml:space="preserve">1</a:t>
+            </a:r>
+          </a:p>
+        </p:txBody>
+      </p:sp>
+      <p:sp>
+        <p:nvSpPr>
+          <p:cNvPr id="1340" name="Cell"/>
+          <p:cNvSpPr txBox="1"/>
+          <p:nvPr/>
+        </p:nvSpPr>
+        <p:spPr>
+          <a:xfrm>
+            <a:off x="1124712" y="4855464"/>
+            <a:ext cx="1051560" cy="173736"/>
+          </a:xfrm>
+          <a:prstGeom prst="rect">
+            <a:avLst/>
+          </a:prstGeom>
+          <a:noFill/>
+          <a:ln>
+            <a:noFill/>
+          </a:ln>
+        </p:spPr>
+        <p:txBody>
+          <a:bodyPr wrap="square" lIns="0" tIns="0" rIns="0" bIns="0" anchor="ctr">
+            <a:noAutofit/>
+          </a:bodyPr>
+          <a:lstStyle/>
+          <a:p>
+            <a:pPr algn="l"/>
+            <a:r>
+              <a:rPr lang="en-US" sz="1050" b="0" i="0" dirty="0">
+                <a:solidFill>
+                  <a:srgbClr val="1F2328"/>
+                </a:solidFill>
+                <a:latin typeface="Consolas"/>
+                <a:cs typeface="Consolas"/>
+              </a:rPr>
+              <a:t xml:space="preserve">A2</a:t>
+            </a:r>
+          </a:p>
+        </p:txBody>
+      </p:sp>
+      <p:sp>
+        <p:nvSpPr>
+          <p:cNvPr id="1341" name="Cell"/>
+          <p:cNvSpPr txBox="1"/>
+          <p:nvPr/>
+        </p:nvSpPr>
+        <p:spPr>
+          <a:xfrm>
+            <a:off x="2176272" y="4855464"/>
+            <a:ext cx="868680" cy="173736"/>
+          </a:xfrm>
+          <a:prstGeom prst="rect">
+            <a:avLst/>
+          </a:prstGeom>
+          <a:noFill/>
+          <a:ln>
+            <a:noFill/>
+          </a:ln>
+        </p:spPr>
+        <p:txBody>
+          <a:bodyPr wrap="square" lIns="0" tIns="0" rIns="0" bIns="0" anchor="ctr">
+            <a:noAutofit/>
+          </a:bodyPr>
+          <a:lstStyle/>
+          <a:p>
+            <a:pPr algn="l"/>
+            <a:r>
+              <a:rPr lang="en-US" sz="1050" b="0" i="0" dirty="0">
+                <a:solidFill>
+                  <a:srgbClr val="1F2328"/>
+                </a:solidFill>
+                <a:latin typeface="Consolas"/>
+                <a:cs typeface="Consolas"/>
+              </a:rPr>
+              <a:t xml:space="preserve">P2</a:t>
+            </a:r>
+          </a:p>
+        </p:txBody>
+      </p:sp>
+      <p:sp>
+        <p:nvSpPr>
+          <p:cNvPr id="1342" name="Cell"/>
+          <p:cNvSpPr txBox="1"/>
+          <p:nvPr/>
+        </p:nvSpPr>
+        <p:spPr>
+          <a:xfrm>
+            <a:off x="3044952" y="4855464"/>
+            <a:ext cx="640080" cy="173736"/>
+          </a:xfrm>
+          <a:prstGeom prst="rect">
+            <a:avLst/>
+          </a:prstGeom>
+          <a:noFill/>
+          <a:ln>
+            <a:noFill/>
+          </a:ln>
+        </p:spPr>
+        <p:txBody>
+          <a:bodyPr wrap="square" lIns="0" tIns="0" rIns="0" bIns="0" anchor="ctr">
+            <a:noAutofit/>
+          </a:bodyPr>
+          <a:lstStyle/>
+          <a:p>
+            <a:pPr algn="l"/>
+            <a:r>
+              <a:rPr lang="en-US" sz="1050" b="0" i="0" dirty="0">
+                <a:solidFill>
+                  <a:srgbClr val="1F2328"/>
+                </a:solidFill>
+                <a:latin typeface="Consolas"/>
+                <a:cs typeface="Consolas"/>
+              </a:rPr>
+              <a:t xml:space="preserve">0</a:t>
+            </a:r>
+          </a:p>
+        </p:txBody>
+      </p:sp>
+      <p:sp>
+        <p:nvSpPr>
+          <p:cNvPr id="1343" name="Row band"/>
+          <p:cNvSpPr/>
+          <p:nvPr/>
+        </p:nvSpPr>
+        <p:spPr>
+          <a:xfrm>
+            <a:off x="1060704" y="5042916"/>
+            <a:ext cx="2541912" cy="173736"/>
+          </a:xfrm>
+          <a:prstGeom prst="rect">
+            <a:avLst/>
+          </a:prstGeom>
+          <a:solidFill>
+            <a:srgbClr val="D7EDE2"/>
+          </a:solidFill>
+          <a:ln>
+            <a:noFill/>
+          </a:ln>
+        </p:spPr>
+        <p:txBody>
           <a:bodyPr wrap="square" lIns="0" tIns="0" rIns="0" bIns="0" anchor="t">
             <a:noAutofit/>
           </a:bodyPr>
           <a:lstStyle/>
           <a:p>
             <a:pPr algn="l"/>
+          </a:p>
+        </p:txBody>
+      </p:sp>
+      <p:sp>
+        <p:nvSpPr>
+          <p:cNvPr id="1344" name="Cell"/>
+          <p:cNvSpPr txBox="1"/>
+          <p:nvPr/>
+        </p:nvSpPr>
+        <p:spPr>
+          <a:xfrm>
+            <a:off x="1124712" y="5042916"/>
+            <a:ext cx="1051560" cy="173736"/>
+          </a:xfrm>
+          <a:prstGeom prst="rect">
+            <a:avLst/>
+          </a:prstGeom>
+          <a:noFill/>
+          <a:ln>
+            <a:noFill/>
+          </a:ln>
+        </p:spPr>
+        <p:txBody>
+          <a:bodyPr wrap="square" lIns="0" tIns="0" rIns="0" bIns="0" anchor="ctr">
+            <a:noAutofit/>
+          </a:bodyPr>
+          <a:lstStyle/>
+          <a:p>
+            <a:pPr algn="l"/>
+            <a:r>
+              <a:rPr lang="en-US" sz="1050" b="0" i="0" dirty="0">
+                <a:solidFill>
+                  <a:srgbClr val="1F2328"/>
+                </a:solidFill>
+                <a:latin typeface="Consolas"/>
+                <a:cs typeface="Consolas"/>
+              </a:rPr>
+              <a:t xml:space="preserve">A3</a:t>
+            </a:r>
+          </a:p>
+        </p:txBody>
+      </p:sp>
+      <p:sp>
+        <p:nvSpPr>
+          <p:cNvPr id="1345" name="Cell"/>
+          <p:cNvSpPr txBox="1"/>
+          <p:nvPr/>
+        </p:nvSpPr>
+        <p:spPr>
+          <a:xfrm>
+            <a:off x="2176272" y="5042916"/>
+            <a:ext cx="868680" cy="173736"/>
+          </a:xfrm>
+          <a:prstGeom prst="rect">
+            <a:avLst/>
+          </a:prstGeom>
+          <a:noFill/>
+          <a:ln>
+            <a:noFill/>
+          </a:ln>
+        </p:spPr>
+        <p:txBody>
+          <a:bodyPr wrap="square" lIns="0" tIns="0" rIns="0" bIns="0" anchor="ctr">
+            <a:noAutofit/>
+          </a:bodyPr>
+          <a:lstStyle/>
+          <a:p>
+            <a:pPr algn="l"/>
+            <a:r>
+              <a:rPr lang="en-US" sz="1050" b="0" i="0" dirty="0">
+                <a:solidFill>
+                  <a:srgbClr val="1F2328"/>
+                </a:solidFill>
+                <a:latin typeface="Consolas"/>
+                <a:cs typeface="Consolas"/>
+              </a:rPr>
+              <a:t xml:space="preserve">P3</a:t>
+            </a:r>
+          </a:p>
+        </p:txBody>
+      </p:sp>
+      <p:sp>
+        <p:nvSpPr>
+          <p:cNvPr id="1346" name="Cell"/>
+          <p:cNvSpPr txBox="1"/>
+          <p:nvPr/>
+        </p:nvSpPr>
+        <p:spPr>
+          <a:xfrm>
+            <a:off x="3044952" y="5042916"/>
+            <a:ext cx="640080" cy="173736"/>
+          </a:xfrm>
+          <a:prstGeom prst="rect">
+            <a:avLst/>
+          </a:prstGeom>
+          <a:noFill/>
+          <a:ln>
+            <a:noFill/>
+          </a:ln>
+        </p:spPr>
+        <p:txBody>
+          <a:bodyPr wrap="square" lIns="0" tIns="0" rIns="0" bIns="0" anchor="ctr">
+            <a:noAutofit/>
+          </a:bodyPr>
+          <a:lstStyle/>
+          <a:p>
+            <a:pPr algn="l"/>
+            <a:r>
+              <a:rPr lang="en-US" sz="1050" b="0" i="0" dirty="0">
+                <a:solidFill>
+                  <a:srgbClr val="1F2328"/>
+                </a:solidFill>
+                <a:latin typeface="Consolas"/>
+                <a:cs typeface="Consolas"/>
+              </a:rPr>
+              <a:t xml:space="preserve">1</a:t>
+            </a:r>
+          </a:p>
+        </p:txBody>
+      </p:sp>
+      <p:sp>
+        <p:nvSpPr>
+          <p:cNvPr id="1347" name="Bridge"/>
+          <p:cNvSpPr txBox="1"/>
+          <p:nvPr/>
+        </p:nvSpPr>
+        <p:spPr>
+          <a:xfrm>
+            <a:off x="4425696" y="4526280"/>
+            <a:ext cx="2423040" cy="566928"/>
+          </a:xfrm>
+          <a:prstGeom prst="rect">
+            <a:avLst/>
+          </a:prstGeom>
+          <a:noFill/>
+          <a:ln>
+            <a:noFill/>
+          </a:ln>
+        </p:spPr>
+        <p:txBody>
+          <a:bodyPr wrap="square" lIns="0" tIns="0" rIns="0" bIns="0" anchor="t">
+            <a:noAutofit/>
+          </a:bodyPr>
+          <a:lstStyle/>
+          <a:p>
+            <a:pPr algn="l"/>
             <a:r>
               <a:rPr lang="en-US" sz="1200" b="0" i="0" dirty="0">
                 <a:solidFill>
@@ -5863,14 +5999,14 @@
       </p:sp>
       <p:sp>
         <p:nvSpPr>
-          <p:cNvPr id="1339" name="Code panel"/>
+          <p:cNvPr id="1348" name="Code panel"/>
           <p:cNvSpPr/>
           <p:nvPr/>
         </p:nvSpPr>
         <p:spPr>
           <a:xfrm>
             <a:off x="7534656" y="2999232"/>
-            <a:ext cx="3666780" cy="1833372"/>
+            <a:ext cx="3666780" cy="1883664"/>
           </a:xfrm>
           <a:prstGeom prst="roundRect">
             <a:avLst>
@@ -5898,14 +6034,14 @@
       </p:sp>
       <p:sp>
         <p:nvSpPr>
-          <p:cNvPr id="1340" name="Code line 1340"/>
+          <p:cNvPr id="1349" name="Code line 1349"/>
           <p:cNvSpPr txBox="1"/>
           <p:nvPr/>
         </p:nvSpPr>
         <p:spPr>
           <a:xfrm>
             <a:off x="7534656" y="3072384"/>
-            <a:ext cx="3621060" cy="187452"/>
+            <a:ext cx="3621060" cy="173736"/>
           </a:xfrm>
           <a:prstGeom prst="rect">
             <a:avLst/>
@@ -5959,14 +6095,14 @@
       </p:sp>
       <p:sp>
         <p:nvSpPr>
-          <p:cNvPr id="1341" name="Code line 1341"/>
+          <p:cNvPr id="1350" name="Code line 1350"/>
           <p:cNvSpPr txBox="1"/>
           <p:nvPr/>
         </p:nvSpPr>
         <p:spPr>
           <a:xfrm>
-            <a:off x="7534656" y="3259836"/>
-            <a:ext cx="3621060" cy="187452"/>
+            <a:off x="7534656" y="3246120"/>
+            <a:ext cx="3621060" cy="173736"/>
           </a:xfrm>
           <a:prstGeom prst="rect">
             <a:avLst/>
@@ -6030,14 +6166,14 @@
       </p:sp>
       <p:sp>
         <p:nvSpPr>
-          <p:cNvPr id="1342" name="Code line 1342"/>
+          <p:cNvPr id="1351" name="Code line 1351"/>
           <p:cNvSpPr txBox="1"/>
           <p:nvPr/>
         </p:nvSpPr>
         <p:spPr>
           <a:xfrm>
-            <a:off x="7534656" y="3447288"/>
-            <a:ext cx="3621060" cy="187452"/>
+            <a:off x="7534656" y="3419856"/>
+            <a:ext cx="3621060" cy="173736"/>
           </a:xfrm>
           <a:prstGeom prst="rect">
             <a:avLst/>
@@ -6081,14 +6217,14 @@
       </p:sp>
       <p:sp>
         <p:nvSpPr>
-          <p:cNvPr id="1343" name="Code line 1343"/>
+          <p:cNvPr id="1352" name="Code line 1352"/>
           <p:cNvSpPr txBox="1"/>
           <p:nvPr/>
         </p:nvSpPr>
         <p:spPr>
           <a:xfrm>
-            <a:off x="7534656" y="3634739"/>
-            <a:ext cx="3621060" cy="187452"/>
+            <a:off x="7534656" y="3593591"/>
+            <a:ext cx="3621060" cy="173736"/>
           </a:xfrm>
           <a:prstGeom prst="rect">
             <a:avLst/>
@@ -6162,14 +6298,14 @@
       </p:sp>
       <p:sp>
         <p:nvSpPr>
-          <p:cNvPr id="1344" name="Code line 1344"/>
+          <p:cNvPr id="1353" name="Code line 1353"/>
           <p:cNvSpPr txBox="1"/>
           <p:nvPr/>
         </p:nvSpPr>
         <p:spPr>
           <a:xfrm>
-            <a:off x="7534656" y="3822191"/>
-            <a:ext cx="3621060" cy="187452"/>
+            <a:off x="7534656" y="3767328"/>
+            <a:ext cx="3621060" cy="173736"/>
           </a:xfrm>
           <a:prstGeom prst="rect">
             <a:avLst/>
@@ -6243,14 +6379,14 @@
       </p:sp>
       <p:sp>
         <p:nvSpPr>
-          <p:cNvPr id="1345" name="Code line 1345"/>
+          <p:cNvPr id="1354" name="Code line 1354"/>
           <p:cNvSpPr txBox="1"/>
           <p:nvPr/>
         </p:nvSpPr>
         <p:spPr>
           <a:xfrm>
-            <a:off x="7534656" y="4009644"/>
-            <a:ext cx="3621060" cy="187452"/>
+            <a:off x="7534656" y="3941063"/>
+            <a:ext cx="3621060" cy="173736"/>
           </a:xfrm>
           <a:prstGeom prst="rect">
             <a:avLst/>
@@ -6314,14 +6450,14 @@
       </p:sp>
       <p:sp>
         <p:nvSpPr>
-          <p:cNvPr id="1346" name="Code line 1346"/>
+          <p:cNvPr id="1355" name="Code line 1355"/>
           <p:cNvSpPr txBox="1"/>
           <p:nvPr/>
         </p:nvSpPr>
         <p:spPr>
           <a:xfrm>
-            <a:off x="7534656" y="4197096"/>
-            <a:ext cx="3621060" cy="187452"/>
+            <a:off x="7534656" y="4114800"/>
+            <a:ext cx="3621060" cy="173736"/>
           </a:xfrm>
           <a:prstGeom prst="rect">
             <a:avLst/>
@@ -6365,14 +6501,14 @@
       </p:sp>
       <p:sp>
         <p:nvSpPr>
-          <p:cNvPr id="1347" name="Code line 1347"/>
+          <p:cNvPr id="1356" name="Code line 1356"/>
           <p:cNvSpPr txBox="1"/>
           <p:nvPr/>
         </p:nvSpPr>
         <p:spPr>
           <a:xfrm>
-            <a:off x="7534656" y="4384548"/>
-            <a:ext cx="3621060" cy="187452"/>
+            <a:off x="7534656" y="4288536"/>
+            <a:ext cx="3621060" cy="173736"/>
           </a:xfrm>
           <a:prstGeom prst="rect">
             <a:avLst/>
@@ -6446,14 +6582,95 @@
       </p:sp>
       <p:sp>
         <p:nvSpPr>
-          <p:cNvPr id="1348" name="Code line 1348"/>
+          <p:cNvPr id="1357" name="Code line 1357"/>
           <p:cNvSpPr txBox="1"/>
           <p:nvPr/>
         </p:nvSpPr>
         <p:spPr>
           <a:xfrm>
-            <a:off x="7534656" y="4572000"/>
-            <a:ext cx="3621060" cy="187452"/>
+            <a:off x="7534656" y="4462272"/>
+            <a:ext cx="3621060" cy="173736"/>
+          </a:xfrm>
+          <a:prstGeom prst="rect">
+            <a:avLst/>
+          </a:prstGeom>
+          <a:noFill/>
+        </p:spPr>
+        <p:txBody>
+          <a:bodyPr wrap="none" lIns="146304" tIns="0" rIns="0" bIns="0" anchor="ctr">
+            <a:noAutofit/>
+          </a:bodyPr>
+          <a:lstStyle/>
+          <a:p>
+            <a:pPr>
+              <a:tabLst>
+                <a:tab pos="4224528" algn="l"/>
+              </a:tabLst>
+            </a:pPr>
+            <a:r>
+              <a:rPr lang="en-US" sz="1050" b="0" i="0" dirty="0">
+                <a:solidFill>
+                  <a:srgbClr val="1F2328"/>
+                </a:solidFill>
+                <a:latin typeface="Consolas"/>
+                <a:cs typeface="Consolas"/>
+              </a:rPr>
+              <a:t xml:space="preserve">    </a:t>
+            </a:r>
+            <a:r>
+              <a:rPr lang="en-US" sz="1050" b="0" i="0" dirty="0">
+                <a:solidFill>
+                  <a:srgbClr val="5B6770"/>
+                </a:solidFill>
+                <a:latin typeface="Consolas"/>
+                <a:cs typeface="Consolas"/>
+              </a:rPr>
+              <a:t xml:space="preserve">prov:wasDerivedFrom</a:t>
+            </a:r>
+            <a:r>
+              <a:rPr lang="en-US" sz="1050" b="0" i="0" dirty="0">
+                <a:solidFill>
+                  <a:srgbClr val="1F2328"/>
+                </a:solidFill>
+                <a:latin typeface="Consolas"/>
+                <a:cs typeface="Consolas"/>
+              </a:rPr>
+              <a:t xml:space="preserve"> </a:t>
+            </a:r>
+            <a:r>
+              <a:rPr lang="en-US" sz="1050" b="0" i="0" dirty="0">
+                <a:solidFill>
+                  <a:srgbClr val="2F6B78"/>
+                </a:solidFill>
+                <a:latin typeface="Consolas"/>
+                <a:cs typeface="Consolas"/>
+              </a:rPr>
+              <a:t xml:space="preserve">treatment:drug</a:t>
+            </a:r>
+            <a:r>
+              <a:rPr lang="en-US" sz="1050" b="0" i="0" dirty="0">
+                <a:solidFill>
+                  <a:srgbClr val="1F2328"/>
+                </a:solidFill>
+                <a:latin typeface="Consolas"/>
+                <a:cs typeface="Consolas"/>
+              </a:rPr>
+              <a:t xml:space="preserve">,</a:t>
+            </a:r>
+            <a:endParaRPr lang="en-US" sz="1050"/>
+          </a:p>
+        </p:txBody>
+      </p:sp>
+      <p:sp>
+        <p:nvSpPr>
+          <p:cNvPr id="1358" name="Code line 1358"/>
+          <p:cNvSpPr txBox="1"/>
+          <p:nvPr/>
+        </p:nvSpPr>
+        <p:spPr>
+          <a:xfrm>
+            <a:off x="7534656" y="4636008"/>
+            <a:ext cx="3621060" cy="173736"/>
           </a:xfrm>
           <a:prstGeom prst="rect">
             <a:avLst/>

</xml_diff>

<commit_message>
Results as five single-topic slides with breakdowns; future work leads with validation
R1 validity in one sentence + OOPS! pitfalls per run, R2 coverage per run, R3
labels/provenance/hierarchy per run, R4 BURR, R5 judge and experts per database,
with competency questions (5 per table, 290, expert-verified) shown. Future work
starts with validators in the loop (NeOn-GPT, Extended NeOn-GPT, RIGOR App demo)
before the instance-data story. Speech updated; the talk ends at 13:53.

Co-Authored-By: Claude Opus 5.5 <noreply@anthropic.com>
Claude-Session: https://claude.ai/code/session_01KcycczqUBG98FnzsgJYAW8
</commit_message>
<xml_diff>
--- a/presentation/RIGOR_future_work.pptx
+++ b/presentation/RIGOR_future_work.pptx
@@ -1775,6 +1775,19 @@
           </a:bodyPr>
           <a:lstStyle/>
           <a:p>
+            <a:pPr indent="-228600" lvl="0" marL="457200" marR="0" rtl="0" algn="l">
+              <a:lnSpc>
+                <a:spcPct val="100000"/>
+              </a:lnSpc>
+              <a:spcBef>
+                <a:spcPts val="0"/>
+              </a:spcBef>
+              <a:spcAft>
+                <a:spcPts val="0"/>
+              </a:spcAft>
+              <a:buSzPts val="1400"/>
+              <a:buNone/>
+            </a:pPr>
             <a:r>
               <a:rPr lang="en-US" sz="1200">
                 <a:solidFill>
@@ -1785,10 +1798,24 @@
                 <a:cs typeface="Calibri"/>
                 <a:sym typeface="Calibri"/>
               </a:rPr>
-              <a:t>[11:19–12:21]  SPOKEN SCRIPT (109 words)</a:t>
-            </a:r>
+              <a:t>[11:05–12:00]  SPOKEN SCRIPT (96 words)</a:t>
+            </a:r>
+            <a:endParaRPr/>
           </a:p>
           <a:p>
+            <a:pPr indent="-228600" lvl="0" marL="457200" marR="0" rtl="0" algn="l">
+              <a:lnSpc>
+                <a:spcPct val="100000"/>
+              </a:lnSpc>
+              <a:spcBef>
+                <a:spcPts val="0"/>
+              </a:spcBef>
+              <a:spcAft>
+                <a:spcPts val="0"/>
+              </a:spcAft>
+              <a:buSzPts val="1400"/>
+              <a:buNone/>
+            </a:pPr>
             <a:r>
               <a:rPr lang="en-US" sz="1200">
                 <a:solidFill>
@@ -1799,11 +1826,51 @@
                 <a:cs typeface="Calibri"/>
                 <a:sym typeface="Calibri"/>
               </a:rPr>
-              <a:t>Where next? Today RIGOR reads schemas and documentation. The next step is to let the data speak. Here the data sits in two tables: treatment says which admissions received cisplatin, admission records bone marrow depression. Joined on the admission id, the rows show a pattern. The drug label adds that bone-marrow suppression is a known adverse reaction of cisplatin. Together, they let RIGOR propose new knowledge: a candidate association between cisplatin and bone marrow depression, with provenance to both tables and the label. Candidate, not cause. Gemcitabine, radiotherapy or cirrhosis could also explain it. So an expert reviews it. We also want validator and reasoner feedback inside the loop.</a:t>
-            </a:r>
+              <a:t>Where next? Today RIGOR reads schemas and documentation. The next step is to let the data speak. Imagine several patients whose records show bone marrow depression after cisplatin cycles. The rows alone show a pattern. The drug label adds that bone-marrow suppression is a known adverse reaction of cisplatin. Together, they let RIGOR propose new knowledge: a candidate association between cisplatin and bone marrow depression, with provenance to both sources. Candidate, not cause. Gemcitabine, radiotherapy or cirrhosis could also explain it. So an expert reviews it. We also want validator and reasoner feedback inside the loop.</a:t>
+            </a:r>
+            <a:endParaRPr/>
           </a:p>
-          <a:p/>
           <a:p>
+            <a:pPr indent="-228600" lvl="0" marL="457200" marR="0" rtl="0" algn="l">
+              <a:lnSpc>
+                <a:spcPct val="100000"/>
+              </a:lnSpc>
+              <a:spcBef>
+                <a:spcPts val="0"/>
+              </a:spcBef>
+              <a:spcAft>
+                <a:spcPts val="0"/>
+              </a:spcAft>
+              <a:buSzPts val="1400"/>
+              <a:buNone/>
+            </a:pPr>
+            <a:r>
+              <a:t/>
+            </a:r>
+            <a:endParaRPr sz="1200">
+              <a:solidFill>
+                <a:schemeClr val="dk1"/>
+              </a:solidFill>
+              <a:latin typeface="Calibri"/>
+              <a:ea typeface="Calibri"/>
+              <a:cs typeface="Calibri"/>
+              <a:sym typeface="Calibri"/>
+            </a:endParaRPr>
+          </a:p>
+          <a:p>
+            <a:pPr indent="-228600" lvl="0" marL="457200" marR="0" rtl="0" algn="l">
+              <a:lnSpc>
+                <a:spcPct val="100000"/>
+              </a:lnSpc>
+              <a:spcBef>
+                <a:spcPts val="0"/>
+              </a:spcBef>
+              <a:spcAft>
+                <a:spcPts val="0"/>
+              </a:spcAft>
+              <a:buSzPts val="1400"/>
+              <a:buNone/>
+            </a:pPr>
             <a:r>
               <a:rPr lang="en-US" sz="1200">
                 <a:solidFill>
@@ -1814,10 +1881,24 @@
                 <a:cs typeface="Calibri"/>
                 <a:sym typeface="Calibri"/>
               </a:rPr>
-              <a:t>PRESENTER / POINTER: Point at A1 and A3 in both tables, then the label, then the code. Say 'candidate', never 'caused'.</a:t>
-            </a:r>
+              <a:t>PRESENTER / POINTER: Rows, label, code, left to right. Say 'candidate' or 'may have contributed', never 'caused'.</a:t>
+            </a:r>
+            <a:endParaRPr/>
           </a:p>
           <a:p>
+            <a:pPr indent="-228600" lvl="0" marL="457200" marR="0" rtl="0" algn="l">
+              <a:lnSpc>
+                <a:spcPct val="100000"/>
+              </a:lnSpc>
+              <a:spcBef>
+                <a:spcPts val="0"/>
+              </a:spcBef>
+              <a:spcAft>
+                <a:spcPts val="0"/>
+              </a:spcAft>
+              <a:buSzPts val="1400"/>
+              <a:buNone/>
+            </a:pPr>
             <a:r>
               <a:rPr lang="en-US" sz="1200">
                 <a:solidFill>
@@ -1830,8 +1911,22 @@
               </a:rPr>
               <a:t>AUDIENCE TAKEAWAY: Instances plus documentation can propose knowledge; experts confirm it.</a:t>
             </a:r>
+            <a:endParaRPr/>
           </a:p>
           <a:p>
+            <a:pPr indent="-228600" lvl="0" marL="457200" marR="0" rtl="0" algn="l">
+              <a:lnSpc>
+                <a:spcPct val="100000"/>
+              </a:lnSpc>
+              <a:spcBef>
+                <a:spcPts val="0"/>
+              </a:spcBef>
+              <a:spcAft>
+                <a:spcPts val="0"/>
+              </a:spcAft>
+              <a:buSzPts val="1400"/>
+              <a:buNone/>
+            </a:pPr>
             <a:r>
               <a:rPr lang="en-US" sz="1200">
                 <a:solidFill>
@@ -1844,8 +1939,22 @@
               </a:rPr>
               <a:t>SOURCE AND SCOPE: Paper Section 5. Rows are synthetic. OWL verified (presentation/excerpts/slide22_future_candidate.omn): a typed individual with provenance, no causal axiom.</a:t>
             </a:r>
+            <a:endParaRPr/>
           </a:p>
           <a:p>
+            <a:pPr indent="-228600" lvl="0" marL="457200" marR="0" rtl="0" algn="l">
+              <a:lnSpc>
+                <a:spcPct val="100000"/>
+              </a:lnSpc>
+              <a:spcBef>
+                <a:spcPts val="0"/>
+              </a:spcBef>
+              <a:spcAft>
+                <a:spcPts val="0"/>
+              </a:spcAft>
+              <a:buSzPts val="1400"/>
+              <a:buNone/>
+            </a:pPr>
             <a:r>
               <a:rPr lang="en-US" sz="1200">
                 <a:solidFill>
@@ -1858,9 +1967,49 @@
               </a:rPr>
               <a:t>IF RUNNING LATE, DROP: "We also want validator and reasoner feedback inside the loop."</a:t>
             </a:r>
+            <a:endParaRPr/>
           </a:p>
-          <a:p/>
           <a:p>
+            <a:pPr indent="-228600" lvl="0" marL="457200" marR="0" rtl="0" algn="l">
+              <a:lnSpc>
+                <a:spcPct val="100000"/>
+              </a:lnSpc>
+              <a:spcBef>
+                <a:spcPts val="0"/>
+              </a:spcBef>
+              <a:spcAft>
+                <a:spcPts val="0"/>
+              </a:spcAft>
+              <a:buSzPts val="1400"/>
+              <a:buNone/>
+            </a:pPr>
+            <a:r>
+              <a:t/>
+            </a:r>
+            <a:endParaRPr sz="1200">
+              <a:solidFill>
+                <a:schemeClr val="dk1"/>
+              </a:solidFill>
+              <a:latin typeface="Calibri"/>
+              <a:ea typeface="Calibri"/>
+              <a:cs typeface="Calibri"/>
+              <a:sym typeface="Calibri"/>
+            </a:endParaRPr>
+          </a:p>
+          <a:p>
+            <a:pPr indent="-228600" lvl="0" marL="457200" marR="0" rtl="0" algn="l">
+              <a:lnSpc>
+                <a:spcPct val="100000"/>
+              </a:lnSpc>
+              <a:spcBef>
+                <a:spcPts val="0"/>
+              </a:spcBef>
+              <a:spcAft>
+                <a:spcPts val="0"/>
+              </a:spcAft>
+              <a:buSzPts val="1400"/>
+              <a:buNone/>
+            </a:pPr>
             <a:r>
               <a:rPr lang="en-US" sz="1200">
                 <a:solidFill>
@@ -1873,6 +2022,7 @@
               </a:rPr>
               <a:t>IF ASKED WHY NOT AN OWL CAUSAL AXIOM: OWL reasoning is deductive and open-world; it cannot derive causation from statistics, and 'Cisplatin SubClassOf causes some BoneMarrowDepression' would wrongly claim it for every case.</a:t>
             </a:r>
+            <a:endParaRPr/>
           </a:p>
         </p:txBody>
       </p:sp>
@@ -3748,7 +3898,7 @@
                 <a:cs typeface="Cambria"/>
                 <a:sym typeface="Cambria"/>
               </a:rPr>
-              <a:t>Next: let the data speak.</a:t>
+              <a:t>Next: check inside the loop, then let the data speak.</a:t>
             </a:r>
             <a:endParaRPr b="0" i="0" sz="1400" u="none" cap="none" strike="noStrike">
               <a:solidFill>
@@ -3770,7 +3920,7 @@
         </p:nvSpPr>
         <p:spPr>
           <a:xfrm>
-            <a:off x="822960" y="1709928"/>
+            <a:off x="822960" y="2331720"/>
             <a:ext cx="10332600" cy="329100"/>
           </a:xfrm>
           <a:prstGeom prst="rect">
@@ -3805,107 +3955,117 @@
               <a:buNone/>
             </a:pPr>
             <a:r>
-              <a:rPr lang="en-US" sz="1700" b="0" i="0" dirty="0">
-                <a:solidFill>
-                  <a:srgbClr val="5B6770"/>
+              <a:rPr lang="en-US" sz="1300" b="1" i="0" dirty="0">
+                <a:solidFill>
+                  <a:srgbClr val="0B6E4F"/>
                 </a:solidFill>
                 <a:latin typeface="Calibri"/>
                 <a:cs typeface="Calibri"/>
               </a:rPr>
-              <a:t xml:space="preserve">Today </a:t>
-            </a:r>
-            <a:r>
-              <a:rPr lang="en-US" sz="1700" b="1" i="1" dirty="0">
-                <a:solidFill>
-                  <a:srgbClr val="3A434C"/>
+              <a:t xml:space="preserve">THEN, LET THE DATA SPEAK   </a:t>
+            </a:r>
+            <a:r>
+              <a:rPr lang="en-US" sz="1500" b="0" i="0" dirty="0">
+                <a:solidFill>
+                  <a:srgbClr val="5B6770"/>
                 </a:solidFill>
                 <a:latin typeface="Calibri"/>
                 <a:cs typeface="Calibri"/>
               </a:rPr>
-              <a:t xml:space="preserve">RIGOR</a:t>
-            </a:r>
-            <a:r>
-              <a:rPr lang="en-US" sz="1700" b="0" i="0" dirty="0">
-                <a:solidFill>
-                  <a:srgbClr val="5B6770"/>
+              <a:t xml:space="preserve">Today </a:t>
+            </a:r>
+            <a:r>
+              <a:rPr lang="en-US" sz="1500" b="1" i="1" dirty="0">
+                <a:solidFill>
+                  <a:srgbClr val="3A434C"/>
                 </a:solidFill>
                 <a:latin typeface="Calibri"/>
                 <a:cs typeface="Calibri"/>
               </a:rPr>
-              <a:t xml:space="preserve"> reads </a:t>
-            </a:r>
-            <a:r>
-              <a:rPr lang="en-US" sz="1700" b="1" i="0" dirty="0">
-                <a:solidFill>
-                  <a:srgbClr val="3A434C"/>
+              <a:t xml:space="preserve">RIGOR</a:t>
+            </a:r>
+            <a:r>
+              <a:rPr lang="en-US" sz="1500" b="0" i="0" dirty="0">
+                <a:solidFill>
+                  <a:srgbClr val="5B6770"/>
                 </a:solidFill>
                 <a:latin typeface="Calibri"/>
                 <a:cs typeface="Calibri"/>
               </a:rPr>
-              <a:t xml:space="preserve">schemas</a:t>
-            </a:r>
-            <a:r>
-              <a:rPr lang="en-US" sz="1700" b="0" i="0" dirty="0">
-                <a:solidFill>
-                  <a:srgbClr val="5B6770"/>
+              <a:t xml:space="preserve"> reads </a:t>
+            </a:r>
+            <a:r>
+              <a:rPr lang="en-US" sz="1500" b="1" i="0" dirty="0">
+                <a:solidFill>
+                  <a:srgbClr val="3A434C"/>
                 </a:solidFill>
                 <a:latin typeface="Calibri"/>
                 <a:cs typeface="Calibri"/>
               </a:rPr>
-              <a:t xml:space="preserve"> and </a:t>
-            </a:r>
-            <a:r>
-              <a:rPr lang="en-US" sz="1700" b="1" i="0" dirty="0">
-                <a:solidFill>
-                  <a:srgbClr val="3A434C"/>
+              <a:t xml:space="preserve">schemas</a:t>
+            </a:r>
+            <a:r>
+              <a:rPr lang="en-US" sz="1500" b="0" i="0" dirty="0">
+                <a:solidFill>
+                  <a:srgbClr val="5B6770"/>
                 </a:solidFill>
                 <a:latin typeface="Calibri"/>
                 <a:cs typeface="Calibri"/>
               </a:rPr>
-              <a:t xml:space="preserve">documentation</a:t>
-            </a:r>
-            <a:r>
-              <a:rPr lang="en-US" sz="1700" b="0" i="0" dirty="0">
-                <a:solidFill>
-                  <a:srgbClr val="5B6770"/>
+              <a:t xml:space="preserve"> and </a:t>
+            </a:r>
+            <a:r>
+              <a:rPr lang="en-US" sz="1500" b="1" i="0" dirty="0">
+                <a:solidFill>
+                  <a:srgbClr val="3A434C"/>
                 </a:solidFill>
                 <a:latin typeface="Calibri"/>
                 <a:cs typeface="Calibri"/>
               </a:rPr>
-              <a:t xml:space="preserve">. </a:t>
-            </a:r>
-            <a:r>
-              <a:rPr lang="en-US" sz="1700" b="1" i="0" dirty="0">
-                <a:solidFill>
-                  <a:srgbClr val="3A434C"/>
+              <a:t xml:space="preserve">documentation</a:t>
+            </a:r>
+            <a:r>
+              <a:rPr lang="en-US" sz="1500" b="0" i="0" dirty="0">
+                <a:solidFill>
+                  <a:srgbClr val="5B6770"/>
                 </a:solidFill>
                 <a:latin typeface="Calibri"/>
                 <a:cs typeface="Calibri"/>
               </a:rPr>
-              <a:t xml:space="preserve">Instance data</a:t>
-            </a:r>
-            <a:r>
-              <a:rPr lang="en-US" sz="1700" b="0" i="0" dirty="0">
-                <a:solidFill>
-                  <a:srgbClr val="5B6770"/>
+              <a:t xml:space="preserve">. </a:t>
+            </a:r>
+            <a:r>
+              <a:rPr lang="en-US" sz="1500" b="1" i="0" dirty="0">
+                <a:solidFill>
+                  <a:srgbClr val="3A434C"/>
                 </a:solidFill>
                 <a:latin typeface="Calibri"/>
                 <a:cs typeface="Calibri"/>
               </a:rPr>
-              <a:t xml:space="preserve"> could propose </a:t>
-            </a:r>
-            <a:r>
-              <a:rPr lang="en-US" sz="1700" b="1" i="0" dirty="0">
-                <a:solidFill>
-                  <a:srgbClr val="3A434C"/>
+              <a:t xml:space="preserve">Instance data</a:t>
+            </a:r>
+            <a:r>
+              <a:rPr lang="en-US" sz="1500" b="0" i="0" dirty="0">
+                <a:solidFill>
+                  <a:srgbClr val="5B6770"/>
                 </a:solidFill>
                 <a:latin typeface="Calibri"/>
                 <a:cs typeface="Calibri"/>
               </a:rPr>
+              <a:t xml:space="preserve"> could propose </a:t>
+            </a:r>
+            <a:r>
+              <a:rPr lang="en-US" sz="1500" b="1" i="0" dirty="0">
+                <a:solidFill>
+                  <a:srgbClr val="3A434C"/>
+                </a:solidFill>
+                <a:latin typeface="Calibri"/>
+                <a:cs typeface="Calibri"/>
+              </a:rPr>
               <a:t xml:space="preserve">new knowledge</a:t>
             </a:r>
             <a:r>
-              <a:rPr lang="en-US" sz="1700" b="0" i="0" dirty="0">
+              <a:rPr lang="en-US" sz="1500" b="0" i="0" dirty="0">
                 <a:solidFill>
                   <a:srgbClr val="5B6770"/>
                 </a:solidFill>
@@ -3925,7 +4085,7 @@
         </p:nvSpPr>
         <p:spPr>
           <a:xfrm>
-            <a:off x="822960" y="2194560"/>
+            <a:off x="822960" y="2761488"/>
             <a:ext cx="3017400" cy="3218688"/>
           </a:xfrm>
           <a:prstGeom prst="roundRect">
@@ -3987,7 +4147,7 @@
         </p:nvSpPr>
         <p:spPr>
           <a:xfrm>
-            <a:off x="4224528" y="2194560"/>
+            <a:off x="4224528" y="2761488"/>
             <a:ext cx="2788800" cy="3218688"/>
           </a:xfrm>
           <a:prstGeom prst="roundRect">
@@ -4049,7 +4209,7 @@
         </p:nvSpPr>
         <p:spPr>
           <a:xfrm>
-            <a:off x="7397496" y="2194560"/>
+            <a:off x="7397496" y="2761488"/>
             <a:ext cx="3941100" cy="3218688"/>
           </a:xfrm>
           <a:prstGeom prst="roundRect">
@@ -4111,7 +4271,7 @@
         </p:nvSpPr>
         <p:spPr>
           <a:xfrm>
-            <a:off x="3877048" y="3611904"/>
+            <a:off x="3877048" y="4178832"/>
             <a:ext cx="429600" cy="384000"/>
           </a:xfrm>
           <a:prstGeom prst="rightArrow">
@@ -4168,7 +4328,7 @@
         </p:nvSpPr>
         <p:spPr>
           <a:xfrm>
-            <a:off x="7050025" y="3611904"/>
+            <a:off x="7050025" y="4178832"/>
             <a:ext cx="429600" cy="384000"/>
           </a:xfrm>
           <a:prstGeom prst="rightArrow">
@@ -4225,7 +4385,7 @@
         </p:nvSpPr>
         <p:spPr>
           <a:xfrm>
-            <a:off x="1024128" y="2359152"/>
+            <a:off x="1024128" y="2926080"/>
             <a:ext cx="2651700" cy="274200"/>
           </a:xfrm>
           <a:prstGeom prst="rect">
@@ -4278,7 +4438,7 @@
         </p:nvSpPr>
         <p:spPr>
           <a:xfrm>
-            <a:off x="1024128" y="2651760"/>
+            <a:off x="1024128" y="3218688"/>
             <a:ext cx="2651700" cy="255900"/>
           </a:xfrm>
           <a:prstGeom prst="rect">
@@ -4328,7 +4488,7 @@
         </p:nvSpPr>
         <p:spPr>
           <a:xfrm>
-            <a:off x="4425696" y="2359152"/>
+            <a:off x="4425696" y="2926080"/>
             <a:ext cx="2423100" cy="274200"/>
           </a:xfrm>
           <a:prstGeom prst="rect">
@@ -4381,7 +4541,7 @@
         </p:nvSpPr>
         <p:spPr>
           <a:xfrm>
-            <a:off x="4425696" y="2651760"/>
+            <a:off x="4425696" y="3218688"/>
             <a:ext cx="2423100" cy="255900"/>
           </a:xfrm>
           <a:prstGeom prst="rect">
@@ -4434,7 +4594,7 @@
         </p:nvSpPr>
         <p:spPr>
           <a:xfrm>
-            <a:off x="4389120" y="3017520"/>
+            <a:off x="4389120" y="3584448"/>
             <a:ext cx="2459700" cy="1115700"/>
           </a:xfrm>
           <a:prstGeom prst="roundRect">
@@ -4491,7 +4651,7 @@
         </p:nvSpPr>
         <p:spPr>
           <a:xfrm>
-            <a:off x="4425696" y="4169664"/>
+            <a:off x="4425696" y="4736592"/>
             <a:ext cx="2423100" cy="201300"/>
           </a:xfrm>
           <a:prstGeom prst="rect">
@@ -4544,7 +4704,7 @@
         </p:nvSpPr>
         <p:spPr>
           <a:xfrm>
-            <a:off x="7598664" y="2359152"/>
+            <a:off x="7598664" y="2926080"/>
             <a:ext cx="3575400" cy="274200"/>
           </a:xfrm>
           <a:prstGeom prst="rect">
@@ -4597,7 +4757,7 @@
         </p:nvSpPr>
         <p:spPr>
           <a:xfrm>
-            <a:off x="7598664" y="2651760"/>
+            <a:off x="7598664" y="3218688"/>
             <a:ext cx="3575400" cy="255900"/>
           </a:xfrm>
           <a:prstGeom prst="rect">
@@ -4650,7 +4810,7 @@
         </p:nvSpPr>
         <p:spPr>
           <a:xfrm>
-            <a:off x="7598664" y="4974336"/>
+            <a:off x="7598664" y="5541264"/>
             <a:ext cx="3575400" cy="384048"/>
           </a:xfrm>
           <a:prstGeom prst="rect">
@@ -4710,8 +4870,8 @@
         </p:nvSpPr>
         <p:spPr>
           <a:xfrm>
-            <a:off x="822960" y="5559552"/>
-            <a:ext cx="10515600" cy="420600"/>
+            <a:off x="822960" y="1664208"/>
+            <a:ext cx="10515600" cy="548640"/>
           </a:xfrm>
           <a:prstGeom prst="roundRect">
             <a:avLst>
@@ -4744,30 +4904,95 @@
               <a:buNone/>
             </a:pPr>
             <a:r>
-              <a:rPr b="1" i="0" lang="en-US" sz="1250" u="none" cap="none" strike="noStrike">
+              <a:rPr lang="en-US" sz="1250" b="1" i="0" dirty="0">
                 <a:solidFill>
                   <a:srgbClr val="0B6E4F"/>
                 </a:solidFill>
                 <a:latin typeface="Calibri"/>
-                <a:ea typeface="Calibri"/>
                 <a:cs typeface="Calibri"/>
-                <a:sym typeface="Calibri"/>
-              </a:rPr>
-              <a:t>ALSO NEXT   </a:t>
-            </a:r>
-            <a:r>
-              <a:rPr b="0" i="0" lang="en-US" sz="1250" u="none" cap="none" strike="noStrike">
+              </a:rPr>
+              <a:t xml:space="preserve">FIRST, VALIDATORS IN THE LOOP   </a:t>
+            </a:r>
+            <a:r>
+              <a:rPr lang="en-US" sz="1250" b="0" i="0" dirty="0">
+                <a:solidFill>
+                  <a:srgbClr val="3A434C"/>
+                </a:solidFill>
+                <a:latin typeface="Calibri"/>
+                <a:cs typeface="Calibri"/>
+              </a:rPr>
+              <a:t xml:space="preserve">Syntax, consistency and pitfall checks feed back to the Gen-LLM, as in </a:t>
+            </a:r>
+            <a:r>
+              <a:rPr lang="en-US" sz="1250" b="1" i="0" dirty="0">
                 <a:solidFill>
                   <a:srgbClr val="1F2328"/>
                 </a:solidFill>
                 <a:latin typeface="Calibri"/>
-                <a:ea typeface="Calibri"/>
                 <a:cs typeface="Calibri"/>
-                <a:sym typeface="Calibri"/>
-              </a:rPr>
-              <a:t>Validator and reasoner feedback inside the loop, to catch residual P19  ·  aggregate statistics only, so patient data stays in the hospital</a:t>
-            </a:r>
-            <a:endParaRPr/>
+              </a:rPr>
+              <a:t xml:space="preserve">NeOn-GPT</a:t>
+            </a:r>
+            <a:r>
+              <a:rPr lang="en-US" sz="1250" b="0" i="0" dirty="0">
+                <a:solidFill>
+                  <a:srgbClr val="5B6770"/>
+                </a:solidFill>
+                <a:latin typeface="Calibri"/>
+                <a:cs typeface="Calibri"/>
+              </a:rPr>
+              <a:t xml:space="preserve"> [Fathallah et al., ESWC 2024] and </a:t>
+            </a:r>
+            <a:r>
+              <a:rPr lang="en-US" sz="1250" b="1" i="0" dirty="0">
+                <a:solidFill>
+                  <a:srgbClr val="1F2328"/>
+                </a:solidFill>
+                <a:latin typeface="Calibri"/>
+                <a:cs typeface="Calibri"/>
+              </a:rPr>
+              <a:t xml:space="preserve">Extended NeOn-GPT</a:t>
+            </a:r>
+            <a:r>
+              <a:rPr lang="en-US" sz="1250" b="0" i="0" dirty="0">
+                <a:solidFill>
+                  <a:srgbClr val="5B6770"/>
+                </a:solidFill>
+                <a:latin typeface="Calibri"/>
+                <a:cs typeface="Calibri"/>
+              </a:rPr>
+              <a:t xml:space="preserve"> [Fathallah et al., SWJ 2026]. </a:t>
+            </a:r>
+            <a:r>
+              <a:rPr lang="en-US" sz="1250" b="0" i="0" dirty="0">
+                <a:solidFill>
+                  <a:srgbClr val="3A434C"/>
+                </a:solidFill>
+                <a:latin typeface="Calibri"/>
+                <a:cs typeface="Calibri"/>
+              </a:rPr>
+              <a:t xml:space="preserve">Now running in the </a:t>
+            </a:r>
+            <a:r>
+              <a:rPr lang="en-US" sz="1250" b="1" i="0" dirty="0">
+                <a:solidFill>
+                  <a:srgbClr val="1F2328"/>
+                </a:solidFill>
+                <a:latin typeface="Calibri"/>
+                <a:cs typeface="Calibri"/>
+              </a:rPr>
+              <a:t xml:space="preserve">RIGOR App</a:t>
+            </a:r>
+            <a:r>
+              <a:rPr lang="en-US" sz="1250" b="0" i="0" dirty="0">
+                <a:solidFill>
+                  <a:srgbClr val="5B6770"/>
+                </a:solidFill>
+                <a:latin typeface="Calibri"/>
+                <a:cs typeface="Calibri"/>
+              </a:rPr>
+              <a:t xml:space="preserve"> [Fathallah, Nayyeri &amp; Staab, ISWC 2026 Demos].</a:t>
+            </a:r>
           </a:p>
         </p:txBody>
       </p:sp>
@@ -4779,7 +5004,7 @@
         </p:nvSpPr>
         <p:spPr>
           <a:xfrm>
-            <a:off x="850392" y="6108192"/>
+            <a:off x="850392" y="6419088"/>
             <a:ext cx="10488300" cy="237600"/>
           </a:xfrm>
           <a:prstGeom prst="rect">
@@ -4832,7 +5057,7 @@
         </p:nvSpPr>
         <p:spPr>
           <a:xfrm>
-            <a:off x="987552" y="2944368"/>
+            <a:off x="987552" y="3511296"/>
             <a:ext cx="2688216" cy="1120140"/>
           </a:xfrm>
           <a:prstGeom prst="roundRect">
@@ -4872,7 +5097,7 @@
         </p:nvSpPr>
         <p:spPr>
           <a:xfrm>
-            <a:off x="1124712" y="2971800"/>
+            <a:off x="1124712" y="3538728"/>
             <a:ext cx="2413896" cy="246888"/>
           </a:xfrm>
           <a:prstGeom prst="rect">
@@ -4911,7 +5136,7 @@
         </p:nvSpPr>
         <p:spPr>
           <a:xfrm>
-            <a:off x="1124712" y="3236976"/>
+            <a:off x="1124712" y="3803904"/>
             <a:ext cx="2413896" cy="10972"/>
           </a:xfrm>
           <a:prstGeom prst="rect">
@@ -4942,7 +5167,7 @@
         </p:nvSpPr>
         <p:spPr>
           <a:xfrm>
-            <a:off x="1124712" y="3264408"/>
+            <a:off x="1124712" y="3831335"/>
             <a:ext cx="1051560" cy="182880"/>
           </a:xfrm>
           <a:prstGeom prst="rect">
@@ -4991,7 +5216,7 @@
         </p:nvSpPr>
         <p:spPr>
           <a:xfrm>
-            <a:off x="2176272" y="3264408"/>
+            <a:off x="2176272" y="3831335"/>
             <a:ext cx="1508760" cy="182880"/>
           </a:xfrm>
           <a:prstGeom prst="rect">
@@ -5030,7 +5255,7 @@
         </p:nvSpPr>
         <p:spPr>
           <a:xfrm>
-            <a:off x="1060704" y="3456432"/>
+            <a:off x="1060704" y="4023359"/>
             <a:ext cx="2541912" cy="173736"/>
           </a:xfrm>
           <a:prstGeom prst="rect">
@@ -5061,7 +5286,7 @@
         </p:nvSpPr>
         <p:spPr>
           <a:xfrm>
-            <a:off x="1124712" y="3456432"/>
+            <a:off x="1124712" y="4023359"/>
             <a:ext cx="1051560" cy="173736"/>
           </a:xfrm>
           <a:prstGeom prst="rect">
@@ -5100,7 +5325,7 @@
         </p:nvSpPr>
         <p:spPr>
           <a:xfrm>
-            <a:off x="2176272" y="3456432"/>
+            <a:off x="2176272" y="4023359"/>
             <a:ext cx="1508760" cy="173736"/>
           </a:xfrm>
           <a:prstGeom prst="rect">
@@ -5139,7 +5364,7 @@
         </p:nvSpPr>
         <p:spPr>
           <a:xfrm>
-            <a:off x="1124712" y="3643884"/>
+            <a:off x="1124712" y="4210812"/>
             <a:ext cx="1051560" cy="173736"/>
           </a:xfrm>
           <a:prstGeom prst="rect">
@@ -5178,7 +5403,7 @@
         </p:nvSpPr>
         <p:spPr>
           <a:xfrm>
-            <a:off x="2176272" y="3643884"/>
+            <a:off x="2176272" y="4210812"/>
             <a:ext cx="1508760" cy="173736"/>
           </a:xfrm>
           <a:prstGeom prst="rect">
@@ -5217,7 +5442,7 @@
         </p:nvSpPr>
         <p:spPr>
           <a:xfrm>
-            <a:off x="1060704" y="3831336"/>
+            <a:off x="1060704" y="4398264"/>
             <a:ext cx="2541912" cy="173736"/>
           </a:xfrm>
           <a:prstGeom prst="rect">
@@ -5248,7 +5473,7 @@
         </p:nvSpPr>
         <p:spPr>
           <a:xfrm>
-            <a:off x="1124712" y="3831336"/>
+            <a:off x="1124712" y="4398264"/>
             <a:ext cx="1051560" cy="173736"/>
           </a:xfrm>
           <a:prstGeom prst="rect">
@@ -5287,7 +5512,7 @@
         </p:nvSpPr>
         <p:spPr>
           <a:xfrm>
-            <a:off x="2176272" y="3831336"/>
+            <a:off x="2176272" y="4398264"/>
             <a:ext cx="1508760" cy="173736"/>
           </a:xfrm>
           <a:prstGeom prst="rect">
@@ -5326,7 +5551,7 @@
         </p:nvSpPr>
         <p:spPr>
           <a:xfrm>
-            <a:off x="987552" y="4155948"/>
+            <a:off x="987552" y="4722876"/>
             <a:ext cx="2688216" cy="1120140"/>
           </a:xfrm>
           <a:prstGeom prst="roundRect">
@@ -5366,7 +5591,7 @@
         </p:nvSpPr>
         <p:spPr>
           <a:xfrm>
-            <a:off x="1124712" y="4183380"/>
+            <a:off x="1124712" y="4750308"/>
             <a:ext cx="2413896" cy="246888"/>
           </a:xfrm>
           <a:prstGeom prst="rect">
@@ -5405,7 +5630,7 @@
         </p:nvSpPr>
         <p:spPr>
           <a:xfrm>
-            <a:off x="1124712" y="4448556"/>
+            <a:off x="1124712" y="5015484"/>
             <a:ext cx="2413896" cy="10972"/>
           </a:xfrm>
           <a:prstGeom prst="rect">
@@ -5436,7 +5661,7 @@
         </p:nvSpPr>
         <p:spPr>
           <a:xfrm>
-            <a:off x="1124712" y="4475988"/>
+            <a:off x="1124712" y="5042916"/>
             <a:ext cx="1051560" cy="182880"/>
           </a:xfrm>
           <a:prstGeom prst="rect">
@@ -5475,7 +5700,7 @@
         </p:nvSpPr>
         <p:spPr>
           <a:xfrm>
-            <a:off x="2176272" y="4475988"/>
+            <a:off x="2176272" y="5042916"/>
             <a:ext cx="868680" cy="182880"/>
           </a:xfrm>
           <a:prstGeom prst="rect">
@@ -5514,7 +5739,7 @@
         </p:nvSpPr>
         <p:spPr>
           <a:xfrm>
-            <a:off x="3044952" y="4475988"/>
+            <a:off x="3044952" y="5042916"/>
             <a:ext cx="640080" cy="182880"/>
           </a:xfrm>
           <a:prstGeom prst="rect">
@@ -5553,7 +5778,7 @@
         </p:nvSpPr>
         <p:spPr>
           <a:xfrm>
-            <a:off x="1060704" y="4668012"/>
+            <a:off x="1060704" y="5234940"/>
             <a:ext cx="2541912" cy="173736"/>
           </a:xfrm>
           <a:prstGeom prst="rect">
@@ -5584,7 +5809,7 @@
         </p:nvSpPr>
         <p:spPr>
           <a:xfrm>
-            <a:off x="1124712" y="4668012"/>
+            <a:off x="1124712" y="5234940"/>
             <a:ext cx="1051560" cy="173736"/>
           </a:xfrm>
           <a:prstGeom prst="rect">
@@ -5623,7 +5848,7 @@
         </p:nvSpPr>
         <p:spPr>
           <a:xfrm>
-            <a:off x="2176272" y="4668012"/>
+            <a:off x="2176272" y="5234940"/>
             <a:ext cx="868680" cy="173736"/>
           </a:xfrm>
           <a:prstGeom prst="rect">
@@ -5662,7 +5887,7 @@
         </p:nvSpPr>
         <p:spPr>
           <a:xfrm>
-            <a:off x="3044952" y="4668012"/>
+            <a:off x="3044952" y="5234940"/>
             <a:ext cx="640080" cy="173736"/>
           </a:xfrm>
           <a:prstGeom prst="rect">
@@ -5701,7 +5926,7 @@
         </p:nvSpPr>
         <p:spPr>
           <a:xfrm>
-            <a:off x="1124712" y="4855464"/>
+            <a:off x="1124712" y="5422392"/>
             <a:ext cx="1051560" cy="173736"/>
           </a:xfrm>
           <a:prstGeom prst="rect">
@@ -5740,7 +5965,7 @@
         </p:nvSpPr>
         <p:spPr>
           <a:xfrm>
-            <a:off x="2176272" y="4855464"/>
+            <a:off x="2176272" y="5422392"/>
             <a:ext cx="868680" cy="173736"/>
           </a:xfrm>
           <a:prstGeom prst="rect">
@@ -5779,7 +6004,7 @@
         </p:nvSpPr>
         <p:spPr>
           <a:xfrm>
-            <a:off x="3044952" y="4855464"/>
+            <a:off x="3044952" y="5422392"/>
             <a:ext cx="640080" cy="173736"/>
           </a:xfrm>
           <a:prstGeom prst="rect">
@@ -5818,7 +6043,7 @@
         </p:nvSpPr>
         <p:spPr>
           <a:xfrm>
-            <a:off x="1060704" y="5042916"/>
+            <a:off x="1060704" y="5609844"/>
             <a:ext cx="2541912" cy="173736"/>
           </a:xfrm>
           <a:prstGeom prst="rect">
@@ -5849,7 +6074,7 @@
         </p:nvSpPr>
         <p:spPr>
           <a:xfrm>
-            <a:off x="1124712" y="5042916"/>
+            <a:off x="1124712" y="5609844"/>
             <a:ext cx="1051560" cy="173736"/>
           </a:xfrm>
           <a:prstGeom prst="rect">
@@ -5888,7 +6113,7 @@
         </p:nvSpPr>
         <p:spPr>
           <a:xfrm>
-            <a:off x="2176272" y="5042916"/>
+            <a:off x="2176272" y="5609844"/>
             <a:ext cx="868680" cy="173736"/>
           </a:xfrm>
           <a:prstGeom prst="rect">
@@ -5927,7 +6152,7 @@
         </p:nvSpPr>
         <p:spPr>
           <a:xfrm>
-            <a:off x="3044952" y="5042916"/>
+            <a:off x="3044952" y="5609844"/>
             <a:ext cx="640080" cy="173736"/>
           </a:xfrm>
           <a:prstGeom prst="rect">
@@ -5966,7 +6191,7 @@
         </p:nvSpPr>
         <p:spPr>
           <a:xfrm>
-            <a:off x="4425696" y="4526280"/>
+            <a:off x="4425696" y="5093208"/>
             <a:ext cx="2423040" cy="566928"/>
           </a:xfrm>
           <a:prstGeom prst="rect">
@@ -6005,7 +6230,7 @@
         </p:nvSpPr>
         <p:spPr>
           <a:xfrm>
-            <a:off x="7534656" y="2999232"/>
+            <a:off x="7534656" y="3566160"/>
             <a:ext cx="3666780" cy="1883664"/>
           </a:xfrm>
           <a:prstGeom prst="roundRect">
@@ -6040,7 +6265,7 @@
         </p:nvSpPr>
         <p:spPr>
           <a:xfrm>
-            <a:off x="7534656" y="3072384"/>
+            <a:off x="7534656" y="3639312"/>
             <a:ext cx="3621060" cy="173736"/>
           </a:xfrm>
           <a:prstGeom prst="rect">
@@ -6101,7 +6326,7 @@
         </p:nvSpPr>
         <p:spPr>
           <a:xfrm>
-            <a:off x="7534656" y="3246120"/>
+            <a:off x="7534656" y="3813048"/>
             <a:ext cx="3621060" cy="173736"/>
           </a:xfrm>
           <a:prstGeom prst="rect">
@@ -6172,7 +6397,7 @@
         </p:nvSpPr>
         <p:spPr>
           <a:xfrm>
-            <a:off x="7534656" y="3419856"/>
+            <a:off x="7534656" y="3986784"/>
             <a:ext cx="3621060" cy="173736"/>
           </a:xfrm>
           <a:prstGeom prst="rect">
@@ -6223,7 +6448,7 @@
         </p:nvSpPr>
         <p:spPr>
           <a:xfrm>
-            <a:off x="7534656" y="3593591"/>
+            <a:off x="7534656" y="4160518"/>
             <a:ext cx="3621060" cy="173736"/>
           </a:xfrm>
           <a:prstGeom prst="rect">
@@ -6304,7 +6529,7 @@
         </p:nvSpPr>
         <p:spPr>
           <a:xfrm>
-            <a:off x="7534656" y="3767328"/>
+            <a:off x="7534656" y="4334256"/>
             <a:ext cx="3621060" cy="173736"/>
           </a:xfrm>
           <a:prstGeom prst="rect">
@@ -6385,7 +6610,7 @@
         </p:nvSpPr>
         <p:spPr>
           <a:xfrm>
-            <a:off x="7534656" y="3941063"/>
+            <a:off x="7534656" y="4507991"/>
             <a:ext cx="3621060" cy="173736"/>
           </a:xfrm>
           <a:prstGeom prst="rect">
@@ -6456,7 +6681,7 @@
         </p:nvSpPr>
         <p:spPr>
           <a:xfrm>
-            <a:off x="7534656" y="4114800"/>
+            <a:off x="7534656" y="4681728"/>
             <a:ext cx="3621060" cy="173736"/>
           </a:xfrm>
           <a:prstGeom prst="rect">
@@ -6507,7 +6732,7 @@
         </p:nvSpPr>
         <p:spPr>
           <a:xfrm>
-            <a:off x="7534656" y="4288536"/>
+            <a:off x="7534656" y="4855464"/>
             <a:ext cx="3621060" cy="173736"/>
           </a:xfrm>
           <a:prstGeom prst="rect">
@@ -6588,7 +6813,7 @@
         </p:nvSpPr>
         <p:spPr>
           <a:xfrm>
-            <a:off x="7534656" y="4462272"/>
+            <a:off x="7534656" y="5029200"/>
             <a:ext cx="3621060" cy="173736"/>
           </a:xfrm>
           <a:prstGeom prst="rect">
@@ -6669,7 +6894,7 @@
         </p:nvSpPr>
         <p:spPr>
           <a:xfrm>
-            <a:off x="7534656" y="4636008"/>
+            <a:off x="7534656" y="5202936"/>
             <a:ext cx="3621060" cy="173736"/>
           </a:xfrm>
           <a:prstGeom prst="rect">
@@ -6729,6 +6954,55 @@
               <a:t xml:space="preserve">doc:cisplatin_label</a:t>
             </a:r>
             <a:endParaRPr lang="en-US" sz="1050"/>
+          </a:p>
+        </p:txBody>
+      </p:sp>
+      <p:sp>
+        <p:nvSpPr>
+          <p:cNvPr id="1359" name="Privacy"/>
+          <p:cNvSpPr txBox="1"/>
+          <p:nvPr/>
+        </p:nvSpPr>
+        <p:spPr>
+          <a:xfrm>
+            <a:off x="822960" y="6053328"/>
+            <a:ext cx="10515600" cy="256032"/>
+          </a:xfrm>
+          <a:prstGeom prst="rect">
+            <a:avLst/>
+          </a:prstGeom>
+          <a:noFill/>
+          <a:ln>
+            <a:noFill/>
+          </a:ln>
+        </p:spPr>
+        <p:txBody>
+          <a:bodyPr wrap="square" lIns="0" tIns="0" rIns="0" bIns="0" anchor="ctr">
+            <a:noAutofit/>
+          </a:bodyPr>
+          <a:lstStyle/>
+          <a:p>
+            <a:pPr algn="l"/>
+            <a:r>
+              <a:rPr lang="en-US" sz="1300" b="1" i="0" dirty="0">
+                <a:solidFill>
+                  <a:srgbClr val="0B6E4F"/>
+                </a:solidFill>
+                <a:latin typeface="Calibri"/>
+                <a:cs typeface="Calibri"/>
+              </a:rPr>
+              <a:t xml:space="preserve">Only aggregate statistics would leave the hospital: </a:t>
+            </a:r>
+            <a:r>
+              <a:rPr lang="en-US" sz="1300" b="0" i="0" dirty="0">
+                <a:solidFill>
+                  <a:srgbClr val="3A434C"/>
+                </a:solidFill>
+                <a:latin typeface="Calibri"/>
+                <a:cs typeface="Calibri"/>
+              </a:rPr>
+              <a:t xml:space="preserve">patient data stays where it is.</a:t>
+            </a:r>
           </a:p>
         </p:txBody>
       </p:sp>

</xml_diff>

<commit_message>
Future work: close the loop, then data explains a cryptic column
The strip moves the evaluation tools (OOPS!, reasoner) into the loop, live in the RIGOR App
demo. The cards tell data -> clues -> answer: without documentation, BM_DEP is a 0/1 flag
that is 1 exactly with cisplatin, so RIGOR proposes 'Bone marrow depression' for expert
review (paper Sec. 5). New fragment verified with the OWL API; citations in the footer;
speech updated. Replaces future_v2.

Co-Authored-By: Claude Opus 5.5 <noreply@anthropic.com>
Claude-Session: https://claude.ai/code/session_01KcycczqUBG98FnzsgJYAW8
</commit_message>
<xml_diff>
--- a/presentation/RIGOR_future_work.pptx
+++ b/presentation/RIGOR_future_work.pptx
@@ -1775,19 +1775,6 @@
           </a:bodyPr>
           <a:lstStyle/>
           <a:p>
-            <a:pPr indent="-228600" lvl="0" marL="457200" marR="0" rtl="0" algn="l">
-              <a:lnSpc>
-                <a:spcPct val="100000"/>
-              </a:lnSpc>
-              <a:spcBef>
-                <a:spcPts val="0"/>
-              </a:spcBef>
-              <a:spcAft>
-                <a:spcPts val="0"/>
-              </a:spcAft>
-              <a:buSzPts val="1400"/>
-              <a:buNone/>
-            </a:pPr>
             <a:r>
               <a:rPr lang="en-US" sz="1200">
                 <a:solidFill>
@@ -1798,24 +1785,10 @@
                 <a:cs typeface="Calibri"/>
                 <a:sym typeface="Calibri"/>
               </a:rPr>
-              <a:t>[11:05–12:00]  SPOKEN SCRIPT (96 words)</a:t>
-            </a:r>
-            <a:endParaRPr/>
-          </a:p>
-          <a:p>
-            <a:pPr indent="-228600" lvl="0" marL="457200" marR="0" rtl="0" algn="l">
-              <a:lnSpc>
-                <a:spcPct val="100000"/>
-              </a:lnSpc>
-              <a:spcBef>
-                <a:spcPts val="0"/>
-              </a:spcBef>
-              <a:spcAft>
-                <a:spcPts val="0"/>
-              </a:spcAft>
-              <a:buSzPts val="1400"/>
-              <a:buNone/>
-            </a:pPr>
+              <a:t>[11:58–13:08]  SPOKEN SCRIPT (119 words)</a:t>
+            </a:r>
+          </a:p>
+          <a:p>
             <a:r>
               <a:rPr lang="en-US" sz="1200">
                 <a:solidFill>
@@ -1826,51 +1799,11 @@
                 <a:cs typeface="Calibri"/>
                 <a:sym typeface="Calibri"/>
               </a:rPr>
-              <a:t>Where next? Today RIGOR reads schemas and documentation. The next step is to let the data speak. Imagine several patients whose records show bone marrow depression after cisplatin cycles. The rows alone show a pattern. The drug label adds that bone-marrow suppression is a known adverse reaction of cisplatin. Together, they let RIGOR propose new knowledge: a candidate association between cisplatin and bone marrow depression, with provenance to both sources. Candidate, not cause. Gemcitabine, radiotherapy or cirrhosis could also explain it. So an expert reviews it. We also want validator and reasoner feedback inside the loop.</a:t>
-            </a:r>
-            <a:endParaRPr/>
-          </a:p>
-          <a:p>
-            <a:pPr indent="-228600" lvl="0" marL="457200" marR="0" rtl="0" algn="l">
-              <a:lnSpc>
-                <a:spcPct val="100000"/>
-              </a:lnSpc>
-              <a:spcBef>
-                <a:spcPts val="0"/>
-              </a:spcBef>
-              <a:spcAft>
-                <a:spcPts val="0"/>
-              </a:spcAft>
-              <a:buSzPts val="1400"/>
-              <a:buNone/>
-            </a:pPr>
-            <a:r>
-              <a:t/>
-            </a:r>
-            <a:endParaRPr sz="1200">
-              <a:solidFill>
-                <a:schemeClr val="dk1"/>
-              </a:solidFill>
-              <a:latin typeface="Calibri"/>
-              <a:ea typeface="Calibri"/>
-              <a:cs typeface="Calibri"/>
-              <a:sym typeface="Calibri"/>
-            </a:endParaRPr>
-          </a:p>
-          <a:p>
-            <a:pPr indent="-228600" lvl="0" marL="457200" marR="0" rtl="0" algn="l">
-              <a:lnSpc>
-                <a:spcPct val="100000"/>
-              </a:lnSpc>
-              <a:spcBef>
-                <a:spcPts val="0"/>
-              </a:spcBef>
-              <a:spcAft>
-                <a:spcPts val="0"/>
-              </a:spcAft>
-              <a:buSzPts val="1400"/>
-              <a:buNone/>
-            </a:pPr>
+              <a:t>Where next? First, close the loop. The tools we evaluated with, OOPS! and the reasoner, only looked at the final ontologies, which is why a few pitfalls slipped through. Next, they flag each error while RIGOR builds. We started this in NeOn-GPT, and it is already live in our RIGOR App demo. [pause] Then, let the data speak. Remember BM_DEP? Without documentation, the name alone is a guess. The data gives two clues: it is only ever zero or one, so it is a flag; and it is one exactly when the patient received cisplatin, a chemotherapy known to suppress the bone marrow. So RIGOR can propose: bone marrow depression, with provenance to both columns, for an expert to confirm.</a:t>
+            </a:r>
+          </a:p>
+          <a:p/>
+          <a:p>
             <a:r>
               <a:rPr lang="en-US" sz="1200">
                 <a:solidFill>
@@ -1881,24 +1814,10 @@
                 <a:cs typeface="Calibri"/>
                 <a:sym typeface="Calibri"/>
               </a:rPr>
-              <a:t>PRESENTER / POINTER: Rows, label, code, left to right. Say 'candidate' or 'may have contributed', never 'caused'.</a:t>
-            </a:r>
-            <a:endParaRPr/>
-          </a:p>
-          <a:p>
-            <a:pPr indent="-228600" lvl="0" marL="457200" marR="0" rtl="0" algn="l">
-              <a:lnSpc>
-                <a:spcPct val="100000"/>
-              </a:lnSpc>
-              <a:spcBef>
-                <a:spcPts val="0"/>
-              </a:spcBef>
-              <a:spcAft>
-                <a:spcPts val="0"/>
-              </a:spcAft>
-              <a:buSzPts val="1400"/>
-              <a:buNone/>
-            </a:pPr>
+              <a:t>PRESENTER / POINTER: Strip first; then the '?' on BM_DEP, the two clues, and the reveal.</a:t>
+            </a:r>
+          </a:p>
+          <a:p>
             <a:r>
               <a:rPr lang="en-US" sz="1200">
                 <a:solidFill>
@@ -1909,24 +1828,10 @@
                 <a:cs typeface="Calibri"/>
                 <a:sym typeface="Calibri"/>
               </a:rPr>
-              <a:t>AUDIENCE TAKEAWAY: Instances plus documentation can propose knowledge; experts confirm it.</a:t>
-            </a:r>
-            <a:endParaRPr/>
-          </a:p>
-          <a:p>
-            <a:pPr indent="-228600" lvl="0" marL="457200" marR="0" rtl="0" algn="l">
-              <a:lnSpc>
-                <a:spcPct val="100000"/>
-              </a:lnSpc>
-              <a:spcBef>
-                <a:spcPts val="0"/>
-              </a:spcBef>
-              <a:spcAft>
-                <a:spcPts val="0"/>
-              </a:spcAft>
-              <a:buSzPts val="1400"/>
-              <a:buNone/>
-            </a:pPr>
+              <a:t>AUDIENCE TAKEAWAY: Close the loop with tool feedback; let instance data explain cryptic columns.</a:t>
+            </a:r>
+          </a:p>
+          <a:p>
             <a:r>
               <a:rPr lang="en-US" sz="1200">
                 <a:solidFill>
@@ -1937,24 +1842,10 @@
                 <a:cs typeface="Calibri"/>
                 <a:sym typeface="Calibri"/>
               </a:rPr>
-              <a:t>SOURCE AND SCOPE: Paper Section 5. Rows are synthetic. OWL verified (presentation/excerpts/slide22_future_candidate.omn): a typed individual with provenance, no causal axiom.</a:t>
-            </a:r>
-            <a:endParaRPr/>
-          </a:p>
-          <a:p>
-            <a:pPr indent="-228600" lvl="0" marL="457200" marR="0" rtl="0" algn="l">
-              <a:lnSpc>
-                <a:spcPct val="100000"/>
-              </a:lnSpc>
-              <a:spcBef>
-                <a:spcPts val="0"/>
-              </a:spcBef>
-              <a:spcAft>
-                <a:spcPts val="0"/>
-              </a:spcAft>
-              <a:buSzPts val="1400"/>
-              <a:buNone/>
-            </a:pPr>
+              <a:t>SOURCE AND SCOPE: Paper Sec. 5 (tool feedback in the loop; instance-level signals for cryptic columns when documentation is missing). NeOn-GPT (ESWC 2024), Extended NeOn-GPT (SWJ 2026), RIGOR App (ISWC 2026 Demos). Rows are synthetic. OWL verified (presentation/excerpts/slide22_future_candidate.omn).</a:t>
+            </a:r>
+          </a:p>
+          <a:p>
             <a:r>
               <a:rPr lang="en-US" sz="1200">
                 <a:solidFill>
@@ -1965,51 +1856,11 @@
                 <a:cs typeface="Calibri"/>
                 <a:sym typeface="Calibri"/>
               </a:rPr>
-              <a:t>IF RUNNING LATE, DROP: "We also want validator and reasoner feedback inside the loop."</a:t>
-            </a:r>
-            <a:endParaRPr/>
-          </a:p>
-          <a:p>
-            <a:pPr indent="-228600" lvl="0" marL="457200" marR="0" rtl="0" algn="l">
-              <a:lnSpc>
-                <a:spcPct val="100000"/>
-              </a:lnSpc>
-              <a:spcBef>
-                <a:spcPts val="0"/>
-              </a:spcBef>
-              <a:spcAft>
-                <a:spcPts val="0"/>
-              </a:spcAft>
-              <a:buSzPts val="1400"/>
-              <a:buNone/>
-            </a:pPr>
-            <a:r>
-              <a:t/>
-            </a:r>
-            <a:endParaRPr sz="1200">
-              <a:solidFill>
-                <a:schemeClr val="dk1"/>
-              </a:solidFill>
-              <a:latin typeface="Calibri"/>
-              <a:ea typeface="Calibri"/>
-              <a:cs typeface="Calibri"/>
-              <a:sym typeface="Calibri"/>
-            </a:endParaRPr>
-          </a:p>
-          <a:p>
-            <a:pPr indent="-228600" lvl="0" marL="457200" marR="0" rtl="0" algn="l">
-              <a:lnSpc>
-                <a:spcPct val="100000"/>
-              </a:lnSpc>
-              <a:spcBef>
-                <a:spcPts val="0"/>
-              </a:spcBef>
-              <a:spcAft>
-                <a:spcPts val="0"/>
-              </a:spcAft>
-              <a:buSzPts val="1400"/>
-              <a:buNone/>
-            </a:pPr>
+              <a:t>IF RUNNING LATE, DROP: "which is why a few pitfalls slipped through"</a:t>
+            </a:r>
+          </a:p>
+          <a:p/>
+          <a:p>
             <a:r>
               <a:rPr lang="en-US" sz="1200">
                 <a:solidFill>
@@ -2020,9 +1871,23 @@
                 <a:cs typeface="Calibri"/>
                 <a:sym typeface="Calibri"/>
               </a:rPr>
-              <a:t>IF ASKED WHY NOT AN OWL CAUSAL AXIOM: OWL reasoning is deductive and open-world; it cannot derive causation from statistics, and 'Cisplatin SubClassOf causes some BoneMarrowDepression' would wrongly claim it for every case.</a:t>
-            </a:r>
-            <a:endParaRPr/>
+              <a:t>IF ASKED 'WHY NOT JUST ASK THE LLM WHAT BM_DEP MEANS?': from the name alone it is a guess. The data narrows it down: a 0/1 flag that switches on with cisplatin. That is evidence, and we keep provenance to both columns.</a:t>
+            </a:r>
+          </a:p>
+          <a:p/>
+          <a:p>
+            <a:r>
+              <a:rPr lang="en-US" sz="1200">
+                <a:solidFill>
+                  <a:schemeClr val="dk1"/>
+                </a:solidFill>
+                <a:latin typeface="Calibri"/>
+                <a:ea typeface="Calibri"/>
+                <a:cs typeface="Calibri"/>
+                <a:sym typeface="Calibri"/>
+              </a:rPr>
+              <a:t>IF ASKED ABOUT PRIVACY: only aggregate statistics (value ranges, co-occurrence) need to leave the database, not patient rows.</a:t>
+            </a:r>
           </a:p>
         </p:txBody>
       </p:sp>
@@ -3832,7 +3697,7 @@
                 <a:cs typeface="Consolas"/>
                 <a:sym typeface="Consolas"/>
               </a:rPr>
-              <a:t>FUTURE WORK  /  FROM SCHEMAS TO INSTANCES</a:t>
+              <a:t>FUTURE WORK</a:t>
             </a:r>
             <a:endParaRPr b="0" i="0" sz="1400" u="none" cap="none" strike="noStrike">
               <a:solidFill>
@@ -3898,7 +3763,7 @@
                 <a:cs typeface="Cambria"/>
                 <a:sym typeface="Cambria"/>
               </a:rPr>
-              <a:t>Next: check inside the loop, then let the data speak.</a:t>
+              <a:t>Next: close the loop, and let the data speak.</a:t>
             </a:r>
             <a:endParaRPr b="0" i="0" sz="1400" u="none" cap="none" strike="noStrike">
               <a:solidFill>
@@ -3914,968 +3779,18 @@
       </p:sp>
       <p:sp>
         <p:nvSpPr>
-          <p:cNvPr id="1291" name="Google Shape;1291;p22"/>
-          <p:cNvSpPr txBox="1"/>
-          <p:nvPr/>
-        </p:nvSpPr>
-        <p:spPr>
-          <a:xfrm>
-            <a:off x="822960" y="2331720"/>
-            <a:ext cx="10332600" cy="329100"/>
-          </a:xfrm>
-          <a:prstGeom prst="rect">
-            <a:avLst/>
-          </a:prstGeom>
-          <a:noFill/>
-          <a:ln>
-            <a:noFill/>
-          </a:ln>
-        </p:spPr>
-        <p:txBody>
-          <a:bodyPr anchorCtr="0" anchor="ctr" bIns="0" lIns="0" spcFirstLastPara="1" rIns="0" wrap="square" tIns="0">
-            <a:spAutoFit/>
-          </a:bodyPr>
-          <a:lstStyle/>
-          <a:p>
-            <a:pPr indent="0" lvl="0" marL="0" marR="0" rtl="0" algn="l">
-              <a:lnSpc>
-                <a:spcPct val="106000"/>
-              </a:lnSpc>
-              <a:spcBef>
-                <a:spcPts val="0"/>
-              </a:spcBef>
-              <a:spcAft>
-                <a:spcPts val="0"/>
-              </a:spcAft>
-              <a:buClr>
-                <a:srgbClr val="000000"/>
-              </a:buClr>
-              <a:buSzPts val="1700"/>
-              <a:buFont typeface="Arial"/>
-              <a:buNone/>
-            </a:pPr>
-            <a:r>
-              <a:rPr lang="en-US" sz="1300" b="1" i="0" dirty="0">
-                <a:solidFill>
-                  <a:srgbClr val="0B6E4F"/>
-                </a:solidFill>
-                <a:latin typeface="Calibri"/>
-                <a:cs typeface="Calibri"/>
-              </a:rPr>
-              <a:t xml:space="preserve">THEN, LET THE DATA SPEAK   </a:t>
-            </a:r>
-            <a:r>
-              <a:rPr lang="en-US" sz="1500" b="0" i="0" dirty="0">
-                <a:solidFill>
-                  <a:srgbClr val="5B6770"/>
-                </a:solidFill>
-                <a:latin typeface="Calibri"/>
-                <a:cs typeface="Calibri"/>
-              </a:rPr>
-              <a:t xml:space="preserve">Today </a:t>
-            </a:r>
-            <a:r>
-              <a:rPr lang="en-US" sz="1500" b="1" i="1" dirty="0">
-                <a:solidFill>
-                  <a:srgbClr val="3A434C"/>
-                </a:solidFill>
-                <a:latin typeface="Calibri"/>
-                <a:cs typeface="Calibri"/>
-              </a:rPr>
-              <a:t xml:space="preserve">RIGOR</a:t>
-            </a:r>
-            <a:r>
-              <a:rPr lang="en-US" sz="1500" b="0" i="0" dirty="0">
-                <a:solidFill>
-                  <a:srgbClr val="5B6770"/>
-                </a:solidFill>
-                <a:latin typeface="Calibri"/>
-                <a:cs typeface="Calibri"/>
-              </a:rPr>
-              <a:t xml:space="preserve"> reads </a:t>
-            </a:r>
-            <a:r>
-              <a:rPr lang="en-US" sz="1500" b="1" i="0" dirty="0">
-                <a:solidFill>
-                  <a:srgbClr val="3A434C"/>
-                </a:solidFill>
-                <a:latin typeface="Calibri"/>
-                <a:cs typeface="Calibri"/>
-              </a:rPr>
-              <a:t xml:space="preserve">schemas</a:t>
-            </a:r>
-            <a:r>
-              <a:rPr lang="en-US" sz="1500" b="0" i="0" dirty="0">
-                <a:solidFill>
-                  <a:srgbClr val="5B6770"/>
-                </a:solidFill>
-                <a:latin typeface="Calibri"/>
-                <a:cs typeface="Calibri"/>
-              </a:rPr>
-              <a:t xml:space="preserve"> and </a:t>
-            </a:r>
-            <a:r>
-              <a:rPr lang="en-US" sz="1500" b="1" i="0" dirty="0">
-                <a:solidFill>
-                  <a:srgbClr val="3A434C"/>
-                </a:solidFill>
-                <a:latin typeface="Calibri"/>
-                <a:cs typeface="Calibri"/>
-              </a:rPr>
-              <a:t xml:space="preserve">documentation</a:t>
-            </a:r>
-            <a:r>
-              <a:rPr lang="en-US" sz="1500" b="0" i="0" dirty="0">
-                <a:solidFill>
-                  <a:srgbClr val="5B6770"/>
-                </a:solidFill>
-                <a:latin typeface="Calibri"/>
-                <a:cs typeface="Calibri"/>
-              </a:rPr>
-              <a:t xml:space="preserve">. </a:t>
-            </a:r>
-            <a:r>
-              <a:rPr lang="en-US" sz="1500" b="1" i="0" dirty="0">
-                <a:solidFill>
-                  <a:srgbClr val="3A434C"/>
-                </a:solidFill>
-                <a:latin typeface="Calibri"/>
-                <a:cs typeface="Calibri"/>
-              </a:rPr>
-              <a:t xml:space="preserve">Instance data</a:t>
-            </a:r>
-            <a:r>
-              <a:rPr lang="en-US" sz="1500" b="0" i="0" dirty="0">
-                <a:solidFill>
-                  <a:srgbClr val="5B6770"/>
-                </a:solidFill>
-                <a:latin typeface="Calibri"/>
-                <a:cs typeface="Calibri"/>
-              </a:rPr>
-              <a:t xml:space="preserve"> could propose </a:t>
-            </a:r>
-            <a:r>
-              <a:rPr lang="en-US" sz="1500" b="1" i="0" dirty="0">
-                <a:solidFill>
-                  <a:srgbClr val="3A434C"/>
-                </a:solidFill>
-                <a:latin typeface="Calibri"/>
-                <a:cs typeface="Calibri"/>
-              </a:rPr>
-              <a:t xml:space="preserve">new knowledge</a:t>
-            </a:r>
-            <a:r>
-              <a:rPr lang="en-US" sz="1500" b="0" i="0" dirty="0">
-                <a:solidFill>
-                  <a:srgbClr val="5B6770"/>
-                </a:solidFill>
-                <a:latin typeface="Calibri"/>
-                <a:cs typeface="Calibri"/>
-              </a:rPr>
-              <a:t xml:space="preserve">.</a:t>
-            </a:r>
-          </a:p>
-        </p:txBody>
-      </p:sp>
-      <p:sp>
-        <p:nvSpPr>
-          <p:cNvPr id="1292" name="Google Shape;1292;p22"/>
+          <p:cNvPr id="1291" name="Loop strip"/>
           <p:cNvSpPr/>
           <p:nvPr/>
         </p:nvSpPr>
         <p:spPr>
           <a:xfrm>
-            <a:off x="822960" y="2761488"/>
-            <a:ext cx="3017400" cy="3218688"/>
+            <a:off x="804672" y="1645920"/>
+            <a:ext cx="10579608" cy="566928"/>
           </a:xfrm>
           <a:prstGeom prst="roundRect">
             <a:avLst>
-              <a:gd fmla="val 12000" name="adj"/>
-            </a:avLst>
-          </a:prstGeom>
-          <a:solidFill>
-            <a:srgbClr val="FFFFFF"/>
-          </a:solidFill>
-          <a:ln cap="flat" cmpd="sng" w="9525">
-            <a:solidFill>
-              <a:srgbClr val="D9DEDB"/>
-            </a:solidFill>
-            <a:prstDash val="solid"/>
-            <a:round/>
-            <a:headEnd len="sm" w="sm" type="none"/>
-            <a:tailEnd len="sm" w="sm" type="none"/>
-          </a:ln>
-        </p:spPr>
-        <p:txBody>
-          <a:bodyPr anchorCtr="0" anchor="t" bIns="0" lIns="0" spcFirstLastPara="1" rIns="0" wrap="square" tIns="0">
-            <a:noAutofit/>
-          </a:bodyPr>
-          <a:lstStyle/>
-          <a:p>
-            <a:pPr indent="0" lvl="0" marL="0" marR="0" rtl="0" algn="l">
-              <a:lnSpc>
-                <a:spcPct val="100000"/>
-              </a:lnSpc>
-              <a:spcBef>
-                <a:spcPts val="0"/>
-              </a:spcBef>
-              <a:spcAft>
-                <a:spcPts val="0"/>
-              </a:spcAft>
-              <a:buNone/>
-            </a:pPr>
-            <a:r>
-              <a:t/>
-            </a:r>
-            <a:endParaRPr b="0" i="0" sz="1400" u="none" cap="none" strike="noStrike">
-              <a:solidFill>
-                <a:srgbClr val="000000"/>
-              </a:solidFill>
-              <a:latin typeface="Arial"/>
-              <a:ea typeface="Arial"/>
-              <a:cs typeface="Arial"/>
-              <a:sym typeface="Arial"/>
-            </a:endParaRPr>
-          </a:p>
-        </p:txBody>
-      </p:sp>
-      <p:sp>
-        <p:nvSpPr>
-          <p:cNvPr id="1293" name="Google Shape;1293;p22"/>
-          <p:cNvSpPr/>
-          <p:nvPr/>
-        </p:nvSpPr>
-        <p:spPr>
-          <a:xfrm>
-            <a:off x="4224528" y="2761488"/>
-            <a:ext cx="2788800" cy="3218688"/>
-          </a:xfrm>
-          <a:prstGeom prst="roundRect">
-            <a:avLst>
-              <a:gd fmla="val 12000" name="adj"/>
-            </a:avLst>
-          </a:prstGeom>
-          <a:solidFill>
-            <a:srgbClr val="FFFFFF"/>
-          </a:solidFill>
-          <a:ln cap="flat" cmpd="sng" w="9525">
-            <a:solidFill>
-              <a:srgbClr val="D9DEDB"/>
-            </a:solidFill>
-            <a:prstDash val="solid"/>
-            <a:round/>
-            <a:headEnd len="sm" w="sm" type="none"/>
-            <a:tailEnd len="sm" w="sm" type="none"/>
-          </a:ln>
-        </p:spPr>
-        <p:txBody>
-          <a:bodyPr anchorCtr="0" anchor="t" bIns="0" lIns="0" spcFirstLastPara="1" rIns="0" wrap="square" tIns="0">
-            <a:noAutofit/>
-          </a:bodyPr>
-          <a:lstStyle/>
-          <a:p>
-            <a:pPr indent="0" lvl="0" marL="0" marR="0" rtl="0" algn="l">
-              <a:lnSpc>
-                <a:spcPct val="100000"/>
-              </a:lnSpc>
-              <a:spcBef>
-                <a:spcPts val="0"/>
-              </a:spcBef>
-              <a:spcAft>
-                <a:spcPts val="0"/>
-              </a:spcAft>
-              <a:buNone/>
-            </a:pPr>
-            <a:r>
-              <a:t/>
-            </a:r>
-            <a:endParaRPr b="0" i="0" sz="1400" u="none" cap="none" strike="noStrike">
-              <a:solidFill>
-                <a:srgbClr val="000000"/>
-              </a:solidFill>
-              <a:latin typeface="Arial"/>
-              <a:ea typeface="Arial"/>
-              <a:cs typeface="Arial"/>
-              <a:sym typeface="Arial"/>
-            </a:endParaRPr>
-          </a:p>
-        </p:txBody>
-      </p:sp>
-      <p:sp>
-        <p:nvSpPr>
-          <p:cNvPr id="1294" name="Google Shape;1294;p22"/>
-          <p:cNvSpPr/>
-          <p:nvPr/>
-        </p:nvSpPr>
-        <p:spPr>
-          <a:xfrm>
-            <a:off x="7397496" y="2761488"/>
-            <a:ext cx="3941100" cy="3218688"/>
-          </a:xfrm>
-          <a:prstGeom prst="roundRect">
-            <a:avLst>
-              <a:gd fmla="val 12000" name="adj"/>
-            </a:avLst>
-          </a:prstGeom>
-          <a:solidFill>
-            <a:srgbClr val="FFFFFF"/>
-          </a:solidFill>
-          <a:ln cap="flat" cmpd="sng" w="9525">
-            <a:solidFill>
-              <a:srgbClr val="D9DEDB"/>
-            </a:solidFill>
-            <a:prstDash val="solid"/>
-            <a:round/>
-            <a:headEnd len="sm" w="sm" type="none"/>
-            <a:tailEnd len="sm" w="sm" type="none"/>
-          </a:ln>
-        </p:spPr>
-        <p:txBody>
-          <a:bodyPr anchorCtr="0" anchor="t" bIns="0" lIns="0" spcFirstLastPara="1" rIns="0" wrap="square" tIns="0">
-            <a:noAutofit/>
-          </a:bodyPr>
-          <a:lstStyle/>
-          <a:p>
-            <a:pPr indent="0" lvl="0" marL="0" marR="0" rtl="0" algn="l">
-              <a:lnSpc>
-                <a:spcPct val="100000"/>
-              </a:lnSpc>
-              <a:spcBef>
-                <a:spcPts val="0"/>
-              </a:spcBef>
-              <a:spcAft>
-                <a:spcPts val="0"/>
-              </a:spcAft>
-              <a:buNone/>
-            </a:pPr>
-            <a:r>
-              <a:t/>
-            </a:r>
-            <a:endParaRPr b="0" i="0" sz="1400" u="none" cap="none" strike="noStrike">
-              <a:solidFill>
-                <a:srgbClr val="000000"/>
-              </a:solidFill>
-              <a:latin typeface="Arial"/>
-              <a:ea typeface="Arial"/>
-              <a:cs typeface="Arial"/>
-              <a:sym typeface="Arial"/>
-            </a:endParaRPr>
-          </a:p>
-        </p:txBody>
-      </p:sp>
-      <p:sp>
-        <p:nvSpPr>
-          <p:cNvPr id="1295" name="Google Shape;1295;p22"/>
-          <p:cNvSpPr/>
-          <p:nvPr/>
-        </p:nvSpPr>
-        <p:spPr>
-          <a:xfrm>
-            <a:off x="3877048" y="4178832"/>
-            <a:ext cx="429600" cy="384000"/>
-          </a:xfrm>
-          <a:prstGeom prst="rightArrow">
-            <a:avLst>
-              <a:gd fmla="val 50000" name="adj1"/>
-              <a:gd fmla="val 50000" name="adj2"/>
-            </a:avLst>
-          </a:prstGeom>
-          <a:solidFill>
-            <a:srgbClr val="0B6E4F"/>
-          </a:solidFill>
-          <a:ln>
-            <a:noFill/>
-          </a:ln>
-        </p:spPr>
-        <p:txBody>
-          <a:bodyPr anchorCtr="0" anchor="t" bIns="0" lIns="0" spcFirstLastPara="1" rIns="0" wrap="square" tIns="0">
-            <a:noAutofit/>
-          </a:bodyPr>
-          <a:lstStyle/>
-          <a:p>
-            <a:pPr indent="0" lvl="0" marL="0" marR="0" rtl="0" algn="l">
-              <a:lnSpc>
-                <a:spcPct val="100000"/>
-              </a:lnSpc>
-              <a:spcBef>
-                <a:spcPts val="0"/>
-              </a:spcBef>
-              <a:spcAft>
-                <a:spcPts val="0"/>
-              </a:spcAft>
-              <a:buNone/>
-            </a:pPr>
-            <a:r>
-              <a:t/>
-            </a:r>
-            <a:endParaRPr b="0" i="0" sz="1400" u="none" cap="none" strike="noStrike">
-              <a:solidFill>
-                <a:srgbClr val="000000"/>
-              </a:solidFill>
-              <a:latin typeface="Arial"/>
-              <a:ea typeface="Arial"/>
-              <a:cs typeface="Arial"/>
-              <a:sym typeface="Arial"/>
-            </a:endParaRPr>
-          </a:p>
-        </p:txBody>
-      </p:sp>
-      <p:sp>
-        <p:nvSpPr>
-          <p:cNvPr id="1296" name="Google Shape;1296;p22"/>
-          <p:cNvSpPr/>
-          <p:nvPr/>
-        </p:nvSpPr>
-        <p:spPr>
-          <a:xfrm>
-            <a:off x="7050025" y="4178832"/>
-            <a:ext cx="429600" cy="384000"/>
-          </a:xfrm>
-          <a:prstGeom prst="rightArrow">
-            <a:avLst>
-              <a:gd fmla="val 50000" name="adj1"/>
-              <a:gd fmla="val 50000" name="adj2"/>
-            </a:avLst>
-          </a:prstGeom>
-          <a:solidFill>
-            <a:srgbClr val="0B6E4F"/>
-          </a:solidFill>
-          <a:ln>
-            <a:noFill/>
-          </a:ln>
-        </p:spPr>
-        <p:txBody>
-          <a:bodyPr anchorCtr="0" anchor="t" bIns="0" lIns="0" spcFirstLastPara="1" rIns="0" wrap="square" tIns="0">
-            <a:noAutofit/>
-          </a:bodyPr>
-          <a:lstStyle/>
-          <a:p>
-            <a:pPr indent="0" lvl="0" marL="0" marR="0" rtl="0" algn="l">
-              <a:lnSpc>
-                <a:spcPct val="100000"/>
-              </a:lnSpc>
-              <a:spcBef>
-                <a:spcPts val="0"/>
-              </a:spcBef>
-              <a:spcAft>
-                <a:spcPts val="0"/>
-              </a:spcAft>
-              <a:buNone/>
-            </a:pPr>
-            <a:r>
-              <a:t/>
-            </a:r>
-            <a:endParaRPr b="0" i="0" sz="1400" u="none" cap="none" strike="noStrike">
-              <a:solidFill>
-                <a:srgbClr val="000000"/>
-              </a:solidFill>
-              <a:latin typeface="Arial"/>
-              <a:ea typeface="Arial"/>
-              <a:cs typeface="Arial"/>
-              <a:sym typeface="Arial"/>
-            </a:endParaRPr>
-          </a:p>
-        </p:txBody>
-      </p:sp>
-      <p:sp>
-        <p:nvSpPr>
-          <p:cNvPr id="1297" name="Google Shape;1297;p22"/>
-          <p:cNvSpPr txBox="1"/>
-          <p:nvPr/>
-        </p:nvSpPr>
-        <p:spPr>
-          <a:xfrm>
-            <a:off x="1024128" y="2926080"/>
-            <a:ext cx="2651700" cy="274200"/>
-          </a:xfrm>
-          <a:prstGeom prst="rect">
-            <a:avLst/>
-          </a:prstGeom>
-          <a:noFill/>
-          <a:ln>
-            <a:noFill/>
-          </a:ln>
-        </p:spPr>
-        <p:txBody>
-          <a:bodyPr anchorCtr="0" anchor="t" bIns="0" lIns="0" spcFirstLastPara="1" rIns="0" wrap="square" tIns="0">
-            <a:noAutofit/>
-          </a:bodyPr>
-          <a:lstStyle/>
-          <a:p>
-            <a:pPr indent="0" lvl="0" marL="0" marR="0" rtl="0" algn="l">
-              <a:lnSpc>
-                <a:spcPct val="100000"/>
-              </a:lnSpc>
-              <a:spcBef>
-                <a:spcPts val="0"/>
-              </a:spcBef>
-              <a:spcAft>
-                <a:spcPts val="0"/>
-              </a:spcAft>
-              <a:buNone/>
-            </a:pPr>
-            <a:r>
-              <a:rPr b="1" i="0" lang="en-US" sz="1300" u="none" cap="none" strike="noStrike">
-                <a:solidFill>
-                  <a:srgbClr val="2F6B78"/>
-                </a:solidFill>
-                <a:latin typeface="Consolas"/>
-                <a:ea typeface="Consolas"/>
-                <a:cs typeface="Consolas"/>
-                <a:sym typeface="Consolas"/>
-              </a:rPr>
-              <a:t>1  INSTANCES</a:t>
-            </a:r>
-            <a:endParaRPr/>
-          </a:p>
-        </p:txBody>
-      </p:sp>
-      <p:sp>
-        <p:nvSpPr>
-          <p:cNvPr id="1298" name="Google Shape;1298;p22"/>
-          <p:cNvSpPr txBox="1"/>
-          <p:nvPr/>
-        </p:nvSpPr>
-        <p:spPr>
-          <a:xfrm>
-            <a:off x="1024128" y="3218688"/>
-            <a:ext cx="2651700" cy="255900"/>
-          </a:xfrm>
-          <a:prstGeom prst="rect">
-            <a:avLst/>
-          </a:prstGeom>
-          <a:noFill/>
-          <a:ln>
-            <a:noFill/>
-          </a:ln>
-        </p:spPr>
-        <p:txBody>
-          <a:bodyPr anchorCtr="0" anchor="t" bIns="0" lIns="0" spcFirstLastPara="1" rIns="0" wrap="square" tIns="0">
-            <a:noAutofit/>
-          </a:bodyPr>
-          <a:lstStyle/>
-          <a:p>
-            <a:pPr indent="0" lvl="0" marL="0" marR="0" rtl="0" algn="l">
-              <a:lnSpc>
-                <a:spcPct val="100000"/>
-              </a:lnSpc>
-              <a:spcBef>
-                <a:spcPts val="0"/>
-              </a:spcBef>
-              <a:spcAft>
-                <a:spcPts val="0"/>
-              </a:spcAft>
-              <a:buNone/>
-            </a:pPr>
-            <a:r>
-              <a:rPr lang="en-US" sz="1300" b="0" i="0" dirty="0">
-                <a:solidFill>
-                  <a:srgbClr val="5B6770"/>
-                </a:solidFill>
-                <a:latin typeface="Calibri"/>
-                <a:cs typeface="Calibri"/>
-              </a:rPr>
-              <a:t xml:space="preserve">What the rows show, across two tables</a:t>
-            </a:r>
-          </a:p>
-        </p:txBody>
-      </p:sp>
-      <p:sp>
-        <p:nvSpPr>
-          <p:cNvPr id="1306" name="Google Shape;1306;p22"/>
-          <p:cNvSpPr txBox="1"/>
-          <p:nvPr/>
-        </p:nvSpPr>
-        <p:spPr>
-          <a:xfrm>
-            <a:off x="4425696" y="2926080"/>
-            <a:ext cx="2423100" cy="274200"/>
-          </a:xfrm>
-          <a:prstGeom prst="rect">
-            <a:avLst/>
-          </a:prstGeom>
-          <a:noFill/>
-          <a:ln>
-            <a:noFill/>
-          </a:ln>
-        </p:spPr>
-        <p:txBody>
-          <a:bodyPr anchorCtr="0" anchor="t" bIns="0" lIns="0" spcFirstLastPara="1" rIns="0" wrap="square" tIns="0">
-            <a:noAutofit/>
-          </a:bodyPr>
-          <a:lstStyle/>
-          <a:p>
-            <a:pPr indent="0" lvl="0" marL="0" marR="0" rtl="0" algn="l">
-              <a:lnSpc>
-                <a:spcPct val="100000"/>
-              </a:lnSpc>
-              <a:spcBef>
-                <a:spcPts val="0"/>
-              </a:spcBef>
-              <a:spcAft>
-                <a:spcPts val="0"/>
-              </a:spcAft>
-              <a:buNone/>
-            </a:pPr>
-            <a:r>
-              <a:rPr b="1" i="0" lang="en-US" sz="1300" u="none" cap="none" strike="noStrike">
-                <a:solidFill>
-                  <a:srgbClr val="2F6B78"/>
-                </a:solidFill>
-                <a:latin typeface="Consolas"/>
-                <a:ea typeface="Consolas"/>
-                <a:cs typeface="Consolas"/>
-                <a:sym typeface="Consolas"/>
-              </a:rPr>
-              <a:t>2  + DOCUMENTATION</a:t>
-            </a:r>
-            <a:endParaRPr/>
-          </a:p>
-        </p:txBody>
-      </p:sp>
-      <p:sp>
-        <p:nvSpPr>
-          <p:cNvPr id="1307" name="Google Shape;1307;p22"/>
-          <p:cNvSpPr txBox="1"/>
-          <p:nvPr/>
-        </p:nvSpPr>
-        <p:spPr>
-          <a:xfrm>
-            <a:off x="4425696" y="3218688"/>
-            <a:ext cx="2423100" cy="255900"/>
-          </a:xfrm>
-          <a:prstGeom prst="rect">
-            <a:avLst/>
-          </a:prstGeom>
-          <a:noFill/>
-          <a:ln>
-            <a:noFill/>
-          </a:ln>
-        </p:spPr>
-        <p:txBody>
-          <a:bodyPr anchorCtr="0" anchor="t" bIns="0" lIns="0" spcFirstLastPara="1" rIns="0" wrap="square" tIns="0">
-            <a:noAutofit/>
-          </a:bodyPr>
-          <a:lstStyle/>
-          <a:p>
-            <a:pPr indent="0" lvl="0" marL="0" marR="0" rtl="0" algn="l">
-              <a:lnSpc>
-                <a:spcPct val="100000"/>
-              </a:lnSpc>
-              <a:spcBef>
-                <a:spcPts val="0"/>
-              </a:spcBef>
-              <a:spcAft>
-                <a:spcPts val="0"/>
-              </a:spcAft>
-              <a:buNone/>
-            </a:pPr>
-            <a:r>
-              <a:rPr b="0" i="0" lang="en-US" sz="1300" u="none" cap="none" strike="noStrike">
-                <a:solidFill>
-                  <a:srgbClr val="5B6770"/>
-                </a:solidFill>
-                <a:latin typeface="Calibri"/>
-                <a:ea typeface="Calibri"/>
-                <a:cs typeface="Calibri"/>
-                <a:sym typeface="Calibri"/>
-              </a:rPr>
-              <a:t>What the drug label says</a:t>
-            </a:r>
-            <a:endParaRPr/>
-          </a:p>
-        </p:txBody>
-      </p:sp>
-      <p:sp>
-        <p:nvSpPr>
-          <p:cNvPr id="1308" name="Google Shape;1308;p22"/>
-          <p:cNvSpPr/>
-          <p:nvPr/>
-        </p:nvSpPr>
-        <p:spPr>
-          <a:xfrm>
-            <a:off x="4389120" y="3584448"/>
-            <a:ext cx="2459700" cy="1115700"/>
-          </a:xfrm>
-          <a:prstGeom prst="roundRect">
-            <a:avLst>
-              <a:gd fmla="val 12000" name="adj"/>
-            </a:avLst>
-          </a:prstGeom>
-          <a:solidFill>
-            <a:srgbClr val="F3F5F4"/>
-          </a:solidFill>
-          <a:ln>
-            <a:noFill/>
-          </a:ln>
-        </p:spPr>
-        <p:txBody>
-          <a:bodyPr anchorCtr="0" anchor="ctr" bIns="0" lIns="128000" spcFirstLastPara="1" rIns="128000" wrap="square" tIns="0">
-            <a:noAutofit/>
-          </a:bodyPr>
-          <a:lstStyle/>
-          <a:p>
-            <a:pPr indent="0" lvl="0" marL="0" marR="0" rtl="0" algn="l">
-              <a:lnSpc>
-                <a:spcPct val="100000"/>
-              </a:lnSpc>
-              <a:spcBef>
-                <a:spcPts val="0"/>
-              </a:spcBef>
-              <a:spcAft>
-                <a:spcPts val="0"/>
-              </a:spcAft>
-              <a:buNone/>
-            </a:pPr>
-            <a:r>
-              <a:rPr b="0" i="1" lang="en-US" sz="1400" u="none" cap="none" strike="noStrike">
-                <a:solidFill>
-                  <a:srgbClr val="1F2328"/>
-                </a:solidFill>
-                <a:latin typeface="Calibri"/>
-                <a:ea typeface="Calibri"/>
-                <a:cs typeface="Calibri"/>
-                <a:sym typeface="Calibri"/>
-              </a:rPr>
-              <a:t>Myelosuppression (bone-marrow suppression) is a documented adverse reaction of cisplatin.</a:t>
-            </a:r>
-            <a:endParaRPr/>
-          </a:p>
-        </p:txBody>
-      </p:sp>
-      <p:sp>
-        <p:nvSpPr>
-          <p:cNvPr id="1309" name="Google Shape;1309;p22"/>
-          <p:cNvSpPr txBox="1"/>
-          <p:nvPr/>
-        </p:nvSpPr>
-        <p:spPr>
-          <a:xfrm>
-            <a:off x="4425696" y="4736592"/>
-            <a:ext cx="2423100" cy="201300"/>
-          </a:xfrm>
-          <a:prstGeom prst="rect">
-            <a:avLst/>
-          </a:prstGeom>
-          <a:noFill/>
-          <a:ln>
-            <a:noFill/>
-          </a:ln>
-        </p:spPr>
-        <p:txBody>
-          <a:bodyPr anchorCtr="0" anchor="t" bIns="0" lIns="0" spcFirstLastPara="1" rIns="0" wrap="square" tIns="0">
-            <a:noAutofit/>
-          </a:bodyPr>
-          <a:lstStyle/>
-          <a:p>
-            <a:pPr indent="0" lvl="0" marL="0" marR="0" rtl="0" algn="l">
-              <a:lnSpc>
-                <a:spcPct val="100000"/>
-              </a:lnSpc>
-              <a:spcBef>
-                <a:spcPts val="0"/>
-              </a:spcBef>
-              <a:spcAft>
-                <a:spcPts val="0"/>
-              </a:spcAft>
-              <a:buNone/>
-            </a:pPr>
-            <a:r>
-              <a:rPr b="0" i="0" lang="en-US" sz="1000" u="none" cap="none" strike="noStrike">
-                <a:solidFill>
-                  <a:srgbClr val="5B6770"/>
-                </a:solidFill>
-                <a:latin typeface="Calibri"/>
-                <a:ea typeface="Calibri"/>
-                <a:cs typeface="Calibri"/>
-                <a:sym typeface="Calibri"/>
-              </a:rPr>
-              <a:t>Cisplatin drug label, paraphrased</a:t>
-            </a:r>
-            <a:endParaRPr/>
-          </a:p>
-        </p:txBody>
-      </p:sp>
-      <p:sp>
-        <p:nvSpPr>
-          <p:cNvPr id="1311" name="Google Shape;1311;p22"/>
-          <p:cNvSpPr txBox="1"/>
-          <p:nvPr/>
-        </p:nvSpPr>
-        <p:spPr>
-          <a:xfrm>
-            <a:off x="7598664" y="2926080"/>
-            <a:ext cx="3575400" cy="274200"/>
-          </a:xfrm>
-          <a:prstGeom prst="rect">
-            <a:avLst/>
-          </a:prstGeom>
-          <a:noFill/>
-          <a:ln>
-            <a:noFill/>
-          </a:ln>
-        </p:spPr>
-        <p:txBody>
-          <a:bodyPr anchorCtr="0" anchor="t" bIns="0" lIns="0" spcFirstLastPara="1" rIns="0" wrap="square" tIns="0">
-            <a:noAutofit/>
-          </a:bodyPr>
-          <a:lstStyle/>
-          <a:p>
-            <a:pPr indent="0" lvl="0" marL="0" marR="0" rtl="0" algn="l">
-              <a:lnSpc>
-                <a:spcPct val="100000"/>
-              </a:lnSpc>
-              <a:spcBef>
-                <a:spcPts val="0"/>
-              </a:spcBef>
-              <a:spcAft>
-                <a:spcPts val="0"/>
-              </a:spcAft>
-              <a:buNone/>
-            </a:pPr>
-            <a:r>
-              <a:rPr b="1" i="0" lang="en-US" sz="1300" u="none" cap="none" strike="noStrike">
-                <a:solidFill>
-                  <a:srgbClr val="0B6E4F"/>
-                </a:solidFill>
-                <a:latin typeface="Consolas"/>
-                <a:ea typeface="Consolas"/>
-                <a:cs typeface="Consolas"/>
-                <a:sym typeface="Consolas"/>
-              </a:rPr>
-              <a:t>3  CANDIDATE KNOWLEDGE</a:t>
-            </a:r>
-            <a:endParaRPr/>
-          </a:p>
-        </p:txBody>
-      </p:sp>
-      <p:sp>
-        <p:nvSpPr>
-          <p:cNvPr id="1312" name="Google Shape;1312;p22"/>
-          <p:cNvSpPr txBox="1"/>
-          <p:nvPr/>
-        </p:nvSpPr>
-        <p:spPr>
-          <a:xfrm>
-            <a:off x="7598664" y="3218688"/>
-            <a:ext cx="3575400" cy="255900"/>
-          </a:xfrm>
-          <a:prstGeom prst="rect">
-            <a:avLst/>
-          </a:prstGeom>
-          <a:noFill/>
-          <a:ln>
-            <a:noFill/>
-          </a:ln>
-        </p:spPr>
-        <p:txBody>
-          <a:bodyPr anchorCtr="0" anchor="t" bIns="0" lIns="0" spcFirstLastPara="1" rIns="0" wrap="square" tIns="0">
-            <a:noAutofit/>
-          </a:bodyPr>
-          <a:lstStyle/>
-          <a:p>
-            <a:pPr indent="0" lvl="0" marL="0" marR="0" rtl="0" algn="l">
-              <a:lnSpc>
-                <a:spcPct val="100000"/>
-              </a:lnSpc>
-              <a:spcBef>
-                <a:spcPts val="0"/>
-              </a:spcBef>
-              <a:spcAft>
-                <a:spcPts val="0"/>
-              </a:spcAft>
-              <a:buNone/>
-            </a:pPr>
-            <a:r>
-              <a:rPr b="0" i="0" lang="en-US" sz="1300" u="none" cap="none" strike="noStrike">
-                <a:solidFill>
-                  <a:srgbClr val="5B6770"/>
-                </a:solidFill>
-                <a:latin typeface="Calibri"/>
-                <a:ea typeface="Calibri"/>
-                <a:cs typeface="Calibri"/>
-                <a:sym typeface="Calibri"/>
-              </a:rPr>
-              <a:t>A reviewable hypothesis, not a fact</a:t>
-            </a:r>
-            <a:endParaRPr/>
-          </a:p>
-        </p:txBody>
-      </p:sp>
-      <p:sp>
-        <p:nvSpPr>
-          <p:cNvPr id="1314" name="Google Shape;1314;p22"/>
-          <p:cNvSpPr txBox="1"/>
-          <p:nvPr/>
-        </p:nvSpPr>
-        <p:spPr>
-          <a:xfrm>
-            <a:off x="7598664" y="5541264"/>
-            <a:ext cx="3575400" cy="384048"/>
-          </a:xfrm>
-          <a:prstGeom prst="rect">
-            <a:avLst/>
-          </a:prstGeom>
-          <a:noFill/>
-          <a:ln>
-            <a:noFill/>
-          </a:ln>
-        </p:spPr>
-        <p:txBody>
-          <a:bodyPr anchorCtr="0" anchor="t" bIns="0" lIns="0" spcFirstLastPara="1" rIns="0" wrap="square" tIns="0">
-            <a:noAutofit/>
-          </a:bodyPr>
-          <a:lstStyle/>
-          <a:p>
-            <a:pPr indent="0" lvl="0" marL="0" marR="0" rtl="0" algn="l">
-              <a:lnSpc>
-                <a:spcPct val="100000"/>
-              </a:lnSpc>
-              <a:spcBef>
-                <a:spcPts val="0"/>
-              </a:spcBef>
-              <a:spcAft>
-                <a:spcPts val="0"/>
-              </a:spcAft>
-              <a:buNone/>
-            </a:pPr>
-            <a:r>
-              <a:rPr lang="en-US" sz="1100" b="1" i="0" dirty="0">
-                <a:solidFill>
-                  <a:srgbClr val="B23A1E"/>
-                </a:solidFill>
-                <a:latin typeface="Calibri"/>
-                <a:cs typeface="Calibri"/>
-              </a:rPr>
-              <a:t xml:space="preserve">No causal claim: </a:t>
-            </a:r>
-            <a:r>
-              <a:rPr lang="en-US" sz="1100" b="0" i="0" dirty="0">
-                <a:solidFill>
-                  <a:srgbClr val="3A434C"/>
-                </a:solidFill>
-                <a:latin typeface="Calibri"/>
-                <a:cs typeface="Calibri"/>
-              </a:rPr>
-              <a:t xml:space="preserve">gemcitabine, radiotherapy or cirrhosis can also suppress the marrow.</a:t>
-            </a:r>
-          </a:p>
-        </p:txBody>
-      </p:sp>
-      <p:sp>
-        <p:nvSpPr>
-          <p:cNvPr id="1315" name="Google Shape;1315;p22"/>
-          <p:cNvSpPr/>
-          <p:nvPr/>
-        </p:nvSpPr>
-        <p:spPr>
-          <a:xfrm>
-            <a:off x="822960" y="1664208"/>
-            <a:ext cx="10515600" cy="548640"/>
-          </a:xfrm>
-          <a:prstGeom prst="roundRect">
-            <a:avLst>
-              <a:gd fmla="val 12000" name="adj"/>
+              <a:gd name="adj" fmla="val 12000"/>
             </a:avLst>
           </a:prstGeom>
           <a:solidFill>
@@ -4886,126 +3801,49 @@
           </a:ln>
         </p:spPr>
         <p:txBody>
-          <a:bodyPr anchorCtr="0" anchor="ctr" bIns="0" lIns="182875" spcFirstLastPara="1" rIns="182875" wrap="square" tIns="0">
+          <a:bodyPr wrap="square" lIns="0" tIns="0" rIns="0" bIns="0" anchor="t">
             <a:noAutofit/>
           </a:bodyPr>
           <a:lstStyle/>
           <a:p>
-            <a:pPr indent="0" lvl="0" marL="0" marR="0" rtl="0" algn="l">
-              <a:lnSpc>
-                <a:spcPct val="100000"/>
-              </a:lnSpc>
-              <a:spcBef>
-                <a:spcPts val="0"/>
-              </a:spcBef>
-              <a:spcAft>
-                <a:spcPts val="0"/>
-              </a:spcAft>
-              <a:buNone/>
-            </a:pPr>
-            <a:r>
-              <a:rPr lang="en-US" sz="1250" b="1" i="0" dirty="0">
-                <a:solidFill>
-                  <a:srgbClr val="0B6E4F"/>
-                </a:solidFill>
-                <a:latin typeface="Calibri"/>
-                <a:cs typeface="Calibri"/>
-              </a:rPr>
-              <a:t xml:space="preserve">FIRST, VALIDATORS IN THE LOOP   </a:t>
-            </a:r>
-            <a:r>
-              <a:rPr lang="en-US" sz="1250" b="0" i="0" dirty="0">
-                <a:solidFill>
-                  <a:srgbClr val="3A434C"/>
-                </a:solidFill>
-                <a:latin typeface="Calibri"/>
-                <a:cs typeface="Calibri"/>
-              </a:rPr>
-              <a:t xml:space="preserve">Syntax, consistency and pitfall checks feed back to the Gen-LLM, as in </a:t>
-            </a:r>
-            <a:r>
-              <a:rPr lang="en-US" sz="1250" b="1" i="0" dirty="0">
-                <a:solidFill>
-                  <a:srgbClr val="1F2328"/>
-                </a:solidFill>
-                <a:latin typeface="Calibri"/>
-                <a:cs typeface="Calibri"/>
-              </a:rPr>
-              <a:t xml:space="preserve">NeOn-GPT</a:t>
-            </a:r>
-            <a:r>
-              <a:rPr lang="en-US" sz="1250" b="0" i="0" dirty="0">
-                <a:solidFill>
-                  <a:srgbClr val="5B6770"/>
-                </a:solidFill>
-                <a:latin typeface="Calibri"/>
-                <a:cs typeface="Calibri"/>
-              </a:rPr>
-              <a:t xml:space="preserve"> [Fathallah et al., ESWC 2024] and </a:t>
-            </a:r>
-            <a:r>
-              <a:rPr lang="en-US" sz="1250" b="1" i="0" dirty="0">
-                <a:solidFill>
-                  <a:srgbClr val="1F2328"/>
-                </a:solidFill>
-                <a:latin typeface="Calibri"/>
-                <a:cs typeface="Calibri"/>
-              </a:rPr>
-              <a:t xml:space="preserve">Extended NeOn-GPT</a:t>
-            </a:r>
-            <a:r>
-              <a:rPr lang="en-US" sz="1250" b="0" i="0" dirty="0">
-                <a:solidFill>
-                  <a:srgbClr val="5B6770"/>
-                </a:solidFill>
-                <a:latin typeface="Calibri"/>
-                <a:cs typeface="Calibri"/>
-              </a:rPr>
-              <a:t xml:space="preserve"> [Fathallah et al., SWJ 2026]. </a:t>
-            </a:r>
-            <a:r>
-              <a:rPr lang="en-US" sz="1250" b="0" i="0" dirty="0">
-                <a:solidFill>
-                  <a:srgbClr val="3A434C"/>
-                </a:solidFill>
-                <a:latin typeface="Calibri"/>
-                <a:cs typeface="Calibri"/>
-              </a:rPr>
-              <a:t xml:space="preserve">Now running in the </a:t>
-            </a:r>
-            <a:r>
-              <a:rPr lang="en-US" sz="1250" b="1" i="0" dirty="0">
-                <a:solidFill>
-                  <a:srgbClr val="1F2328"/>
-                </a:solidFill>
-                <a:latin typeface="Calibri"/>
-                <a:cs typeface="Calibri"/>
-              </a:rPr>
-              <a:t xml:space="preserve">RIGOR App</a:t>
-            </a:r>
-            <a:r>
-              <a:rPr lang="en-US" sz="1250" b="0" i="0" dirty="0">
-                <a:solidFill>
-                  <a:srgbClr val="5B6770"/>
-                </a:solidFill>
-                <a:latin typeface="Calibri"/>
-                <a:cs typeface="Calibri"/>
-              </a:rPr>
-              <a:t xml:space="preserve"> [Fathallah, Nayyeri &amp; Staab, ISWC 2026 Demos].</a:t>
-            </a:r>
-          </a:p>
-        </p:txBody>
-      </p:sp>
-      <p:sp>
-        <p:nvSpPr>
-          <p:cNvPr id="1316" name="Google Shape;1316;p22"/>
+            <a:pPr algn="l"/>
+          </a:p>
+        </p:txBody>
+      </p:sp>
+      <p:pic>
+        <p:nvPicPr>
+          <p:cNvPr id="1292" name="Icon" descr="Graph validation icon"/>
+          <p:cNvPicPr>
+            <a:picLocks noChangeAspect="1"/>
+          </p:cNvPicPr>
+          <p:nvPr/>
+        </p:nvPicPr>
+        <p:blipFill>
+          <a:blip r:embed="rIdIcon"/>
+          <a:stretch>
+            <a:fillRect/>
+          </a:stretch>
+        </p:blipFill>
+        <p:spPr>
+          <a:xfrm>
+            <a:off x="932688" y="1700784"/>
+            <a:ext cx="457200" cy="457200"/>
+          </a:xfrm>
+          <a:prstGeom prst="rect">
+            <a:avLst/>
+          </a:prstGeom>
+        </p:spPr>
+      </p:pic>
+      <p:sp>
+        <p:nvSpPr>
+          <p:cNvPr id="1293" name="Loop text"/>
           <p:cNvSpPr txBox="1"/>
           <p:nvPr/>
         </p:nvSpPr>
         <p:spPr>
           <a:xfrm>
-            <a:off x="850392" y="6419088"/>
-            <a:ext cx="10488300" cy="237600"/>
+            <a:off x="1481328" y="1645920"/>
+            <a:ext cx="9784080" cy="566928"/>
           </a:xfrm>
           <a:prstGeom prst="rect">
             <a:avLst/>
@@ -5016,49 +3854,257 @@
           </a:ln>
         </p:spPr>
         <p:txBody>
-          <a:bodyPr anchorCtr="0" anchor="t" bIns="0" lIns="0" spcFirstLastPara="1" rIns="0" wrap="square" tIns="0">
+          <a:bodyPr wrap="square" lIns="0" tIns="0" rIns="0" bIns="0" anchor="ctr">
             <a:noAutofit/>
           </a:bodyPr>
           <a:lstStyle/>
           <a:p>
-            <a:pPr indent="0" lvl="0" marL="0" marR="0" rtl="0" algn="l">
-              <a:lnSpc>
-                <a:spcPct val="100000"/>
-              </a:lnSpc>
-              <a:spcBef>
-                <a:spcPts val="0"/>
-              </a:spcBef>
-              <a:spcAft>
-                <a:spcPts val="0"/>
-              </a:spcAft>
-              <a:buNone/>
-            </a:pPr>
-            <a:r>
-              <a:rPr b="0" i="0" lang="en-US" sz="1050" u="none" cap="none" strike="noStrike">
-                <a:solidFill>
-                  <a:srgbClr val="5B6770"/>
+            <a:pPr algn="l"/>
+            <a:r>
+              <a:rPr lang="en-US" sz="1250" b="1" i="0" dirty="0">
+                <a:solidFill>
+                  <a:srgbClr val="0B6E4F"/>
                 </a:solidFill>
                 <a:latin typeface="Calibri"/>
-                <a:ea typeface="Calibri"/>
                 <a:cs typeface="Calibri"/>
-                <a:sym typeface="Calibri"/>
-              </a:rPr>
-              <a:t>Instance rows are synthetic. Future directions follow paper Section 5 (instance-level signals, tool feedback, symbolic reasoning).</a:t>
-            </a:r>
-            <a:endParaRPr/>
-          </a:p>
-        </p:txBody>
-      </p:sp>
-      <p:sp>
-        <p:nvSpPr>
-          <p:cNvPr id="1317" name="Table treatment"/>
+              </a:rPr>
+              <a:t xml:space="preserve">FIRST, MOVE THE EVALUATION TOOLS INTO THE LOOP   </a:t>
+            </a:r>
+            <a:r>
+              <a:rPr lang="en-US" sz="1250" b="0" i="0" dirty="0">
+                <a:solidFill>
+                  <a:srgbClr val="3A434C"/>
+                </a:solidFill>
+                <a:latin typeface="Calibri"/>
+                <a:cs typeface="Calibri"/>
+              </a:rPr>
+              <a:t xml:space="preserve">OOPS! and the reasoner only checked our final ontologies. Next, they flag each error while RIGOR builds, so the generator fixes it before merging.  </a:t>
+            </a:r>
+            <a:r>
+              <a:rPr lang="en-US" sz="1250" b="1" i="1" dirty="0">
+                <a:solidFill>
+                  <a:srgbClr val="1F2328"/>
+                </a:solidFill>
+                <a:latin typeface="Calibri"/>
+                <a:cs typeface="Calibri"/>
+              </a:rPr>
+              <a:t xml:space="preserve">Live in our RIGOR App demo.</a:t>
+            </a:r>
+          </a:p>
+        </p:txBody>
+      </p:sp>
+      <p:sp>
+        <p:nvSpPr>
+          <p:cNvPr id="1294" name="Data lead"/>
+          <p:cNvSpPr txBox="1"/>
+          <p:nvPr/>
+        </p:nvSpPr>
+        <p:spPr>
+          <a:xfrm>
+            <a:off x="822960" y="2340864"/>
+            <a:ext cx="10515600" cy="310896"/>
+          </a:xfrm>
+          <a:prstGeom prst="rect">
+            <a:avLst/>
+          </a:prstGeom>
+          <a:noFill/>
+          <a:ln>
+            <a:noFill/>
+          </a:ln>
+        </p:spPr>
+        <p:txBody>
+          <a:bodyPr wrap="square" lIns="0" tIns="0" rIns="0" bIns="0" anchor="ctr">
+            <a:noAutofit/>
+          </a:bodyPr>
+          <a:lstStyle/>
+          <a:p>
+            <a:pPr algn="l"/>
+            <a:r>
+              <a:rPr lang="en-US" sz="1300" b="1" i="0" dirty="0">
+                <a:solidFill>
+                  <a:srgbClr val="0B6E4F"/>
+                </a:solidFill>
+                <a:latin typeface="Calibri"/>
+                <a:cs typeface="Calibri"/>
+              </a:rPr>
+              <a:t xml:space="preserve">THEN, LET THE DATA SPEAK   </a:t>
+            </a:r>
+            <a:r>
+              <a:rPr lang="en-US" sz="1450" b="0" i="0" dirty="0">
+                <a:solidFill>
+                  <a:srgbClr val="3A434C"/>
+                </a:solidFill>
+                <a:latin typeface="Calibri"/>
+                <a:cs typeface="Calibri"/>
+              </a:rPr>
+              <a:t xml:space="preserve">When documentation is missing, instance data can explain </a:t>
+            </a:r>
+            <a:r>
+              <a:rPr lang="en-US" sz="1450" b="1" i="0" dirty="0">
+                <a:solidFill>
+                  <a:srgbClr val="1F2328"/>
+                </a:solidFill>
+                <a:latin typeface="Calibri"/>
+                <a:cs typeface="Calibri"/>
+              </a:rPr>
+              <a:t xml:space="preserve">cryptic columns</a:t>
+            </a:r>
+            <a:r>
+              <a:rPr lang="en-US" sz="1450" b="0" i="0" dirty="0">
+                <a:solidFill>
+                  <a:srgbClr val="3A434C"/>
+                </a:solidFill>
+                <a:latin typeface="Calibri"/>
+                <a:cs typeface="Calibri"/>
+              </a:rPr>
+              <a:t xml:space="preserve">.</a:t>
+            </a:r>
+          </a:p>
+        </p:txBody>
+      </p:sp>
+      <p:sp>
+        <p:nvSpPr>
+          <p:cNvPr id="1295" name="Card"/>
           <p:cNvSpPr/>
           <p:nvPr/>
         </p:nvSpPr>
         <p:spPr>
           <a:xfrm>
-            <a:off x="987552" y="3511296"/>
-            <a:ext cx="2688216" cy="1120140"/>
+            <a:off x="804672" y="2743200"/>
+            <a:ext cx="3246120" cy="3246120"/>
+          </a:xfrm>
+          <a:prstGeom prst="roundRect">
+            <a:avLst>
+              <a:gd name="adj" fmla="val 12000"/>
+            </a:avLst>
+          </a:prstGeom>
+          <a:solidFill>
+            <a:srgbClr val="FFFFFF"/>
+          </a:solidFill>
+          <a:ln w="9525">
+            <a:solidFill>
+              <a:srgbClr val="D9DEDB"/>
+            </a:solidFill>
+          </a:ln>
+        </p:spPr>
+        <p:txBody>
+          <a:bodyPr wrap="square" lIns="0" tIns="0" rIns="0" bIns="0" anchor="t">
+            <a:noAutofit/>
+          </a:bodyPr>
+          <a:lstStyle/>
+          <a:p>
+            <a:pPr algn="l"/>
+          </a:p>
+        </p:txBody>
+      </p:sp>
+      <p:sp>
+        <p:nvSpPr>
+          <p:cNvPr id="1296" name="Card label"/>
+          <p:cNvSpPr txBox="1"/>
+          <p:nvPr/>
+        </p:nvSpPr>
+        <p:spPr>
+          <a:xfrm>
+            <a:off x="1033271" y="2907792"/>
+            <a:ext cx="2788920" cy="274320"/>
+          </a:xfrm>
+          <a:prstGeom prst="rect">
+            <a:avLst/>
+          </a:prstGeom>
+          <a:noFill/>
+          <a:ln>
+            <a:noFill/>
+          </a:ln>
+        </p:spPr>
+        <p:txBody>
+          <a:bodyPr wrap="square" lIns="0" tIns="0" rIns="0" bIns="0" anchor="t">
+            <a:noAutofit/>
+          </a:bodyPr>
+          <a:lstStyle/>
+          <a:p>
+            <a:pPr algn="l"/>
+            <a:r>
+              <a:rPr lang="en-US" sz="1300" b="1" i="0" dirty="0">
+                <a:solidFill>
+                  <a:srgbClr val="2F6B78"/>
+                </a:solidFill>
+                <a:latin typeface="Consolas"/>
+                <a:cs typeface="Consolas"/>
+              </a:rPr>
+              <a:t xml:space="preserve">1  THE DATA</a:t>
+            </a:r>
+          </a:p>
+        </p:txBody>
+      </p:sp>
+      <p:sp>
+        <p:nvSpPr>
+          <p:cNvPr id="1297" name="Question"/>
+          <p:cNvSpPr txBox="1"/>
+          <p:nvPr/>
+        </p:nvSpPr>
+        <p:spPr>
+          <a:xfrm>
+            <a:off x="1033271" y="3182112"/>
+            <a:ext cx="2788920" cy="256032"/>
+          </a:xfrm>
+          <a:prstGeom prst="rect">
+            <a:avLst/>
+          </a:prstGeom>
+          <a:noFill/>
+          <a:ln>
+            <a:noFill/>
+          </a:ln>
+        </p:spPr>
+        <p:txBody>
+          <a:bodyPr wrap="square" lIns="0" tIns="0" rIns="0" bIns="0" anchor="t">
+            <a:noAutofit/>
+          </a:bodyPr>
+          <a:lstStyle/>
+          <a:p>
+            <a:pPr algn="l"/>
+            <a:r>
+              <a:rPr lang="en-US" sz="1250" b="0" i="1" dirty="0">
+                <a:solidFill>
+                  <a:srgbClr val="3A434C"/>
+                </a:solidFill>
+                <a:latin typeface="Calibri"/>
+                <a:cs typeface="Calibri"/>
+              </a:rPr>
+              <a:t xml:space="preserve">What does </a:t>
+            </a:r>
+            <a:r>
+              <a:rPr lang="en-US" sz="1250" b="1" i="0" dirty="0">
+                <a:solidFill>
+                  <a:srgbClr val="93600F"/>
+                </a:solidFill>
+                <a:latin typeface="Consolas"/>
+                <a:cs typeface="Consolas"/>
+              </a:rPr>
+              <a:t xml:space="preserve">BM_DEP</a:t>
+            </a:r>
+            <a:r>
+              <a:rPr lang="en-US" sz="1250" b="0" i="1" dirty="0">
+                <a:solidFill>
+                  <a:srgbClr val="3A434C"/>
+                </a:solidFill>
+                <a:latin typeface="Calibri"/>
+                <a:cs typeface="Calibri"/>
+              </a:rPr>
+              <a:t xml:space="preserve"> mean?</a:t>
+            </a:r>
+          </a:p>
+        </p:txBody>
+      </p:sp>
+      <p:sp>
+        <p:nvSpPr>
+          <p:cNvPr id="1298" name="Table treatment"/>
+          <p:cNvSpPr/>
+          <p:nvPr/>
+        </p:nvSpPr>
+        <p:spPr>
+          <a:xfrm>
+            <a:off x="941832" y="3493008"/>
+            <a:ext cx="2971800" cy="1120140"/>
           </a:xfrm>
           <a:prstGeom prst="roundRect">
             <a:avLst>
@@ -5091,14 +4137,14 @@
       </p:sp>
       <p:sp>
         <p:nvSpPr>
-          <p:cNvPr id="1318" name="Table name"/>
+          <p:cNvPr id="1299" name="Table name"/>
           <p:cNvSpPr txBox="1"/>
           <p:nvPr/>
         </p:nvSpPr>
         <p:spPr>
           <a:xfrm>
-            <a:off x="1124712" y="3538728"/>
-            <a:ext cx="2413896" cy="246888"/>
+            <a:off x="1078992" y="3520439"/>
+            <a:ext cx="2697480" cy="246888"/>
           </a:xfrm>
           <a:prstGeom prst="rect">
             <a:avLst/>
@@ -5130,14 +4176,14 @@
       </p:sp>
       <p:sp>
         <p:nvSpPr>
-          <p:cNvPr id="1319" name="Rule"/>
+          <p:cNvPr id="1300" name="Rule"/>
           <p:cNvSpPr/>
           <p:nvPr/>
         </p:nvSpPr>
         <p:spPr>
           <a:xfrm>
-            <a:off x="1124712" y="3803904"/>
-            <a:ext cx="2413896" cy="10972"/>
+            <a:off x="1078992" y="3785615"/>
+            <a:ext cx="2697480" cy="10972"/>
           </a:xfrm>
           <a:prstGeom prst="rect">
             <a:avLst/>
@@ -5161,13 +4207,13 @@
       </p:sp>
       <p:sp>
         <p:nvSpPr>
-          <p:cNvPr id="1320" name="Column"/>
+          <p:cNvPr id="1301" name="Column"/>
           <p:cNvSpPr txBox="1"/>
           <p:nvPr/>
         </p:nvSpPr>
         <p:spPr>
           <a:xfrm>
-            <a:off x="1124712" y="3831335"/>
+            <a:off x="1078992" y="3813048"/>
             <a:ext cx="1051560" cy="182880"/>
           </a:xfrm>
           <a:prstGeom prst="rect">
@@ -5210,14 +4256,14 @@
       </p:sp>
       <p:sp>
         <p:nvSpPr>
-          <p:cNvPr id="1321" name="Column"/>
+          <p:cNvPr id="1302" name="Column"/>
           <p:cNvSpPr txBox="1"/>
           <p:nvPr/>
         </p:nvSpPr>
         <p:spPr>
           <a:xfrm>
-            <a:off x="2176272" y="3831335"/>
-            <a:ext cx="1508760" cy="182880"/>
+            <a:off x="2130552" y="3813048"/>
+            <a:ext cx="1463040" cy="182880"/>
           </a:xfrm>
           <a:prstGeom prst="rect">
             <a:avLst/>
@@ -5249,14 +4295,14 @@
       </p:sp>
       <p:sp>
         <p:nvSpPr>
-          <p:cNvPr id="1322" name="Row band"/>
+          <p:cNvPr id="1303" name="Row band"/>
           <p:cNvSpPr/>
           <p:nvPr/>
         </p:nvSpPr>
         <p:spPr>
           <a:xfrm>
-            <a:off x="1060704" y="4023359"/>
-            <a:ext cx="2541912" cy="173736"/>
+            <a:off x="1014984" y="4005072"/>
+            <a:ext cx="2825496" cy="173736"/>
           </a:xfrm>
           <a:prstGeom prst="rect">
             <a:avLst/>
@@ -5280,13 +4326,13 @@
       </p:sp>
       <p:sp>
         <p:nvSpPr>
-          <p:cNvPr id="1323" name="Cell"/>
+          <p:cNvPr id="1304" name="Cell"/>
           <p:cNvSpPr txBox="1"/>
           <p:nvPr/>
         </p:nvSpPr>
         <p:spPr>
           <a:xfrm>
-            <a:off x="1124712" y="4023359"/>
+            <a:off x="1078992" y="4005072"/>
             <a:ext cx="1051560" cy="173736"/>
           </a:xfrm>
           <a:prstGeom prst="rect">
@@ -5319,14 +4365,14 @@
       </p:sp>
       <p:sp>
         <p:nvSpPr>
-          <p:cNvPr id="1324" name="Cell"/>
+          <p:cNvPr id="1305" name="Cell"/>
           <p:cNvSpPr txBox="1"/>
           <p:nvPr/>
         </p:nvSpPr>
         <p:spPr>
           <a:xfrm>
-            <a:off x="2176272" y="4023359"/>
-            <a:ext cx="1508760" cy="173736"/>
+            <a:off x="2130552" y="4005072"/>
+            <a:ext cx="1463040" cy="173736"/>
           </a:xfrm>
           <a:prstGeom prst="rect">
             <a:avLst/>
@@ -5358,13 +4404,13 @@
       </p:sp>
       <p:sp>
         <p:nvSpPr>
-          <p:cNvPr id="1325" name="Cell"/>
+          <p:cNvPr id="1306" name="Cell"/>
           <p:cNvSpPr txBox="1"/>
           <p:nvPr/>
         </p:nvSpPr>
         <p:spPr>
           <a:xfrm>
-            <a:off x="1124712" y="4210812"/>
+            <a:off x="1078992" y="4192524"/>
             <a:ext cx="1051560" cy="173736"/>
           </a:xfrm>
           <a:prstGeom prst="rect">
@@ -5397,14 +4443,14 @@
       </p:sp>
       <p:sp>
         <p:nvSpPr>
-          <p:cNvPr id="1326" name="Cell"/>
+          <p:cNvPr id="1307" name="Cell"/>
           <p:cNvSpPr txBox="1"/>
           <p:nvPr/>
         </p:nvSpPr>
         <p:spPr>
           <a:xfrm>
-            <a:off x="2176272" y="4210812"/>
-            <a:ext cx="1508760" cy="173736"/>
+            <a:off x="2130552" y="4192524"/>
+            <a:ext cx="1463040" cy="173736"/>
           </a:xfrm>
           <a:prstGeom prst="rect">
             <a:avLst/>
@@ -5436,14 +4482,14 @@
       </p:sp>
       <p:sp>
         <p:nvSpPr>
-          <p:cNvPr id="1327" name="Row band"/>
+          <p:cNvPr id="1308" name="Row band"/>
           <p:cNvSpPr/>
           <p:nvPr/>
         </p:nvSpPr>
         <p:spPr>
           <a:xfrm>
-            <a:off x="1060704" y="4398264"/>
-            <a:ext cx="2541912" cy="173736"/>
+            <a:off x="1014984" y="4379976"/>
+            <a:ext cx="2825496" cy="173736"/>
           </a:xfrm>
           <a:prstGeom prst="rect">
             <a:avLst/>
@@ -5467,13 +4513,13 @@
       </p:sp>
       <p:sp>
         <p:nvSpPr>
-          <p:cNvPr id="1328" name="Cell"/>
+          <p:cNvPr id="1309" name="Cell"/>
           <p:cNvSpPr txBox="1"/>
           <p:nvPr/>
         </p:nvSpPr>
         <p:spPr>
           <a:xfrm>
-            <a:off x="1124712" y="4398264"/>
+            <a:off x="1078992" y="4379976"/>
             <a:ext cx="1051560" cy="173736"/>
           </a:xfrm>
           <a:prstGeom prst="rect">
@@ -5506,14 +4552,14 @@
       </p:sp>
       <p:sp>
         <p:nvSpPr>
-          <p:cNvPr id="1329" name="Cell"/>
+          <p:cNvPr id="1310" name="Cell"/>
           <p:cNvSpPr txBox="1"/>
           <p:nvPr/>
         </p:nvSpPr>
         <p:spPr>
           <a:xfrm>
-            <a:off x="2176272" y="4398264"/>
-            <a:ext cx="1508760" cy="173736"/>
+            <a:off x="2130552" y="4379976"/>
+            <a:ext cx="1463040" cy="173736"/>
           </a:xfrm>
           <a:prstGeom prst="rect">
             <a:avLst/>
@@ -5545,14 +4591,14 @@
       </p:sp>
       <p:sp>
         <p:nvSpPr>
-          <p:cNvPr id="1330" name="Table admission"/>
+          <p:cNvPr id="1311" name="Table admission"/>
           <p:cNvSpPr/>
           <p:nvPr/>
         </p:nvSpPr>
         <p:spPr>
           <a:xfrm>
-            <a:off x="987552" y="4722876"/>
-            <a:ext cx="2688216" cy="1120140"/>
+            <a:off x="941832" y="4704588"/>
+            <a:ext cx="2971800" cy="1120140"/>
           </a:xfrm>
           <a:prstGeom prst="roundRect">
             <a:avLst>
@@ -5585,14 +4631,14 @@
       </p:sp>
       <p:sp>
         <p:nvSpPr>
-          <p:cNvPr id="1331" name="Table name"/>
+          <p:cNvPr id="1312" name="Table name"/>
           <p:cNvSpPr txBox="1"/>
           <p:nvPr/>
         </p:nvSpPr>
         <p:spPr>
           <a:xfrm>
-            <a:off x="1124712" y="4750308"/>
-            <a:ext cx="2413896" cy="246888"/>
+            <a:off x="1078992" y="4732020"/>
+            <a:ext cx="2697480" cy="246888"/>
           </a:xfrm>
           <a:prstGeom prst="rect">
             <a:avLst/>
@@ -5624,14 +4670,14 @@
       </p:sp>
       <p:sp>
         <p:nvSpPr>
-          <p:cNvPr id="1332" name="Rule"/>
+          <p:cNvPr id="1313" name="Rule"/>
           <p:cNvSpPr/>
           <p:nvPr/>
         </p:nvSpPr>
         <p:spPr>
           <a:xfrm>
-            <a:off x="1124712" y="5015484"/>
-            <a:ext cx="2413896" cy="10972"/>
+            <a:off x="1078992" y="4997196"/>
+            <a:ext cx="2697480" cy="10972"/>
           </a:xfrm>
           <a:prstGeom prst="rect">
             <a:avLst/>
@@ -5655,13 +4701,13 @@
       </p:sp>
       <p:sp>
         <p:nvSpPr>
-          <p:cNvPr id="1333" name="Column"/>
+          <p:cNvPr id="1314" name="Column"/>
           <p:cNvSpPr txBox="1"/>
           <p:nvPr/>
         </p:nvSpPr>
         <p:spPr>
           <a:xfrm>
-            <a:off x="1124712" y="5042916"/>
+            <a:off x="1078992" y="5024627"/>
             <a:ext cx="1051560" cy="182880"/>
           </a:xfrm>
           <a:prstGeom prst="rect">
@@ -5694,13 +4740,13 @@
       </p:sp>
       <p:sp>
         <p:nvSpPr>
-          <p:cNvPr id="1334" name="Column"/>
+          <p:cNvPr id="1315" name="Column"/>
           <p:cNvSpPr txBox="1"/>
           <p:nvPr/>
         </p:nvSpPr>
         <p:spPr>
           <a:xfrm>
-            <a:off x="2176272" y="5042916"/>
+            <a:off x="2130552" y="5024627"/>
             <a:ext cx="868680" cy="182880"/>
           </a:xfrm>
           <a:prstGeom prst="rect">
@@ -5733,14 +4779,14 @@
       </p:sp>
       <p:sp>
         <p:nvSpPr>
-          <p:cNvPr id="1335" name="Column"/>
+          <p:cNvPr id="1316" name="Column"/>
           <p:cNvSpPr txBox="1"/>
           <p:nvPr/>
         </p:nvSpPr>
         <p:spPr>
           <a:xfrm>
-            <a:off x="3044952" y="5042916"/>
-            <a:ext cx="640080" cy="182880"/>
+            <a:off x="2999232" y="5024627"/>
+            <a:ext cx="731520" cy="182880"/>
           </a:xfrm>
           <a:prstGeom prst="rect">
             <a:avLst/>
@@ -5772,14 +4818,55 @@
       </p:sp>
       <p:sp>
         <p:nvSpPr>
-          <p:cNvPr id="1336" name="Row band"/>
+          <p:cNvPr id="1317" name="Question"/>
           <p:cNvSpPr/>
           <p:nvPr/>
         </p:nvSpPr>
         <p:spPr>
           <a:xfrm>
-            <a:off x="1060704" y="5234940"/>
-            <a:ext cx="2541912" cy="173736"/>
+            <a:off x="3529584" y="5015483"/>
+            <a:ext cx="201168" cy="201168"/>
+          </a:xfrm>
+          <a:prstGeom prst="ellipse">
+            <a:avLst/>
+          </a:prstGeom>
+          <a:solidFill>
+            <a:srgbClr val="93600F"/>
+          </a:solidFill>
+          <a:ln>
+            <a:noFill/>
+          </a:ln>
+        </p:spPr>
+        <p:txBody>
+          <a:bodyPr wrap="square" lIns="0" tIns="0" rIns="0" bIns="0" anchor="ctr">
+            <a:noAutofit/>
+          </a:bodyPr>
+          <a:lstStyle/>
+          <a:p>
+            <a:pPr algn="ctr"/>
+            <a:r>
+              <a:rPr lang="en-US" sz="1100" b="1" i="0" dirty="0">
+                <a:solidFill>
+                  <a:srgbClr val="FFFFFF"/>
+                </a:solidFill>
+                <a:latin typeface="Calibri"/>
+                <a:cs typeface="Calibri"/>
+              </a:rPr>
+              <a:t xml:space="preserve">?</a:t>
+            </a:r>
+          </a:p>
+        </p:txBody>
+      </p:sp>
+      <p:sp>
+        <p:nvSpPr>
+          <p:cNvPr id="1318" name="Row band"/>
+          <p:cNvSpPr/>
+          <p:nvPr/>
+        </p:nvSpPr>
+        <p:spPr>
+          <a:xfrm>
+            <a:off x="1014984" y="5216652"/>
+            <a:ext cx="2825496" cy="173736"/>
           </a:xfrm>
           <a:prstGeom prst="rect">
             <a:avLst/>
@@ -5803,13 +4890,13 @@
       </p:sp>
       <p:sp>
         <p:nvSpPr>
-          <p:cNvPr id="1337" name="Cell"/>
+          <p:cNvPr id="1319" name="Cell"/>
           <p:cNvSpPr txBox="1"/>
           <p:nvPr/>
         </p:nvSpPr>
         <p:spPr>
           <a:xfrm>
-            <a:off x="1124712" y="5234940"/>
+            <a:off x="1078992" y="5216652"/>
             <a:ext cx="1051560" cy="173736"/>
           </a:xfrm>
           <a:prstGeom prst="rect">
@@ -5842,13 +4929,13 @@
       </p:sp>
       <p:sp>
         <p:nvSpPr>
-          <p:cNvPr id="1338" name="Cell"/>
+          <p:cNvPr id="1320" name="Cell"/>
           <p:cNvSpPr txBox="1"/>
           <p:nvPr/>
         </p:nvSpPr>
         <p:spPr>
           <a:xfrm>
-            <a:off x="2176272" y="5234940"/>
+            <a:off x="2130552" y="5216652"/>
             <a:ext cx="868680" cy="173736"/>
           </a:xfrm>
           <a:prstGeom prst="rect">
@@ -5881,14 +4968,14 @@
       </p:sp>
       <p:sp>
         <p:nvSpPr>
-          <p:cNvPr id="1339" name="Cell"/>
+          <p:cNvPr id="1321" name="Cell"/>
           <p:cNvSpPr txBox="1"/>
           <p:nvPr/>
         </p:nvSpPr>
         <p:spPr>
           <a:xfrm>
-            <a:off x="3044952" y="5234940"/>
-            <a:ext cx="640080" cy="173736"/>
+            <a:off x="2999232" y="5216652"/>
+            <a:ext cx="731520" cy="173736"/>
           </a:xfrm>
           <a:prstGeom prst="rect">
             <a:avLst/>
@@ -5920,13 +5007,13 @@
       </p:sp>
       <p:sp>
         <p:nvSpPr>
-          <p:cNvPr id="1340" name="Cell"/>
+          <p:cNvPr id="1322" name="Cell"/>
           <p:cNvSpPr txBox="1"/>
           <p:nvPr/>
         </p:nvSpPr>
         <p:spPr>
           <a:xfrm>
-            <a:off x="1124712" y="5422392"/>
+            <a:off x="1078992" y="5404104"/>
             <a:ext cx="1051560" cy="173736"/>
           </a:xfrm>
           <a:prstGeom prst="rect">
@@ -5959,13 +5046,13 @@
       </p:sp>
       <p:sp>
         <p:nvSpPr>
-          <p:cNvPr id="1341" name="Cell"/>
+          <p:cNvPr id="1323" name="Cell"/>
           <p:cNvSpPr txBox="1"/>
           <p:nvPr/>
         </p:nvSpPr>
         <p:spPr>
           <a:xfrm>
-            <a:off x="2176272" y="5422392"/>
+            <a:off x="2130552" y="5404104"/>
             <a:ext cx="868680" cy="173736"/>
           </a:xfrm>
           <a:prstGeom prst="rect">
@@ -5998,14 +5085,14 @@
       </p:sp>
       <p:sp>
         <p:nvSpPr>
-          <p:cNvPr id="1342" name="Cell"/>
+          <p:cNvPr id="1324" name="Cell"/>
           <p:cNvSpPr txBox="1"/>
           <p:nvPr/>
         </p:nvSpPr>
         <p:spPr>
           <a:xfrm>
-            <a:off x="3044952" y="5422392"/>
-            <a:ext cx="640080" cy="173736"/>
+            <a:off x="2999232" y="5404104"/>
+            <a:ext cx="731520" cy="173736"/>
           </a:xfrm>
           <a:prstGeom prst="rect">
             <a:avLst/>
@@ -6037,14 +5124,14 @@
       </p:sp>
       <p:sp>
         <p:nvSpPr>
-          <p:cNvPr id="1343" name="Row band"/>
+          <p:cNvPr id="1325" name="Row band"/>
           <p:cNvSpPr/>
           <p:nvPr/>
         </p:nvSpPr>
         <p:spPr>
           <a:xfrm>
-            <a:off x="1060704" y="5609844"/>
-            <a:ext cx="2541912" cy="173736"/>
+            <a:off x="1014984" y="5591556"/>
+            <a:ext cx="2825496" cy="173736"/>
           </a:xfrm>
           <a:prstGeom prst="rect">
             <a:avLst/>
@@ -6068,13 +5155,13 @@
       </p:sp>
       <p:sp>
         <p:nvSpPr>
-          <p:cNvPr id="1344" name="Cell"/>
+          <p:cNvPr id="1326" name="Cell"/>
           <p:cNvSpPr txBox="1"/>
           <p:nvPr/>
         </p:nvSpPr>
         <p:spPr>
           <a:xfrm>
-            <a:off x="1124712" y="5609844"/>
+            <a:off x="1078992" y="5591556"/>
             <a:ext cx="1051560" cy="173736"/>
           </a:xfrm>
           <a:prstGeom prst="rect">
@@ -6107,13 +5194,13 @@
       </p:sp>
       <p:sp>
         <p:nvSpPr>
-          <p:cNvPr id="1345" name="Cell"/>
+          <p:cNvPr id="1327" name="Cell"/>
           <p:cNvSpPr txBox="1"/>
           <p:nvPr/>
         </p:nvSpPr>
         <p:spPr>
           <a:xfrm>
-            <a:off x="2176272" y="5609844"/>
+            <a:off x="2130552" y="5591556"/>
             <a:ext cx="868680" cy="173736"/>
           </a:xfrm>
           <a:prstGeom prst="rect">
@@ -6146,14 +5233,14 @@
       </p:sp>
       <p:sp>
         <p:nvSpPr>
-          <p:cNvPr id="1346" name="Cell"/>
+          <p:cNvPr id="1328" name="Cell"/>
           <p:cNvSpPr txBox="1"/>
           <p:nvPr/>
         </p:nvSpPr>
         <p:spPr>
           <a:xfrm>
-            <a:off x="3044952" y="5609844"/>
-            <a:ext cx="640080" cy="173736"/>
+            <a:off x="2999232" y="5591556"/>
+            <a:ext cx="731520" cy="173736"/>
           </a:xfrm>
           <a:prstGeom prst="rect">
             <a:avLst/>
@@ -6185,14 +5272,49 @@
       </p:sp>
       <p:sp>
         <p:nvSpPr>
-          <p:cNvPr id="1347" name="Bridge"/>
+          <p:cNvPr id="1329" name="Card"/>
+          <p:cNvSpPr/>
+          <p:nvPr/>
+        </p:nvSpPr>
+        <p:spPr>
+          <a:xfrm>
+            <a:off x="4379976" y="2743200"/>
+            <a:ext cx="3154680" cy="3246120"/>
+          </a:xfrm>
+          <a:prstGeom prst="roundRect">
+            <a:avLst>
+              <a:gd name="adj" fmla="val 12000"/>
+            </a:avLst>
+          </a:prstGeom>
+          <a:solidFill>
+            <a:srgbClr val="FFFFFF"/>
+          </a:solidFill>
+          <a:ln w="9525">
+            <a:solidFill>
+              <a:srgbClr val="D9DEDB"/>
+            </a:solidFill>
+          </a:ln>
+        </p:spPr>
+        <p:txBody>
+          <a:bodyPr wrap="square" lIns="0" tIns="0" rIns="0" bIns="0" anchor="t">
+            <a:noAutofit/>
+          </a:bodyPr>
+          <a:lstStyle/>
+          <a:p>
+            <a:pPr algn="l"/>
+          </a:p>
+        </p:txBody>
+      </p:sp>
+      <p:sp>
+        <p:nvSpPr>
+          <p:cNvPr id="1330" name="Card label"/>
           <p:cNvSpPr txBox="1"/>
           <p:nvPr/>
         </p:nvSpPr>
         <p:spPr>
           <a:xfrm>
-            <a:off x="4425696" y="5093208"/>
-            <a:ext cx="2423040" cy="566928"/>
+            <a:off x="4608576" y="2907792"/>
+            <a:ext cx="2697480" cy="274320"/>
           </a:xfrm>
           <a:prstGeom prst="rect">
             <a:avLst/>
@@ -6210,28 +5332,648 @@
           <a:p>
             <a:pPr algn="l"/>
             <a:r>
-              <a:rPr lang="en-US" sz="1200" b="0" i="0" dirty="0">
-                <a:solidFill>
-                  <a:srgbClr val="3A434C"/>
+              <a:rPr lang="en-US" sz="1300" b="1" i="0" dirty="0">
+                <a:solidFill>
+                  <a:srgbClr val="2F6B78"/>
+                </a:solidFill>
+                <a:latin typeface="Consolas"/>
+                <a:cs typeface="Consolas"/>
+              </a:rPr>
+              <a:t xml:space="preserve">2  THE CLUES</a:t>
+            </a:r>
+          </a:p>
+        </p:txBody>
+      </p:sp>
+      <p:sp>
+        <p:nvSpPr>
+          <p:cNvPr id="1331" name="Clue"/>
+          <p:cNvSpPr/>
+          <p:nvPr/>
+        </p:nvSpPr>
+        <p:spPr>
+          <a:xfrm>
+            <a:off x="4517136" y="3310128"/>
+            <a:ext cx="2880360" cy="1188720"/>
+          </a:xfrm>
+          <a:prstGeom prst="roundRect">
+            <a:avLst>
+              <a:gd name="adj" fmla="val 12000"/>
+            </a:avLst>
+          </a:prstGeom>
+          <a:solidFill>
+            <a:srgbClr val="F6F8FA"/>
+          </a:solidFill>
+          <a:ln w="9525">
+            <a:solidFill>
+              <a:srgbClr val="D9DEDB"/>
+            </a:solidFill>
+          </a:ln>
+        </p:spPr>
+        <p:txBody>
+          <a:bodyPr wrap="square" lIns="0" tIns="0" rIns="0" bIns="0" anchor="t">
+            <a:noAutofit/>
+          </a:bodyPr>
+          <a:lstStyle/>
+          <a:p>
+            <a:pPr algn="l"/>
+          </a:p>
+        </p:txBody>
+      </p:sp>
+      <p:sp>
+        <p:nvSpPr>
+          <p:cNvPr id="1332" name="Magnifier ring"/>
+          <p:cNvSpPr/>
+          <p:nvPr/>
+        </p:nvSpPr>
+        <p:spPr>
+          <a:xfrm>
+            <a:off x="4636008" y="3438144"/>
+            <a:ext cx="223845" cy="223845"/>
+          </a:xfrm>
+          <a:prstGeom prst="ellipse">
+            <a:avLst/>
+          </a:prstGeom>
+          <a:solidFill>
+            <a:srgbClr val="FFFFFF"/>
+          </a:solidFill>
+          <a:ln w="28575">
+            <a:solidFill>
+              <a:srgbClr val="0B6E4F"/>
+            </a:solidFill>
+          </a:ln>
+        </p:spPr>
+      </p:sp>
+      <p:sp>
+        <p:nvSpPr>
+          <p:cNvPr id="1333" name="Magnifier handle"/>
+          <p:cNvSpPr/>
+          <p:nvPr/>
+        </p:nvSpPr>
+        <p:spPr>
+          <a:xfrm rot="-2700000">
+            <a:off x="4828763" y="3599809"/>
+            <a:ext cx="37307" cy="124358"/>
+          </a:xfrm>
+          <a:prstGeom prst="roundRect">
+            <a:avLst/>
+          </a:prstGeom>
+          <a:solidFill>
+            <a:srgbClr val="0B6E4F"/>
+          </a:solidFill>
+          <a:ln>
+            <a:noFill/>
+          </a:ln>
+        </p:spPr>
+      </p:sp>
+      <p:sp>
+        <p:nvSpPr>
+          <p:cNvPr id="1334" name="Clue head"/>
+          <p:cNvSpPr txBox="1"/>
+          <p:nvPr/>
+        </p:nvSpPr>
+        <p:spPr>
+          <a:xfrm>
+            <a:off x="5038344" y="3401568"/>
+            <a:ext cx="2240280" cy="457200"/>
+          </a:xfrm>
+          <a:prstGeom prst="rect">
+            <a:avLst/>
+          </a:prstGeom>
+          <a:noFill/>
+          <a:ln>
+            <a:noFill/>
+          </a:ln>
+        </p:spPr>
+        <p:txBody>
+          <a:bodyPr wrap="square" lIns="0" tIns="0" rIns="0" bIns="0" anchor="ctr">
+            <a:noAutofit/>
+          </a:bodyPr>
+          <a:lstStyle/>
+          <a:p>
+            <a:pPr algn="l"/>
+            <a:r>
+              <a:rPr lang="en-US" sz="1400" b="1" i="0" dirty="0">
+                <a:solidFill>
+                  <a:srgbClr val="1F2328"/>
                 </a:solidFill>
                 <a:latin typeface="Calibri"/>
                 <a:cs typeface="Calibri"/>
               </a:rPr>
-              <a:t xml:space="preserve">Data and label point the same way: a link worth checking.</a:t>
-            </a:r>
-          </a:p>
-        </p:txBody>
-      </p:sp>
-      <p:sp>
-        <p:nvSpPr>
-          <p:cNvPr id="1348" name="Code panel"/>
+              <a:t xml:space="preserve">Only 0 and 1</a:t>
+            </a:r>
+          </a:p>
+        </p:txBody>
+      </p:sp>
+      <p:sp>
+        <p:nvSpPr>
+          <p:cNvPr id="1335" name="Clue body"/>
+          <p:cNvSpPr txBox="1"/>
+          <p:nvPr/>
+        </p:nvSpPr>
+        <p:spPr>
+          <a:xfrm>
+            <a:off x="4654296" y="3913632"/>
+            <a:ext cx="2011680" cy="530352"/>
+          </a:xfrm>
+          <a:prstGeom prst="rect">
+            <a:avLst/>
+          </a:prstGeom>
+          <a:noFill/>
+          <a:ln>
+            <a:noFill/>
+          </a:ln>
+        </p:spPr>
+        <p:txBody>
+          <a:bodyPr wrap="square" lIns="0" tIns="0" rIns="0" bIns="0" anchor="t">
+            <a:noAutofit/>
+          </a:bodyPr>
+          <a:lstStyle/>
+          <a:p>
+            <a:pPr algn="l"/>
+            <a:r>
+              <a:rPr lang="en-US" sz="1200" b="0" i="0" dirty="0">
+                <a:solidFill>
+                  <a:srgbClr val="3A434C"/>
+                </a:solidFill>
+                <a:latin typeface="Calibri"/>
+                <a:cs typeface="Calibri"/>
+              </a:rPr>
+              <a:t xml:space="preserve">A yes/no flag, not a score.</a:t>
+            </a:r>
+          </a:p>
+        </p:txBody>
+      </p:sp>
+      <p:sp>
+        <p:nvSpPr>
+          <p:cNvPr id="1336" name="Value bar"/>
           <p:cNvSpPr/>
           <p:nvPr/>
         </p:nvSpPr>
         <p:spPr>
           <a:xfrm>
-            <a:off x="7534656" y="3566160"/>
-            <a:ext cx="3666780" cy="1883664"/>
+            <a:off x="6757416" y="4151376"/>
+            <a:ext cx="182880" cy="182880"/>
+          </a:xfrm>
+          <a:prstGeom prst="rect">
+            <a:avLst/>
+          </a:prstGeom>
+          <a:solidFill>
+            <a:srgbClr val="9AA3A9"/>
+          </a:solidFill>
+          <a:ln>
+            <a:noFill/>
+          </a:ln>
+        </p:spPr>
+        <p:txBody>
+          <a:bodyPr wrap="square" lIns="0" tIns="0" rIns="0" bIns="0" anchor="t">
+            <a:noAutofit/>
+          </a:bodyPr>
+          <a:lstStyle/>
+          <a:p>
+            <a:pPr algn="l"/>
+          </a:p>
+        </p:txBody>
+      </p:sp>
+      <p:sp>
+        <p:nvSpPr>
+          <p:cNvPr id="1337" name="Value label"/>
+          <p:cNvSpPr txBox="1"/>
+          <p:nvPr/>
+        </p:nvSpPr>
+        <p:spPr>
+          <a:xfrm>
+            <a:off x="6711696" y="4343400"/>
+            <a:ext cx="274320" cy="146304"/>
+          </a:xfrm>
+          <a:prstGeom prst="rect">
+            <a:avLst/>
+          </a:prstGeom>
+          <a:noFill/>
+          <a:ln>
+            <a:noFill/>
+          </a:ln>
+        </p:spPr>
+        <p:txBody>
+          <a:bodyPr wrap="square" lIns="0" tIns="0" rIns="0" bIns="0" anchor="t">
+            <a:noAutofit/>
+          </a:bodyPr>
+          <a:lstStyle/>
+          <a:p>
+            <a:pPr algn="ctr"/>
+            <a:r>
+              <a:rPr lang="en-US" sz="900" b="0" i="0" dirty="0">
+                <a:solidFill>
+                  <a:srgbClr val="5B6770"/>
+                </a:solidFill>
+                <a:latin typeface="Consolas"/>
+                <a:cs typeface="Consolas"/>
+              </a:rPr>
+              <a:t xml:space="preserve">0</a:t>
+            </a:r>
+          </a:p>
+        </p:txBody>
+      </p:sp>
+      <p:sp>
+        <p:nvSpPr>
+          <p:cNvPr id="1338" name="Value bar"/>
+          <p:cNvSpPr/>
+          <p:nvPr/>
+        </p:nvSpPr>
+        <p:spPr>
+          <a:xfrm>
+            <a:off x="7031736" y="3968496"/>
+            <a:ext cx="182880" cy="365760"/>
+          </a:xfrm>
+          <a:prstGeom prst="rect">
+            <a:avLst/>
+          </a:prstGeom>
+          <a:solidFill>
+            <a:srgbClr val="0B6E4F"/>
+          </a:solidFill>
+          <a:ln>
+            <a:noFill/>
+          </a:ln>
+        </p:spPr>
+        <p:txBody>
+          <a:bodyPr wrap="square" lIns="0" tIns="0" rIns="0" bIns="0" anchor="t">
+            <a:noAutofit/>
+          </a:bodyPr>
+          <a:lstStyle/>
+          <a:p>
+            <a:pPr algn="l"/>
+          </a:p>
+        </p:txBody>
+      </p:sp>
+      <p:sp>
+        <p:nvSpPr>
+          <p:cNvPr id="1339" name="Value label"/>
+          <p:cNvSpPr txBox="1"/>
+          <p:nvPr/>
+        </p:nvSpPr>
+        <p:spPr>
+          <a:xfrm>
+            <a:off x="6986016" y="4343400"/>
+            <a:ext cx="274320" cy="146304"/>
+          </a:xfrm>
+          <a:prstGeom prst="rect">
+            <a:avLst/>
+          </a:prstGeom>
+          <a:noFill/>
+          <a:ln>
+            <a:noFill/>
+          </a:ln>
+        </p:spPr>
+        <p:txBody>
+          <a:bodyPr wrap="square" lIns="0" tIns="0" rIns="0" bIns="0" anchor="t">
+            <a:noAutofit/>
+          </a:bodyPr>
+          <a:lstStyle/>
+          <a:p>
+            <a:pPr algn="ctr"/>
+            <a:r>
+              <a:rPr lang="en-US" sz="900" b="0" i="0" dirty="0">
+                <a:solidFill>
+                  <a:srgbClr val="5B6770"/>
+                </a:solidFill>
+                <a:latin typeface="Consolas"/>
+                <a:cs typeface="Consolas"/>
+              </a:rPr>
+              <a:t xml:space="preserve">1</a:t>
+            </a:r>
+          </a:p>
+        </p:txBody>
+      </p:sp>
+      <p:sp>
+        <p:nvSpPr>
+          <p:cNvPr id="1340" name="Clue"/>
+          <p:cNvSpPr/>
+          <p:nvPr/>
+        </p:nvSpPr>
+        <p:spPr>
+          <a:xfrm>
+            <a:off x="4517136" y="4608576"/>
+            <a:ext cx="2880360" cy="1188720"/>
+          </a:xfrm>
+          <a:prstGeom prst="roundRect">
+            <a:avLst>
+              <a:gd name="adj" fmla="val 12000"/>
+            </a:avLst>
+          </a:prstGeom>
+          <a:solidFill>
+            <a:srgbClr val="F6F8FA"/>
+          </a:solidFill>
+          <a:ln w="9525">
+            <a:solidFill>
+              <a:srgbClr val="D9DEDB"/>
+            </a:solidFill>
+          </a:ln>
+        </p:spPr>
+        <p:txBody>
+          <a:bodyPr wrap="square" lIns="0" tIns="0" rIns="0" bIns="0" anchor="t">
+            <a:noAutofit/>
+          </a:bodyPr>
+          <a:lstStyle/>
+          <a:p>
+            <a:pPr algn="l"/>
+          </a:p>
+        </p:txBody>
+      </p:sp>
+      <p:sp>
+        <p:nvSpPr>
+          <p:cNvPr id="1341" name="Magnifier ring"/>
+          <p:cNvSpPr/>
+          <p:nvPr/>
+        </p:nvSpPr>
+        <p:spPr>
+          <a:xfrm>
+            <a:off x="4636008" y="4736592"/>
+            <a:ext cx="223845" cy="223845"/>
+          </a:xfrm>
+          <a:prstGeom prst="ellipse">
+            <a:avLst/>
+          </a:prstGeom>
+          <a:solidFill>
+            <a:srgbClr val="FFFFFF"/>
+          </a:solidFill>
+          <a:ln w="28575">
+            <a:solidFill>
+              <a:srgbClr val="0B6E4F"/>
+            </a:solidFill>
+          </a:ln>
+        </p:spPr>
+      </p:sp>
+      <p:sp>
+        <p:nvSpPr>
+          <p:cNvPr id="1342" name="Magnifier handle"/>
+          <p:cNvSpPr/>
+          <p:nvPr/>
+        </p:nvSpPr>
+        <p:spPr>
+          <a:xfrm rot="-2700000">
+            <a:off x="4828763" y="4898257"/>
+            <a:ext cx="37307" cy="124358"/>
+          </a:xfrm>
+          <a:prstGeom prst="roundRect">
+            <a:avLst/>
+          </a:prstGeom>
+          <a:solidFill>
+            <a:srgbClr val="0B6E4F"/>
+          </a:solidFill>
+          <a:ln>
+            <a:noFill/>
+          </a:ln>
+        </p:spPr>
+      </p:sp>
+      <p:sp>
+        <p:nvSpPr>
+          <p:cNvPr id="1343" name="Clue head"/>
+          <p:cNvSpPr txBox="1"/>
+          <p:nvPr/>
+        </p:nvSpPr>
+        <p:spPr>
+          <a:xfrm>
+            <a:off x="5038344" y="4700016"/>
+            <a:ext cx="2240280" cy="457200"/>
+          </a:xfrm>
+          <a:prstGeom prst="rect">
+            <a:avLst/>
+          </a:prstGeom>
+          <a:noFill/>
+          <a:ln>
+            <a:noFill/>
+          </a:ln>
+        </p:spPr>
+        <p:txBody>
+          <a:bodyPr wrap="square" lIns="0" tIns="0" rIns="0" bIns="0" anchor="ctr">
+            <a:noAutofit/>
+          </a:bodyPr>
+          <a:lstStyle/>
+          <a:p>
+            <a:pPr algn="l"/>
+            <a:r>
+              <a:rPr lang="en-US" sz="1400" b="1" i="0" dirty="0">
+                <a:solidFill>
+                  <a:srgbClr val="1F2328"/>
+                </a:solidFill>
+                <a:latin typeface="Calibri"/>
+                <a:cs typeface="Calibri"/>
+              </a:rPr>
+              <a:t xml:space="preserve">1 exactly when cisplatin was given</a:t>
+            </a:r>
+          </a:p>
+        </p:txBody>
+      </p:sp>
+      <p:sp>
+        <p:nvSpPr>
+          <p:cNvPr id="1344" name="Clue body"/>
+          <p:cNvSpPr txBox="1"/>
+          <p:nvPr/>
+        </p:nvSpPr>
+        <p:spPr>
+          <a:xfrm>
+            <a:off x="4654296" y="5212080"/>
+            <a:ext cx="2606040" cy="530352"/>
+          </a:xfrm>
+          <a:prstGeom prst="rect">
+            <a:avLst/>
+          </a:prstGeom>
+          <a:noFill/>
+          <a:ln>
+            <a:noFill/>
+          </a:ln>
+        </p:spPr>
+        <p:txBody>
+          <a:bodyPr wrap="square" lIns="0" tIns="0" rIns="0" bIns="0" anchor="t">
+            <a:noAutofit/>
+          </a:bodyPr>
+          <a:lstStyle/>
+          <a:p>
+            <a:pPr algn="l"/>
+            <a:r>
+              <a:rPr lang="en-US" sz="1200" b="0" i="0" dirty="0">
+                <a:solidFill>
+                  <a:srgbClr val="3A434C"/>
+                </a:solidFill>
+                <a:latin typeface="Calibri"/>
+                <a:cs typeface="Calibri"/>
+              </a:rPr>
+              <a:t xml:space="preserve">Cisplatin is a chemotherapy known to suppress the bone marrow.</a:t>
+            </a:r>
+          </a:p>
+        </p:txBody>
+      </p:sp>
+      <p:sp>
+        <p:nvSpPr>
+          <p:cNvPr id="1345" name="Card"/>
+          <p:cNvSpPr/>
+          <p:nvPr/>
+        </p:nvSpPr>
+        <p:spPr>
+          <a:xfrm>
+            <a:off x="7863840" y="2743200"/>
+            <a:ext cx="3520440" cy="3246120"/>
+          </a:xfrm>
+          <a:prstGeom prst="roundRect">
+            <a:avLst>
+              <a:gd name="adj" fmla="val 12000"/>
+            </a:avLst>
+          </a:prstGeom>
+          <a:solidFill>
+            <a:srgbClr val="FFFFFF"/>
+          </a:solidFill>
+          <a:ln w="9525">
+            <a:solidFill>
+              <a:srgbClr val="D9DEDB"/>
+            </a:solidFill>
+          </a:ln>
+        </p:spPr>
+        <p:txBody>
+          <a:bodyPr wrap="square" lIns="0" tIns="0" rIns="0" bIns="0" anchor="t">
+            <a:noAutofit/>
+          </a:bodyPr>
+          <a:lstStyle/>
+          <a:p>
+            <a:pPr algn="l"/>
+          </a:p>
+        </p:txBody>
+      </p:sp>
+      <p:sp>
+        <p:nvSpPr>
+          <p:cNvPr id="1346" name="Card label"/>
+          <p:cNvSpPr txBox="1"/>
+          <p:nvPr/>
+        </p:nvSpPr>
+        <p:spPr>
+          <a:xfrm>
+            <a:off x="8092440" y="2907792"/>
+            <a:ext cx="3063240" cy="274320"/>
+          </a:xfrm>
+          <a:prstGeom prst="rect">
+            <a:avLst/>
+          </a:prstGeom>
+          <a:noFill/>
+          <a:ln>
+            <a:noFill/>
+          </a:ln>
+        </p:spPr>
+        <p:txBody>
+          <a:bodyPr wrap="square" lIns="0" tIns="0" rIns="0" bIns="0" anchor="t">
+            <a:noAutofit/>
+          </a:bodyPr>
+          <a:lstStyle/>
+          <a:p>
+            <a:pPr algn="l"/>
+            <a:r>
+              <a:rPr lang="en-US" sz="1300" b="1" i="0" dirty="0">
+                <a:solidFill>
+                  <a:srgbClr val="2F6B78"/>
+                </a:solidFill>
+                <a:latin typeface="Consolas"/>
+                <a:cs typeface="Consolas"/>
+              </a:rPr>
+              <a:t xml:space="preserve">3  THE ANSWER</a:t>
+            </a:r>
+          </a:p>
+        </p:txBody>
+      </p:sp>
+      <p:sp>
+        <p:nvSpPr>
+          <p:cNvPr id="1347" name="Reveal key"/>
+          <p:cNvSpPr txBox="1"/>
+          <p:nvPr/>
+        </p:nvSpPr>
+        <p:spPr>
+          <a:xfrm>
+            <a:off x="8092440" y="3310128"/>
+            <a:ext cx="3063240" cy="310896"/>
+          </a:xfrm>
+          <a:prstGeom prst="rect">
+            <a:avLst/>
+          </a:prstGeom>
+          <a:noFill/>
+          <a:ln>
+            <a:noFill/>
+          </a:ln>
+        </p:spPr>
+        <p:txBody>
+          <a:bodyPr wrap="square" lIns="0" tIns="0" rIns="0" bIns="0" anchor="t">
+            <a:noAutofit/>
+          </a:bodyPr>
+          <a:lstStyle/>
+          <a:p>
+            <a:pPr algn="l"/>
+            <a:r>
+              <a:rPr lang="en-US" sz="1700" b="1" i="0" dirty="0">
+                <a:solidFill>
+                  <a:srgbClr val="0B6E4F"/>
+                </a:solidFill>
+                <a:latin typeface="Consolas"/>
+                <a:cs typeface="Consolas"/>
+              </a:rPr>
+              <a:t xml:space="preserve">BM_DEP</a:t>
+            </a:r>
+            <a:r>
+              <a:rPr lang="en-US" sz="1700" b="0" i="0" dirty="0">
+                <a:solidFill>
+                  <a:srgbClr val="5B6770"/>
+                </a:solidFill>
+                <a:latin typeface="Calibri"/>
+                <a:cs typeface="Calibri"/>
+              </a:rPr>
+              <a:t xml:space="preserve">   →</a:t>
+            </a:r>
+          </a:p>
+        </p:txBody>
+      </p:sp>
+      <p:sp>
+        <p:nvSpPr>
+          <p:cNvPr id="1348" name="Reveal"/>
+          <p:cNvSpPr txBox="1"/>
+          <p:nvPr/>
+        </p:nvSpPr>
+        <p:spPr>
+          <a:xfrm>
+            <a:off x="8092440" y="3639312"/>
+            <a:ext cx="3063240" cy="384048"/>
+          </a:xfrm>
+          <a:prstGeom prst="rect">
+            <a:avLst/>
+          </a:prstGeom>
+          <a:noFill/>
+          <a:ln>
+            <a:noFill/>
+          </a:ln>
+        </p:spPr>
+        <p:txBody>
+          <a:bodyPr wrap="square" lIns="0" tIns="0" rIns="0" bIns="0" anchor="t">
+            <a:noAutofit/>
+          </a:bodyPr>
+          <a:lstStyle/>
+          <a:p>
+            <a:pPr algn="l"/>
+            <a:r>
+              <a:rPr lang="en-US" sz="2000" b="1" i="0" dirty="0">
+                <a:solidFill>
+                  <a:srgbClr val="1F2328"/>
+                </a:solidFill>
+                <a:latin typeface="Cambria"/>
+                <a:cs typeface="Cambria"/>
+              </a:rPr>
+              <a:t xml:space="preserve">Bone marrow depression</a:t>
+            </a:r>
+          </a:p>
+        </p:txBody>
+      </p:sp>
+      <p:sp>
+        <p:nvSpPr>
+          <p:cNvPr id="1349" name="Code panel"/>
+          <p:cNvSpPr/>
+          <p:nvPr/>
+        </p:nvSpPr>
+        <p:spPr>
+          <a:xfrm>
+            <a:off x="8001000" y="4160520"/>
+            <a:ext cx="3246120" cy="1170432"/>
           </a:xfrm>
           <a:prstGeom prst="roundRect">
             <a:avLst>
@@ -6259,14 +6001,14 @@
       </p:sp>
       <p:sp>
         <p:nvSpPr>
-          <p:cNvPr id="1349" name="Code line 1349"/>
+          <p:cNvPr id="1350" name="Code line 1350"/>
           <p:cNvSpPr txBox="1"/>
           <p:nvPr/>
         </p:nvSpPr>
         <p:spPr>
           <a:xfrm>
-            <a:off x="7534656" y="3639312"/>
-            <a:ext cx="3621060" cy="173736"/>
+            <a:off x="8001000" y="4224528"/>
+            <a:ext cx="3200400" cy="173736"/>
           </a:xfrm>
           <a:prstGeom prst="rect">
             <a:avLst/>
@@ -6285,17 +6027,17 @@
               </a:tabLst>
             </a:pPr>
             <a:r>
-              <a:rPr lang="en-US" sz="1050" b="1" i="0" dirty="0">
+              <a:rPr lang="en-US" sz="1000" b="1" i="0" dirty="0">
                 <a:solidFill>
                   <a:srgbClr val="0B6E4F"/>
                 </a:solidFill>
                 <a:latin typeface="Consolas"/>
                 <a:cs typeface="Consolas"/>
               </a:rPr>
-              <a:t xml:space="preserve">Individual:</a:t>
-            </a:r>
-            <a:r>
-              <a:rPr lang="en-US" sz="1050" b="0" i="0" dirty="0">
+              <a:t xml:space="preserve">DataProperty:</a:t>
+            </a:r>
+            <a:r>
+              <a:rPr lang="en-US" sz="1000" b="0" i="0" dirty="0">
                 <a:solidFill>
                   <a:srgbClr val="1F2328"/>
                 </a:solidFill>
@@ -6305,29 +6047,29 @@
               <a:t xml:space="preserve"> </a:t>
             </a:r>
             <a:r>
-              <a:rPr lang="en-US" sz="1050" b="0" i="0" dirty="0">
+              <a:rPr lang="en-US" sz="1000" b="0" i="0" dirty="0">
                 <a:solidFill>
                   <a:srgbClr val="1F2328"/>
                 </a:solidFill>
                 <a:latin typeface="Consolas"/>
                 <a:cs typeface="Consolas"/>
               </a:rPr>
-              <a:t xml:space="preserve">cisplatin_bmdep</a:t>
-            </a:r>
-            <a:endParaRPr lang="en-US" sz="1050"/>
-          </a:p>
-        </p:txBody>
-      </p:sp>
-      <p:sp>
-        <p:nvSpPr>
-          <p:cNvPr id="1350" name="Code line 1350"/>
+              <a:t xml:space="preserve">BM_DEP</a:t>
+            </a:r>
+            <a:endParaRPr lang="en-US" sz="1000"/>
+          </a:p>
+        </p:txBody>
+      </p:sp>
+      <p:sp>
+        <p:nvSpPr>
+          <p:cNvPr id="1351" name="Code line 1351"/>
           <p:cNvSpPr txBox="1"/>
           <p:nvPr/>
         </p:nvSpPr>
         <p:spPr>
           <a:xfrm>
-            <a:off x="7534656" y="3813048"/>
-            <a:ext cx="3621060" cy="173736"/>
+            <a:off x="8001000" y="4398264"/>
+            <a:ext cx="3200400" cy="173736"/>
           </a:xfrm>
           <a:prstGeom prst="rect">
             <a:avLst/>
@@ -6346,7 +6088,7 @@
               </a:tabLst>
             </a:pPr>
             <a:r>
-              <a:rPr lang="en-US" sz="1050" b="0" i="0" dirty="0">
+              <a:rPr lang="en-US" sz="1000" b="0" i="0" dirty="0">
                 <a:solidFill>
                   <a:srgbClr val="1F2328"/>
                 </a:solidFill>
@@ -6356,49 +6098,29 @@
               <a:t xml:space="preserve">  </a:t>
             </a:r>
             <a:r>
-              <a:rPr lang="en-US" sz="1050" b="1" i="0" dirty="0">
+              <a:rPr lang="en-US" sz="1000" b="1" i="0" dirty="0">
                 <a:solidFill>
                   <a:srgbClr val="0B6E4F"/>
                 </a:solidFill>
                 <a:latin typeface="Consolas"/>
                 <a:cs typeface="Consolas"/>
               </a:rPr>
-              <a:t xml:space="preserve">Types:</a:t>
-            </a:r>
-            <a:r>
-              <a:rPr lang="en-US" sz="1050" b="0" i="0" dirty="0">
-                <a:solidFill>
-                  <a:srgbClr val="1F2328"/>
-                </a:solidFill>
-                <a:latin typeface="Consolas"/>
-                <a:cs typeface="Consolas"/>
-              </a:rPr>
-              <a:t xml:space="preserve"> </a:t>
-            </a:r>
-            <a:r>
-              <a:rPr lang="en-US" sz="1050" b="0" i="0" dirty="0">
-                <a:solidFill>
-                  <a:srgbClr val="1F2328"/>
-                </a:solidFill>
-                <a:latin typeface="Consolas"/>
-                <a:cs typeface="Consolas"/>
-              </a:rPr>
-              <a:t xml:space="preserve">CandidateAssociation</a:t>
-            </a:r>
-            <a:endParaRPr lang="en-US" sz="1050"/>
-          </a:p>
-        </p:txBody>
-      </p:sp>
-      <p:sp>
-        <p:nvSpPr>
-          <p:cNvPr id="1351" name="Code line 1351"/>
+              <a:t xml:space="preserve">Annotations:</a:t>
+            </a:r>
+            <a:endParaRPr lang="en-US" sz="1000"/>
+          </a:p>
+        </p:txBody>
+      </p:sp>
+      <p:sp>
+        <p:nvSpPr>
+          <p:cNvPr id="1352" name="Code line 1352"/>
           <p:cNvSpPr txBox="1"/>
           <p:nvPr/>
         </p:nvSpPr>
         <p:spPr>
           <a:xfrm>
-            <a:off x="7534656" y="3986784"/>
-            <a:ext cx="3621060" cy="173736"/>
+            <a:off x="8001000" y="4572000"/>
+            <a:ext cx="3200400" cy="173736"/>
           </a:xfrm>
           <a:prstGeom prst="rect">
             <a:avLst/>
@@ -6417,39 +6139,69 @@
               </a:tabLst>
             </a:pPr>
             <a:r>
-              <a:rPr lang="en-US" sz="1050" b="0" i="0" dirty="0">
+              <a:rPr lang="en-US" sz="1000" b="0" i="0" dirty="0">
                 <a:solidFill>
                   <a:srgbClr val="1F2328"/>
                 </a:solidFill>
                 <a:latin typeface="Consolas"/>
                 <a:cs typeface="Consolas"/>
               </a:rPr>
-              <a:t xml:space="preserve">  </a:t>
-            </a:r>
-            <a:r>
-              <a:rPr lang="en-US" sz="1050" b="1" i="0" dirty="0">
-                <a:solidFill>
-                  <a:srgbClr val="0B6E4F"/>
+              <a:t xml:space="preserve">    </a:t>
+            </a:r>
+            <a:r>
+              <a:rPr lang="en-US" sz="1000" b="0" i="0" dirty="0">
+                <a:solidFill>
+                  <a:srgbClr val="5B6770"/>
                 </a:solidFill>
                 <a:latin typeface="Consolas"/>
                 <a:cs typeface="Consolas"/>
               </a:rPr>
-              <a:t xml:space="preserve">Facts:</a:t>
-            </a:r>
-            <a:endParaRPr lang="en-US" sz="1050"/>
-          </a:p>
-        </p:txBody>
-      </p:sp>
-      <p:sp>
-        <p:nvSpPr>
-          <p:cNvPr id="1352" name="Code line 1352"/>
+              <a:t xml:space="preserve">rdfs:label</a:t>
+            </a:r>
+            <a:r>
+              <a:rPr lang="en-US" sz="1000" b="0" i="0" dirty="0">
+                <a:solidFill>
+                  <a:srgbClr val="1F2328"/>
+                </a:solidFill>
+                <a:latin typeface="Consolas"/>
+                <a:cs typeface="Consolas"/>
+              </a:rPr>
+              <a:t xml:space="preserve"> </a:t>
+            </a:r>
+            <a:r>
+              <a:rPr lang="en-US" sz="1000" b="0" i="0" dirty="0">
+                <a:solidFill>
+                  <a:srgbClr val="A3401E"/>
+                </a:solidFill>
+                <a:latin typeface="Consolas"/>
+                <a:cs typeface="Consolas"/>
+              </a:rPr>
+              <a:t xml:space="preserve">"Bone marrow depression"@en</a:t>
+            </a:r>
+            <a:r>
+              <a:rPr lang="en-US" sz="1000" b="0" i="0" dirty="0">
+                <a:solidFill>
+                  <a:srgbClr val="1F2328"/>
+                </a:solidFill>
+                <a:latin typeface="Consolas"/>
+                <a:cs typeface="Consolas"/>
+              </a:rPr>
+              <a:t xml:space="preserve">,</a:t>
+            </a:r>
+            <a:endParaRPr lang="en-US" sz="1000"/>
+          </a:p>
+        </p:txBody>
+      </p:sp>
+      <p:sp>
+        <p:nvSpPr>
+          <p:cNvPr id="1353" name="Code line 1353"/>
           <p:cNvSpPr txBox="1"/>
           <p:nvPr/>
         </p:nvSpPr>
         <p:spPr>
           <a:xfrm>
-            <a:off x="7534656" y="4160518"/>
-            <a:ext cx="3621060" cy="173736"/>
+            <a:off x="8001000" y="4745736"/>
+            <a:ext cx="3200400" cy="173736"/>
           </a:xfrm>
           <a:prstGeom prst="rect">
             <a:avLst/>
@@ -6468,7 +6220,7 @@
               </a:tabLst>
             </a:pPr>
             <a:r>
-              <a:rPr lang="en-US" sz="1050" b="0" i="0" dirty="0">
+              <a:rPr lang="en-US" sz="1000" b="0" i="0" dirty="0">
                 <a:solidFill>
                   <a:srgbClr val="1F2328"/>
                 </a:solidFill>
@@ -6478,17 +6230,17 @@
               <a:t xml:space="preserve">    </a:t>
             </a:r>
             <a:r>
-              <a:rPr lang="en-US" sz="1050" b="0" i="0" dirty="0">
-                <a:solidFill>
-                  <a:srgbClr val="1F2328"/>
+              <a:rPr lang="en-US" sz="1000" b="0" i="0" dirty="0">
+                <a:solidFill>
+                  <a:srgbClr val="5B6770"/>
                 </a:solidFill>
                 <a:latin typeface="Consolas"/>
                 <a:cs typeface="Consolas"/>
               </a:rPr>
-              <a:t xml:space="preserve">hasDrug</a:t>
-            </a:r>
-            <a:r>
-              <a:rPr lang="en-US" sz="1050" b="0" i="0" dirty="0">
+              <a:t xml:space="preserve">rdfs:comment</a:t>
+            </a:r>
+            <a:r>
+              <a:rPr lang="en-US" sz="1000" b="0" i="0" dirty="0">
                 <a:solidFill>
                   <a:srgbClr val="1F2328"/>
                 </a:solidFill>
@@ -6498,17 +6250,17 @@
               <a:t xml:space="preserve"> </a:t>
             </a:r>
             <a:r>
-              <a:rPr lang="en-US" sz="1050" b="0" i="0" dirty="0">
-                <a:solidFill>
-                  <a:srgbClr val="1F2328"/>
+              <a:rPr lang="en-US" sz="1000" b="0" i="0" dirty="0">
+                <a:solidFill>
+                  <a:srgbClr val="A3401E"/>
                 </a:solidFill>
                 <a:latin typeface="Consolas"/>
                 <a:cs typeface="Consolas"/>
               </a:rPr>
-              <a:t xml:space="preserve">Cisplatin</a:t>
-            </a:r>
-            <a:r>
-              <a:rPr lang="en-US" sz="1050" b="0" i="0" dirty="0">
+              <a:t xml:space="preserve">"1 = yes, 0 = no"@en</a:t>
+            </a:r>
+            <a:r>
+              <a:rPr lang="en-US" sz="1000" b="0" i="0" dirty="0">
                 <a:solidFill>
                   <a:srgbClr val="1F2328"/>
                 </a:solidFill>
@@ -6517,20 +6269,20 @@
               </a:rPr>
               <a:t xml:space="preserve">,</a:t>
             </a:r>
-            <a:endParaRPr lang="en-US" sz="1050"/>
-          </a:p>
-        </p:txBody>
-      </p:sp>
-      <p:sp>
-        <p:nvSpPr>
-          <p:cNvPr id="1353" name="Code line 1353"/>
+            <a:endParaRPr lang="en-US" sz="1000"/>
+          </a:p>
+        </p:txBody>
+      </p:sp>
+      <p:sp>
+        <p:nvSpPr>
+          <p:cNvPr id="1354" name="Code line 1354"/>
           <p:cNvSpPr txBox="1"/>
           <p:nvPr/>
         </p:nvSpPr>
         <p:spPr>
           <a:xfrm>
-            <a:off x="7534656" y="4334256"/>
-            <a:ext cx="3621060" cy="173736"/>
+            <a:off x="8001000" y="4919472"/>
+            <a:ext cx="3200400" cy="173736"/>
           </a:xfrm>
           <a:prstGeom prst="rect">
             <a:avLst/>
@@ -6549,7 +6301,7 @@
               </a:tabLst>
             </a:pPr>
             <a:r>
-              <a:rPr lang="en-US" sz="1050" b="0" i="0" dirty="0">
+              <a:rPr lang="en-US" sz="1000" b="0" i="0" dirty="0">
                 <a:solidFill>
                   <a:srgbClr val="1F2328"/>
                 </a:solidFill>
@@ -6559,17 +6311,17 @@
               <a:t xml:space="preserve">    </a:t>
             </a:r>
             <a:r>
-              <a:rPr lang="en-US" sz="1050" b="0" i="0" dirty="0">
-                <a:solidFill>
-                  <a:srgbClr val="1F2328"/>
+              <a:rPr lang="en-US" sz="1000" b="0" i="0" dirty="0">
+                <a:solidFill>
+                  <a:srgbClr val="5B6770"/>
                 </a:solidFill>
                 <a:latin typeface="Consolas"/>
                 <a:cs typeface="Consolas"/>
               </a:rPr>
-              <a:t xml:space="preserve">hasCondition</a:t>
-            </a:r>
-            <a:r>
-              <a:rPr lang="en-US" sz="1050" b="0" i="0" dirty="0">
+              <a:t xml:space="preserve">prov:wasDerivedFrom</a:t>
+            </a:r>
+            <a:r>
+              <a:rPr lang="en-US" sz="1000" b="0" i="0" dirty="0">
                 <a:solidFill>
                   <a:srgbClr val="1F2328"/>
                 </a:solidFill>
@@ -6579,17 +6331,17 @@
               <a:t xml:space="preserve"> </a:t>
             </a:r>
             <a:r>
-              <a:rPr lang="en-US" sz="1050" b="0" i="0" dirty="0">
-                <a:solidFill>
-                  <a:srgbClr val="1F2328"/>
+              <a:rPr lang="en-US" sz="1000" b="0" i="0" dirty="0">
+                <a:solidFill>
+                  <a:srgbClr val="2F6B78"/>
                 </a:solidFill>
                 <a:latin typeface="Consolas"/>
                 <a:cs typeface="Consolas"/>
               </a:rPr>
-              <a:t xml:space="preserve">BoneMarrowDepression</a:t>
-            </a:r>
-            <a:r>
-              <a:rPr lang="en-US" sz="1050" b="0" i="0" dirty="0">
+              <a:t xml:space="preserve">admission:BM_DEP</a:t>
+            </a:r>
+            <a:r>
+              <a:rPr lang="en-US" sz="1000" b="0" i="0" dirty="0">
                 <a:solidFill>
                   <a:srgbClr val="1F2328"/>
                 </a:solidFill>
@@ -6598,20 +6350,20 @@
               </a:rPr>
               <a:t xml:space="preserve">,</a:t>
             </a:r>
-            <a:endParaRPr lang="en-US" sz="1050"/>
-          </a:p>
-        </p:txBody>
-      </p:sp>
-      <p:sp>
-        <p:nvSpPr>
-          <p:cNvPr id="1354" name="Code line 1354"/>
+            <a:endParaRPr lang="en-US" sz="1000"/>
+          </a:p>
+        </p:txBody>
+      </p:sp>
+      <p:sp>
+        <p:nvSpPr>
+          <p:cNvPr id="1355" name="Code line 1355"/>
           <p:cNvSpPr txBox="1"/>
           <p:nvPr/>
         </p:nvSpPr>
         <p:spPr>
           <a:xfrm>
-            <a:off x="7534656" y="4507991"/>
-            <a:ext cx="3621060" cy="173736"/>
+            <a:off x="8001000" y="5093208"/>
+            <a:ext cx="3200400" cy="173736"/>
           </a:xfrm>
           <a:prstGeom prst="rect">
             <a:avLst/>
@@ -6630,7 +6382,7 @@
               </a:tabLst>
             </a:pPr>
             <a:r>
-              <a:rPr lang="en-US" sz="1050" b="0" i="0" dirty="0">
+              <a:rPr lang="en-US" sz="1000" b="0" i="0" dirty="0">
                 <a:solidFill>
                   <a:srgbClr val="1F2328"/>
                 </a:solidFill>
@@ -6640,17 +6392,17 @@
               <a:t xml:space="preserve">    </a:t>
             </a:r>
             <a:r>
-              <a:rPr lang="en-US" sz="1050" b="0" i="0" dirty="0">
-                <a:solidFill>
-                  <a:srgbClr val="1F2328"/>
+              <a:rPr lang="en-US" sz="1000" b="0" i="0" dirty="0">
+                <a:solidFill>
+                  <a:srgbClr val="5B6770"/>
                 </a:solidFill>
                 <a:latin typeface="Consolas"/>
                 <a:cs typeface="Consolas"/>
               </a:rPr>
-              <a:t xml:space="preserve">status</a:t>
-            </a:r>
-            <a:r>
-              <a:rPr lang="en-US" sz="1050" b="0" i="0" dirty="0">
+              <a:t xml:space="preserve">prov:wasDerivedFrom</a:t>
+            </a:r>
+            <a:r>
+              <a:rPr lang="en-US" sz="1000" b="0" i="0" dirty="0">
                 <a:solidFill>
                   <a:srgbClr val="1F2328"/>
                 </a:solidFill>
@@ -6660,313 +6412,126 @@
               <a:t xml:space="preserve"> </a:t>
             </a:r>
             <a:r>
-              <a:rPr lang="en-US" sz="1050" b="0" i="0" dirty="0">
-                <a:solidFill>
-                  <a:srgbClr val="A3401E"/>
+              <a:rPr lang="en-US" sz="1000" b="0" i="0" dirty="0">
+                <a:solidFill>
+                  <a:srgbClr val="2F6B78"/>
                 </a:solidFill>
                 <a:latin typeface="Consolas"/>
                 <a:cs typeface="Consolas"/>
               </a:rPr>
-              <a:t xml:space="preserve">"needs expert review"</a:t>
-            </a:r>
-            <a:endParaRPr lang="en-US" sz="1050"/>
-          </a:p>
-        </p:txBody>
-      </p:sp>
-      <p:sp>
-        <p:nvSpPr>
-          <p:cNvPr id="1355" name="Code line 1355"/>
+              <a:t xml:space="preserve">treatment:drug</a:t>
+            </a:r>
+            <a:endParaRPr lang="en-US" sz="1000"/>
+          </a:p>
+        </p:txBody>
+      </p:sp>
+      <p:sp>
+        <p:nvSpPr>
+          <p:cNvPr id="1356" name="Candidate"/>
+          <p:cNvSpPr/>
+          <p:nvPr/>
+        </p:nvSpPr>
+        <p:spPr>
+          <a:xfrm>
+            <a:off x="8001000" y="5413248"/>
+            <a:ext cx="3246120" cy="420624"/>
+          </a:xfrm>
+          <a:prstGeom prst="roundRect">
+            <a:avLst>
+              <a:gd name="adj" fmla="val 12000"/>
+            </a:avLst>
+          </a:prstGeom>
+          <a:solidFill>
+            <a:srgbClr val="FFF7E8"/>
+          </a:solidFill>
+          <a:ln>
+            <a:noFill/>
+          </a:ln>
+        </p:spPr>
+        <p:txBody>
+          <a:bodyPr wrap="square" lIns="0" tIns="0" rIns="0" bIns="0" anchor="ctr">
+            <a:noAutofit/>
+          </a:bodyPr>
+          <a:lstStyle/>
+          <a:p>
+            <a:pPr algn="ctr"/>
+            <a:r>
+              <a:rPr lang="en-US" sz="1150" b="1" i="0" dirty="0">
+                <a:solidFill>
+                  <a:srgbClr val="93600F"/>
+                </a:solidFill>
+                <a:latin typeface="Consolas"/>
+                <a:cs typeface="Consolas"/>
+              </a:rPr>
+              <a:t xml:space="preserve">CANDIDATE  </a:t>
+            </a:r>
+            <a:r>
+              <a:rPr lang="en-US" sz="1200" b="0" i="0" dirty="0">
+                <a:solidFill>
+                  <a:srgbClr val="3A434C"/>
+                </a:solidFill>
+                <a:latin typeface="Calibri"/>
+                <a:cs typeface="Calibri"/>
+              </a:rPr>
+              <a:t xml:space="preserve">an expert confirms it first</a:t>
+            </a:r>
+          </a:p>
+        </p:txBody>
+      </p:sp>
+      <p:sp>
+        <p:nvSpPr>
+          <p:cNvPr id="1357" name="Arrow"/>
+          <p:cNvSpPr/>
+          <p:nvPr/>
+        </p:nvSpPr>
+        <p:spPr>
+          <a:xfrm>
+            <a:off x="4078224" y="4201668"/>
+            <a:ext cx="274320" cy="329184"/>
+          </a:xfrm>
+          <a:prstGeom prst="rightArrow">
+            <a:avLst/>
+          </a:prstGeom>
+          <a:solidFill>
+            <a:srgbClr val="0B6E4F"/>
+          </a:solidFill>
+          <a:ln>
+            <a:noFill/>
+          </a:ln>
+        </p:spPr>
+      </p:sp>
+      <p:sp>
+        <p:nvSpPr>
+          <p:cNvPr id="1358" name="Arrow"/>
+          <p:cNvSpPr/>
+          <p:nvPr/>
+        </p:nvSpPr>
+        <p:spPr>
+          <a:xfrm>
+            <a:off x="7562088" y="4201668"/>
+            <a:ext cx="274320" cy="329184"/>
+          </a:xfrm>
+          <a:prstGeom prst="rightArrow">
+            <a:avLst/>
+          </a:prstGeom>
+          <a:solidFill>
+            <a:srgbClr val="0B6E4F"/>
+          </a:solidFill>
+          <a:ln>
+            <a:noFill/>
+          </a:ln>
+        </p:spPr>
+      </p:sp>
+      <p:sp>
+        <p:nvSpPr>
+          <p:cNvPr id="1359" name="Source"/>
           <p:cNvSpPr txBox="1"/>
           <p:nvPr/>
         </p:nvSpPr>
         <p:spPr>
           <a:xfrm>
-            <a:off x="7534656" y="4681728"/>
-            <a:ext cx="3621060" cy="173736"/>
-          </a:xfrm>
-          <a:prstGeom prst="rect">
-            <a:avLst/>
-          </a:prstGeom>
-          <a:noFill/>
-        </p:spPr>
-        <p:txBody>
-          <a:bodyPr wrap="none" lIns="146304" tIns="0" rIns="0" bIns="0" anchor="ctr">
-            <a:noAutofit/>
-          </a:bodyPr>
-          <a:lstStyle/>
-          <a:p>
-            <a:pPr>
-              <a:tabLst>
-                <a:tab pos="4224528" algn="l"/>
-              </a:tabLst>
-            </a:pPr>
-            <a:r>
-              <a:rPr lang="en-US" sz="1050" b="0" i="0" dirty="0">
-                <a:solidFill>
-                  <a:srgbClr val="1F2328"/>
-                </a:solidFill>
-                <a:latin typeface="Consolas"/>
-                <a:cs typeface="Consolas"/>
-              </a:rPr>
-              <a:t xml:space="preserve">  </a:t>
-            </a:r>
-            <a:r>
-              <a:rPr lang="en-US" sz="1050" b="1" i="0" dirty="0">
-                <a:solidFill>
-                  <a:srgbClr val="0B6E4F"/>
-                </a:solidFill>
-                <a:latin typeface="Consolas"/>
-                <a:cs typeface="Consolas"/>
-              </a:rPr>
-              <a:t xml:space="preserve">Annotations:</a:t>
-            </a:r>
-            <a:endParaRPr lang="en-US" sz="1050"/>
-          </a:p>
-        </p:txBody>
-      </p:sp>
-      <p:sp>
-        <p:nvSpPr>
-          <p:cNvPr id="1356" name="Code line 1356"/>
-          <p:cNvSpPr txBox="1"/>
-          <p:nvPr/>
-        </p:nvSpPr>
-        <p:spPr>
-          <a:xfrm>
-            <a:off x="7534656" y="4855464"/>
-            <a:ext cx="3621060" cy="173736"/>
-          </a:xfrm>
-          <a:prstGeom prst="rect">
-            <a:avLst/>
-          </a:prstGeom>
-          <a:noFill/>
-        </p:spPr>
-        <p:txBody>
-          <a:bodyPr wrap="none" lIns="146304" tIns="0" rIns="0" bIns="0" anchor="ctr">
-            <a:noAutofit/>
-          </a:bodyPr>
-          <a:lstStyle/>
-          <a:p>
-            <a:pPr>
-              <a:tabLst>
-                <a:tab pos="4224528" algn="l"/>
-              </a:tabLst>
-            </a:pPr>
-            <a:r>
-              <a:rPr lang="en-US" sz="1050" b="0" i="0" dirty="0">
-                <a:solidFill>
-                  <a:srgbClr val="1F2328"/>
-                </a:solidFill>
-                <a:latin typeface="Consolas"/>
-                <a:cs typeface="Consolas"/>
-              </a:rPr>
-              <a:t xml:space="preserve">    </a:t>
-            </a:r>
-            <a:r>
-              <a:rPr lang="en-US" sz="1050" b="0" i="0" dirty="0">
-                <a:solidFill>
-                  <a:srgbClr val="5B6770"/>
-                </a:solidFill>
-                <a:latin typeface="Consolas"/>
-                <a:cs typeface="Consolas"/>
-              </a:rPr>
-              <a:t xml:space="preserve">prov:wasDerivedFrom</a:t>
-            </a:r>
-            <a:r>
-              <a:rPr lang="en-US" sz="1050" b="0" i="0" dirty="0">
-                <a:solidFill>
-                  <a:srgbClr val="1F2328"/>
-                </a:solidFill>
-                <a:latin typeface="Consolas"/>
-                <a:cs typeface="Consolas"/>
-              </a:rPr>
-              <a:t xml:space="preserve"> </a:t>
-            </a:r>
-            <a:r>
-              <a:rPr lang="en-US" sz="1050" b="0" i="0" dirty="0">
-                <a:solidFill>
-                  <a:srgbClr val="2F6B78"/>
-                </a:solidFill>
-                <a:latin typeface="Consolas"/>
-                <a:cs typeface="Consolas"/>
-              </a:rPr>
-              <a:t xml:space="preserve">admission:BM_DEP</a:t>
-            </a:r>
-            <a:r>
-              <a:rPr lang="en-US" sz="1050" b="0" i="0" dirty="0">
-                <a:solidFill>
-                  <a:srgbClr val="1F2328"/>
-                </a:solidFill>
-                <a:latin typeface="Consolas"/>
-                <a:cs typeface="Consolas"/>
-              </a:rPr>
-              <a:t xml:space="preserve">,</a:t>
-            </a:r>
-            <a:endParaRPr lang="en-US" sz="1050"/>
-          </a:p>
-        </p:txBody>
-      </p:sp>
-      <p:sp>
-        <p:nvSpPr>
-          <p:cNvPr id="1357" name="Code line 1357"/>
-          <p:cNvSpPr txBox="1"/>
-          <p:nvPr/>
-        </p:nvSpPr>
-        <p:spPr>
-          <a:xfrm>
-            <a:off x="7534656" y="5029200"/>
-            <a:ext cx="3621060" cy="173736"/>
-          </a:xfrm>
-          <a:prstGeom prst="rect">
-            <a:avLst/>
-          </a:prstGeom>
-          <a:noFill/>
-        </p:spPr>
-        <p:txBody>
-          <a:bodyPr wrap="none" lIns="146304" tIns="0" rIns="0" bIns="0" anchor="ctr">
-            <a:noAutofit/>
-          </a:bodyPr>
-          <a:lstStyle/>
-          <a:p>
-            <a:pPr>
-              <a:tabLst>
-                <a:tab pos="4224528" algn="l"/>
-              </a:tabLst>
-            </a:pPr>
-            <a:r>
-              <a:rPr lang="en-US" sz="1050" b="0" i="0" dirty="0">
-                <a:solidFill>
-                  <a:srgbClr val="1F2328"/>
-                </a:solidFill>
-                <a:latin typeface="Consolas"/>
-                <a:cs typeface="Consolas"/>
-              </a:rPr>
-              <a:t xml:space="preserve">    </a:t>
-            </a:r>
-            <a:r>
-              <a:rPr lang="en-US" sz="1050" b="0" i="0" dirty="0">
-                <a:solidFill>
-                  <a:srgbClr val="5B6770"/>
-                </a:solidFill>
-                <a:latin typeface="Consolas"/>
-                <a:cs typeface="Consolas"/>
-              </a:rPr>
-              <a:t xml:space="preserve">prov:wasDerivedFrom</a:t>
-            </a:r>
-            <a:r>
-              <a:rPr lang="en-US" sz="1050" b="0" i="0" dirty="0">
-                <a:solidFill>
-                  <a:srgbClr val="1F2328"/>
-                </a:solidFill>
-                <a:latin typeface="Consolas"/>
-                <a:cs typeface="Consolas"/>
-              </a:rPr>
-              <a:t xml:space="preserve"> </a:t>
-            </a:r>
-            <a:r>
-              <a:rPr lang="en-US" sz="1050" b="0" i="0" dirty="0">
-                <a:solidFill>
-                  <a:srgbClr val="2F6B78"/>
-                </a:solidFill>
-                <a:latin typeface="Consolas"/>
-                <a:cs typeface="Consolas"/>
-              </a:rPr>
-              <a:t xml:space="preserve">treatment:drug</a:t>
-            </a:r>
-            <a:r>
-              <a:rPr lang="en-US" sz="1050" b="0" i="0" dirty="0">
-                <a:solidFill>
-                  <a:srgbClr val="1F2328"/>
-                </a:solidFill>
-                <a:latin typeface="Consolas"/>
-                <a:cs typeface="Consolas"/>
-              </a:rPr>
-              <a:t xml:space="preserve">,</a:t>
-            </a:r>
-            <a:endParaRPr lang="en-US" sz="1050"/>
-          </a:p>
-        </p:txBody>
-      </p:sp>
-      <p:sp>
-        <p:nvSpPr>
-          <p:cNvPr id="1358" name="Code line 1358"/>
-          <p:cNvSpPr txBox="1"/>
-          <p:nvPr/>
-        </p:nvSpPr>
-        <p:spPr>
-          <a:xfrm>
-            <a:off x="7534656" y="5202936"/>
-            <a:ext cx="3621060" cy="173736"/>
-          </a:xfrm>
-          <a:prstGeom prst="rect">
-            <a:avLst/>
-          </a:prstGeom>
-          <a:noFill/>
-        </p:spPr>
-        <p:txBody>
-          <a:bodyPr wrap="none" lIns="146304" tIns="0" rIns="0" bIns="0" anchor="ctr">
-            <a:noAutofit/>
-          </a:bodyPr>
-          <a:lstStyle/>
-          <a:p>
-            <a:pPr>
-              <a:tabLst>
-                <a:tab pos="4224528" algn="l"/>
-              </a:tabLst>
-            </a:pPr>
-            <a:r>
-              <a:rPr lang="en-US" sz="1050" b="0" i="0" dirty="0">
-                <a:solidFill>
-                  <a:srgbClr val="1F2328"/>
-                </a:solidFill>
-                <a:latin typeface="Consolas"/>
-                <a:cs typeface="Consolas"/>
-              </a:rPr>
-              <a:t xml:space="preserve">    </a:t>
-            </a:r>
-            <a:r>
-              <a:rPr lang="en-US" sz="1050" b="0" i="0" dirty="0">
-                <a:solidFill>
-                  <a:srgbClr val="5B6770"/>
-                </a:solidFill>
-                <a:latin typeface="Consolas"/>
-                <a:cs typeface="Consolas"/>
-              </a:rPr>
-              <a:t xml:space="preserve">prov:wasDerivedFrom</a:t>
-            </a:r>
-            <a:r>
-              <a:rPr lang="en-US" sz="1050" b="0" i="0" dirty="0">
-                <a:solidFill>
-                  <a:srgbClr val="1F2328"/>
-                </a:solidFill>
-                <a:latin typeface="Consolas"/>
-                <a:cs typeface="Consolas"/>
-              </a:rPr>
-              <a:t xml:space="preserve"> </a:t>
-            </a:r>
-            <a:r>
-              <a:rPr lang="en-US" sz="1050" b="0" i="0" dirty="0">
-                <a:solidFill>
-                  <a:srgbClr val="2F6B78"/>
-                </a:solidFill>
-                <a:latin typeface="Consolas"/>
-                <a:cs typeface="Consolas"/>
-              </a:rPr>
-              <a:t xml:space="preserve">doc:cisplatin_label</a:t>
-            </a:r>
-            <a:endParaRPr lang="en-US" sz="1050"/>
-          </a:p>
-        </p:txBody>
-      </p:sp>
-      <p:sp>
-        <p:nvSpPr>
-          <p:cNvPr id="1359" name="Privacy"/>
-          <p:cNvSpPr txBox="1"/>
-          <p:nvPr/>
-        </p:nvSpPr>
-        <p:spPr>
-          <a:xfrm>
-            <a:off x="822960" y="6053328"/>
-            <a:ext cx="10515600" cy="256032"/>
+            <a:off x="822960" y="6089904"/>
+            <a:ext cx="10607040" cy="384048"/>
           </a:xfrm>
           <a:prstGeom prst="rect">
             <a:avLst/>
@@ -6977,31 +6542,21 @@
           </a:ln>
         </p:spPr>
         <p:txBody>
-          <a:bodyPr wrap="square" lIns="0" tIns="0" rIns="0" bIns="0" anchor="ctr">
+          <a:bodyPr wrap="square" lIns="0" tIns="0" rIns="0" bIns="0" anchor="t">
             <a:noAutofit/>
           </a:bodyPr>
           <a:lstStyle/>
           <a:p>
             <a:pPr algn="l"/>
             <a:r>
-              <a:rPr lang="en-US" sz="1300" b="1" i="0" dirty="0">
-                <a:solidFill>
-                  <a:srgbClr val="0B6E4F"/>
+              <a:rPr lang="en-US" sz="1000" b="0" i="0" dirty="0">
+                <a:solidFill>
+                  <a:srgbClr val="5B6770"/>
                 </a:solidFill>
                 <a:latin typeface="Calibri"/>
                 <a:cs typeface="Calibri"/>
               </a:rPr>
-              <a:t xml:space="preserve">Only aggregate statistics would leave the hospital: </a:t>
-            </a:r>
-            <a:r>
-              <a:rPr lang="en-US" sz="1300" b="0" i="0" dirty="0">
-                <a:solidFill>
-                  <a:srgbClr val="3A434C"/>
-                </a:solidFill>
-                <a:latin typeface="Calibri"/>
-                <a:cs typeface="Calibri"/>
-              </a:rPr>
-              <a:t xml:space="preserve">patient data stays where it is.</a:t>
+              <a:t xml:space="preserve">Rows are synthetic. Instance-level signals for cryptic columns: paper Sec. 5. Tool feedback in the loop: NeOn-GPT [Fathallah et al., ESWC 2024]; Extended NeOn-GPT [Fathallah et al., SWJ 2026]; RIGOR App [Fathallah, Nayyeri &amp; Staab, ISWC 2026 Demos].</a:t>
             </a:r>
           </a:p>
         </p:txBody>

</xml_diff>

<commit_message>
Future work: only about instance data
The evaluation-loop step now has its own slide in the author's deck, so this slide drops the
strip and icon: title 'Next: let the data speak.', lead line as subtitle, larger cards, data
-> clues -> answer, footer cites paper Sec. 5 only. Speech updated; the talk ends at 13:09
without the loop slide's lines.

Co-Authored-By: Claude Opus 5.5 <noreply@anthropic.com>
Claude-Session: https://claude.ai/code/session_01KcycczqUBG98FnzsgJYAW8
</commit_message>
<xml_diff>
--- a/presentation/RIGOR_future_work.pptx
+++ b/presentation/RIGOR_future_work.pptx
@@ -1785,7 +1785,7 @@
                 <a:cs typeface="Calibri"/>
                 <a:sym typeface="Calibri"/>
               </a:rPr>
-              <a:t>[11:58–13:08]  SPOKEN SCRIPT (119 words)</a:t>
+              <a:t>[11:58–12:37]  SPOKEN SCRIPT (68 words)</a:t>
             </a:r>
           </a:p>
           <a:p>
@@ -1799,7 +1799,7 @@
                 <a:cs typeface="Calibri"/>
                 <a:sym typeface="Calibri"/>
               </a:rPr>
-              <a:t>Where next? First, close the loop. The tools we evaluated with, OOPS! and the reasoner, only looked at the final ontologies, which is why a few pitfalls slipped through. Next, they flag each error while RIGOR builds. We started this in NeOn-GPT, and it is already live in our RIGOR App demo. [pause] Then, let the data speak. Remember BM_DEP? Without documentation, the name alone is a guess. The data gives two clues: it is only ever zero or one, so it is a flag; and it is one exactly when the patient received cisplatin, a chemotherapy known to suppress the bone marrow. So RIGOR can propose: bone marrow depression, with provenance to both columns, for an expert to confirm.</a:t>
+              <a:t>Where next? Let the data speak. Remember BM_DEP? Without documentation, the name alone is a guess. The data gives two clues: it is only ever zero or one, so it is a flag; and it is one exactly when the patient received cisplatin, a chemotherapy known to suppress the bone marrow. So RIGOR can propose: bone marrow depression, with provenance to both columns, for an expert to confirm.</a:t>
             </a:r>
           </a:p>
           <a:p/>
@@ -1814,7 +1814,7 @@
                 <a:cs typeface="Calibri"/>
                 <a:sym typeface="Calibri"/>
               </a:rPr>
-              <a:t>PRESENTER / POINTER: Strip first; then the '?' on BM_DEP, the two clues, and the reveal.</a:t>
+              <a:t>PRESENTER / POINTER: The '?' on BM_DEP, then the two clues, then the reveal.</a:t>
             </a:r>
           </a:p>
           <a:p>
@@ -1828,7 +1828,7 @@
                 <a:cs typeface="Calibri"/>
                 <a:sym typeface="Calibri"/>
               </a:rPr>
-              <a:t>AUDIENCE TAKEAWAY: Close the loop with tool feedback; let instance data explain cryptic columns.</a:t>
+              <a:t>AUDIENCE TAKEAWAY: When documentation is missing, instance data can explain cryptic columns.</a:t>
             </a:r>
           </a:p>
           <a:p>
@@ -1842,7 +1842,7 @@
                 <a:cs typeface="Calibri"/>
                 <a:sym typeface="Calibri"/>
               </a:rPr>
-              <a:t>SOURCE AND SCOPE: Paper Sec. 5 (tool feedback in the loop; instance-level signals for cryptic columns when documentation is missing). NeOn-GPT (ESWC 2024), Extended NeOn-GPT (SWJ 2026), RIGOR App (ISWC 2026 Demos). Rows are synthetic. OWL verified (presentation/excerpts/slide22_future_candidate.omn).</a:t>
+              <a:t>SOURCE AND SCOPE: Paper Sec. 5 (instance-level signals for cryptic columns when documentation is unavailable). Rows are synthetic. OWL verified (presentation/excerpts/slide22_future_candidate.omn).</a:t>
             </a:r>
           </a:p>
           <a:p>
@@ -1856,7 +1856,7 @@
                 <a:cs typeface="Calibri"/>
                 <a:sym typeface="Calibri"/>
               </a:rPr>
-              <a:t>IF RUNNING LATE, DROP: "which is why a few pitfalls slipped through"</a:t>
+              <a:t>IF RUNNING LATE, DROP: "Without documentation, the name alone is a guess."</a:t>
             </a:r>
           </a:p>
           <a:p/>
@@ -3763,7 +3763,7 @@
                 <a:cs typeface="Cambria"/>
                 <a:sym typeface="Cambria"/>
               </a:rPr>
-              <a:t>Next: close the loop, and let the data speak.</a:t>
+              <a:t>Next: let the data speak.</a:t>
             </a:r>
             <a:endParaRPr b="0" i="0" sz="1400" u="none" cap="none" strike="noStrike">
               <a:solidFill>
@@ -3779,71 +3779,14 @@
       </p:sp>
       <p:sp>
         <p:nvSpPr>
-          <p:cNvPr id="1291" name="Loop strip"/>
-          <p:cNvSpPr/>
-          <p:nvPr/>
-        </p:nvSpPr>
-        <p:spPr>
-          <a:xfrm>
-            <a:off x="804672" y="1645920"/>
-            <a:ext cx="10579608" cy="566928"/>
-          </a:xfrm>
-          <a:prstGeom prst="roundRect">
-            <a:avLst>
-              <a:gd name="adj" fmla="val 12000"/>
-            </a:avLst>
-          </a:prstGeom>
-          <a:solidFill>
-            <a:srgbClr val="E6F2EC"/>
-          </a:solidFill>
-          <a:ln>
-            <a:noFill/>
-          </a:ln>
-        </p:spPr>
-        <p:txBody>
-          <a:bodyPr wrap="square" lIns="0" tIns="0" rIns="0" bIns="0" anchor="t">
-            <a:noAutofit/>
-          </a:bodyPr>
-          <a:lstStyle/>
-          <a:p>
-            <a:pPr algn="l"/>
-          </a:p>
-        </p:txBody>
-      </p:sp>
-      <p:pic>
-        <p:nvPicPr>
-          <p:cNvPr id="1292" name="Icon" descr="Graph validation icon"/>
-          <p:cNvPicPr>
-            <a:picLocks noChangeAspect="1"/>
-          </p:cNvPicPr>
-          <p:nvPr/>
-        </p:nvPicPr>
-        <p:blipFill>
-          <a:blip r:embed="rIdIcon"/>
-          <a:stretch>
-            <a:fillRect/>
-          </a:stretch>
-        </p:blipFill>
-        <p:spPr>
-          <a:xfrm>
-            <a:off x="932688" y="1700784"/>
-            <a:ext cx="457200" cy="457200"/>
-          </a:xfrm>
-          <a:prstGeom prst="rect">
-            <a:avLst/>
-          </a:prstGeom>
-        </p:spPr>
-      </p:pic>
-      <p:sp>
-        <p:nvSpPr>
-          <p:cNvPr id="1293" name="Loop text"/>
+          <p:cNvPr id="1291" name="Subtitle"/>
           <p:cNvSpPr txBox="1"/>
           <p:nvPr/>
         </p:nvSpPr>
         <p:spPr>
           <a:xfrm>
-            <a:off x="1481328" y="1645920"/>
-            <a:ext cx="9784080" cy="566928"/>
+            <a:off x="822960" y="1682496"/>
+            <a:ext cx="10515600" cy="365760"/>
           </a:xfrm>
           <a:prstGeom prst="rect">
             <a:avLst/>
@@ -3861,102 +3804,113 @@
           <a:p>
             <a:pPr algn="l"/>
             <a:r>
-              <a:rPr lang="en-US" sz="1250" b="1" i="0" dirty="0">
-                <a:solidFill>
-                  <a:srgbClr val="0B6E4F"/>
+              <a:rPr lang="en-US" sz="1650" b="0" i="0" dirty="0">
+                <a:solidFill>
+                  <a:srgbClr val="5B6770"/>
                 </a:solidFill>
                 <a:latin typeface="Calibri"/>
                 <a:cs typeface="Calibri"/>
               </a:rPr>
-              <a:t xml:space="preserve">FIRST, MOVE THE EVALUATION TOOLS INTO THE LOOP   </a:t>
-            </a:r>
-            <a:r>
-              <a:rPr lang="en-US" sz="1250" b="0" i="0" dirty="0">
+              <a:t xml:space="preserve">Today </a:t>
+            </a:r>
+            <a:r>
+              <a:rPr lang="en-US" sz="1650" b="1" i="1" dirty="0">
                 <a:solidFill>
                   <a:srgbClr val="3A434C"/>
                 </a:solidFill>
                 <a:latin typeface="Calibri"/>
                 <a:cs typeface="Calibri"/>
               </a:rPr>
-              <a:t xml:space="preserve">OOPS! and the reasoner only checked our final ontologies. Next, they flag each error while RIGOR builds, so the generator fixes it before merging.  </a:t>
-            </a:r>
-            <a:r>
-              <a:rPr lang="en-US" sz="1250" b="1" i="1" dirty="0">
-                <a:solidFill>
-                  <a:srgbClr val="1F2328"/>
+              <a:t xml:space="preserve">RIGOR</a:t>
+            </a:r>
+            <a:r>
+              <a:rPr lang="en-US" sz="1650" b="0" i="0" dirty="0">
+                <a:solidFill>
+                  <a:srgbClr val="5B6770"/>
                 </a:solidFill>
                 <a:latin typeface="Calibri"/>
                 <a:cs typeface="Calibri"/>
               </a:rPr>
-              <a:t xml:space="preserve">Live in our RIGOR App demo.</a:t>
-            </a:r>
-          </a:p>
-        </p:txBody>
-      </p:sp>
-      <p:sp>
-        <p:nvSpPr>
-          <p:cNvPr id="1294" name="Data lead"/>
-          <p:cNvSpPr txBox="1"/>
-          <p:nvPr/>
-        </p:nvSpPr>
-        <p:spPr>
-          <a:xfrm>
-            <a:off x="822960" y="2340864"/>
-            <a:ext cx="10515600" cy="310896"/>
-          </a:xfrm>
-          <a:prstGeom prst="rect">
-            <a:avLst/>
-          </a:prstGeom>
-          <a:noFill/>
-          <a:ln>
-            <a:noFill/>
-          </a:ln>
-        </p:spPr>
-        <p:txBody>
-          <a:bodyPr wrap="square" lIns="0" tIns="0" rIns="0" bIns="0" anchor="ctr">
-            <a:noAutofit/>
-          </a:bodyPr>
-          <a:lstStyle/>
-          <a:p>
-            <a:pPr algn="l"/>
-            <a:r>
-              <a:rPr lang="en-US" sz="1300" b="1" i="0" dirty="0">
-                <a:solidFill>
-                  <a:srgbClr val="0B6E4F"/>
+              <a:t xml:space="preserve"> reads </a:t>
+            </a:r>
+            <a:r>
+              <a:rPr lang="en-US" sz="1650" b="1" i="0" dirty="0">
+                <a:solidFill>
+                  <a:srgbClr val="3A434C"/>
                 </a:solidFill>
                 <a:latin typeface="Calibri"/>
                 <a:cs typeface="Calibri"/>
               </a:rPr>
-              <a:t xml:space="preserve">THEN, LET THE DATA SPEAK   </a:t>
-            </a:r>
-            <a:r>
-              <a:rPr lang="en-US" sz="1450" b="0" i="0" dirty="0">
-                <a:solidFill>
-                  <a:srgbClr val="3A434C"/>
+              <a:t xml:space="preserve">schemas</a:t>
+            </a:r>
+            <a:r>
+              <a:rPr lang="en-US" sz="1650" b="0" i="0" dirty="0">
+                <a:solidFill>
+                  <a:srgbClr val="5B6770"/>
                 </a:solidFill>
                 <a:latin typeface="Calibri"/>
                 <a:cs typeface="Calibri"/>
               </a:rPr>
-              <a:t xml:space="preserve">When documentation is missing, instance data can explain </a:t>
-            </a:r>
-            <a:r>
-              <a:rPr lang="en-US" sz="1450" b="1" i="0" dirty="0">
-                <a:solidFill>
-                  <a:srgbClr val="1F2328"/>
+              <a:t xml:space="preserve"> and </a:t>
+            </a:r>
+            <a:r>
+              <a:rPr lang="en-US" sz="1650" b="1" i="0" dirty="0">
+                <a:solidFill>
+                  <a:srgbClr val="3A434C"/>
                 </a:solidFill>
                 <a:latin typeface="Calibri"/>
                 <a:cs typeface="Calibri"/>
               </a:rPr>
-              <a:t xml:space="preserve">cryptic columns</a:t>
-            </a:r>
-            <a:r>
-              <a:rPr lang="en-US" sz="1450" b="0" i="0" dirty="0">
-                <a:solidFill>
-                  <a:srgbClr val="3A434C"/>
+              <a:t xml:space="preserve">documentation</a:t>
+            </a:r>
+            <a:r>
+              <a:rPr lang="en-US" sz="1650" b="0" i="0" dirty="0">
+                <a:solidFill>
+                  <a:srgbClr val="5B6770"/>
                 </a:solidFill>
                 <a:latin typeface="Calibri"/>
                 <a:cs typeface="Calibri"/>
               </a:rPr>
+              <a:t xml:space="preserve">. When documentation is missing, </a:t>
+            </a:r>
+            <a:r>
+              <a:rPr lang="en-US" sz="1650" b="1" i="0" dirty="0">
+                <a:solidFill>
+                  <a:srgbClr val="3A434C"/>
+                </a:solidFill>
+                <a:latin typeface="Calibri"/>
+                <a:cs typeface="Calibri"/>
+              </a:rPr>
+              <a:t xml:space="preserve">instance data</a:t>
+            </a:r>
+            <a:r>
+              <a:rPr lang="en-US" sz="1650" b="0" i="0" dirty="0">
+                <a:solidFill>
+                  <a:srgbClr val="5B6770"/>
+                </a:solidFill>
+                <a:latin typeface="Calibri"/>
+                <a:cs typeface="Calibri"/>
+              </a:rPr>
+              <a:t xml:space="preserve"> can explain </a:t>
+            </a:r>
+            <a:r>
+              <a:rPr lang="en-US" sz="1650" b="1" i="0" dirty="0">
+                <a:solidFill>
+                  <a:srgbClr val="3A434C"/>
+                </a:solidFill>
+                <a:latin typeface="Calibri"/>
+                <a:cs typeface="Calibri"/>
+              </a:rPr>
+              <a:t xml:space="preserve">cryptic columns</a:t>
+            </a:r>
+            <a:r>
+              <a:rPr lang="en-US" sz="1650" b="0" i="0" dirty="0">
+                <a:solidFill>
+                  <a:srgbClr val="5B6770"/>
+                </a:solidFill>
+                <a:latin typeface="Calibri"/>
+                <a:cs typeface="Calibri"/>
+              </a:rPr>
               <a:t xml:space="preserve">.</a:t>
             </a:r>
           </a:p>
@@ -3964,14 +3918,14 @@
       </p:sp>
       <p:sp>
         <p:nvSpPr>
-          <p:cNvPr id="1295" name="Card"/>
+          <p:cNvPr id="1292" name="Card"/>
           <p:cNvSpPr/>
           <p:nvPr/>
         </p:nvSpPr>
         <p:spPr>
           <a:xfrm>
-            <a:off x="804672" y="2743200"/>
-            <a:ext cx="3246120" cy="3246120"/>
+            <a:off x="804672" y="2395728"/>
+            <a:ext cx="3246120" cy="3364992"/>
           </a:xfrm>
           <a:prstGeom prst="roundRect">
             <a:avLst>
@@ -3999,13 +3953,13 @@
       </p:sp>
       <p:sp>
         <p:nvSpPr>
-          <p:cNvPr id="1296" name="Card label"/>
+          <p:cNvPr id="1293" name="Card label"/>
           <p:cNvSpPr txBox="1"/>
           <p:nvPr/>
         </p:nvSpPr>
         <p:spPr>
           <a:xfrm>
-            <a:off x="1033271" y="2907792"/>
+            <a:off x="1033271" y="2560320"/>
             <a:ext cx="2788920" cy="274320"/>
           </a:xfrm>
           <a:prstGeom prst="rect">
@@ -4038,13 +3992,13 @@
       </p:sp>
       <p:sp>
         <p:nvSpPr>
-          <p:cNvPr id="1297" name="Question"/>
+          <p:cNvPr id="1294" name="Question"/>
           <p:cNvSpPr txBox="1"/>
           <p:nvPr/>
         </p:nvSpPr>
         <p:spPr>
           <a:xfrm>
-            <a:off x="1033271" y="3182112"/>
+            <a:off x="1033271" y="2834640"/>
             <a:ext cx="2788920" cy="256032"/>
           </a:xfrm>
           <a:prstGeom prst="rect">
@@ -4097,13 +4051,13 @@
       </p:sp>
       <p:sp>
         <p:nvSpPr>
-          <p:cNvPr id="1298" name="Table treatment"/>
+          <p:cNvPr id="1295" name="Table treatment"/>
           <p:cNvSpPr/>
           <p:nvPr/>
         </p:nvSpPr>
         <p:spPr>
           <a:xfrm>
-            <a:off x="941832" y="3493008"/>
+            <a:off x="941832" y="3145536"/>
             <a:ext cx="2971800" cy="1120140"/>
           </a:xfrm>
           <a:prstGeom prst="roundRect">
@@ -4137,13 +4091,13 @@
       </p:sp>
       <p:sp>
         <p:nvSpPr>
-          <p:cNvPr id="1299" name="Table name"/>
+          <p:cNvPr id="1296" name="Table name"/>
           <p:cNvSpPr txBox="1"/>
           <p:nvPr/>
         </p:nvSpPr>
         <p:spPr>
           <a:xfrm>
-            <a:off x="1078992" y="3520439"/>
+            <a:off x="1078992" y="3172968"/>
             <a:ext cx="2697480" cy="246888"/>
           </a:xfrm>
           <a:prstGeom prst="rect">
@@ -4176,13 +4130,13 @@
       </p:sp>
       <p:sp>
         <p:nvSpPr>
-          <p:cNvPr id="1300" name="Rule"/>
+          <p:cNvPr id="1297" name="Rule"/>
           <p:cNvSpPr/>
           <p:nvPr/>
         </p:nvSpPr>
         <p:spPr>
           <a:xfrm>
-            <a:off x="1078992" y="3785615"/>
+            <a:off x="1078992" y="3438144"/>
             <a:ext cx="2697480" cy="10972"/>
           </a:xfrm>
           <a:prstGeom prst="rect">
@@ -4207,13 +4161,13 @@
       </p:sp>
       <p:sp>
         <p:nvSpPr>
-          <p:cNvPr id="1301" name="Column"/>
+          <p:cNvPr id="1298" name="Column"/>
           <p:cNvSpPr txBox="1"/>
           <p:nvPr/>
         </p:nvSpPr>
         <p:spPr>
           <a:xfrm>
-            <a:off x="1078992" y="3813048"/>
+            <a:off x="1078992" y="3465576"/>
             <a:ext cx="1051560" cy="182880"/>
           </a:xfrm>
           <a:prstGeom prst="rect">
@@ -4256,13 +4210,13 @@
       </p:sp>
       <p:sp>
         <p:nvSpPr>
-          <p:cNvPr id="1302" name="Column"/>
+          <p:cNvPr id="1299" name="Column"/>
           <p:cNvSpPr txBox="1"/>
           <p:nvPr/>
         </p:nvSpPr>
         <p:spPr>
           <a:xfrm>
-            <a:off x="2130552" y="3813048"/>
+            <a:off x="2130552" y="3465576"/>
             <a:ext cx="1463040" cy="182880"/>
           </a:xfrm>
           <a:prstGeom prst="rect">
@@ -4295,13 +4249,13 @@
       </p:sp>
       <p:sp>
         <p:nvSpPr>
-          <p:cNvPr id="1303" name="Row band"/>
+          <p:cNvPr id="1300" name="Row band"/>
           <p:cNvSpPr/>
           <p:nvPr/>
         </p:nvSpPr>
         <p:spPr>
           <a:xfrm>
-            <a:off x="1014984" y="4005072"/>
+            <a:off x="1014984" y="3657600"/>
             <a:ext cx="2825496" cy="173736"/>
           </a:xfrm>
           <a:prstGeom prst="rect">
@@ -4326,14 +4280,131 @@
       </p:sp>
       <p:sp>
         <p:nvSpPr>
+          <p:cNvPr id="1301" name="Cell"/>
+          <p:cNvSpPr txBox="1"/>
+          <p:nvPr/>
+        </p:nvSpPr>
+        <p:spPr>
+          <a:xfrm>
+            <a:off x="1078992" y="3657600"/>
+            <a:ext cx="1051560" cy="173736"/>
+          </a:xfrm>
+          <a:prstGeom prst="rect">
+            <a:avLst/>
+          </a:prstGeom>
+          <a:noFill/>
+          <a:ln>
+            <a:noFill/>
+          </a:ln>
+        </p:spPr>
+        <p:txBody>
+          <a:bodyPr wrap="square" lIns="0" tIns="0" rIns="0" bIns="0" anchor="ctr">
+            <a:noAutofit/>
+          </a:bodyPr>
+          <a:lstStyle/>
+          <a:p>
+            <a:pPr algn="l"/>
+            <a:r>
+              <a:rPr lang="en-US" sz="1050" b="0" i="0" dirty="0">
+                <a:solidFill>
+                  <a:srgbClr val="1F2328"/>
+                </a:solidFill>
+                <a:latin typeface="Consolas"/>
+                <a:cs typeface="Consolas"/>
+              </a:rPr>
+              <a:t xml:space="preserve">A1</a:t>
+            </a:r>
+          </a:p>
+        </p:txBody>
+      </p:sp>
+      <p:sp>
+        <p:nvSpPr>
+          <p:cNvPr id="1302" name="Cell"/>
+          <p:cNvSpPr txBox="1"/>
+          <p:nvPr/>
+        </p:nvSpPr>
+        <p:spPr>
+          <a:xfrm>
+            <a:off x="2130552" y="3657600"/>
+            <a:ext cx="1463040" cy="173736"/>
+          </a:xfrm>
+          <a:prstGeom prst="rect">
+            <a:avLst/>
+          </a:prstGeom>
+          <a:noFill/>
+          <a:ln>
+            <a:noFill/>
+          </a:ln>
+        </p:spPr>
+        <p:txBody>
+          <a:bodyPr wrap="square" lIns="0" tIns="0" rIns="0" bIns="0" anchor="ctr">
+            <a:noAutofit/>
+          </a:bodyPr>
+          <a:lstStyle/>
+          <a:p>
+            <a:pPr algn="l"/>
+            <a:r>
+              <a:rPr lang="en-US" sz="1050" b="0" i="0" dirty="0">
+                <a:solidFill>
+                  <a:srgbClr val="1F2328"/>
+                </a:solidFill>
+                <a:latin typeface="Consolas"/>
+                <a:cs typeface="Consolas"/>
+              </a:rPr>
+              <a:t xml:space="preserve">cisplatin</a:t>
+            </a:r>
+          </a:p>
+        </p:txBody>
+      </p:sp>
+      <p:sp>
+        <p:nvSpPr>
+          <p:cNvPr id="1303" name="Cell"/>
+          <p:cNvSpPr txBox="1"/>
+          <p:nvPr/>
+        </p:nvSpPr>
+        <p:spPr>
+          <a:xfrm>
+            <a:off x="1078992" y="3845052"/>
+            <a:ext cx="1051560" cy="173736"/>
+          </a:xfrm>
+          <a:prstGeom prst="rect">
+            <a:avLst/>
+          </a:prstGeom>
+          <a:noFill/>
+          <a:ln>
+            <a:noFill/>
+          </a:ln>
+        </p:spPr>
+        <p:txBody>
+          <a:bodyPr wrap="square" lIns="0" tIns="0" rIns="0" bIns="0" anchor="ctr">
+            <a:noAutofit/>
+          </a:bodyPr>
+          <a:lstStyle/>
+          <a:p>
+            <a:pPr algn="l"/>
+            <a:r>
+              <a:rPr lang="en-US" sz="1050" b="0" i="0" dirty="0">
+                <a:solidFill>
+                  <a:srgbClr val="1F2328"/>
+                </a:solidFill>
+                <a:latin typeface="Consolas"/>
+                <a:cs typeface="Consolas"/>
+              </a:rPr>
+              <a:t xml:space="preserve">A2</a:t>
+            </a:r>
+          </a:p>
+        </p:txBody>
+      </p:sp>
+      <p:sp>
+        <p:nvSpPr>
           <p:cNvPr id="1304" name="Cell"/>
           <p:cNvSpPr txBox="1"/>
           <p:nvPr/>
         </p:nvSpPr>
         <p:spPr>
           <a:xfrm>
-            <a:off x="1078992" y="4005072"/>
-            <a:ext cx="1051560" cy="173736"/>
+            <a:off x="2130552" y="3845052"/>
+            <a:ext cx="1463040" cy="173736"/>
           </a:xfrm>
           <a:prstGeom prst="rect">
             <a:avLst/>
@@ -4358,123 +4429,6 @@
                 <a:latin typeface="Consolas"/>
                 <a:cs typeface="Consolas"/>
               </a:rPr>
-              <a:t xml:space="preserve">A1</a:t>
-            </a:r>
-          </a:p>
-        </p:txBody>
-      </p:sp>
-      <p:sp>
-        <p:nvSpPr>
-          <p:cNvPr id="1305" name="Cell"/>
-          <p:cNvSpPr txBox="1"/>
-          <p:nvPr/>
-        </p:nvSpPr>
-        <p:spPr>
-          <a:xfrm>
-            <a:off x="2130552" y="4005072"/>
-            <a:ext cx="1463040" cy="173736"/>
-          </a:xfrm>
-          <a:prstGeom prst="rect">
-            <a:avLst/>
-          </a:prstGeom>
-          <a:noFill/>
-          <a:ln>
-            <a:noFill/>
-          </a:ln>
-        </p:spPr>
-        <p:txBody>
-          <a:bodyPr wrap="square" lIns="0" tIns="0" rIns="0" bIns="0" anchor="ctr">
-            <a:noAutofit/>
-          </a:bodyPr>
-          <a:lstStyle/>
-          <a:p>
-            <a:pPr algn="l"/>
-            <a:r>
-              <a:rPr lang="en-US" sz="1050" b="0" i="0" dirty="0">
-                <a:solidFill>
-                  <a:srgbClr val="1F2328"/>
-                </a:solidFill>
-                <a:latin typeface="Consolas"/>
-                <a:cs typeface="Consolas"/>
-              </a:rPr>
-              <a:t xml:space="preserve">cisplatin</a:t>
-            </a:r>
-          </a:p>
-        </p:txBody>
-      </p:sp>
-      <p:sp>
-        <p:nvSpPr>
-          <p:cNvPr id="1306" name="Cell"/>
-          <p:cNvSpPr txBox="1"/>
-          <p:nvPr/>
-        </p:nvSpPr>
-        <p:spPr>
-          <a:xfrm>
-            <a:off x="1078992" y="4192524"/>
-            <a:ext cx="1051560" cy="173736"/>
-          </a:xfrm>
-          <a:prstGeom prst="rect">
-            <a:avLst/>
-          </a:prstGeom>
-          <a:noFill/>
-          <a:ln>
-            <a:noFill/>
-          </a:ln>
-        </p:spPr>
-        <p:txBody>
-          <a:bodyPr wrap="square" lIns="0" tIns="0" rIns="0" bIns="0" anchor="ctr">
-            <a:noAutofit/>
-          </a:bodyPr>
-          <a:lstStyle/>
-          <a:p>
-            <a:pPr algn="l"/>
-            <a:r>
-              <a:rPr lang="en-US" sz="1050" b="0" i="0" dirty="0">
-                <a:solidFill>
-                  <a:srgbClr val="1F2328"/>
-                </a:solidFill>
-                <a:latin typeface="Consolas"/>
-                <a:cs typeface="Consolas"/>
-              </a:rPr>
-              <a:t xml:space="preserve">A2</a:t>
-            </a:r>
-          </a:p>
-        </p:txBody>
-      </p:sp>
-      <p:sp>
-        <p:nvSpPr>
-          <p:cNvPr id="1307" name="Cell"/>
-          <p:cNvSpPr txBox="1"/>
-          <p:nvPr/>
-        </p:nvSpPr>
-        <p:spPr>
-          <a:xfrm>
-            <a:off x="2130552" y="4192524"/>
-            <a:ext cx="1463040" cy="173736"/>
-          </a:xfrm>
-          <a:prstGeom prst="rect">
-            <a:avLst/>
-          </a:prstGeom>
-          <a:noFill/>
-          <a:ln>
-            <a:noFill/>
-          </a:ln>
-        </p:spPr>
-        <p:txBody>
-          <a:bodyPr wrap="square" lIns="0" tIns="0" rIns="0" bIns="0" anchor="ctr">
-            <a:noAutofit/>
-          </a:bodyPr>
-          <a:lstStyle/>
-          <a:p>
-            <a:pPr algn="l"/>
-            <a:r>
-              <a:rPr lang="en-US" sz="1050" b="0" i="0" dirty="0">
-                <a:solidFill>
-                  <a:srgbClr val="1F2328"/>
-                </a:solidFill>
-                <a:latin typeface="Consolas"/>
-                <a:cs typeface="Consolas"/>
-              </a:rPr>
               <a:t xml:space="preserve">nivolumab</a:t>
             </a:r>
           </a:p>
@@ -4482,13 +4436,13 @@
       </p:sp>
       <p:sp>
         <p:nvSpPr>
-          <p:cNvPr id="1308" name="Row band"/>
+          <p:cNvPr id="1305" name="Row band"/>
           <p:cNvSpPr/>
           <p:nvPr/>
         </p:nvSpPr>
         <p:spPr>
           <a:xfrm>
-            <a:off x="1014984" y="4379976"/>
+            <a:off x="1014984" y="4032504"/>
             <a:ext cx="2825496" cy="173736"/>
           </a:xfrm>
           <a:prstGeom prst="rect">
@@ -4513,13 +4467,13 @@
       </p:sp>
       <p:sp>
         <p:nvSpPr>
-          <p:cNvPr id="1309" name="Cell"/>
+          <p:cNvPr id="1306" name="Cell"/>
           <p:cNvSpPr txBox="1"/>
           <p:nvPr/>
         </p:nvSpPr>
         <p:spPr>
           <a:xfrm>
-            <a:off x="1078992" y="4379976"/>
+            <a:off x="1078992" y="4032504"/>
             <a:ext cx="1051560" cy="173736"/>
           </a:xfrm>
           <a:prstGeom prst="rect">
@@ -4552,13 +4506,13 @@
       </p:sp>
       <p:sp>
         <p:nvSpPr>
-          <p:cNvPr id="1310" name="Cell"/>
+          <p:cNvPr id="1307" name="Cell"/>
           <p:cNvSpPr txBox="1"/>
           <p:nvPr/>
         </p:nvSpPr>
         <p:spPr>
           <a:xfrm>
-            <a:off x="2130552" y="4379976"/>
+            <a:off x="2130552" y="4032504"/>
             <a:ext cx="1463040" cy="173736"/>
           </a:xfrm>
           <a:prstGeom prst="rect">
@@ -4591,13 +4545,13 @@
       </p:sp>
       <p:sp>
         <p:nvSpPr>
-          <p:cNvPr id="1311" name="Table admission"/>
+          <p:cNvPr id="1308" name="Table admission"/>
           <p:cNvSpPr/>
           <p:nvPr/>
         </p:nvSpPr>
         <p:spPr>
           <a:xfrm>
-            <a:off x="941832" y="4704588"/>
+            <a:off x="941832" y="4357116"/>
             <a:ext cx="2971800" cy="1120140"/>
           </a:xfrm>
           <a:prstGeom prst="roundRect">
@@ -4631,13 +4585,13 @@
       </p:sp>
       <p:sp>
         <p:nvSpPr>
-          <p:cNvPr id="1312" name="Table name"/>
+          <p:cNvPr id="1309" name="Table name"/>
           <p:cNvSpPr txBox="1"/>
           <p:nvPr/>
         </p:nvSpPr>
         <p:spPr>
           <a:xfrm>
-            <a:off x="1078992" y="4732020"/>
+            <a:off x="1078992" y="4384548"/>
             <a:ext cx="2697480" cy="246888"/>
           </a:xfrm>
           <a:prstGeom prst="rect">
@@ -4670,13 +4624,13 @@
       </p:sp>
       <p:sp>
         <p:nvSpPr>
-          <p:cNvPr id="1313" name="Rule"/>
+          <p:cNvPr id="1310" name="Rule"/>
           <p:cNvSpPr/>
           <p:nvPr/>
         </p:nvSpPr>
         <p:spPr>
           <a:xfrm>
-            <a:off x="1078992" y="4997196"/>
+            <a:off x="1078992" y="4649724"/>
             <a:ext cx="2697480" cy="10972"/>
           </a:xfrm>
           <a:prstGeom prst="rect">
@@ -4701,13 +4655,13 @@
       </p:sp>
       <p:sp>
         <p:nvSpPr>
-          <p:cNvPr id="1314" name="Column"/>
+          <p:cNvPr id="1311" name="Column"/>
           <p:cNvSpPr txBox="1"/>
           <p:nvPr/>
         </p:nvSpPr>
         <p:spPr>
           <a:xfrm>
-            <a:off x="1078992" y="5024627"/>
+            <a:off x="1078992" y="4677156"/>
             <a:ext cx="1051560" cy="182880"/>
           </a:xfrm>
           <a:prstGeom prst="rect">
@@ -4740,13 +4694,13 @@
       </p:sp>
       <p:sp>
         <p:nvSpPr>
-          <p:cNvPr id="1315" name="Column"/>
+          <p:cNvPr id="1312" name="Column"/>
           <p:cNvSpPr txBox="1"/>
           <p:nvPr/>
         </p:nvSpPr>
         <p:spPr>
           <a:xfrm>
-            <a:off x="2130552" y="5024627"/>
+            <a:off x="2130552" y="4677156"/>
             <a:ext cx="868680" cy="182880"/>
           </a:xfrm>
           <a:prstGeom prst="rect">
@@ -4779,13 +4733,13 @@
       </p:sp>
       <p:sp>
         <p:nvSpPr>
-          <p:cNvPr id="1316" name="Column"/>
+          <p:cNvPr id="1313" name="Column"/>
           <p:cNvSpPr txBox="1"/>
           <p:nvPr/>
         </p:nvSpPr>
         <p:spPr>
           <a:xfrm>
-            <a:off x="2999232" y="5024627"/>
+            <a:off x="2999232" y="4677156"/>
             <a:ext cx="731520" cy="182880"/>
           </a:xfrm>
           <a:prstGeom prst="rect">
@@ -4818,13 +4772,13 @@
       </p:sp>
       <p:sp>
         <p:nvSpPr>
-          <p:cNvPr id="1317" name="Question"/>
+          <p:cNvPr id="1314" name="Question"/>
           <p:cNvSpPr/>
           <p:nvPr/>
         </p:nvSpPr>
         <p:spPr>
           <a:xfrm>
-            <a:off x="3529584" y="5015483"/>
+            <a:off x="3529584" y="4668012"/>
             <a:ext cx="201168" cy="201168"/>
           </a:xfrm>
           <a:prstGeom prst="ellipse">
@@ -4859,13 +4813,13 @@
       </p:sp>
       <p:sp>
         <p:nvSpPr>
-          <p:cNvPr id="1318" name="Row band"/>
+          <p:cNvPr id="1315" name="Row band"/>
           <p:cNvSpPr/>
           <p:nvPr/>
         </p:nvSpPr>
         <p:spPr>
           <a:xfrm>
-            <a:off x="1014984" y="5216652"/>
+            <a:off x="1014984" y="4869180"/>
             <a:ext cx="2825496" cy="173736"/>
           </a:xfrm>
           <a:prstGeom prst="rect">
@@ -4890,13 +4844,130 @@
       </p:sp>
       <p:sp>
         <p:nvSpPr>
+          <p:cNvPr id="1316" name="Cell"/>
+          <p:cNvSpPr txBox="1"/>
+          <p:nvPr/>
+        </p:nvSpPr>
+        <p:spPr>
+          <a:xfrm>
+            <a:off x="1078992" y="4869180"/>
+            <a:ext cx="1051560" cy="173736"/>
+          </a:xfrm>
+          <a:prstGeom prst="rect">
+            <a:avLst/>
+          </a:prstGeom>
+          <a:noFill/>
+          <a:ln>
+            <a:noFill/>
+          </a:ln>
+        </p:spPr>
+        <p:txBody>
+          <a:bodyPr wrap="square" lIns="0" tIns="0" rIns="0" bIns="0" anchor="ctr">
+            <a:noAutofit/>
+          </a:bodyPr>
+          <a:lstStyle/>
+          <a:p>
+            <a:pPr algn="l"/>
+            <a:r>
+              <a:rPr lang="en-US" sz="1050" b="0" i="0" dirty="0">
+                <a:solidFill>
+                  <a:srgbClr val="1F2328"/>
+                </a:solidFill>
+                <a:latin typeface="Consolas"/>
+                <a:cs typeface="Consolas"/>
+              </a:rPr>
+              <a:t xml:space="preserve">A1</a:t>
+            </a:r>
+          </a:p>
+        </p:txBody>
+      </p:sp>
+      <p:sp>
+        <p:nvSpPr>
+          <p:cNvPr id="1317" name="Cell"/>
+          <p:cNvSpPr txBox="1"/>
+          <p:nvPr/>
+        </p:nvSpPr>
+        <p:spPr>
+          <a:xfrm>
+            <a:off x="2130552" y="4869180"/>
+            <a:ext cx="868680" cy="173736"/>
+          </a:xfrm>
+          <a:prstGeom prst="rect">
+            <a:avLst/>
+          </a:prstGeom>
+          <a:noFill/>
+          <a:ln>
+            <a:noFill/>
+          </a:ln>
+        </p:spPr>
+        <p:txBody>
+          <a:bodyPr wrap="square" lIns="0" tIns="0" rIns="0" bIns="0" anchor="ctr">
+            <a:noAutofit/>
+          </a:bodyPr>
+          <a:lstStyle/>
+          <a:p>
+            <a:pPr algn="l"/>
+            <a:r>
+              <a:rPr lang="en-US" sz="1050" b="0" i="0" dirty="0">
+                <a:solidFill>
+                  <a:srgbClr val="1F2328"/>
+                </a:solidFill>
+                <a:latin typeface="Consolas"/>
+                <a:cs typeface="Consolas"/>
+              </a:rPr>
+              <a:t xml:space="preserve">P1</a:t>
+            </a:r>
+          </a:p>
+        </p:txBody>
+      </p:sp>
+      <p:sp>
+        <p:nvSpPr>
+          <p:cNvPr id="1318" name="Cell"/>
+          <p:cNvSpPr txBox="1"/>
+          <p:nvPr/>
+        </p:nvSpPr>
+        <p:spPr>
+          <a:xfrm>
+            <a:off x="2999232" y="4869180"/>
+            <a:ext cx="731520" cy="173736"/>
+          </a:xfrm>
+          <a:prstGeom prst="rect">
+            <a:avLst/>
+          </a:prstGeom>
+          <a:noFill/>
+          <a:ln>
+            <a:noFill/>
+          </a:ln>
+        </p:spPr>
+        <p:txBody>
+          <a:bodyPr wrap="square" lIns="0" tIns="0" rIns="0" bIns="0" anchor="ctr">
+            <a:noAutofit/>
+          </a:bodyPr>
+          <a:lstStyle/>
+          <a:p>
+            <a:pPr algn="l"/>
+            <a:r>
+              <a:rPr lang="en-US" sz="1050" b="0" i="0" dirty="0">
+                <a:solidFill>
+                  <a:srgbClr val="1F2328"/>
+                </a:solidFill>
+                <a:latin typeface="Consolas"/>
+                <a:cs typeface="Consolas"/>
+              </a:rPr>
+              <a:t xml:space="preserve">1</a:t>
+            </a:r>
+          </a:p>
+        </p:txBody>
+      </p:sp>
+      <p:sp>
+        <p:nvSpPr>
           <p:cNvPr id="1319" name="Cell"/>
           <p:cNvSpPr txBox="1"/>
           <p:nvPr/>
         </p:nvSpPr>
         <p:spPr>
           <a:xfrm>
-            <a:off x="1078992" y="5216652"/>
+            <a:off x="1078992" y="5056632"/>
             <a:ext cx="1051560" cy="173736"/>
           </a:xfrm>
           <a:prstGeom prst="rect">
@@ -4922,7 +4993,7 @@
                 <a:latin typeface="Consolas"/>
                 <a:cs typeface="Consolas"/>
               </a:rPr>
-              <a:t xml:space="preserve">A1</a:t>
+              <a:t xml:space="preserve">A2</a:t>
             </a:r>
           </a:p>
         </p:txBody>
@@ -4935,7 +5006,7 @@
         </p:nvSpPr>
         <p:spPr>
           <a:xfrm>
-            <a:off x="2130552" y="5216652"/>
+            <a:off x="2130552" y="5056632"/>
             <a:ext cx="868680" cy="173736"/>
           </a:xfrm>
           <a:prstGeom prst="rect">
@@ -4961,7 +5032,7 @@
                 <a:latin typeface="Consolas"/>
                 <a:cs typeface="Consolas"/>
               </a:rPr>
-              <a:t xml:space="preserve">P1</a:t>
+              <a:t xml:space="preserve">P2</a:t>
             </a:r>
           </a:p>
         </p:txBody>
@@ -4974,7 +5045,7 @@
         </p:nvSpPr>
         <p:spPr>
           <a:xfrm>
-            <a:off x="2999232" y="5216652"/>
+            <a:off x="2999232" y="5056632"/>
             <a:ext cx="731520" cy="173736"/>
           </a:xfrm>
           <a:prstGeom prst="rect">
@@ -5000,123 +5071,6 @@
                 <a:latin typeface="Consolas"/>
                 <a:cs typeface="Consolas"/>
               </a:rPr>
-              <a:t xml:space="preserve">1</a:t>
-            </a:r>
-          </a:p>
-        </p:txBody>
-      </p:sp>
-      <p:sp>
-        <p:nvSpPr>
-          <p:cNvPr id="1322" name="Cell"/>
-          <p:cNvSpPr txBox="1"/>
-          <p:nvPr/>
-        </p:nvSpPr>
-        <p:spPr>
-          <a:xfrm>
-            <a:off x="1078992" y="5404104"/>
-            <a:ext cx="1051560" cy="173736"/>
-          </a:xfrm>
-          <a:prstGeom prst="rect">
-            <a:avLst/>
-          </a:prstGeom>
-          <a:noFill/>
-          <a:ln>
-            <a:noFill/>
-          </a:ln>
-        </p:spPr>
-        <p:txBody>
-          <a:bodyPr wrap="square" lIns="0" tIns="0" rIns="0" bIns="0" anchor="ctr">
-            <a:noAutofit/>
-          </a:bodyPr>
-          <a:lstStyle/>
-          <a:p>
-            <a:pPr algn="l"/>
-            <a:r>
-              <a:rPr lang="en-US" sz="1050" b="0" i="0" dirty="0">
-                <a:solidFill>
-                  <a:srgbClr val="1F2328"/>
-                </a:solidFill>
-                <a:latin typeface="Consolas"/>
-                <a:cs typeface="Consolas"/>
-              </a:rPr>
-              <a:t xml:space="preserve">A2</a:t>
-            </a:r>
-          </a:p>
-        </p:txBody>
-      </p:sp>
-      <p:sp>
-        <p:nvSpPr>
-          <p:cNvPr id="1323" name="Cell"/>
-          <p:cNvSpPr txBox="1"/>
-          <p:nvPr/>
-        </p:nvSpPr>
-        <p:spPr>
-          <a:xfrm>
-            <a:off x="2130552" y="5404104"/>
-            <a:ext cx="868680" cy="173736"/>
-          </a:xfrm>
-          <a:prstGeom prst="rect">
-            <a:avLst/>
-          </a:prstGeom>
-          <a:noFill/>
-          <a:ln>
-            <a:noFill/>
-          </a:ln>
-        </p:spPr>
-        <p:txBody>
-          <a:bodyPr wrap="square" lIns="0" tIns="0" rIns="0" bIns="0" anchor="ctr">
-            <a:noAutofit/>
-          </a:bodyPr>
-          <a:lstStyle/>
-          <a:p>
-            <a:pPr algn="l"/>
-            <a:r>
-              <a:rPr lang="en-US" sz="1050" b="0" i="0" dirty="0">
-                <a:solidFill>
-                  <a:srgbClr val="1F2328"/>
-                </a:solidFill>
-                <a:latin typeface="Consolas"/>
-                <a:cs typeface="Consolas"/>
-              </a:rPr>
-              <a:t xml:space="preserve">P2</a:t>
-            </a:r>
-          </a:p>
-        </p:txBody>
-      </p:sp>
-      <p:sp>
-        <p:nvSpPr>
-          <p:cNvPr id="1324" name="Cell"/>
-          <p:cNvSpPr txBox="1"/>
-          <p:nvPr/>
-        </p:nvSpPr>
-        <p:spPr>
-          <a:xfrm>
-            <a:off x="2999232" y="5404104"/>
-            <a:ext cx="731520" cy="173736"/>
-          </a:xfrm>
-          <a:prstGeom prst="rect">
-            <a:avLst/>
-          </a:prstGeom>
-          <a:noFill/>
-          <a:ln>
-            <a:noFill/>
-          </a:ln>
-        </p:spPr>
-        <p:txBody>
-          <a:bodyPr wrap="square" lIns="0" tIns="0" rIns="0" bIns="0" anchor="ctr">
-            <a:noAutofit/>
-          </a:bodyPr>
-          <a:lstStyle/>
-          <a:p>
-            <a:pPr algn="l"/>
-            <a:r>
-              <a:rPr lang="en-US" sz="1050" b="0" i="0" dirty="0">
-                <a:solidFill>
-                  <a:srgbClr val="1F2328"/>
-                </a:solidFill>
-                <a:latin typeface="Consolas"/>
-                <a:cs typeface="Consolas"/>
-              </a:rPr>
               <a:t xml:space="preserve">0</a:t>
             </a:r>
           </a:p>
@@ -5124,13 +5078,13 @@
       </p:sp>
       <p:sp>
         <p:nvSpPr>
-          <p:cNvPr id="1325" name="Row band"/>
+          <p:cNvPr id="1322" name="Row band"/>
           <p:cNvSpPr/>
           <p:nvPr/>
         </p:nvSpPr>
         <p:spPr>
           <a:xfrm>
-            <a:off x="1014984" y="5591556"/>
+            <a:off x="1014984" y="5244084"/>
             <a:ext cx="2825496" cy="173736"/>
           </a:xfrm>
           <a:prstGeom prst="rect">
@@ -5155,13 +5109,13 @@
       </p:sp>
       <p:sp>
         <p:nvSpPr>
-          <p:cNvPr id="1326" name="Cell"/>
+          <p:cNvPr id="1323" name="Cell"/>
           <p:cNvSpPr txBox="1"/>
           <p:nvPr/>
         </p:nvSpPr>
         <p:spPr>
           <a:xfrm>
-            <a:off x="1078992" y="5591556"/>
+            <a:off x="1078992" y="5244084"/>
             <a:ext cx="1051560" cy="173736"/>
           </a:xfrm>
           <a:prstGeom prst="rect">
@@ -5194,13 +5148,13 @@
       </p:sp>
       <p:sp>
         <p:nvSpPr>
-          <p:cNvPr id="1327" name="Cell"/>
+          <p:cNvPr id="1324" name="Cell"/>
           <p:cNvSpPr txBox="1"/>
           <p:nvPr/>
         </p:nvSpPr>
         <p:spPr>
           <a:xfrm>
-            <a:off x="2130552" y="5591556"/>
+            <a:off x="2130552" y="5244084"/>
             <a:ext cx="868680" cy="173736"/>
           </a:xfrm>
           <a:prstGeom prst="rect">
@@ -5233,13 +5187,13 @@
       </p:sp>
       <p:sp>
         <p:nvSpPr>
-          <p:cNvPr id="1328" name="Cell"/>
+          <p:cNvPr id="1325" name="Cell"/>
           <p:cNvSpPr txBox="1"/>
           <p:nvPr/>
         </p:nvSpPr>
         <p:spPr>
           <a:xfrm>
-            <a:off x="2999232" y="5591556"/>
+            <a:off x="2999232" y="5244084"/>
             <a:ext cx="731520" cy="173736"/>
           </a:xfrm>
           <a:prstGeom prst="rect">
@@ -5272,14 +5226,14 @@
       </p:sp>
       <p:sp>
         <p:nvSpPr>
-          <p:cNvPr id="1329" name="Card"/>
+          <p:cNvPr id="1326" name="Card"/>
           <p:cNvSpPr/>
           <p:nvPr/>
         </p:nvSpPr>
         <p:spPr>
           <a:xfrm>
-            <a:off x="4379976" y="2743200"/>
-            <a:ext cx="3154680" cy="3246120"/>
+            <a:off x="4379976" y="2395728"/>
+            <a:ext cx="3154680" cy="3364992"/>
           </a:xfrm>
           <a:prstGeom prst="roundRect">
             <a:avLst>
@@ -5307,13 +5261,13 @@
       </p:sp>
       <p:sp>
         <p:nvSpPr>
-          <p:cNvPr id="1330" name="Card label"/>
+          <p:cNvPr id="1327" name="Card label"/>
           <p:cNvSpPr txBox="1"/>
           <p:nvPr/>
         </p:nvSpPr>
         <p:spPr>
           <a:xfrm>
-            <a:off x="4608576" y="2907792"/>
+            <a:off x="4608576" y="2560320"/>
             <a:ext cx="2697480" cy="274320"/>
           </a:xfrm>
           <a:prstGeom prst="rect">
@@ -5346,13 +5300,13 @@
       </p:sp>
       <p:sp>
         <p:nvSpPr>
-          <p:cNvPr id="1331" name="Clue"/>
+          <p:cNvPr id="1328" name="Clue"/>
           <p:cNvSpPr/>
           <p:nvPr/>
         </p:nvSpPr>
         <p:spPr>
           <a:xfrm>
-            <a:off x="4517136" y="3310128"/>
+            <a:off x="4517136" y="2962656"/>
             <a:ext cx="2880360" cy="1188720"/>
           </a:xfrm>
           <a:prstGeom prst="roundRect">
@@ -5381,13 +5335,13 @@
       </p:sp>
       <p:sp>
         <p:nvSpPr>
-          <p:cNvPr id="1332" name="Magnifier ring"/>
+          <p:cNvPr id="1329" name="Magnifier ring"/>
           <p:cNvSpPr/>
           <p:nvPr/>
         </p:nvSpPr>
         <p:spPr>
           <a:xfrm>
-            <a:off x="4636008" y="3438144"/>
+            <a:off x="4636008" y="3090672"/>
             <a:ext cx="223845" cy="223845"/>
           </a:xfrm>
           <a:prstGeom prst="ellipse">
@@ -5405,13 +5359,13 @@
       </p:sp>
       <p:sp>
         <p:nvSpPr>
-          <p:cNvPr id="1333" name="Magnifier handle"/>
+          <p:cNvPr id="1330" name="Magnifier handle"/>
           <p:cNvSpPr/>
           <p:nvPr/>
         </p:nvSpPr>
         <p:spPr>
           <a:xfrm rot="-2700000">
-            <a:off x="4828763" y="3599809"/>
+            <a:off x="4828763" y="3252337"/>
             <a:ext cx="37307" cy="124358"/>
           </a:xfrm>
           <a:prstGeom prst="roundRect">
@@ -5427,13 +5381,13 @@
       </p:sp>
       <p:sp>
         <p:nvSpPr>
-          <p:cNvPr id="1334" name="Clue head"/>
+          <p:cNvPr id="1331" name="Clue head"/>
           <p:cNvSpPr txBox="1"/>
           <p:nvPr/>
         </p:nvSpPr>
         <p:spPr>
           <a:xfrm>
-            <a:off x="5038344" y="3401568"/>
+            <a:off x="5038344" y="3054096"/>
             <a:ext cx="2240280" cy="457200"/>
           </a:xfrm>
           <a:prstGeom prst="rect">
@@ -5466,13 +5420,13 @@
       </p:sp>
       <p:sp>
         <p:nvSpPr>
-          <p:cNvPr id="1335" name="Clue body"/>
+          <p:cNvPr id="1332" name="Clue body"/>
           <p:cNvSpPr txBox="1"/>
           <p:nvPr/>
         </p:nvSpPr>
         <p:spPr>
           <a:xfrm>
-            <a:off x="4654296" y="3913632"/>
+            <a:off x="4654296" y="3566160"/>
             <a:ext cx="2011680" cy="530352"/>
           </a:xfrm>
           <a:prstGeom prst="rect">
@@ -5505,13 +5459,13 @@
       </p:sp>
       <p:sp>
         <p:nvSpPr>
-          <p:cNvPr id="1336" name="Value bar"/>
+          <p:cNvPr id="1333" name="Value bar"/>
           <p:cNvSpPr/>
           <p:nvPr/>
         </p:nvSpPr>
         <p:spPr>
           <a:xfrm>
-            <a:off x="6757416" y="4151376"/>
+            <a:off x="6757416" y="3803904"/>
             <a:ext cx="182880" cy="182880"/>
           </a:xfrm>
           <a:prstGeom prst="rect">
@@ -5536,13 +5490,13 @@
       </p:sp>
       <p:sp>
         <p:nvSpPr>
-          <p:cNvPr id="1337" name="Value label"/>
+          <p:cNvPr id="1334" name="Value label"/>
           <p:cNvSpPr txBox="1"/>
           <p:nvPr/>
         </p:nvSpPr>
         <p:spPr>
           <a:xfrm>
-            <a:off x="6711696" y="4343400"/>
+            <a:off x="6711696" y="3995928"/>
             <a:ext cx="274320" cy="146304"/>
           </a:xfrm>
           <a:prstGeom prst="rect">
@@ -5575,13 +5529,13 @@
       </p:sp>
       <p:sp>
         <p:nvSpPr>
-          <p:cNvPr id="1338" name="Value bar"/>
+          <p:cNvPr id="1335" name="Value bar"/>
           <p:cNvSpPr/>
           <p:nvPr/>
         </p:nvSpPr>
         <p:spPr>
           <a:xfrm>
-            <a:off x="7031736" y="3968496"/>
+            <a:off x="7031736" y="3621024"/>
             <a:ext cx="182880" cy="365760"/>
           </a:xfrm>
           <a:prstGeom prst="rect">
@@ -5606,13 +5560,13 @@
       </p:sp>
       <p:sp>
         <p:nvSpPr>
-          <p:cNvPr id="1339" name="Value label"/>
+          <p:cNvPr id="1336" name="Value label"/>
           <p:cNvSpPr txBox="1"/>
           <p:nvPr/>
         </p:nvSpPr>
         <p:spPr>
           <a:xfrm>
-            <a:off x="6986016" y="4343400"/>
+            <a:off x="6986016" y="3995928"/>
             <a:ext cx="274320" cy="146304"/>
           </a:xfrm>
           <a:prstGeom prst="rect">
@@ -5645,13 +5599,13 @@
       </p:sp>
       <p:sp>
         <p:nvSpPr>
-          <p:cNvPr id="1340" name="Clue"/>
+          <p:cNvPr id="1337" name="Clue"/>
           <p:cNvSpPr/>
           <p:nvPr/>
         </p:nvSpPr>
         <p:spPr>
           <a:xfrm>
-            <a:off x="4517136" y="4608576"/>
+            <a:off x="4517136" y="4261104"/>
             <a:ext cx="2880360" cy="1188720"/>
           </a:xfrm>
           <a:prstGeom prst="roundRect">
@@ -5680,13 +5634,13 @@
       </p:sp>
       <p:sp>
         <p:nvSpPr>
-          <p:cNvPr id="1341" name="Magnifier ring"/>
+          <p:cNvPr id="1338" name="Magnifier ring"/>
           <p:cNvSpPr/>
           <p:nvPr/>
         </p:nvSpPr>
         <p:spPr>
           <a:xfrm>
-            <a:off x="4636008" y="4736592"/>
+            <a:off x="4636008" y="4389120"/>
             <a:ext cx="223845" cy="223845"/>
           </a:xfrm>
           <a:prstGeom prst="ellipse">
@@ -5704,13 +5658,13 @@
       </p:sp>
       <p:sp>
         <p:nvSpPr>
-          <p:cNvPr id="1342" name="Magnifier handle"/>
+          <p:cNvPr id="1339" name="Magnifier handle"/>
           <p:cNvSpPr/>
           <p:nvPr/>
         </p:nvSpPr>
         <p:spPr>
           <a:xfrm rot="-2700000">
-            <a:off x="4828763" y="4898257"/>
+            <a:off x="4828763" y="4550785"/>
             <a:ext cx="37307" cy="124358"/>
           </a:xfrm>
           <a:prstGeom prst="roundRect">
@@ -5726,13 +5680,13 @@
       </p:sp>
       <p:sp>
         <p:nvSpPr>
-          <p:cNvPr id="1343" name="Clue head"/>
+          <p:cNvPr id="1340" name="Clue head"/>
           <p:cNvSpPr txBox="1"/>
           <p:nvPr/>
         </p:nvSpPr>
         <p:spPr>
           <a:xfrm>
-            <a:off x="5038344" y="4700016"/>
+            <a:off x="5038344" y="4352544"/>
             <a:ext cx="2240280" cy="457200"/>
           </a:xfrm>
           <a:prstGeom prst="rect">
@@ -5765,13 +5719,13 @@
       </p:sp>
       <p:sp>
         <p:nvSpPr>
-          <p:cNvPr id="1344" name="Clue body"/>
+          <p:cNvPr id="1341" name="Clue body"/>
           <p:cNvSpPr txBox="1"/>
           <p:nvPr/>
         </p:nvSpPr>
         <p:spPr>
           <a:xfrm>
-            <a:off x="4654296" y="5212080"/>
+            <a:off x="4654296" y="4864608"/>
             <a:ext cx="2606040" cy="530352"/>
           </a:xfrm>
           <a:prstGeom prst="rect">
@@ -5804,14 +5758,14 @@
       </p:sp>
       <p:sp>
         <p:nvSpPr>
-          <p:cNvPr id="1345" name="Card"/>
+          <p:cNvPr id="1342" name="Card"/>
           <p:cNvSpPr/>
           <p:nvPr/>
         </p:nvSpPr>
         <p:spPr>
           <a:xfrm>
-            <a:off x="7863840" y="2743200"/>
-            <a:ext cx="3520440" cy="3246120"/>
+            <a:off x="7863840" y="2395728"/>
+            <a:ext cx="3520440" cy="3364992"/>
           </a:xfrm>
           <a:prstGeom prst="roundRect">
             <a:avLst>
@@ -5839,13 +5793,13 @@
       </p:sp>
       <p:sp>
         <p:nvSpPr>
-          <p:cNvPr id="1346" name="Card label"/>
+          <p:cNvPr id="1343" name="Card label"/>
           <p:cNvSpPr txBox="1"/>
           <p:nvPr/>
         </p:nvSpPr>
         <p:spPr>
           <a:xfrm>
-            <a:off x="8092440" y="2907792"/>
+            <a:off x="8092440" y="2560320"/>
             <a:ext cx="3063240" cy="274320"/>
           </a:xfrm>
           <a:prstGeom prst="rect">
@@ -5878,13 +5832,13 @@
       </p:sp>
       <p:sp>
         <p:nvSpPr>
-          <p:cNvPr id="1347" name="Reveal key"/>
+          <p:cNvPr id="1344" name="Reveal key"/>
           <p:cNvSpPr txBox="1"/>
           <p:nvPr/>
         </p:nvSpPr>
         <p:spPr>
           <a:xfrm>
-            <a:off x="8092440" y="3310128"/>
+            <a:off x="8092440" y="2962656"/>
             <a:ext cx="3063240" cy="310896"/>
           </a:xfrm>
           <a:prstGeom prst="rect">
@@ -5927,13 +5881,13 @@
       </p:sp>
       <p:sp>
         <p:nvSpPr>
-          <p:cNvPr id="1348" name="Reveal"/>
+          <p:cNvPr id="1345" name="Reveal"/>
           <p:cNvSpPr txBox="1"/>
           <p:nvPr/>
         </p:nvSpPr>
         <p:spPr>
           <a:xfrm>
-            <a:off x="8092440" y="3639312"/>
+            <a:off x="8092440" y="3291840"/>
             <a:ext cx="3063240" cy="384048"/>
           </a:xfrm>
           <a:prstGeom prst="rect">
@@ -5966,13 +5920,13 @@
       </p:sp>
       <p:sp>
         <p:nvSpPr>
-          <p:cNvPr id="1349" name="Code panel"/>
+          <p:cNvPr id="1346" name="Code panel"/>
           <p:cNvSpPr/>
           <p:nvPr/>
         </p:nvSpPr>
         <p:spPr>
           <a:xfrm>
-            <a:off x="8001000" y="4160520"/>
+            <a:off x="8001000" y="3813048"/>
             <a:ext cx="3246120" cy="1170432"/>
           </a:xfrm>
           <a:prstGeom prst="roundRect">
@@ -6001,13 +5955,13 @@
       </p:sp>
       <p:sp>
         <p:nvSpPr>
-          <p:cNvPr id="1350" name="Code line 1350"/>
+          <p:cNvPr id="1347" name="Code line 1347"/>
           <p:cNvSpPr txBox="1"/>
           <p:nvPr/>
         </p:nvSpPr>
         <p:spPr>
           <a:xfrm>
-            <a:off x="8001000" y="4224528"/>
+            <a:off x="8001000" y="3877056"/>
             <a:ext cx="3200400" cy="173736"/>
           </a:xfrm>
           <a:prstGeom prst="rect">
@@ -6062,13 +6016,13 @@
       </p:sp>
       <p:sp>
         <p:nvSpPr>
-          <p:cNvPr id="1351" name="Code line 1351"/>
+          <p:cNvPr id="1348" name="Code line 1348"/>
           <p:cNvSpPr txBox="1"/>
           <p:nvPr/>
         </p:nvSpPr>
         <p:spPr>
           <a:xfrm>
-            <a:off x="8001000" y="4398264"/>
+            <a:off x="8001000" y="4050792"/>
             <a:ext cx="3200400" cy="173736"/>
           </a:xfrm>
           <a:prstGeom prst="rect">
@@ -6113,13 +6067,13 @@
       </p:sp>
       <p:sp>
         <p:nvSpPr>
-          <p:cNvPr id="1352" name="Code line 1352"/>
+          <p:cNvPr id="1349" name="Code line 1349"/>
           <p:cNvSpPr txBox="1"/>
           <p:nvPr/>
         </p:nvSpPr>
         <p:spPr>
           <a:xfrm>
-            <a:off x="8001000" y="4572000"/>
+            <a:off x="8001000" y="4224528"/>
             <a:ext cx="3200400" cy="173736"/>
           </a:xfrm>
           <a:prstGeom prst="rect">
@@ -6194,13 +6148,13 @@
       </p:sp>
       <p:sp>
         <p:nvSpPr>
-          <p:cNvPr id="1353" name="Code line 1353"/>
+          <p:cNvPr id="1350" name="Code line 1350"/>
           <p:cNvSpPr txBox="1"/>
           <p:nvPr/>
         </p:nvSpPr>
         <p:spPr>
           <a:xfrm>
-            <a:off x="8001000" y="4745736"/>
+            <a:off x="8001000" y="4398264"/>
             <a:ext cx="3200400" cy="173736"/>
           </a:xfrm>
           <a:prstGeom prst="rect">
@@ -6275,13 +6229,13 @@
       </p:sp>
       <p:sp>
         <p:nvSpPr>
-          <p:cNvPr id="1354" name="Code line 1354"/>
+          <p:cNvPr id="1351" name="Code line 1351"/>
           <p:cNvSpPr txBox="1"/>
           <p:nvPr/>
         </p:nvSpPr>
         <p:spPr>
           <a:xfrm>
-            <a:off x="8001000" y="4919472"/>
+            <a:off x="8001000" y="4572000"/>
             <a:ext cx="3200400" cy="173736"/>
           </a:xfrm>
           <a:prstGeom prst="rect">
@@ -6356,13 +6310,13 @@
       </p:sp>
       <p:sp>
         <p:nvSpPr>
-          <p:cNvPr id="1355" name="Code line 1355"/>
+          <p:cNvPr id="1352" name="Code line 1352"/>
           <p:cNvSpPr txBox="1"/>
           <p:nvPr/>
         </p:nvSpPr>
         <p:spPr>
           <a:xfrm>
-            <a:off x="8001000" y="5093208"/>
+            <a:off x="8001000" y="4745736"/>
             <a:ext cx="3200400" cy="173736"/>
           </a:xfrm>
           <a:prstGeom prst="rect">
@@ -6427,13 +6381,13 @@
       </p:sp>
       <p:sp>
         <p:nvSpPr>
-          <p:cNvPr id="1356" name="Candidate"/>
+          <p:cNvPr id="1353" name="Candidate"/>
           <p:cNvSpPr/>
           <p:nvPr/>
         </p:nvSpPr>
         <p:spPr>
           <a:xfrm>
-            <a:off x="8001000" y="5413248"/>
+            <a:off x="8001000" y="5065776"/>
             <a:ext cx="3246120" cy="420624"/>
           </a:xfrm>
           <a:prstGeom prst="roundRect">
@@ -6480,13 +6434,13 @@
       </p:sp>
       <p:sp>
         <p:nvSpPr>
-          <p:cNvPr id="1357" name="Arrow"/>
+          <p:cNvPr id="1354" name="Arrow"/>
           <p:cNvSpPr/>
           <p:nvPr/>
         </p:nvSpPr>
         <p:spPr>
           <a:xfrm>
-            <a:off x="4078224" y="4201668"/>
+            <a:off x="4078224" y="3913632"/>
             <a:ext cx="274320" cy="329184"/>
           </a:xfrm>
           <a:prstGeom prst="rightArrow">
@@ -6502,13 +6456,13 @@
       </p:sp>
       <p:sp>
         <p:nvSpPr>
-          <p:cNvPr id="1358" name="Arrow"/>
+          <p:cNvPr id="1355" name="Arrow"/>
           <p:cNvSpPr/>
           <p:nvPr/>
         </p:nvSpPr>
         <p:spPr>
           <a:xfrm>
-            <a:off x="7562088" y="4201668"/>
+            <a:off x="7562088" y="3913632"/>
             <a:ext cx="274320" cy="329184"/>
           </a:xfrm>
           <a:prstGeom prst="rightArrow">
@@ -6524,14 +6478,14 @@
       </p:sp>
       <p:sp>
         <p:nvSpPr>
-          <p:cNvPr id="1359" name="Source"/>
+          <p:cNvPr id="1356" name="Source"/>
           <p:cNvSpPr txBox="1"/>
           <p:nvPr/>
         </p:nvSpPr>
         <p:spPr>
           <a:xfrm>
-            <a:off x="822960" y="6089904"/>
-            <a:ext cx="10607040" cy="384048"/>
+            <a:off x="822960" y="5961888"/>
+            <a:ext cx="10607040" cy="237744"/>
           </a:xfrm>
           <a:prstGeom prst="rect">
             <a:avLst/>
@@ -6556,7 +6510,7 @@
                 <a:latin typeface="Calibri"/>
                 <a:cs typeface="Calibri"/>
               </a:rPr>
-              <a:t xml:space="preserve">Rows are synthetic. Instance-level signals for cryptic columns: paper Sec. 5. Tool feedback in the loop: NeOn-GPT [Fathallah et al., ESWC 2024]; Extended NeOn-GPT [Fathallah et al., SWJ 2026]; RIGOR App [Fathallah, Nayyeri &amp; Staab, ISWC 2026 Demos].</a:t>
+              <a:t xml:space="preserve">Rows are synthetic. Instance-level signals to disambiguate cryptic columns when documentation is unavailable: paper Sec. 5.</a:t>
             </a:r>
           </a:p>
         </p:txBody>

</xml_diff>

<commit_message>
Future work: make cisplatin the deciding clue
Clue 2 states the ambiguity ('BM' could be bone metastasis or bowel movement) and why
cisplatin resolves it; the answer card adds 'because it switches on with cisplatin, which
suppresses the marrow', so the treatment:drug provenance reads as evidence. Speech updated.

Co-Authored-By: Claude Opus 5.5 <noreply@anthropic.com>
Claude-Session: https://claude.ai/code/session_01KcycczqUBG98FnzsgJYAW8
</commit_message>
<xml_diff>
--- a/presentation/RIGOR_future_work.pptx
+++ b/presentation/RIGOR_future_work.pptx
@@ -1785,7 +1785,7 @@
                 <a:cs typeface="Calibri"/>
                 <a:sym typeface="Calibri"/>
               </a:rPr>
-              <a:t>[11:58–12:37]  SPOKEN SCRIPT (68 words)</a:t>
+              <a:t>[12:03–12:49]  SPOKEN SCRIPT (81 words)</a:t>
             </a:r>
           </a:p>
           <a:p>
@@ -1799,7 +1799,7 @@
                 <a:cs typeface="Calibri"/>
                 <a:sym typeface="Calibri"/>
               </a:rPr>
-              <a:t>Where next? Let the data speak. Remember BM_DEP? Without documentation, the name alone is a guess. The data gives two clues: it is only ever zero or one, so it is a flag; and it is one exactly when the patient received cisplatin, a chemotherapy known to suppress the bone marrow. So RIGOR can propose: bone marrow depression, with provenance to both columns, for an expert to confirm.</a:t>
+              <a:t>Where next? Let the data speak. Remember BM_DEP? Without documentation, the name alone is a guess: BM could be bone metastasis, or bowel movement. The data gives two clues: it is only ever zero or one, so it is a flag; and it is one exactly when the patient received cisplatin, a chemotherapy known to suppress the bone marrow. So RIGOR can propose: bone marrow depression, with provenance to both columns, the flag and the drug, for an expert to confirm.</a:t>
             </a:r>
           </a:p>
           <a:p/>
@@ -1856,7 +1856,7 @@
                 <a:cs typeface="Calibri"/>
                 <a:sym typeface="Calibri"/>
               </a:rPr>
-              <a:t>IF RUNNING LATE, DROP: "Without documentation, the name alone is a guess."</a:t>
+              <a:t>IF RUNNING LATE, DROP: "BM could be bone metastasis, or bowel movement."</a:t>
             </a:r>
           </a:p>
           <a:p/>
@@ -5307,7 +5307,7 @@
         <p:spPr>
           <a:xfrm>
             <a:off x="4517136" y="2962656"/>
-            <a:ext cx="2880360" cy="1188720"/>
+            <a:ext cx="2880360" cy="1051560"/>
           </a:xfrm>
           <a:prstGeom prst="roundRect">
             <a:avLst>
@@ -5426,8 +5426,8 @@
         </p:nvSpPr>
         <p:spPr>
           <a:xfrm>
-            <a:off x="4654296" y="3566160"/>
-            <a:ext cx="2011680" cy="530352"/>
+            <a:off x="4654296" y="3547872"/>
+            <a:ext cx="2011680" cy="393191"/>
           </a:xfrm>
           <a:prstGeom prst="rect">
             <a:avLst/>
@@ -5465,8 +5465,8 @@
         </p:nvSpPr>
         <p:spPr>
           <a:xfrm>
-            <a:off x="6757416" y="3803904"/>
-            <a:ext cx="182880" cy="182880"/>
+            <a:off x="6757416" y="3648456"/>
+            <a:ext cx="182880" cy="164592"/>
           </a:xfrm>
           <a:prstGeom prst="rect">
             <a:avLst/>
@@ -5496,7 +5496,7 @@
         </p:nvSpPr>
         <p:spPr>
           <a:xfrm>
-            <a:off x="6711696" y="3995928"/>
+            <a:off x="6711696" y="3822192"/>
             <a:ext cx="274320" cy="146304"/>
           </a:xfrm>
           <a:prstGeom prst="rect">
@@ -5535,8 +5535,8 @@
         </p:nvSpPr>
         <p:spPr>
           <a:xfrm>
-            <a:off x="7031736" y="3621024"/>
-            <a:ext cx="182880" cy="365760"/>
+            <a:off x="7031736" y="3483864"/>
+            <a:ext cx="182880" cy="329184"/>
           </a:xfrm>
           <a:prstGeom prst="rect">
             <a:avLst/>
@@ -5566,7 +5566,7 @@
         </p:nvSpPr>
         <p:spPr>
           <a:xfrm>
-            <a:off x="6986016" y="3995928"/>
+            <a:off x="6986016" y="3822192"/>
             <a:ext cx="274320" cy="146304"/>
           </a:xfrm>
           <a:prstGeom prst="rect">
@@ -5605,8 +5605,8 @@
         </p:nvSpPr>
         <p:spPr>
           <a:xfrm>
-            <a:off x="4517136" y="4261104"/>
-            <a:ext cx="2880360" cy="1188720"/>
+            <a:off x="4517136" y="4123944"/>
+            <a:ext cx="2880360" cy="1444752"/>
           </a:xfrm>
           <a:prstGeom prst="roundRect">
             <a:avLst>
@@ -5640,7 +5640,7 @@
         </p:nvSpPr>
         <p:spPr>
           <a:xfrm>
-            <a:off x="4636008" y="4389120"/>
+            <a:off x="4636008" y="4251959"/>
             <a:ext cx="223845" cy="223845"/>
           </a:xfrm>
           <a:prstGeom prst="ellipse">
@@ -5664,7 +5664,7 @@
         </p:nvSpPr>
         <p:spPr>
           <a:xfrm rot="-2700000">
-            <a:off x="4828763" y="4550785"/>
+            <a:off x="4828763" y="4413625"/>
             <a:ext cx="37307" cy="124358"/>
           </a:xfrm>
           <a:prstGeom prst="roundRect">
@@ -5686,7 +5686,7 @@
         </p:nvSpPr>
         <p:spPr>
           <a:xfrm>
-            <a:off x="5038344" y="4352544"/>
+            <a:off x="5038344" y="4215383"/>
             <a:ext cx="2240280" cy="457200"/>
           </a:xfrm>
           <a:prstGeom prst="rect">
@@ -5725,8 +5725,8 @@
         </p:nvSpPr>
         <p:spPr>
           <a:xfrm>
-            <a:off x="4654296" y="4864608"/>
-            <a:ext cx="2606040" cy="530352"/>
+            <a:off x="4654296" y="4709159"/>
+            <a:ext cx="2606040" cy="786384"/>
           </a:xfrm>
           <a:prstGeom prst="rect">
             <a:avLst/>
@@ -5744,14 +5744,14 @@
           <a:p>
             <a:pPr algn="l"/>
             <a:r>
-              <a:rPr lang="en-US" sz="1200" b="0" i="0" dirty="0">
+              <a:rPr lang="en-US" sz="1150" b="0" i="0" dirty="0">
                 <a:solidFill>
                   <a:srgbClr val="3A434C"/>
                 </a:solidFill>
                 <a:latin typeface="Calibri"/>
                 <a:cs typeface="Calibri"/>
               </a:rPr>
-              <a:t xml:space="preserve">Cisplatin is a chemotherapy known to suppress the bone marrow.</a:t>
+              <a:t xml:space="preserve">“BM” could also be bone metastasis or bowel movement. Cisplatin suppresses the bone marrow, so it points to the marrow.</a:t>
             </a:r>
           </a:p>
         </p:txBody>
@@ -5920,13 +5920,72 @@
       </p:sp>
       <p:sp>
         <p:nvSpPr>
-          <p:cNvPr id="1346" name="Code panel"/>
+          <p:cNvPr id="1346" name="Because"/>
+          <p:cNvSpPr txBox="1"/>
+          <p:nvPr/>
+        </p:nvSpPr>
+        <p:spPr>
+          <a:xfrm>
+            <a:off x="8092440" y="3694176"/>
+            <a:ext cx="3063240" cy="402336"/>
+          </a:xfrm>
+          <a:prstGeom prst="rect">
+            <a:avLst/>
+          </a:prstGeom>
+          <a:noFill/>
+          <a:ln>
+            <a:noFill/>
+          </a:ln>
+        </p:spPr>
+        <p:txBody>
+          <a:bodyPr wrap="square" lIns="0" tIns="0" rIns="0" bIns="0" anchor="t">
+            <a:noAutofit/>
+          </a:bodyPr>
+          <a:lstStyle/>
+          <a:p>
+            <a:pPr algn="l"/>
+            <a:r>
+              <a:rPr lang="en-US" sz="1150" b="0" i="1" dirty="0">
+                <a:solidFill>
+                  <a:srgbClr val="3A434C"/>
+                </a:solidFill>
+                <a:latin typeface="Calibri"/>
+                <a:cs typeface="Calibri"/>
+              </a:rPr>
+              <a:t xml:space="preserve">because it switches on with </a:t>
+            </a:r>
+            <a:r>
+              <a:rPr lang="en-US" sz="1150" b="1" i="1" dirty="0">
+                <a:solidFill>
+                  <a:srgbClr val="1F2328"/>
+                </a:solidFill>
+                <a:latin typeface="Calibri"/>
+                <a:cs typeface="Calibri"/>
+              </a:rPr>
+              <a:t xml:space="preserve">cisplatin</a:t>
+            </a:r>
+            <a:r>
+              <a:rPr lang="en-US" sz="1150" b="0" i="1" dirty="0">
+                <a:solidFill>
+                  <a:srgbClr val="3A434C"/>
+                </a:solidFill>
+                <a:latin typeface="Calibri"/>
+                <a:cs typeface="Calibri"/>
+              </a:rPr>
+              <a:t xml:space="preserve">, which suppresses the marrow</a:t>
+            </a:r>
+          </a:p>
+        </p:txBody>
+      </p:sp>
+      <p:sp>
+        <p:nvSpPr>
+          <p:cNvPr id="1347" name="Code panel"/>
           <p:cNvSpPr/>
           <p:nvPr/>
         </p:nvSpPr>
         <p:spPr>
           <a:xfrm>
-            <a:off x="8001000" y="3813048"/>
+            <a:off x="8001000" y="4133087"/>
             <a:ext cx="3246120" cy="1170432"/>
           </a:xfrm>
           <a:prstGeom prst="roundRect">
@@ -5955,13 +6014,13 @@
       </p:sp>
       <p:sp>
         <p:nvSpPr>
-          <p:cNvPr id="1347" name="Code line 1347"/>
+          <p:cNvPr id="1348" name="Code line 1348"/>
           <p:cNvSpPr txBox="1"/>
           <p:nvPr/>
         </p:nvSpPr>
         <p:spPr>
           <a:xfrm>
-            <a:off x="8001000" y="3877056"/>
+            <a:off x="8001000" y="4197096"/>
             <a:ext cx="3200400" cy="173736"/>
           </a:xfrm>
           <a:prstGeom prst="rect">
@@ -6016,13 +6075,13 @@
       </p:sp>
       <p:sp>
         <p:nvSpPr>
-          <p:cNvPr id="1348" name="Code line 1348"/>
+          <p:cNvPr id="1349" name="Code line 1349"/>
           <p:cNvSpPr txBox="1"/>
           <p:nvPr/>
         </p:nvSpPr>
         <p:spPr>
           <a:xfrm>
-            <a:off x="8001000" y="4050792"/>
+            <a:off x="8001000" y="4370832"/>
             <a:ext cx="3200400" cy="173736"/>
           </a:xfrm>
           <a:prstGeom prst="rect">
@@ -6067,13 +6126,13 @@
       </p:sp>
       <p:sp>
         <p:nvSpPr>
-          <p:cNvPr id="1349" name="Code line 1349"/>
+          <p:cNvPr id="1350" name="Code line 1350"/>
           <p:cNvSpPr txBox="1"/>
           <p:nvPr/>
         </p:nvSpPr>
         <p:spPr>
           <a:xfrm>
-            <a:off x="8001000" y="4224528"/>
+            <a:off x="8001000" y="4544568"/>
             <a:ext cx="3200400" cy="173736"/>
           </a:xfrm>
           <a:prstGeom prst="rect">
@@ -6148,13 +6207,13 @@
       </p:sp>
       <p:sp>
         <p:nvSpPr>
-          <p:cNvPr id="1350" name="Code line 1350"/>
+          <p:cNvPr id="1351" name="Code line 1351"/>
           <p:cNvSpPr txBox="1"/>
           <p:nvPr/>
         </p:nvSpPr>
         <p:spPr>
           <a:xfrm>
-            <a:off x="8001000" y="4398264"/>
+            <a:off x="8001000" y="4718304"/>
             <a:ext cx="3200400" cy="173736"/>
           </a:xfrm>
           <a:prstGeom prst="rect">
@@ -6229,13 +6288,13 @@
       </p:sp>
       <p:sp>
         <p:nvSpPr>
-          <p:cNvPr id="1351" name="Code line 1351"/>
+          <p:cNvPr id="1352" name="Code line 1352"/>
           <p:cNvSpPr txBox="1"/>
           <p:nvPr/>
         </p:nvSpPr>
         <p:spPr>
           <a:xfrm>
-            <a:off x="8001000" y="4572000"/>
+            <a:off x="8001000" y="4892040"/>
             <a:ext cx="3200400" cy="173736"/>
           </a:xfrm>
           <a:prstGeom prst="rect">
@@ -6310,13 +6369,13 @@
       </p:sp>
       <p:sp>
         <p:nvSpPr>
-          <p:cNvPr id="1352" name="Code line 1352"/>
+          <p:cNvPr id="1353" name="Code line 1353"/>
           <p:cNvSpPr txBox="1"/>
           <p:nvPr/>
         </p:nvSpPr>
         <p:spPr>
           <a:xfrm>
-            <a:off x="8001000" y="4745736"/>
+            <a:off x="8001000" y="5065776"/>
             <a:ext cx="3200400" cy="173736"/>
           </a:xfrm>
           <a:prstGeom prst="rect">
@@ -6381,14 +6440,14 @@
       </p:sp>
       <p:sp>
         <p:nvSpPr>
-          <p:cNvPr id="1353" name="Candidate"/>
+          <p:cNvPr id="1354" name="Candidate"/>
           <p:cNvSpPr/>
           <p:nvPr/>
         </p:nvSpPr>
         <p:spPr>
           <a:xfrm>
-            <a:off x="8001000" y="5065776"/>
-            <a:ext cx="3246120" cy="420624"/>
+            <a:off x="8001000" y="5340096"/>
+            <a:ext cx="3246120" cy="292608"/>
           </a:xfrm>
           <a:prstGeom prst="roundRect">
             <a:avLst>
@@ -6434,7 +6493,7 @@
       </p:sp>
       <p:sp>
         <p:nvSpPr>
-          <p:cNvPr id="1354" name="Arrow"/>
+          <p:cNvPr id="1355" name="Arrow"/>
           <p:cNvSpPr/>
           <p:nvPr/>
         </p:nvSpPr>
@@ -6456,7 +6515,7 @@
       </p:sp>
       <p:sp>
         <p:nvSpPr>
-          <p:cNvPr id="1355" name="Arrow"/>
+          <p:cNvPr id="1356" name="Arrow"/>
           <p:cNvSpPr/>
           <p:nvPr/>
         </p:nvSpPr>
@@ -6478,7 +6537,7 @@
       </p:sp>
       <p:sp>
         <p:nvSpPr>
-          <p:cNvPr id="1356" name="Source"/>
+          <p:cNvPr id="1357" name="Source"/>
           <p:cNvSpPr txBox="1"/>
           <p:nvPr/>
         </p:nvSpPr>

</xml_diff>

<commit_message>
Future work: instance data proposes new knowledge (author's storyline)
Data -> pattern -> candidate knowledge: joined on admission_id, every cisplatin admission has
bone marrow depression, a link not in the documentation, proposed as a candidate association
with provenance to both columns and flagged 'a pattern, not a cause' for expert review. No
documentation in the evidence. Fragment verified with the OWL API; speech updated.

Co-Authored-By: Claude Opus 5.5 <noreply@anthropic.com>
Claude-Session: https://claude.ai/code/session_01KcycczqUBG98FnzsgJYAW8
</commit_message>
<xml_diff>
--- a/presentation/RIGOR_future_work.pptx
+++ b/presentation/RIGOR_future_work.pptx
@@ -1785,7 +1785,7 @@
                 <a:cs typeface="Calibri"/>
                 <a:sym typeface="Calibri"/>
               </a:rPr>
-              <a:t>[12:03–12:49]  SPOKEN SCRIPT (81 words)</a:t>
+              <a:t>[12:03–12:52]  SPOKEN SCRIPT (86 words)</a:t>
             </a:r>
           </a:p>
           <a:p>
@@ -1799,7 +1799,7 @@
                 <a:cs typeface="Calibri"/>
                 <a:sym typeface="Calibri"/>
               </a:rPr>
-              <a:t>Where next? Let the data speak. Remember BM_DEP? Without documentation, the name alone is a guess: BM could be bone metastasis, or bowel movement. The data gives two clues: it is only ever zero or one, so it is a flag; and it is one exactly when the patient received cisplatin, a chemotherapy known to suppress the bone marrow. So RIGOR can propose: bone marrow depression, with provenance to both columns, the flag and the drug, for an expert to confirm.</a:t>
+              <a:t>Where next? Let the data speak. Today RIGOR reads schemas and documentation, but the data can show links the documentation does not contain. Here, the treatment table says which admissions received cisplatin, and the admission table records bone marrow depression. Joined on the admission id, every cisplatin admission has bone marrow depression. That link is not in the documentation, so RIGOR can propose it as candidate knowledge, with provenance to both columns. A pattern, not a cause: an expert reviews it before it joins the ontology.</a:t>
             </a:r>
           </a:p>
           <a:p/>
@@ -1814,7 +1814,7 @@
                 <a:cs typeface="Calibri"/>
                 <a:sym typeface="Calibri"/>
               </a:rPr>
-              <a:t>PRESENTER / POINTER: The '?' on BM_DEP, then the two clues, then the reveal.</a:t>
+              <a:t>PRESENTER / POINTER: A1 and A3 in both tables; then the pattern bars; then the candidate code and its badge.</a:t>
             </a:r>
           </a:p>
           <a:p>
@@ -1828,7 +1828,7 @@
                 <a:cs typeface="Calibri"/>
                 <a:sym typeface="Calibri"/>
               </a:rPr>
-              <a:t>AUDIENCE TAKEAWAY: When documentation is missing, instance data can explain cryptic columns.</a:t>
+              <a:t>AUDIENCE TAKEAWAY: Instance data can propose new, reviewable knowledge that the documentation does not contain.</a:t>
             </a:r>
           </a:p>
           <a:p>
@@ -1842,7 +1842,7 @@
                 <a:cs typeface="Calibri"/>
                 <a:sym typeface="Calibri"/>
               </a:rPr>
-              <a:t>SOURCE AND SCOPE: Paper Sec. 5 (instance-level signals for cryptic columns when documentation is unavailable). Rows are synthetic. OWL verified (presentation/excerpts/slide22_future_candidate.omn).</a:t>
+              <a:t>SOURCE AND SCOPE: Rows are synthetic. OWL verified (presentation/excerpts/slide22_future_candidate.omn): a typed individual with provenance, no causal axiom.</a:t>
             </a:r>
           </a:p>
           <a:p>
@@ -1856,7 +1856,7 @@
                 <a:cs typeface="Calibri"/>
                 <a:sym typeface="Calibri"/>
               </a:rPr>
-              <a:t>IF RUNNING LATE, DROP: "BM could be bone metastasis, or bowel movement."</a:t>
+              <a:t>IF RUNNING LATE, DROP: "Today RIGOR reads schemas and documentation, but"</a:t>
             </a:r>
           </a:p>
           <a:p/>
@@ -1871,7 +1871,7 @@
                 <a:cs typeface="Calibri"/>
                 <a:sym typeface="Calibri"/>
               </a:rPr>
-              <a:t>IF ASKED 'WHY NOT JUST ASK THE LLM WHAT BM_DEP MEANS?': from the name alone it is a guess. The data narrows it down: a 0/1 flag that switches on with cisplatin. That is evidence, and we keep provenance to both columns.</a:t>
+              <a:t>IF ASKED WHY NOT AN OWL CAUSAL AXIOM: OWL reasoning is deductive and open-world; it cannot derive causation from statistics, and 'Cisplatin SubClassOf causes some BoneMarrowDepression' would wrongly claim it for every case. Other treatments or conditions could explain the pattern.</a:t>
             </a:r>
           </a:p>
           <a:p/>
@@ -1886,7 +1886,7 @@
                 <a:cs typeface="Calibri"/>
                 <a:sym typeface="Calibri"/>
               </a:rPr>
-              <a:t>IF ASKED ABOUT PRIVACY: only aggregate statistics (value ranges, co-occurrence) need to leave the database, not patient rows.</a:t>
+              <a:t>IF ASKED ABOUT PRIVACY: only aggregate statistics (co-occurrence counts) need to leave the database, not patient rows.</a:t>
             </a:r>
           </a:p>
         </p:txBody>
@@ -3871,7 +3871,7 @@
                 <a:latin typeface="Calibri"/>
                 <a:cs typeface="Calibri"/>
               </a:rPr>
-              <a:t xml:space="preserve">. When documentation is missing, </a:t>
+              <a:t xml:space="preserve">. </a:t>
             </a:r>
             <a:r>
               <a:rPr lang="en-US" sz="1650" b="1" i="0" dirty="0">
@@ -3881,7 +3881,7 @@
                 <a:latin typeface="Calibri"/>
                 <a:cs typeface="Calibri"/>
               </a:rPr>
-              <a:t xml:space="preserve">instance data</a:t>
+              <a:t xml:space="preserve">Instance data</a:t>
             </a:r>
             <a:r>
               <a:rPr lang="en-US" sz="1650" b="0" i="0" dirty="0">
@@ -3891,7 +3891,7 @@
                 <a:latin typeface="Calibri"/>
                 <a:cs typeface="Calibri"/>
               </a:rPr>
-              <a:t xml:space="preserve"> can explain </a:t>
+              <a:t xml:space="preserve"> can reveal links the documentation does not contain, and propose </a:t>
             </a:r>
             <a:r>
               <a:rPr lang="en-US" sz="1650" b="1" i="0" dirty="0">
@@ -3901,7 +3901,7 @@
                 <a:latin typeface="Calibri"/>
                 <a:cs typeface="Calibri"/>
               </a:rPr>
-              <a:t xml:space="preserve">cryptic columns</a:t>
+              <a:t xml:space="preserve">new knowledge</a:t>
             </a:r>
             <a:r>
               <a:rPr lang="en-US" sz="1650" b="0" i="0" dirty="0">
@@ -3992,14 +3992,14 @@
       </p:sp>
       <p:sp>
         <p:nvSpPr>
-          <p:cNvPr id="1294" name="Question"/>
+          <p:cNvPr id="1294" name="Note"/>
           <p:cNvSpPr txBox="1"/>
           <p:nvPr/>
         </p:nvSpPr>
         <p:spPr>
           <a:xfrm>
             <a:off x="1033271" y="2834640"/>
-            <a:ext cx="2788920" cy="256032"/>
+            <a:ext cx="2788920" cy="237744"/>
           </a:xfrm>
           <a:prstGeom prst="rect">
             <a:avLst/>
@@ -4017,34 +4017,14 @@
           <a:p>
             <a:pPr algn="l"/>
             <a:r>
-              <a:rPr lang="en-US" sz="1250" b="0" i="1" dirty="0">
-                <a:solidFill>
-                  <a:srgbClr val="3A434C"/>
+              <a:rPr lang="en-US" sz="1150" b="0" i="1" dirty="0">
+                <a:solidFill>
+                  <a:srgbClr val="5B6770"/>
                 </a:solidFill>
                 <a:latin typeface="Calibri"/>
                 <a:cs typeface="Calibri"/>
               </a:rPr>
-              <a:t xml:space="preserve">What does </a:t>
-            </a:r>
-            <a:r>
-              <a:rPr lang="en-US" sz="1250" b="1" i="0" dirty="0">
-                <a:solidFill>
-                  <a:srgbClr val="93600F"/>
-                </a:solidFill>
-                <a:latin typeface="Consolas"/>
-                <a:cs typeface="Consolas"/>
-              </a:rPr>
-              <a:t xml:space="preserve">BM_DEP</a:t>
-            </a:r>
-            <a:r>
-              <a:rPr lang="en-US" sz="1250" b="0" i="1" dirty="0">
-                <a:solidFill>
-                  <a:srgbClr val="3A434C"/>
-                </a:solidFill>
-                <a:latin typeface="Calibri"/>
-                <a:cs typeface="Calibri"/>
-              </a:rPr>
-              <a:t xml:space="preserve"> mean?</a:t>
+              <a:t xml:space="preserve">two tables, joined on admission_id</a:t>
             </a:r>
           </a:p>
         </p:txBody>
@@ -4772,48 +4752,7 @@
       </p:sp>
       <p:sp>
         <p:nvSpPr>
-          <p:cNvPr id="1314" name="Question"/>
-          <p:cNvSpPr/>
-          <p:nvPr/>
-        </p:nvSpPr>
-        <p:spPr>
-          <a:xfrm>
-            <a:off x="3529584" y="4668012"/>
-            <a:ext cx="201168" cy="201168"/>
-          </a:xfrm>
-          <a:prstGeom prst="ellipse">
-            <a:avLst/>
-          </a:prstGeom>
-          <a:solidFill>
-            <a:srgbClr val="93600F"/>
-          </a:solidFill>
-          <a:ln>
-            <a:noFill/>
-          </a:ln>
-        </p:spPr>
-        <p:txBody>
-          <a:bodyPr wrap="square" lIns="0" tIns="0" rIns="0" bIns="0" anchor="ctr">
-            <a:noAutofit/>
-          </a:bodyPr>
-          <a:lstStyle/>
-          <a:p>
-            <a:pPr algn="ctr"/>
-            <a:r>
-              <a:rPr lang="en-US" sz="1100" b="1" i="0" dirty="0">
-                <a:solidFill>
-                  <a:srgbClr val="FFFFFF"/>
-                </a:solidFill>
-                <a:latin typeface="Calibri"/>
-                <a:cs typeface="Calibri"/>
-              </a:rPr>
-              <a:t xml:space="preserve">?</a:t>
-            </a:r>
-          </a:p>
-        </p:txBody>
-      </p:sp>
-      <p:sp>
-        <p:nvSpPr>
-          <p:cNvPr id="1315" name="Row band"/>
+          <p:cNvPr id="1314" name="Row band"/>
           <p:cNvSpPr/>
           <p:nvPr/>
         </p:nvSpPr>
@@ -4844,7 +4783,7 @@
       </p:sp>
       <p:sp>
         <p:nvSpPr>
-          <p:cNvPr id="1316" name="Cell"/>
+          <p:cNvPr id="1315" name="Cell"/>
           <p:cNvSpPr txBox="1"/>
           <p:nvPr/>
         </p:nvSpPr>
@@ -4883,7 +4822,7 @@
       </p:sp>
       <p:sp>
         <p:nvSpPr>
-          <p:cNvPr id="1317" name="Cell"/>
+          <p:cNvPr id="1316" name="Cell"/>
           <p:cNvSpPr txBox="1"/>
           <p:nvPr/>
         </p:nvSpPr>
@@ -4922,7 +4861,7 @@
       </p:sp>
       <p:sp>
         <p:nvSpPr>
-          <p:cNvPr id="1318" name="Cell"/>
+          <p:cNvPr id="1317" name="Cell"/>
           <p:cNvSpPr txBox="1"/>
           <p:nvPr/>
         </p:nvSpPr>
@@ -4961,7 +4900,7 @@
       </p:sp>
       <p:sp>
         <p:nvSpPr>
-          <p:cNvPr id="1319" name="Cell"/>
+          <p:cNvPr id="1318" name="Cell"/>
           <p:cNvSpPr txBox="1"/>
           <p:nvPr/>
         </p:nvSpPr>
@@ -5000,7 +4939,7 @@
       </p:sp>
       <p:sp>
         <p:nvSpPr>
-          <p:cNvPr id="1320" name="Cell"/>
+          <p:cNvPr id="1319" name="Cell"/>
           <p:cNvSpPr txBox="1"/>
           <p:nvPr/>
         </p:nvSpPr>
@@ -5039,7 +4978,7 @@
       </p:sp>
       <p:sp>
         <p:nvSpPr>
-          <p:cNvPr id="1321" name="Cell"/>
+          <p:cNvPr id="1320" name="Cell"/>
           <p:cNvSpPr txBox="1"/>
           <p:nvPr/>
         </p:nvSpPr>
@@ -5078,7 +5017,7 @@
       </p:sp>
       <p:sp>
         <p:nvSpPr>
-          <p:cNvPr id="1322" name="Row band"/>
+          <p:cNvPr id="1321" name="Row band"/>
           <p:cNvSpPr/>
           <p:nvPr/>
         </p:nvSpPr>
@@ -5109,7 +5048,7 @@
       </p:sp>
       <p:sp>
         <p:nvSpPr>
-          <p:cNvPr id="1323" name="Cell"/>
+          <p:cNvPr id="1322" name="Cell"/>
           <p:cNvSpPr txBox="1"/>
           <p:nvPr/>
         </p:nvSpPr>
@@ -5148,7 +5087,7 @@
       </p:sp>
       <p:sp>
         <p:nvSpPr>
-          <p:cNvPr id="1324" name="Cell"/>
+          <p:cNvPr id="1323" name="Cell"/>
           <p:cNvSpPr txBox="1"/>
           <p:nvPr/>
         </p:nvSpPr>
@@ -5187,7 +5126,7 @@
       </p:sp>
       <p:sp>
         <p:nvSpPr>
-          <p:cNvPr id="1325" name="Cell"/>
+          <p:cNvPr id="1324" name="Cell"/>
           <p:cNvSpPr txBox="1"/>
           <p:nvPr/>
         </p:nvSpPr>
@@ -5226,7 +5165,7 @@
       </p:sp>
       <p:sp>
         <p:nvSpPr>
-          <p:cNvPr id="1326" name="Card"/>
+          <p:cNvPr id="1325" name="Card"/>
           <p:cNvSpPr/>
           <p:nvPr/>
         </p:nvSpPr>
@@ -5261,7 +5200,7 @@
       </p:sp>
       <p:sp>
         <p:nvSpPr>
-          <p:cNvPr id="1327" name="Card label"/>
+          <p:cNvPr id="1326" name="Card label"/>
           <p:cNvSpPr txBox="1"/>
           <p:nvPr/>
         </p:nvSpPr>
@@ -5293,34 +5232,147 @@
                 <a:latin typeface="Consolas"/>
                 <a:cs typeface="Consolas"/>
               </a:rPr>
-              <a:t xml:space="preserve">2  THE CLUES</a:t>
-            </a:r>
-          </a:p>
-        </p:txBody>
-      </p:sp>
-      <p:sp>
-        <p:nvSpPr>
-          <p:cNvPr id="1328" name="Clue"/>
+              <a:t xml:space="preserve">2  THE PATTERN</a:t>
+            </a:r>
+          </a:p>
+        </p:txBody>
+      </p:sp>
+      <p:sp>
+        <p:nvSpPr>
+          <p:cNvPr id="1327" name="Note"/>
+          <p:cNvSpPr txBox="1"/>
+          <p:nvPr/>
+        </p:nvSpPr>
+        <p:spPr>
+          <a:xfrm>
+            <a:off x="4608576" y="2834640"/>
+            <a:ext cx="2697480" cy="237744"/>
+          </a:xfrm>
+          <a:prstGeom prst="rect">
+            <a:avLst/>
+          </a:prstGeom>
+          <a:noFill/>
+          <a:ln>
+            <a:noFill/>
+          </a:ln>
+        </p:spPr>
+        <p:txBody>
+          <a:bodyPr wrap="square" lIns="0" tIns="0" rIns="0" bIns="0" anchor="t">
+            <a:noAutofit/>
+          </a:bodyPr>
+          <a:lstStyle/>
+          <a:p>
+            <a:pPr algn="l"/>
+            <a:r>
+              <a:rPr lang="en-US" sz="1150" b="0" i="1" dirty="0">
+                <a:solidFill>
+                  <a:srgbClr val="5B6770"/>
+                </a:solidFill>
+                <a:latin typeface="Calibri"/>
+                <a:cs typeface="Calibri"/>
+              </a:rPr>
+              <a:t xml:space="preserve">what the joined rows show</a:t>
+            </a:r>
+          </a:p>
+        </p:txBody>
+      </p:sp>
+      <p:sp>
+        <p:nvSpPr>
+          <p:cNvPr id="1328" name="Pattern"/>
+          <p:cNvSpPr txBox="1"/>
+          <p:nvPr/>
+        </p:nvSpPr>
+        <p:spPr>
+          <a:xfrm>
+            <a:off x="4608576" y="3172968"/>
+            <a:ext cx="2697480" cy="566928"/>
+          </a:xfrm>
+          <a:prstGeom prst="rect">
+            <a:avLst/>
+          </a:prstGeom>
+          <a:noFill/>
+          <a:ln>
+            <a:noFill/>
+          </a:ln>
+        </p:spPr>
+        <p:txBody>
+          <a:bodyPr wrap="square" lIns="0" tIns="0" rIns="0" bIns="0" anchor="t">
+            <a:noAutofit/>
+          </a:bodyPr>
+          <a:lstStyle/>
+          <a:p>
+            <a:pPr algn="l"/>
+            <a:r>
+              <a:rPr lang="en-US" sz="1400" b="1" i="0" dirty="0">
+                <a:solidFill>
+                  <a:srgbClr val="1F2328"/>
+                </a:solidFill>
+                <a:latin typeface="Calibri"/>
+                <a:cs typeface="Calibri"/>
+              </a:rPr>
+              <a:t xml:space="preserve">Every cisplatin admission has bone marrow depression.</a:t>
+            </a:r>
+          </a:p>
+        </p:txBody>
+      </p:sp>
+      <p:sp>
+        <p:nvSpPr>
+          <p:cNvPr id="1329" name="Group"/>
+          <p:cNvSpPr txBox="1"/>
+          <p:nvPr/>
+        </p:nvSpPr>
+        <p:spPr>
+          <a:xfrm>
+            <a:off x="4608576" y="3886200"/>
+            <a:ext cx="1143000" cy="274320"/>
+          </a:xfrm>
+          <a:prstGeom prst="rect">
+            <a:avLst/>
+          </a:prstGeom>
+          <a:noFill/>
+          <a:ln>
+            <a:noFill/>
+          </a:ln>
+        </p:spPr>
+        <p:txBody>
+          <a:bodyPr wrap="square" lIns="0" tIns="0" rIns="0" bIns="0" anchor="ctr">
+            <a:noAutofit/>
+          </a:bodyPr>
+          <a:lstStyle/>
+          <a:p>
+            <a:pPr algn="l"/>
+            <a:r>
+              <a:rPr lang="en-US" sz="1150" b="0" i="0" dirty="0">
+                <a:solidFill>
+                  <a:srgbClr val="1F2328"/>
+                </a:solidFill>
+                <a:latin typeface="Consolas"/>
+                <a:cs typeface="Consolas"/>
+              </a:rPr>
+              <a:t xml:space="preserve">cisplatin</a:t>
+            </a:r>
+          </a:p>
+        </p:txBody>
+      </p:sp>
+      <p:sp>
+        <p:nvSpPr>
+          <p:cNvPr id="1330" name="Track"/>
           <p:cNvSpPr/>
           <p:nvPr/>
         </p:nvSpPr>
         <p:spPr>
           <a:xfrm>
-            <a:off x="4517136" y="2962656"/>
-            <a:ext cx="2880360" cy="1051560"/>
-          </a:xfrm>
-          <a:prstGeom prst="roundRect">
-            <a:avLst>
-              <a:gd name="adj" fmla="val 12000"/>
-            </a:avLst>
+            <a:off x="5751576" y="3959352"/>
+            <a:ext cx="960120" cy="128016"/>
+          </a:xfrm>
+          <a:prstGeom prst="rect">
+            <a:avLst/>
           </a:prstGeom>
           <a:solidFill>
-            <a:srgbClr val="F6F8FA"/>
+            <a:srgbClr val="E1E6E3"/>
           </a:solidFill>
-          <a:ln w="9525">
-            <a:solidFill>
-              <a:srgbClr val="D9DEDB"/>
-            </a:solidFill>
+          <a:ln>
+            <a:noFill/>
           </a:ln>
         </p:spPr>
         <p:txBody>
@@ -5335,40 +5387,16 @@
       </p:sp>
       <p:sp>
         <p:nvSpPr>
-          <p:cNvPr id="1329" name="Magnifier ring"/>
+          <p:cNvPr id="1331" name="Bar"/>
           <p:cNvSpPr/>
           <p:nvPr/>
         </p:nvSpPr>
         <p:spPr>
           <a:xfrm>
-            <a:off x="4636008" y="3090672"/>
-            <a:ext cx="223845" cy="223845"/>
-          </a:xfrm>
-          <a:prstGeom prst="ellipse">
-            <a:avLst/>
-          </a:prstGeom>
-          <a:solidFill>
-            <a:srgbClr val="FFFFFF"/>
-          </a:solidFill>
-          <a:ln w="28575">
-            <a:solidFill>
-              <a:srgbClr val="0B6E4F"/>
-            </a:solidFill>
-          </a:ln>
-        </p:spPr>
-      </p:sp>
-      <p:sp>
-        <p:nvSpPr>
-          <p:cNvPr id="1330" name="Magnifier handle"/>
-          <p:cNvSpPr/>
-          <p:nvPr/>
-        </p:nvSpPr>
-        <p:spPr>
-          <a:xfrm rot="-2700000">
-            <a:off x="4828763" y="3252337"/>
-            <a:ext cx="37307" cy="124358"/>
-          </a:xfrm>
-          <a:prstGeom prst="roundRect">
+            <a:off x="5751576" y="3959352"/>
+            <a:ext cx="960120" cy="128016"/>
+          </a:xfrm>
+          <a:prstGeom prst="rect">
             <a:avLst/>
           </a:prstGeom>
           <a:solidFill>
@@ -5378,17 +5406,26 @@
             <a:noFill/>
           </a:ln>
         </p:spPr>
-      </p:sp>
-      <p:sp>
-        <p:nvSpPr>
-          <p:cNvPr id="1331" name="Clue head"/>
+        <p:txBody>
+          <a:bodyPr wrap="square" lIns="0" tIns="0" rIns="0" bIns="0" anchor="t">
+            <a:noAutofit/>
+          </a:bodyPr>
+          <a:lstStyle/>
+          <a:p>
+            <a:pPr algn="l"/>
+          </a:p>
+        </p:txBody>
+      </p:sp>
+      <p:sp>
+        <p:nvSpPr>
+          <p:cNvPr id="1332" name="Count"/>
           <p:cNvSpPr txBox="1"/>
           <p:nvPr/>
         </p:nvSpPr>
         <p:spPr>
           <a:xfrm>
-            <a:off x="5038344" y="3054096"/>
-            <a:ext cx="2240280" cy="457200"/>
+            <a:off x="6775704" y="3886200"/>
+            <a:ext cx="594360" cy="274320"/>
           </a:xfrm>
           <a:prstGeom prst="rect">
             <a:avLst/>
@@ -5406,28 +5443,28 @@
           <a:p>
             <a:pPr algn="l"/>
             <a:r>
-              <a:rPr lang="en-US" sz="1400" b="1" i="0" dirty="0">
-                <a:solidFill>
-                  <a:srgbClr val="1F2328"/>
+              <a:rPr lang="en-US" sz="1150" b="1" i="0" dirty="0">
+                <a:solidFill>
+                  <a:srgbClr val="0B6E4F"/>
                 </a:solidFill>
                 <a:latin typeface="Calibri"/>
                 <a:cs typeface="Calibri"/>
               </a:rPr>
-              <a:t xml:space="preserve">Only 0 and 1</a:t>
-            </a:r>
-          </a:p>
-        </p:txBody>
-      </p:sp>
-      <p:sp>
-        <p:nvSpPr>
-          <p:cNvPr id="1332" name="Clue body"/>
+              <a:t xml:space="preserve">2 of 2</a:t>
+            </a:r>
+          </a:p>
+        </p:txBody>
+      </p:sp>
+      <p:sp>
+        <p:nvSpPr>
+          <p:cNvPr id="1333" name="Group"/>
           <p:cNvSpPr txBox="1"/>
           <p:nvPr/>
         </p:nvSpPr>
         <p:spPr>
           <a:xfrm>
-            <a:off x="4654296" y="3547872"/>
-            <a:ext cx="2011680" cy="393191"/>
+            <a:off x="4608576" y="4233672"/>
+            <a:ext cx="1143000" cy="274320"/>
           </a:xfrm>
           <a:prstGeom prst="rect">
             <a:avLst/>
@@ -5438,41 +5475,41 @@
           </a:ln>
         </p:spPr>
         <p:txBody>
-          <a:bodyPr wrap="square" lIns="0" tIns="0" rIns="0" bIns="0" anchor="t">
+          <a:bodyPr wrap="square" lIns="0" tIns="0" rIns="0" bIns="0" anchor="ctr">
             <a:noAutofit/>
           </a:bodyPr>
           <a:lstStyle/>
           <a:p>
             <a:pPr algn="l"/>
             <a:r>
-              <a:rPr lang="en-US" sz="1200" b="0" i="0" dirty="0">
-                <a:solidFill>
-                  <a:srgbClr val="3A434C"/>
-                </a:solidFill>
-                <a:latin typeface="Calibri"/>
-                <a:cs typeface="Calibri"/>
-              </a:rPr>
-              <a:t xml:space="preserve">A yes/no flag, not a score.</a:t>
-            </a:r>
-          </a:p>
-        </p:txBody>
-      </p:sp>
-      <p:sp>
-        <p:nvSpPr>
-          <p:cNvPr id="1333" name="Value bar"/>
+              <a:rPr lang="en-US" sz="1150" b="0" i="0" dirty="0">
+                <a:solidFill>
+                  <a:srgbClr val="1F2328"/>
+                </a:solidFill>
+                <a:latin typeface="Consolas"/>
+                <a:cs typeface="Consolas"/>
+              </a:rPr>
+              <a:t xml:space="preserve">other drugs</a:t>
+            </a:r>
+          </a:p>
+        </p:txBody>
+      </p:sp>
+      <p:sp>
+        <p:nvSpPr>
+          <p:cNvPr id="1334" name="Track"/>
           <p:cNvSpPr/>
           <p:nvPr/>
         </p:nvSpPr>
         <p:spPr>
           <a:xfrm>
-            <a:off x="6757416" y="3648456"/>
-            <a:ext cx="182880" cy="164592"/>
+            <a:off x="5751576" y="4306824"/>
+            <a:ext cx="960120" cy="128016"/>
           </a:xfrm>
           <a:prstGeom prst="rect">
             <a:avLst/>
           </a:prstGeom>
           <a:solidFill>
-            <a:srgbClr val="9AA3A9"/>
+            <a:srgbClr val="E1E6E3"/>
           </a:solidFill>
           <a:ln>
             <a:noFill/>
@@ -5490,14 +5527,14 @@
       </p:sp>
       <p:sp>
         <p:nvSpPr>
-          <p:cNvPr id="1334" name="Value label"/>
+          <p:cNvPr id="1335" name="Count"/>
           <p:cNvSpPr txBox="1"/>
           <p:nvPr/>
         </p:nvSpPr>
         <p:spPr>
           <a:xfrm>
-            <a:off x="6711696" y="3822192"/>
-            <a:ext cx="274320" cy="146304"/>
+            <a:off x="6775704" y="4233672"/>
+            <a:ext cx="594360" cy="274320"/>
           </a:xfrm>
           <a:prstGeom prst="rect">
             <a:avLst/>
@@ -5508,257 +5545,120 @@
           </a:ln>
         </p:spPr>
         <p:txBody>
+          <a:bodyPr wrap="square" lIns="0" tIns="0" rIns="0" bIns="0" anchor="ctr">
+            <a:noAutofit/>
+          </a:bodyPr>
+          <a:lstStyle/>
+          <a:p>
+            <a:pPr algn="l"/>
+            <a:r>
+              <a:rPr lang="en-US" sz="1150" b="1" i="0" dirty="0">
+                <a:solidFill>
+                  <a:srgbClr val="3A434C"/>
+                </a:solidFill>
+                <a:latin typeface="Calibri"/>
+                <a:cs typeface="Calibri"/>
+              </a:rPr>
+              <a:t xml:space="preserve">0 of 1</a:t>
+            </a:r>
+          </a:p>
+        </p:txBody>
+      </p:sp>
+      <p:sp>
+        <p:nvSpPr>
+          <p:cNvPr id="1336" name="Axis note"/>
+          <p:cNvSpPr txBox="1"/>
+          <p:nvPr/>
+        </p:nvSpPr>
+        <p:spPr>
+          <a:xfrm>
+            <a:off x="4608576" y="4562856"/>
+            <a:ext cx="2697480" cy="201168"/>
+          </a:xfrm>
+          <a:prstGeom prst="rect">
+            <a:avLst/>
+          </a:prstGeom>
+          <a:noFill/>
+          <a:ln>
+            <a:noFill/>
+          </a:ln>
+        </p:spPr>
+        <p:txBody>
           <a:bodyPr wrap="square" lIns="0" tIns="0" rIns="0" bIns="0" anchor="t">
             <a:noAutofit/>
           </a:bodyPr>
           <a:lstStyle/>
           <a:p>
-            <a:pPr algn="ctr"/>
-            <a:r>
-              <a:rPr lang="en-US" sz="900" b="0" i="0" dirty="0">
+            <a:pPr algn="l"/>
+            <a:r>
+              <a:rPr lang="en-US" sz="950" b="0" i="1" dirty="0">
                 <a:solidFill>
                   <a:srgbClr val="5B6770"/>
                 </a:solidFill>
-                <a:latin typeface="Consolas"/>
-                <a:cs typeface="Consolas"/>
-              </a:rPr>
-              <a:t xml:space="preserve">0</a:t>
-            </a:r>
-          </a:p>
-        </p:txBody>
-      </p:sp>
-      <p:sp>
-        <p:nvSpPr>
-          <p:cNvPr id="1335" name="Value bar"/>
+                <a:latin typeface="Calibri"/>
+                <a:cs typeface="Calibri"/>
+              </a:rPr>
+              <a:t xml:space="preserve">admissions with BM_DEP = 1</a:t>
+            </a:r>
+          </a:p>
+        </p:txBody>
+      </p:sp>
+      <p:sp>
+        <p:nvSpPr>
+          <p:cNvPr id="1337" name="Not documented"/>
           <p:cNvSpPr/>
           <p:nvPr/>
         </p:nvSpPr>
         <p:spPr>
           <a:xfrm>
-            <a:off x="7031736" y="3483864"/>
-            <a:ext cx="182880" cy="329184"/>
-          </a:xfrm>
-          <a:prstGeom prst="rect">
-            <a:avLst/>
+            <a:off x="4517136" y="4937760"/>
+            <a:ext cx="2880360" cy="640080"/>
+          </a:xfrm>
+          <a:prstGeom prst="roundRect">
+            <a:avLst>
+              <a:gd name="adj" fmla="val 12000"/>
+            </a:avLst>
           </a:prstGeom>
           <a:solidFill>
-            <a:srgbClr val="0B6E4F"/>
+            <a:srgbClr val="E8F6EF"/>
           </a:solidFill>
           <a:ln>
             <a:noFill/>
           </a:ln>
         </p:spPr>
         <p:txBody>
-          <a:bodyPr wrap="square" lIns="0" tIns="0" rIns="0" bIns="0" anchor="t">
+          <a:bodyPr wrap="square" lIns="109728" tIns="0" rIns="109728" bIns="0" anchor="ctr">
             <a:noAutofit/>
           </a:bodyPr>
           <a:lstStyle/>
           <a:p>
-            <a:pPr algn="l"/>
-          </a:p>
-        </p:txBody>
-      </p:sp>
-      <p:sp>
-        <p:nvSpPr>
-          <p:cNvPr id="1336" name="Value label"/>
-          <p:cNvSpPr txBox="1"/>
-          <p:nvPr/>
-        </p:nvSpPr>
-        <p:spPr>
-          <a:xfrm>
-            <a:off x="6986016" y="3822192"/>
-            <a:ext cx="274320" cy="146304"/>
-          </a:xfrm>
-          <a:prstGeom prst="rect">
-            <a:avLst/>
-          </a:prstGeom>
-          <a:noFill/>
-          <a:ln>
-            <a:noFill/>
-          </a:ln>
-        </p:spPr>
-        <p:txBody>
-          <a:bodyPr wrap="square" lIns="0" tIns="0" rIns="0" bIns="0" anchor="t">
-            <a:noAutofit/>
-          </a:bodyPr>
-          <a:lstStyle/>
-          <a:p>
             <a:pPr algn="ctr"/>
             <a:r>
-              <a:rPr lang="en-US" sz="900" b="0" i="0" dirty="0">
-                <a:solidFill>
-                  <a:srgbClr val="5B6770"/>
-                </a:solidFill>
-                <a:latin typeface="Consolas"/>
-                <a:cs typeface="Consolas"/>
-              </a:rPr>
-              <a:t xml:space="preserve">1</a:t>
-            </a:r>
-          </a:p>
-        </p:txBody>
-      </p:sp>
-      <p:sp>
-        <p:nvSpPr>
-          <p:cNvPr id="1337" name="Clue"/>
-          <p:cNvSpPr/>
-          <p:nvPr/>
-        </p:nvSpPr>
-        <p:spPr>
-          <a:xfrm>
-            <a:off x="4517136" y="4123944"/>
-            <a:ext cx="2880360" cy="1444752"/>
-          </a:xfrm>
-          <a:prstGeom prst="roundRect">
-            <a:avLst>
-              <a:gd name="adj" fmla="val 12000"/>
-            </a:avLst>
-          </a:prstGeom>
-          <a:solidFill>
-            <a:srgbClr val="F6F8FA"/>
-          </a:solidFill>
-          <a:ln w="9525">
-            <a:solidFill>
-              <a:srgbClr val="D9DEDB"/>
-            </a:solidFill>
-          </a:ln>
-        </p:spPr>
-        <p:txBody>
-          <a:bodyPr wrap="square" lIns="0" tIns="0" rIns="0" bIns="0" anchor="t">
-            <a:noAutofit/>
-          </a:bodyPr>
-          <a:lstStyle/>
-          <a:p>
-            <a:pPr algn="l"/>
-          </a:p>
-        </p:txBody>
-      </p:sp>
-      <p:sp>
-        <p:nvSpPr>
-          <p:cNvPr id="1338" name="Magnifier ring"/>
-          <p:cNvSpPr/>
-          <p:nvPr/>
-        </p:nvSpPr>
-        <p:spPr>
-          <a:xfrm>
-            <a:off x="4636008" y="4251959"/>
-            <a:ext cx="223845" cy="223845"/>
-          </a:xfrm>
-          <a:prstGeom prst="ellipse">
-            <a:avLst/>
-          </a:prstGeom>
-          <a:solidFill>
-            <a:srgbClr val="FFFFFF"/>
-          </a:solidFill>
-          <a:ln w="28575">
-            <a:solidFill>
-              <a:srgbClr val="0B6E4F"/>
-            </a:solidFill>
-          </a:ln>
-        </p:spPr>
-      </p:sp>
-      <p:sp>
-        <p:nvSpPr>
-          <p:cNvPr id="1339" name="Magnifier handle"/>
-          <p:cNvSpPr/>
-          <p:nvPr/>
-        </p:nvSpPr>
-        <p:spPr>
-          <a:xfrm rot="-2700000">
-            <a:off x="4828763" y="4413625"/>
-            <a:ext cx="37307" cy="124358"/>
-          </a:xfrm>
-          <a:prstGeom prst="roundRect">
-            <a:avLst/>
-          </a:prstGeom>
-          <a:solidFill>
-            <a:srgbClr val="0B6E4F"/>
-          </a:solidFill>
-          <a:ln>
-            <a:noFill/>
-          </a:ln>
-        </p:spPr>
-      </p:sp>
-      <p:sp>
-        <p:nvSpPr>
-          <p:cNvPr id="1340" name="Clue head"/>
-          <p:cNvSpPr txBox="1"/>
-          <p:nvPr/>
-        </p:nvSpPr>
-        <p:spPr>
-          <a:xfrm>
-            <a:off x="5038344" y="4215383"/>
-            <a:ext cx="2240280" cy="457200"/>
-          </a:xfrm>
-          <a:prstGeom prst="rect">
-            <a:avLst/>
-          </a:prstGeom>
-          <a:noFill/>
-          <a:ln>
-            <a:noFill/>
-          </a:ln>
-        </p:spPr>
-        <p:txBody>
-          <a:bodyPr wrap="square" lIns="0" tIns="0" rIns="0" bIns="0" anchor="ctr">
-            <a:noAutofit/>
-          </a:bodyPr>
-          <a:lstStyle/>
-          <a:p>
-            <a:pPr algn="l"/>
-            <a:r>
-              <a:rPr lang="en-US" sz="1400" b="1" i="0" dirty="0">
-                <a:solidFill>
-                  <a:srgbClr val="1F2328"/>
+              <a:rPr lang="en-US" sz="1200" b="1" i="0" dirty="0">
+                <a:solidFill>
+                  <a:srgbClr val="0B6E4F"/>
                 </a:solidFill>
                 <a:latin typeface="Calibri"/>
                 <a:cs typeface="Calibri"/>
               </a:rPr>
-              <a:t xml:space="preserve">1 exactly when cisplatin was given</a:t>
-            </a:r>
-          </a:p>
-        </p:txBody>
-      </p:sp>
-      <p:sp>
-        <p:nvSpPr>
-          <p:cNvPr id="1341" name="Clue body"/>
-          <p:cNvSpPr txBox="1"/>
-          <p:nvPr/>
-        </p:nvSpPr>
-        <p:spPr>
-          <a:xfrm>
-            <a:off x="4654296" y="4709159"/>
-            <a:ext cx="2606040" cy="786384"/>
-          </a:xfrm>
-          <a:prstGeom prst="rect">
-            <a:avLst/>
-          </a:prstGeom>
-          <a:noFill/>
-          <a:ln>
-            <a:noFill/>
-          </a:ln>
-        </p:spPr>
-        <p:txBody>
-          <a:bodyPr wrap="square" lIns="0" tIns="0" rIns="0" bIns="0" anchor="t">
-            <a:noAutofit/>
-          </a:bodyPr>
-          <a:lstStyle/>
-          <a:p>
-            <a:pPr algn="l"/>
-            <a:r>
-              <a:rPr lang="en-US" sz="1150" b="0" i="0" dirty="0">
+              <a:t xml:space="preserve">Not in the documentation: </a:t>
+            </a:r>
+            <a:r>
+              <a:rPr lang="en-US" sz="1200" b="0" i="0" dirty="0">
                 <a:solidFill>
                   <a:srgbClr val="3A434C"/>
                 </a:solidFill>
                 <a:latin typeface="Calibri"/>
                 <a:cs typeface="Calibri"/>
               </a:rPr>
-              <a:t xml:space="preserve">“BM” could also be bone metastasis or bowel movement. Cisplatin suppresses the bone marrow, so it points to the marrow.</a:t>
-            </a:r>
-          </a:p>
-        </p:txBody>
-      </p:sp>
-      <p:sp>
-        <p:nvSpPr>
-          <p:cNvPr id="1342" name="Card"/>
+              <a:t xml:space="preserve">a candidate for new knowledge.</a:t>
+            </a:r>
+          </a:p>
+        </p:txBody>
+      </p:sp>
+      <p:sp>
+        <p:nvSpPr>
+          <p:cNvPr id="1338" name="Card"/>
           <p:cNvSpPr/>
           <p:nvPr/>
         </p:nvSpPr>
@@ -5793,7 +5693,7 @@
       </p:sp>
       <p:sp>
         <p:nvSpPr>
-          <p:cNvPr id="1343" name="Card label"/>
+          <p:cNvPr id="1339" name="Card label"/>
           <p:cNvSpPr txBox="1"/>
           <p:nvPr/>
         </p:nvSpPr>
@@ -5825,21 +5725,21 @@
                 <a:latin typeface="Consolas"/>
                 <a:cs typeface="Consolas"/>
               </a:rPr>
-              <a:t xml:space="preserve">3  THE ANSWER</a:t>
-            </a:r>
-          </a:p>
-        </p:txBody>
-      </p:sp>
-      <p:sp>
-        <p:nvSpPr>
-          <p:cNvPr id="1344" name="Reveal key"/>
+              <a:t xml:space="preserve">3  CANDIDATE KNOWLEDGE</a:t>
+            </a:r>
+          </a:p>
+        </p:txBody>
+      </p:sp>
+      <p:sp>
+        <p:nvSpPr>
+          <p:cNvPr id="1340" name="Note"/>
           <p:cNvSpPr txBox="1"/>
           <p:nvPr/>
         </p:nvSpPr>
         <p:spPr>
           <a:xfrm>
-            <a:off x="8092440" y="2962656"/>
-            <a:ext cx="3063240" cy="310896"/>
+            <a:off x="8092440" y="2834640"/>
+            <a:ext cx="3063240" cy="256032"/>
           </a:xfrm>
           <a:prstGeom prst="rect">
             <a:avLst/>
@@ -5857,136 +5757,28 @@
           <a:p>
             <a:pPr algn="l"/>
             <a:r>
-              <a:rPr lang="en-US" sz="1700" b="1" i="0" dirty="0">
-                <a:solidFill>
-                  <a:srgbClr val="0B6E4F"/>
-                </a:solidFill>
-                <a:latin typeface="Consolas"/>
-                <a:cs typeface="Consolas"/>
-              </a:rPr>
-              <a:t xml:space="preserve">BM_DEP</a:t>
-            </a:r>
-            <a:r>
-              <a:rPr lang="en-US" sz="1700" b="0" i="0" dirty="0">
+              <a:rPr lang="en-US" sz="1150" b="0" i="1" dirty="0">
                 <a:solidFill>
                   <a:srgbClr val="5B6770"/>
                 </a:solidFill>
                 <a:latin typeface="Calibri"/>
                 <a:cs typeface="Calibri"/>
               </a:rPr>
-              <a:t xml:space="preserve">   →</a:t>
-            </a:r>
-          </a:p>
-        </p:txBody>
-      </p:sp>
-      <p:sp>
-        <p:nvSpPr>
-          <p:cNvPr id="1345" name="Reveal"/>
-          <p:cNvSpPr txBox="1"/>
-          <p:nvPr/>
-        </p:nvSpPr>
-        <p:spPr>
-          <a:xfrm>
-            <a:off x="8092440" y="3291840"/>
-            <a:ext cx="3063240" cy="384048"/>
-          </a:xfrm>
-          <a:prstGeom prst="rect">
-            <a:avLst/>
-          </a:prstGeom>
-          <a:noFill/>
-          <a:ln>
-            <a:noFill/>
-          </a:ln>
-        </p:spPr>
-        <p:txBody>
-          <a:bodyPr wrap="square" lIns="0" tIns="0" rIns="0" bIns="0" anchor="t">
-            <a:noAutofit/>
-          </a:bodyPr>
-          <a:lstStyle/>
-          <a:p>
-            <a:pPr algn="l"/>
-            <a:r>
-              <a:rPr lang="en-US" sz="2000" b="1" i="0" dirty="0">
-                <a:solidFill>
-                  <a:srgbClr val="1F2328"/>
-                </a:solidFill>
-                <a:latin typeface="Cambria"/>
-                <a:cs typeface="Cambria"/>
-              </a:rPr>
-              <a:t xml:space="preserve">Bone marrow depression</a:t>
-            </a:r>
-          </a:p>
-        </p:txBody>
-      </p:sp>
-      <p:sp>
-        <p:nvSpPr>
-          <p:cNvPr id="1346" name="Because"/>
-          <p:cNvSpPr txBox="1"/>
-          <p:nvPr/>
-        </p:nvSpPr>
-        <p:spPr>
-          <a:xfrm>
-            <a:off x="8092440" y="3694176"/>
-            <a:ext cx="3063240" cy="402336"/>
-          </a:xfrm>
-          <a:prstGeom prst="rect">
-            <a:avLst/>
-          </a:prstGeom>
-          <a:noFill/>
-          <a:ln>
-            <a:noFill/>
-          </a:ln>
-        </p:spPr>
-        <p:txBody>
-          <a:bodyPr wrap="square" lIns="0" tIns="0" rIns="0" bIns="0" anchor="t">
-            <a:noAutofit/>
-          </a:bodyPr>
-          <a:lstStyle/>
-          <a:p>
-            <a:pPr algn="l"/>
-            <a:r>
-              <a:rPr lang="en-US" sz="1150" b="0" i="1" dirty="0">
-                <a:solidFill>
-                  <a:srgbClr val="3A434C"/>
-                </a:solidFill>
-                <a:latin typeface="Calibri"/>
-                <a:cs typeface="Calibri"/>
-              </a:rPr>
-              <a:t xml:space="preserve">because it switches on with </a:t>
-            </a:r>
-            <a:r>
-              <a:rPr lang="en-US" sz="1150" b="1" i="1" dirty="0">
-                <a:solidFill>
-                  <a:srgbClr val="1F2328"/>
-                </a:solidFill>
-                <a:latin typeface="Calibri"/>
-                <a:cs typeface="Calibri"/>
-              </a:rPr>
-              <a:t xml:space="preserve">cisplatin</a:t>
-            </a:r>
-            <a:r>
-              <a:rPr lang="en-US" sz="1150" b="0" i="1" dirty="0">
-                <a:solidFill>
-                  <a:srgbClr val="3A434C"/>
-                </a:solidFill>
-                <a:latin typeface="Calibri"/>
-                <a:cs typeface="Calibri"/>
-              </a:rPr>
-              <a:t xml:space="preserve">, which suppresses the marrow</a:t>
-            </a:r>
-          </a:p>
-        </p:txBody>
-      </p:sp>
-      <p:sp>
-        <p:nvSpPr>
-          <p:cNvPr id="1347" name="Code panel"/>
+              <a:t xml:space="preserve">A reviewable hypothesis, not a fact</a:t>
+            </a:r>
+          </a:p>
+        </p:txBody>
+      </p:sp>
+      <p:sp>
+        <p:nvSpPr>
+          <p:cNvPr id="1341" name="Code panel"/>
           <p:cNvSpPr/>
           <p:nvPr/>
         </p:nvSpPr>
         <p:spPr>
           <a:xfrm>
-            <a:off x="8001000" y="4133087"/>
-            <a:ext cx="3246120" cy="1170432"/>
+            <a:off x="8001000" y="3200400"/>
+            <a:ext cx="3246120" cy="1691640"/>
           </a:xfrm>
           <a:prstGeom prst="roundRect">
             <a:avLst>
@@ -6014,13 +5806,13 @@
       </p:sp>
       <p:sp>
         <p:nvSpPr>
-          <p:cNvPr id="1348" name="Code line 1348"/>
+          <p:cNvPr id="1342" name="Code line 1342"/>
           <p:cNvSpPr txBox="1"/>
           <p:nvPr/>
         </p:nvSpPr>
         <p:spPr>
           <a:xfrm>
-            <a:off x="8001000" y="4197096"/>
+            <a:off x="8001000" y="3264408"/>
             <a:ext cx="3200400" cy="173736"/>
           </a:xfrm>
           <a:prstGeom prst="rect">
@@ -6047,7 +5839,7 @@
                 <a:latin typeface="Consolas"/>
                 <a:cs typeface="Consolas"/>
               </a:rPr>
-              <a:t xml:space="preserve">DataProperty:</a:t>
+              <a:t xml:space="preserve">Individual:</a:t>
             </a:r>
             <a:r>
               <a:rPr lang="en-US" sz="1000" b="0" i="0" dirty="0">
@@ -6067,7 +5859,7 @@
                 <a:latin typeface="Consolas"/>
                 <a:cs typeface="Consolas"/>
               </a:rPr>
-              <a:t xml:space="preserve">BM_DEP</a:t>
+              <a:t xml:space="preserve">cisplatin_bmdep</a:t>
             </a:r>
             <a:endParaRPr lang="en-US" sz="1000"/>
           </a:p>
@@ -6075,13 +5867,13 @@
       </p:sp>
       <p:sp>
         <p:nvSpPr>
-          <p:cNvPr id="1349" name="Code line 1349"/>
+          <p:cNvPr id="1343" name="Code line 1343"/>
           <p:cNvSpPr txBox="1"/>
           <p:nvPr/>
         </p:nvSpPr>
         <p:spPr>
           <a:xfrm>
-            <a:off x="8001000" y="4370832"/>
+            <a:off x="8001000" y="3438144"/>
             <a:ext cx="3200400" cy="173736"/>
           </a:xfrm>
           <a:prstGeom prst="rect">
@@ -6118,7 +5910,27 @@
                 <a:latin typeface="Consolas"/>
                 <a:cs typeface="Consolas"/>
               </a:rPr>
-              <a:t xml:space="preserve">Annotations:</a:t>
+              <a:t xml:space="preserve">Types:</a:t>
+            </a:r>
+            <a:r>
+              <a:rPr lang="en-US" sz="1000" b="0" i="0" dirty="0">
+                <a:solidFill>
+                  <a:srgbClr val="1F2328"/>
+                </a:solidFill>
+                <a:latin typeface="Consolas"/>
+                <a:cs typeface="Consolas"/>
+              </a:rPr>
+              <a:t xml:space="preserve"> </a:t>
+            </a:r>
+            <a:r>
+              <a:rPr lang="en-US" sz="1000" b="0" i="0" dirty="0">
+                <a:solidFill>
+                  <a:srgbClr val="1F2328"/>
+                </a:solidFill>
+                <a:latin typeface="Consolas"/>
+                <a:cs typeface="Consolas"/>
+              </a:rPr>
+              <a:t xml:space="preserve">CandidateAssociation</a:t>
             </a:r>
             <a:endParaRPr lang="en-US" sz="1000"/>
           </a:p>
@@ -6126,13 +5938,13 @@
       </p:sp>
       <p:sp>
         <p:nvSpPr>
-          <p:cNvPr id="1350" name="Code line 1350"/>
+          <p:cNvPr id="1344" name="Code line 1344"/>
           <p:cNvSpPr txBox="1"/>
           <p:nvPr/>
         </p:nvSpPr>
         <p:spPr>
           <a:xfrm>
-            <a:off x="8001000" y="4544568"/>
+            <a:off x="8001000" y="3611879"/>
             <a:ext cx="3200400" cy="173736"/>
           </a:xfrm>
           <a:prstGeom prst="rect">
@@ -6159,47 +5971,17 @@
                 <a:latin typeface="Consolas"/>
                 <a:cs typeface="Consolas"/>
               </a:rPr>
-              <a:t xml:space="preserve">    </a:t>
-            </a:r>
-            <a:r>
-              <a:rPr lang="en-US" sz="1000" b="0" i="0" dirty="0">
-                <a:solidFill>
-                  <a:srgbClr val="5B6770"/>
+              <a:t xml:space="preserve">  </a:t>
+            </a:r>
+            <a:r>
+              <a:rPr lang="en-US" sz="1000" b="1" i="0" dirty="0">
+                <a:solidFill>
+                  <a:srgbClr val="0B6E4F"/>
                 </a:solidFill>
                 <a:latin typeface="Consolas"/>
                 <a:cs typeface="Consolas"/>
               </a:rPr>
-              <a:t xml:space="preserve">rdfs:label</a:t>
-            </a:r>
-            <a:r>
-              <a:rPr lang="en-US" sz="1000" b="0" i="0" dirty="0">
-                <a:solidFill>
-                  <a:srgbClr val="1F2328"/>
-                </a:solidFill>
-                <a:latin typeface="Consolas"/>
-                <a:cs typeface="Consolas"/>
-              </a:rPr>
-              <a:t xml:space="preserve"> </a:t>
-            </a:r>
-            <a:r>
-              <a:rPr lang="en-US" sz="1000" b="0" i="0" dirty="0">
-                <a:solidFill>
-                  <a:srgbClr val="A3401E"/>
-                </a:solidFill>
-                <a:latin typeface="Consolas"/>
-                <a:cs typeface="Consolas"/>
-              </a:rPr>
-              <a:t xml:space="preserve">"Bone marrow depression"@en</a:t>
-            </a:r>
-            <a:r>
-              <a:rPr lang="en-US" sz="1000" b="0" i="0" dirty="0">
-                <a:solidFill>
-                  <a:srgbClr val="1F2328"/>
-                </a:solidFill>
-                <a:latin typeface="Consolas"/>
-                <a:cs typeface="Consolas"/>
-              </a:rPr>
-              <a:t xml:space="preserve">,</a:t>
+              <a:t xml:space="preserve">Facts:</a:t>
             </a:r>
             <a:endParaRPr lang="en-US" sz="1000"/>
           </a:p>
@@ -6207,13 +5989,13 @@
       </p:sp>
       <p:sp>
         <p:nvSpPr>
-          <p:cNvPr id="1351" name="Code line 1351"/>
+          <p:cNvPr id="1345" name="Code line 1345"/>
           <p:cNvSpPr txBox="1"/>
           <p:nvPr/>
         </p:nvSpPr>
         <p:spPr>
           <a:xfrm>
-            <a:off x="8001000" y="4718304"/>
+            <a:off x="8001000" y="3785615"/>
             <a:ext cx="3200400" cy="173736"/>
           </a:xfrm>
           <a:prstGeom prst="rect">
@@ -6245,12 +6027,12 @@
             <a:r>
               <a:rPr lang="en-US" sz="1000" b="0" i="0" dirty="0">
                 <a:solidFill>
-                  <a:srgbClr val="5B6770"/>
+                  <a:srgbClr val="1F2328"/>
                 </a:solidFill>
                 <a:latin typeface="Consolas"/>
                 <a:cs typeface="Consolas"/>
               </a:rPr>
-              <a:t xml:space="preserve">rdfs:comment</a:t>
+              <a:t xml:space="preserve">hasDrug</a:t>
             </a:r>
             <a:r>
               <a:rPr lang="en-US" sz="1000" b="0" i="0" dirty="0">
@@ -6265,12 +6047,12 @@
             <a:r>
               <a:rPr lang="en-US" sz="1000" b="0" i="0" dirty="0">
                 <a:solidFill>
-                  <a:srgbClr val="A3401E"/>
+                  <a:srgbClr val="1F2328"/>
                 </a:solidFill>
                 <a:latin typeface="Consolas"/>
                 <a:cs typeface="Consolas"/>
               </a:rPr>
-              <a:t xml:space="preserve">"1 = yes, 0 = no"@en</a:t>
+              <a:t xml:space="preserve">Cisplatin</a:t>
             </a:r>
             <a:r>
               <a:rPr lang="en-US" sz="1000" b="0" i="0" dirty="0">
@@ -6288,13 +6070,13 @@
       </p:sp>
       <p:sp>
         <p:nvSpPr>
-          <p:cNvPr id="1352" name="Code line 1352"/>
+          <p:cNvPr id="1346" name="Code line 1346"/>
           <p:cNvSpPr txBox="1"/>
           <p:nvPr/>
         </p:nvSpPr>
         <p:spPr>
           <a:xfrm>
-            <a:off x="8001000" y="4892040"/>
+            <a:off x="8001000" y="3959352"/>
             <a:ext cx="3200400" cy="173736"/>
           </a:xfrm>
           <a:prstGeom prst="rect">
@@ -6326,12 +6108,12 @@
             <a:r>
               <a:rPr lang="en-US" sz="1000" b="0" i="0" dirty="0">
                 <a:solidFill>
-                  <a:srgbClr val="5B6770"/>
+                  <a:srgbClr val="1F2328"/>
                 </a:solidFill>
                 <a:latin typeface="Consolas"/>
                 <a:cs typeface="Consolas"/>
               </a:rPr>
-              <a:t xml:space="preserve">prov:wasDerivedFrom</a:t>
+              <a:t xml:space="preserve">hasCondition</a:t>
             </a:r>
             <a:r>
               <a:rPr lang="en-US" sz="1000" b="0" i="0" dirty="0">
@@ -6346,12 +6128,12 @@
             <a:r>
               <a:rPr lang="en-US" sz="1000" b="0" i="0" dirty="0">
                 <a:solidFill>
-                  <a:srgbClr val="2F6B78"/>
+                  <a:srgbClr val="1F2328"/>
                 </a:solidFill>
                 <a:latin typeface="Consolas"/>
                 <a:cs typeface="Consolas"/>
               </a:rPr>
-              <a:t xml:space="preserve">admission:BM_DEP</a:t>
+              <a:t xml:space="preserve">BoneMarrowDepression</a:t>
             </a:r>
             <a:r>
               <a:rPr lang="en-US" sz="1000" b="0" i="0" dirty="0">
@@ -6369,13 +6151,13 @@
       </p:sp>
       <p:sp>
         <p:nvSpPr>
-          <p:cNvPr id="1353" name="Code line 1353"/>
+          <p:cNvPr id="1347" name="Code line 1347"/>
           <p:cNvSpPr txBox="1"/>
           <p:nvPr/>
         </p:nvSpPr>
         <p:spPr>
           <a:xfrm>
-            <a:off x="8001000" y="5065776"/>
+            <a:off x="8001000" y="4133087"/>
             <a:ext cx="3200400" cy="173736"/>
           </a:xfrm>
           <a:prstGeom prst="rect">
@@ -6407,12 +6189,12 @@
             <a:r>
               <a:rPr lang="en-US" sz="1000" b="0" i="0" dirty="0">
                 <a:solidFill>
-                  <a:srgbClr val="5B6770"/>
+                  <a:srgbClr val="1F2328"/>
                 </a:solidFill>
                 <a:latin typeface="Consolas"/>
                 <a:cs typeface="Consolas"/>
               </a:rPr>
-              <a:t xml:space="preserve">prov:wasDerivedFrom</a:t>
+              <a:t xml:space="preserve">status</a:t>
             </a:r>
             <a:r>
               <a:rPr lang="en-US" sz="1000" b="0" i="0" dirty="0">
@@ -6427,27 +6209,230 @@
             <a:r>
               <a:rPr lang="en-US" sz="1000" b="0" i="0" dirty="0">
                 <a:solidFill>
-                  <a:srgbClr val="2F6B78"/>
+                  <a:srgbClr val="A3401E"/>
                 </a:solidFill>
                 <a:latin typeface="Consolas"/>
                 <a:cs typeface="Consolas"/>
               </a:rPr>
+              <a:t xml:space="preserve">"needs expert review"</a:t>
+            </a:r>
+            <a:endParaRPr lang="en-US" sz="1000"/>
+          </a:p>
+        </p:txBody>
+      </p:sp>
+      <p:sp>
+        <p:nvSpPr>
+          <p:cNvPr id="1348" name="Code line 1348"/>
+          <p:cNvSpPr txBox="1"/>
+          <p:nvPr/>
+        </p:nvSpPr>
+        <p:spPr>
+          <a:xfrm>
+            <a:off x="8001000" y="4306824"/>
+            <a:ext cx="3200400" cy="173736"/>
+          </a:xfrm>
+          <a:prstGeom prst="rect">
+            <a:avLst/>
+          </a:prstGeom>
+          <a:noFill/>
+        </p:spPr>
+        <p:txBody>
+          <a:bodyPr wrap="none" lIns="146304" tIns="0" rIns="0" bIns="0" anchor="ctr">
+            <a:noAutofit/>
+          </a:bodyPr>
+          <a:lstStyle/>
+          <a:p>
+            <a:pPr>
+              <a:tabLst>
+                <a:tab pos="4224528" algn="l"/>
+              </a:tabLst>
+            </a:pPr>
+            <a:r>
+              <a:rPr lang="en-US" sz="1000" b="0" i="0" dirty="0">
+                <a:solidFill>
+                  <a:srgbClr val="1F2328"/>
+                </a:solidFill>
+                <a:latin typeface="Consolas"/>
+                <a:cs typeface="Consolas"/>
+              </a:rPr>
+              <a:t xml:space="preserve">  </a:t>
+            </a:r>
+            <a:r>
+              <a:rPr lang="en-US" sz="1000" b="1" i="0" dirty="0">
+                <a:solidFill>
+                  <a:srgbClr val="0B6E4F"/>
+                </a:solidFill>
+                <a:latin typeface="Consolas"/>
+                <a:cs typeface="Consolas"/>
+              </a:rPr>
+              <a:t xml:space="preserve">Annotations:</a:t>
+            </a:r>
+            <a:endParaRPr lang="en-US" sz="1000"/>
+          </a:p>
+        </p:txBody>
+      </p:sp>
+      <p:sp>
+        <p:nvSpPr>
+          <p:cNvPr id="1349" name="Code line 1349"/>
+          <p:cNvSpPr txBox="1"/>
+          <p:nvPr/>
+        </p:nvSpPr>
+        <p:spPr>
+          <a:xfrm>
+            <a:off x="8001000" y="4480560"/>
+            <a:ext cx="3200400" cy="173736"/>
+          </a:xfrm>
+          <a:prstGeom prst="rect">
+            <a:avLst/>
+          </a:prstGeom>
+          <a:noFill/>
+        </p:spPr>
+        <p:txBody>
+          <a:bodyPr wrap="none" lIns="146304" tIns="0" rIns="0" bIns="0" anchor="ctr">
+            <a:noAutofit/>
+          </a:bodyPr>
+          <a:lstStyle/>
+          <a:p>
+            <a:pPr>
+              <a:tabLst>
+                <a:tab pos="4224528" algn="l"/>
+              </a:tabLst>
+            </a:pPr>
+            <a:r>
+              <a:rPr lang="en-US" sz="1000" b="0" i="0" dirty="0">
+                <a:solidFill>
+                  <a:srgbClr val="1F2328"/>
+                </a:solidFill>
+                <a:latin typeface="Consolas"/>
+                <a:cs typeface="Consolas"/>
+              </a:rPr>
+              <a:t xml:space="preserve">    </a:t>
+            </a:r>
+            <a:r>
+              <a:rPr lang="en-US" sz="1000" b="0" i="0" dirty="0">
+                <a:solidFill>
+                  <a:srgbClr val="5B6770"/>
+                </a:solidFill>
+                <a:latin typeface="Consolas"/>
+                <a:cs typeface="Consolas"/>
+              </a:rPr>
+              <a:t xml:space="preserve">prov:wasDerivedFrom</a:t>
+            </a:r>
+            <a:r>
+              <a:rPr lang="en-US" sz="1000" b="0" i="0" dirty="0">
+                <a:solidFill>
+                  <a:srgbClr val="1F2328"/>
+                </a:solidFill>
+                <a:latin typeface="Consolas"/>
+                <a:cs typeface="Consolas"/>
+              </a:rPr>
+              <a:t xml:space="preserve"> </a:t>
+            </a:r>
+            <a:r>
+              <a:rPr lang="en-US" sz="1000" b="0" i="0" dirty="0">
+                <a:solidFill>
+                  <a:srgbClr val="2F6B78"/>
+                </a:solidFill>
+                <a:latin typeface="Consolas"/>
+                <a:cs typeface="Consolas"/>
+              </a:rPr>
               <a:t xml:space="preserve">treatment:drug</a:t>
             </a:r>
+            <a:r>
+              <a:rPr lang="en-US" sz="1000" b="0" i="0" dirty="0">
+                <a:solidFill>
+                  <a:srgbClr val="1F2328"/>
+                </a:solidFill>
+                <a:latin typeface="Consolas"/>
+                <a:cs typeface="Consolas"/>
+              </a:rPr>
+              <a:t xml:space="preserve">,</a:t>
+            </a:r>
             <a:endParaRPr lang="en-US" sz="1000"/>
           </a:p>
         </p:txBody>
       </p:sp>
       <p:sp>
         <p:nvSpPr>
-          <p:cNvPr id="1354" name="Candidate"/>
+          <p:cNvPr id="1350" name="Code line 1350"/>
+          <p:cNvSpPr txBox="1"/>
+          <p:nvPr/>
+        </p:nvSpPr>
+        <p:spPr>
+          <a:xfrm>
+            <a:off x="8001000" y="4654296"/>
+            <a:ext cx="3200400" cy="173736"/>
+          </a:xfrm>
+          <a:prstGeom prst="rect">
+            <a:avLst/>
+          </a:prstGeom>
+          <a:noFill/>
+        </p:spPr>
+        <p:txBody>
+          <a:bodyPr wrap="none" lIns="146304" tIns="0" rIns="0" bIns="0" anchor="ctr">
+            <a:noAutofit/>
+          </a:bodyPr>
+          <a:lstStyle/>
+          <a:p>
+            <a:pPr>
+              <a:tabLst>
+                <a:tab pos="4224528" algn="l"/>
+              </a:tabLst>
+            </a:pPr>
+            <a:r>
+              <a:rPr lang="en-US" sz="1000" b="0" i="0" dirty="0">
+                <a:solidFill>
+                  <a:srgbClr val="1F2328"/>
+                </a:solidFill>
+                <a:latin typeface="Consolas"/>
+                <a:cs typeface="Consolas"/>
+              </a:rPr>
+              <a:t xml:space="preserve">    </a:t>
+            </a:r>
+            <a:r>
+              <a:rPr lang="en-US" sz="1000" b="0" i="0" dirty="0">
+                <a:solidFill>
+                  <a:srgbClr val="5B6770"/>
+                </a:solidFill>
+                <a:latin typeface="Consolas"/>
+                <a:cs typeface="Consolas"/>
+              </a:rPr>
+              <a:t xml:space="preserve">prov:wasDerivedFrom</a:t>
+            </a:r>
+            <a:r>
+              <a:rPr lang="en-US" sz="1000" b="0" i="0" dirty="0">
+                <a:solidFill>
+                  <a:srgbClr val="1F2328"/>
+                </a:solidFill>
+                <a:latin typeface="Consolas"/>
+                <a:cs typeface="Consolas"/>
+              </a:rPr>
+              <a:t xml:space="preserve"> </a:t>
+            </a:r>
+            <a:r>
+              <a:rPr lang="en-US" sz="1000" b="0" i="0" dirty="0">
+                <a:solidFill>
+                  <a:srgbClr val="2F6B78"/>
+                </a:solidFill>
+                <a:latin typeface="Consolas"/>
+                <a:cs typeface="Consolas"/>
+              </a:rPr>
+              <a:t xml:space="preserve">admission:BM_DEP</a:t>
+            </a:r>
+            <a:endParaRPr lang="en-US" sz="1000"/>
+          </a:p>
+        </p:txBody>
+      </p:sp>
+      <p:sp>
+        <p:nvSpPr>
+          <p:cNvPr id="1351" name="Candidate"/>
           <p:cNvSpPr/>
           <p:nvPr/>
         </p:nvSpPr>
         <p:spPr>
           <a:xfrm>
-            <a:off x="8001000" y="5340096"/>
-            <a:ext cx="3246120" cy="292608"/>
+            <a:off x="8001000" y="5065776"/>
+            <a:ext cx="3246120" cy="512064"/>
           </a:xfrm>
           <a:prstGeom prst="roundRect">
             <a:avLst>
@@ -6462,38 +6447,38 @@
           </a:ln>
         </p:spPr>
         <p:txBody>
-          <a:bodyPr wrap="square" lIns="0" tIns="0" rIns="0" bIns="0" anchor="ctr">
+          <a:bodyPr wrap="square" lIns="91440" tIns="0" rIns="91440" bIns="0" anchor="ctr">
             <a:noAutofit/>
           </a:bodyPr>
           <a:lstStyle/>
           <a:p>
             <a:pPr algn="ctr"/>
             <a:r>
-              <a:rPr lang="en-US" sz="1150" b="1" i="0" dirty="0">
+              <a:rPr lang="en-US" sz="1100" b="1" i="0" dirty="0">
                 <a:solidFill>
                   <a:srgbClr val="93600F"/>
                 </a:solidFill>
                 <a:latin typeface="Consolas"/>
                 <a:cs typeface="Consolas"/>
               </a:rPr>
-              <a:t xml:space="preserve">CANDIDATE  </a:t>
-            </a:r>
-            <a:r>
-              <a:rPr lang="en-US" sz="1200" b="0" i="0" dirty="0">
+              <a:t xml:space="preserve">A PATTERN, NOT A CAUSE  </a:t>
+            </a:r>
+            <a:r>
+              <a:rPr lang="en-US" sz="1150" b="0" i="0" dirty="0">
                 <a:solidFill>
                   <a:srgbClr val="3A434C"/>
                 </a:solidFill>
                 <a:latin typeface="Calibri"/>
                 <a:cs typeface="Calibri"/>
               </a:rPr>
-              <a:t xml:space="preserve">an expert confirms it first</a:t>
-            </a:r>
-          </a:p>
-        </p:txBody>
-      </p:sp>
-      <p:sp>
-        <p:nvSpPr>
-          <p:cNvPr id="1355" name="Arrow"/>
+              <a:t xml:space="preserve">an expert reviews it before it joins the ontology</a:t>
+            </a:r>
+          </a:p>
+        </p:txBody>
+      </p:sp>
+      <p:sp>
+        <p:nvSpPr>
+          <p:cNvPr id="1352" name="Arrow"/>
           <p:cNvSpPr/>
           <p:nvPr/>
         </p:nvSpPr>
@@ -6515,7 +6500,7 @@
       </p:sp>
       <p:sp>
         <p:nvSpPr>
-          <p:cNvPr id="1356" name="Arrow"/>
+          <p:cNvPr id="1353" name="Arrow"/>
           <p:cNvSpPr/>
           <p:nvPr/>
         </p:nvSpPr>
@@ -6537,7 +6522,7 @@
       </p:sp>
       <p:sp>
         <p:nvSpPr>
-          <p:cNvPr id="1357" name="Source"/>
+          <p:cNvPr id="1354" name="Source"/>
           <p:cNvSpPr txBox="1"/>
           <p:nvPr/>
         </p:nvSpPr>
@@ -6569,7 +6554,7 @@
                 <a:latin typeface="Calibri"/>
                 <a:cs typeface="Calibri"/>
               </a:rPr>
-              <a:t xml:space="preserve">Rows are synthetic. Instance-level signals to disambiguate cryptic columns when documentation is unavailable: paper Sec. 5.</a:t>
+              <a:t xml:space="preserve">Rows are synthetic. In practice, RIGOR would use aggregate statistics only, so patient data stays in the hospital.</a:t>
             </a:r>
           </a:p>
         </p:txBody>

</xml_diff>

<commit_message>
Enlarge future-work panel fonts; drop table counts from R5 footer
R5 headline wording is still under review with the author.

Co-Authored-By: Claude Opus 5.5 <noreply@anthropic.com>
Claude-Session: https://claude.ai/code/session_01KcycczqUBG98FnzsgJYAW8
</commit_message>
<xml_diff>
--- a/presentation/RIGOR_future_work.pptx
+++ b/presentation/RIGOR_future_work.pptx
@@ -1785,7 +1785,7 @@
                 <a:cs typeface="Calibri"/>
                 <a:sym typeface="Calibri"/>
               </a:rPr>
-              <a:t>[12:03–12:52]  SPOKEN SCRIPT (86 words)</a:t>
+              <a:t>[12:00–12:49]  SPOKEN SCRIPT (86 words)</a:t>
             </a:r>
           </a:p>
           <a:p>
@@ -3924,8 +3924,8 @@
         </p:nvSpPr>
         <p:spPr>
           <a:xfrm>
-            <a:off x="804672" y="2395728"/>
-            <a:ext cx="3246120" cy="3364992"/>
+            <a:off x="804672" y="2304288"/>
+            <a:ext cx="3246120" cy="3566160"/>
           </a:xfrm>
           <a:prstGeom prst="roundRect">
             <a:avLst>
@@ -3959,7 +3959,7 @@
         </p:nvSpPr>
         <p:spPr>
           <a:xfrm>
-            <a:off x="1033271" y="2560320"/>
+            <a:off x="1033271" y="2468880"/>
             <a:ext cx="2788920" cy="274320"/>
           </a:xfrm>
           <a:prstGeom prst="rect">
@@ -3998,7 +3998,7 @@
         </p:nvSpPr>
         <p:spPr>
           <a:xfrm>
-            <a:off x="1033271" y="2834640"/>
+            <a:off x="1033271" y="2743200"/>
             <a:ext cx="2788920" cy="237744"/>
           </a:xfrm>
           <a:prstGeom prst="rect">
@@ -4037,8 +4037,8 @@
         </p:nvSpPr>
         <p:spPr>
           <a:xfrm>
-            <a:off x="941832" y="3145536"/>
-            <a:ext cx="2971800" cy="1120140"/>
+            <a:off x="941832" y="3054096"/>
+            <a:ext cx="2971800" cy="1312164"/>
           </a:xfrm>
           <a:prstGeom prst="roundRect">
             <a:avLst>
@@ -4077,8 +4077,8 @@
         </p:nvSpPr>
         <p:spPr>
           <a:xfrm>
-            <a:off x="1078992" y="3172968"/>
-            <a:ext cx="2697480" cy="246888"/>
+            <a:off x="1078992" y="3081527"/>
+            <a:ext cx="2697480" cy="274320"/>
           </a:xfrm>
           <a:prstGeom prst="rect">
             <a:avLst/>
@@ -4096,7 +4096,7 @@
           <a:p>
             <a:pPr algn="l"/>
             <a:r>
-              <a:rPr lang="en-US" sz="1450" b="1" i="0" dirty="0">
+              <a:rPr lang="en-US" sz="1600" b="1" i="0" dirty="0">
                 <a:solidFill>
                   <a:srgbClr val="1F2328"/>
                 </a:solidFill>
@@ -4116,7 +4116,7 @@
         </p:nvSpPr>
         <p:spPr>
           <a:xfrm>
-            <a:off x="1078992" y="3438144"/>
+            <a:off x="1078992" y="3383279"/>
             <a:ext cx="2697480" cy="10972"/>
           </a:xfrm>
           <a:prstGeom prst="rect">
@@ -4147,8 +4147,8 @@
         </p:nvSpPr>
         <p:spPr>
           <a:xfrm>
-            <a:off x="1078992" y="3465576"/>
-            <a:ext cx="1051560" cy="182880"/>
+            <a:off x="1078992" y="3410712"/>
+            <a:ext cx="1051560" cy="219456"/>
           </a:xfrm>
           <a:prstGeom prst="rect">
             <a:avLst/>
@@ -4166,7 +4166,7 @@
           <a:p>
             <a:pPr algn="l"/>
             <a:r>
-              <a:rPr lang="en-US" sz="1050" b="1" i="0" dirty="0">
+              <a:rPr lang="en-US" sz="1150" b="1" i="0" dirty="0">
                 <a:solidFill>
                   <a:srgbClr val="0B6E4F"/>
                 </a:solidFill>
@@ -4176,14 +4176,14 @@
               <a:t xml:space="preserve">admission_id</a:t>
             </a:r>
             <a:r>
-              <a:rPr lang="en-US" sz="900" b="0" i="0" dirty="0">
+              <a:rPr lang="en-US" sz="950" b="0" i="0" dirty="0">
                 <a:solidFill>
                   <a:srgbClr val="5B6770"/>
                 </a:solidFill>
                 <a:latin typeface="Calibri"/>
                 <a:cs typeface="Calibri"/>
               </a:rPr>
-              <a:t xml:space="preserve">  FK</a:t>
+              <a:t xml:space="preserve"> FK</a:t>
             </a:r>
           </a:p>
         </p:txBody>
@@ -4196,8 +4196,8 @@
         </p:nvSpPr>
         <p:spPr>
           <a:xfrm>
-            <a:off x="2130552" y="3465576"/>
-            <a:ext cx="1463040" cy="182880"/>
+            <a:off x="2130552" y="3410712"/>
+            <a:ext cx="1463040" cy="219456"/>
           </a:xfrm>
           <a:prstGeom prst="rect">
             <a:avLst/>
@@ -4215,7 +4215,7 @@
           <a:p>
             <a:pPr algn="l"/>
             <a:r>
-              <a:rPr lang="en-US" sz="1050" b="1" i="0" dirty="0">
+              <a:rPr lang="en-US" sz="1150" b="1" i="0" dirty="0">
                 <a:solidFill>
                   <a:srgbClr val="0B6E4F"/>
                 </a:solidFill>
@@ -4235,8 +4235,8 @@
         </p:nvSpPr>
         <p:spPr>
           <a:xfrm>
-            <a:off x="1014984" y="3657600"/>
-            <a:ext cx="2825496" cy="173736"/>
+            <a:off x="1014984" y="3639312"/>
+            <a:ext cx="2825496" cy="205740"/>
           </a:xfrm>
           <a:prstGeom prst="rect">
             <a:avLst/>
@@ -4266,8 +4266,8 @@
         </p:nvSpPr>
         <p:spPr>
           <a:xfrm>
-            <a:off x="1078992" y="3657600"/>
-            <a:ext cx="1051560" cy="173736"/>
+            <a:off x="1078992" y="3639312"/>
+            <a:ext cx="1051560" cy="205740"/>
           </a:xfrm>
           <a:prstGeom prst="rect">
             <a:avLst/>
@@ -4285,7 +4285,7 @@
           <a:p>
             <a:pPr algn="l"/>
             <a:r>
-              <a:rPr lang="en-US" sz="1050" b="0" i="0" dirty="0">
+              <a:rPr lang="en-US" sz="1250" b="0" i="0" dirty="0">
                 <a:solidFill>
                   <a:srgbClr val="1F2328"/>
                 </a:solidFill>
@@ -4305,8 +4305,8 @@
         </p:nvSpPr>
         <p:spPr>
           <a:xfrm>
-            <a:off x="2130552" y="3657600"/>
-            <a:ext cx="1463040" cy="173736"/>
+            <a:off x="2130552" y="3639312"/>
+            <a:ext cx="1463040" cy="205740"/>
           </a:xfrm>
           <a:prstGeom prst="rect">
             <a:avLst/>
@@ -4324,7 +4324,7 @@
           <a:p>
             <a:pPr algn="l"/>
             <a:r>
-              <a:rPr lang="en-US" sz="1050" b="0" i="0" dirty="0">
+              <a:rPr lang="en-US" sz="1250" b="0" i="0" dirty="0">
                 <a:solidFill>
                   <a:srgbClr val="1F2328"/>
                 </a:solidFill>
@@ -4344,8 +4344,8 @@
         </p:nvSpPr>
         <p:spPr>
           <a:xfrm>
-            <a:off x="1078992" y="3845052"/>
-            <a:ext cx="1051560" cy="173736"/>
+            <a:off x="1078992" y="3863339"/>
+            <a:ext cx="1051560" cy="205740"/>
           </a:xfrm>
           <a:prstGeom prst="rect">
             <a:avLst/>
@@ -4363,7 +4363,7 @@
           <a:p>
             <a:pPr algn="l"/>
             <a:r>
-              <a:rPr lang="en-US" sz="1050" b="0" i="0" dirty="0">
+              <a:rPr lang="en-US" sz="1250" b="0" i="0" dirty="0">
                 <a:solidFill>
                   <a:srgbClr val="1F2328"/>
                 </a:solidFill>
@@ -4383,8 +4383,8 @@
         </p:nvSpPr>
         <p:spPr>
           <a:xfrm>
-            <a:off x="2130552" y="3845052"/>
-            <a:ext cx="1463040" cy="173736"/>
+            <a:off x="2130552" y="3863339"/>
+            <a:ext cx="1463040" cy="205740"/>
           </a:xfrm>
           <a:prstGeom prst="rect">
             <a:avLst/>
@@ -4402,7 +4402,7 @@
           <a:p>
             <a:pPr algn="l"/>
             <a:r>
-              <a:rPr lang="en-US" sz="1050" b="0" i="0" dirty="0">
+              <a:rPr lang="en-US" sz="1250" b="0" i="0" dirty="0">
                 <a:solidFill>
                   <a:srgbClr val="1F2328"/>
                 </a:solidFill>
@@ -4422,8 +4422,8 @@
         </p:nvSpPr>
         <p:spPr>
           <a:xfrm>
-            <a:off x="1014984" y="4032504"/>
-            <a:ext cx="2825496" cy="173736"/>
+            <a:off x="1014984" y="4087368"/>
+            <a:ext cx="2825496" cy="205740"/>
           </a:xfrm>
           <a:prstGeom prst="rect">
             <a:avLst/>
@@ -4453,8 +4453,8 @@
         </p:nvSpPr>
         <p:spPr>
           <a:xfrm>
-            <a:off x="1078992" y="4032504"/>
-            <a:ext cx="1051560" cy="173736"/>
+            <a:off x="1078992" y="4087368"/>
+            <a:ext cx="1051560" cy="205740"/>
           </a:xfrm>
           <a:prstGeom prst="rect">
             <a:avLst/>
@@ -4472,7 +4472,7 @@
           <a:p>
             <a:pPr algn="l"/>
             <a:r>
-              <a:rPr lang="en-US" sz="1050" b="0" i="0" dirty="0">
+              <a:rPr lang="en-US" sz="1250" b="0" i="0" dirty="0">
                 <a:solidFill>
                   <a:srgbClr val="1F2328"/>
                 </a:solidFill>
@@ -4492,8 +4492,8 @@
         </p:nvSpPr>
         <p:spPr>
           <a:xfrm>
-            <a:off x="2130552" y="4032504"/>
-            <a:ext cx="1463040" cy="173736"/>
+            <a:off x="2130552" y="4087368"/>
+            <a:ext cx="1463040" cy="205740"/>
           </a:xfrm>
           <a:prstGeom prst="rect">
             <a:avLst/>
@@ -4511,7 +4511,7 @@
           <a:p>
             <a:pPr algn="l"/>
             <a:r>
-              <a:rPr lang="en-US" sz="1050" b="0" i="0" dirty="0">
+              <a:rPr lang="en-US" sz="1250" b="0" i="0" dirty="0">
                 <a:solidFill>
                   <a:srgbClr val="1F2328"/>
                 </a:solidFill>
@@ -4531,8 +4531,8 @@
         </p:nvSpPr>
         <p:spPr>
           <a:xfrm>
-            <a:off x="941832" y="4357116"/>
-            <a:ext cx="2971800" cy="1120140"/>
+            <a:off x="941832" y="4457700"/>
+            <a:ext cx="2971800" cy="1312164"/>
           </a:xfrm>
           <a:prstGeom prst="roundRect">
             <a:avLst>
@@ -4571,8 +4571,8 @@
         </p:nvSpPr>
         <p:spPr>
           <a:xfrm>
-            <a:off x="1078992" y="4384548"/>
-            <a:ext cx="2697480" cy="246888"/>
+            <a:off x="1078992" y="4485132"/>
+            <a:ext cx="2697480" cy="274320"/>
           </a:xfrm>
           <a:prstGeom prst="rect">
             <a:avLst/>
@@ -4590,7 +4590,7 @@
           <a:p>
             <a:pPr algn="l"/>
             <a:r>
-              <a:rPr lang="en-US" sz="1450" b="1" i="0" dirty="0">
+              <a:rPr lang="en-US" sz="1600" b="1" i="0" dirty="0">
                 <a:solidFill>
                   <a:srgbClr val="1F2328"/>
                 </a:solidFill>
@@ -4610,7 +4610,7 @@
         </p:nvSpPr>
         <p:spPr>
           <a:xfrm>
-            <a:off x="1078992" y="4649724"/>
+            <a:off x="1078992" y="4786884"/>
             <a:ext cx="2697480" cy="10972"/>
           </a:xfrm>
           <a:prstGeom prst="rect">
@@ -4641,8 +4641,8 @@
         </p:nvSpPr>
         <p:spPr>
           <a:xfrm>
-            <a:off x="1078992" y="4677156"/>
-            <a:ext cx="1051560" cy="182880"/>
+            <a:off x="1078992" y="4814316"/>
+            <a:ext cx="1051560" cy="219456"/>
           </a:xfrm>
           <a:prstGeom prst="rect">
             <a:avLst/>
@@ -4660,7 +4660,7 @@
           <a:p>
             <a:pPr algn="l"/>
             <a:r>
-              <a:rPr lang="en-US" sz="1050" b="1" i="0" dirty="0">
+              <a:rPr lang="en-US" sz="1150" b="1" i="0" dirty="0">
                 <a:solidFill>
                   <a:srgbClr val="0B6E4F"/>
                 </a:solidFill>
@@ -4680,8 +4680,8 @@
         </p:nvSpPr>
         <p:spPr>
           <a:xfrm>
-            <a:off x="2130552" y="4677156"/>
-            <a:ext cx="868680" cy="182880"/>
+            <a:off x="2130552" y="4814316"/>
+            <a:ext cx="868680" cy="219456"/>
           </a:xfrm>
           <a:prstGeom prst="rect">
             <a:avLst/>
@@ -4699,7 +4699,7 @@
           <a:p>
             <a:pPr algn="l"/>
             <a:r>
-              <a:rPr lang="en-US" sz="1050" b="1" i="0" dirty="0">
+              <a:rPr lang="en-US" sz="1150" b="1" i="0" dirty="0">
                 <a:solidFill>
                   <a:srgbClr val="0B6E4F"/>
                 </a:solidFill>
@@ -4719,8 +4719,8 @@
         </p:nvSpPr>
         <p:spPr>
           <a:xfrm>
-            <a:off x="2999232" y="4677156"/>
-            <a:ext cx="731520" cy="182880"/>
+            <a:off x="2999232" y="4814316"/>
+            <a:ext cx="731520" cy="219456"/>
           </a:xfrm>
           <a:prstGeom prst="rect">
             <a:avLst/>
@@ -4738,7 +4738,7 @@
           <a:p>
             <a:pPr algn="l"/>
             <a:r>
-              <a:rPr lang="en-US" sz="1050" b="1" i="0" dirty="0">
+              <a:rPr lang="en-US" sz="1150" b="1" i="0" dirty="0">
                 <a:solidFill>
                   <a:srgbClr val="0B6E4F"/>
                 </a:solidFill>
@@ -4758,8 +4758,8 @@
         </p:nvSpPr>
         <p:spPr>
           <a:xfrm>
-            <a:off x="1014984" y="4869180"/>
-            <a:ext cx="2825496" cy="173736"/>
+            <a:off x="1014984" y="5042916"/>
+            <a:ext cx="2825496" cy="205740"/>
           </a:xfrm>
           <a:prstGeom prst="rect">
             <a:avLst/>
@@ -4789,8 +4789,8 @@
         </p:nvSpPr>
         <p:spPr>
           <a:xfrm>
-            <a:off x="1078992" y="4869180"/>
-            <a:ext cx="1051560" cy="173736"/>
+            <a:off x="1078992" y="5042916"/>
+            <a:ext cx="1051560" cy="205740"/>
           </a:xfrm>
           <a:prstGeom prst="rect">
             <a:avLst/>
@@ -4808,7 +4808,7 @@
           <a:p>
             <a:pPr algn="l"/>
             <a:r>
-              <a:rPr lang="en-US" sz="1050" b="0" i="0" dirty="0">
+              <a:rPr lang="en-US" sz="1250" b="0" i="0" dirty="0">
                 <a:solidFill>
                   <a:srgbClr val="1F2328"/>
                 </a:solidFill>
@@ -4828,8 +4828,8 @@
         </p:nvSpPr>
         <p:spPr>
           <a:xfrm>
-            <a:off x="2130552" y="4869180"/>
-            <a:ext cx="868680" cy="173736"/>
+            <a:off x="2130552" y="5042916"/>
+            <a:ext cx="868680" cy="205740"/>
           </a:xfrm>
           <a:prstGeom prst="rect">
             <a:avLst/>
@@ -4847,7 +4847,7 @@
           <a:p>
             <a:pPr algn="l"/>
             <a:r>
-              <a:rPr lang="en-US" sz="1050" b="0" i="0" dirty="0">
+              <a:rPr lang="en-US" sz="1250" b="0" i="0" dirty="0">
                 <a:solidFill>
                   <a:srgbClr val="1F2328"/>
                 </a:solidFill>
@@ -4867,8 +4867,8 @@
         </p:nvSpPr>
         <p:spPr>
           <a:xfrm>
-            <a:off x="2999232" y="4869180"/>
-            <a:ext cx="731520" cy="173736"/>
+            <a:off x="2999232" y="5042916"/>
+            <a:ext cx="731520" cy="205740"/>
           </a:xfrm>
           <a:prstGeom prst="rect">
             <a:avLst/>
@@ -4886,7 +4886,7 @@
           <a:p>
             <a:pPr algn="l"/>
             <a:r>
-              <a:rPr lang="en-US" sz="1050" b="0" i="0" dirty="0">
+              <a:rPr lang="en-US" sz="1250" b="0" i="0" dirty="0">
                 <a:solidFill>
                   <a:srgbClr val="1F2328"/>
                 </a:solidFill>
@@ -4906,8 +4906,8 @@
         </p:nvSpPr>
         <p:spPr>
           <a:xfrm>
-            <a:off x="1078992" y="5056632"/>
-            <a:ext cx="1051560" cy="173736"/>
+            <a:off x="1078992" y="5266944"/>
+            <a:ext cx="1051560" cy="205740"/>
           </a:xfrm>
           <a:prstGeom prst="rect">
             <a:avLst/>
@@ -4925,7 +4925,7 @@
           <a:p>
             <a:pPr algn="l"/>
             <a:r>
-              <a:rPr lang="en-US" sz="1050" b="0" i="0" dirty="0">
+              <a:rPr lang="en-US" sz="1250" b="0" i="0" dirty="0">
                 <a:solidFill>
                   <a:srgbClr val="1F2328"/>
                 </a:solidFill>
@@ -4945,8 +4945,8 @@
         </p:nvSpPr>
         <p:spPr>
           <a:xfrm>
-            <a:off x="2130552" y="5056632"/>
-            <a:ext cx="868680" cy="173736"/>
+            <a:off x="2130552" y="5266944"/>
+            <a:ext cx="868680" cy="205740"/>
           </a:xfrm>
           <a:prstGeom prst="rect">
             <a:avLst/>
@@ -4964,7 +4964,7 @@
           <a:p>
             <a:pPr algn="l"/>
             <a:r>
-              <a:rPr lang="en-US" sz="1050" b="0" i="0" dirty="0">
+              <a:rPr lang="en-US" sz="1250" b="0" i="0" dirty="0">
                 <a:solidFill>
                   <a:srgbClr val="1F2328"/>
                 </a:solidFill>
@@ -4984,8 +4984,8 @@
         </p:nvSpPr>
         <p:spPr>
           <a:xfrm>
-            <a:off x="2999232" y="5056632"/>
-            <a:ext cx="731520" cy="173736"/>
+            <a:off x="2999232" y="5266944"/>
+            <a:ext cx="731520" cy="205740"/>
           </a:xfrm>
           <a:prstGeom prst="rect">
             <a:avLst/>
@@ -5003,7 +5003,7 @@
           <a:p>
             <a:pPr algn="l"/>
             <a:r>
-              <a:rPr lang="en-US" sz="1050" b="0" i="0" dirty="0">
+              <a:rPr lang="en-US" sz="1250" b="0" i="0" dirty="0">
                 <a:solidFill>
                   <a:srgbClr val="1F2328"/>
                 </a:solidFill>
@@ -5023,8 +5023,8 @@
         </p:nvSpPr>
         <p:spPr>
           <a:xfrm>
-            <a:off x="1014984" y="5244084"/>
-            <a:ext cx="2825496" cy="173736"/>
+            <a:off x="1014984" y="5490972"/>
+            <a:ext cx="2825496" cy="205740"/>
           </a:xfrm>
           <a:prstGeom prst="rect">
             <a:avLst/>
@@ -5054,8 +5054,8 @@
         </p:nvSpPr>
         <p:spPr>
           <a:xfrm>
-            <a:off x="1078992" y="5244084"/>
-            <a:ext cx="1051560" cy="173736"/>
+            <a:off x="1078992" y="5490972"/>
+            <a:ext cx="1051560" cy="205740"/>
           </a:xfrm>
           <a:prstGeom prst="rect">
             <a:avLst/>
@@ -5073,7 +5073,7 @@
           <a:p>
             <a:pPr algn="l"/>
             <a:r>
-              <a:rPr lang="en-US" sz="1050" b="0" i="0" dirty="0">
+              <a:rPr lang="en-US" sz="1250" b="0" i="0" dirty="0">
                 <a:solidFill>
                   <a:srgbClr val="1F2328"/>
                 </a:solidFill>
@@ -5093,8 +5093,8 @@
         </p:nvSpPr>
         <p:spPr>
           <a:xfrm>
-            <a:off x="2130552" y="5244084"/>
-            <a:ext cx="868680" cy="173736"/>
+            <a:off x="2130552" y="5490972"/>
+            <a:ext cx="868680" cy="205740"/>
           </a:xfrm>
           <a:prstGeom prst="rect">
             <a:avLst/>
@@ -5112,7 +5112,7 @@
           <a:p>
             <a:pPr algn="l"/>
             <a:r>
-              <a:rPr lang="en-US" sz="1050" b="0" i="0" dirty="0">
+              <a:rPr lang="en-US" sz="1250" b="0" i="0" dirty="0">
                 <a:solidFill>
                   <a:srgbClr val="1F2328"/>
                 </a:solidFill>
@@ -5132,8 +5132,8 @@
         </p:nvSpPr>
         <p:spPr>
           <a:xfrm>
-            <a:off x="2999232" y="5244084"/>
-            <a:ext cx="731520" cy="173736"/>
+            <a:off x="2999232" y="5490972"/>
+            <a:ext cx="731520" cy="205740"/>
           </a:xfrm>
           <a:prstGeom prst="rect">
             <a:avLst/>
@@ -5151,7 +5151,7 @@
           <a:p>
             <a:pPr algn="l"/>
             <a:r>
-              <a:rPr lang="en-US" sz="1050" b="0" i="0" dirty="0">
+              <a:rPr lang="en-US" sz="1250" b="0" i="0" dirty="0">
                 <a:solidFill>
                   <a:srgbClr val="1F2328"/>
                 </a:solidFill>
@@ -5171,8 +5171,8 @@
         </p:nvSpPr>
         <p:spPr>
           <a:xfrm>
-            <a:off x="4379976" y="2395728"/>
-            <a:ext cx="3154680" cy="3364992"/>
+            <a:off x="4379976" y="2304288"/>
+            <a:ext cx="3017520" cy="3566160"/>
           </a:xfrm>
           <a:prstGeom prst="roundRect">
             <a:avLst>
@@ -5206,8 +5206,8 @@
         </p:nvSpPr>
         <p:spPr>
           <a:xfrm>
-            <a:off x="4608576" y="2560320"/>
-            <a:ext cx="2697480" cy="274320"/>
+            <a:off x="4608576" y="2468880"/>
+            <a:ext cx="2560320" cy="274320"/>
           </a:xfrm>
           <a:prstGeom prst="rect">
             <a:avLst/>
@@ -5245,8 +5245,8 @@
         </p:nvSpPr>
         <p:spPr>
           <a:xfrm>
-            <a:off x="4608576" y="2834640"/>
-            <a:ext cx="2697480" cy="237744"/>
+            <a:off x="4608576" y="2743200"/>
+            <a:ext cx="2560320" cy="237744"/>
           </a:xfrm>
           <a:prstGeom prst="rect">
             <a:avLst/>
@@ -5284,8 +5284,8 @@
         </p:nvSpPr>
         <p:spPr>
           <a:xfrm>
-            <a:off x="4608576" y="3172968"/>
-            <a:ext cx="2697480" cy="566928"/>
+            <a:off x="4608576" y="3081528"/>
+            <a:ext cx="2560320" cy="731520"/>
           </a:xfrm>
           <a:prstGeom prst="rect">
             <a:avLst/>
@@ -5303,7 +5303,7 @@
           <a:p>
             <a:pPr algn="l"/>
             <a:r>
-              <a:rPr lang="en-US" sz="1400" b="1" i="0" dirty="0">
+              <a:rPr lang="en-US" sz="1600" b="1" i="0" dirty="0">
                 <a:solidFill>
                   <a:srgbClr val="1F2328"/>
                 </a:solidFill>
@@ -5323,8 +5323,8 @@
         </p:nvSpPr>
         <p:spPr>
           <a:xfrm>
-            <a:off x="4608576" y="3886200"/>
-            <a:ext cx="1143000" cy="274320"/>
+            <a:off x="4608576" y="3995928"/>
+            <a:ext cx="1188720" cy="310896"/>
           </a:xfrm>
           <a:prstGeom prst="rect">
             <a:avLst/>
@@ -5342,7 +5342,7 @@
           <a:p>
             <a:pPr algn="l"/>
             <a:r>
-              <a:rPr lang="en-US" sz="1150" b="0" i="0" dirty="0">
+              <a:rPr lang="en-US" sz="1300" b="0" i="0" dirty="0">
                 <a:solidFill>
                   <a:srgbClr val="1F2328"/>
                 </a:solidFill>
@@ -5362,8 +5362,8 @@
         </p:nvSpPr>
         <p:spPr>
           <a:xfrm>
-            <a:off x="5751576" y="3959352"/>
-            <a:ext cx="960120" cy="128016"/>
+            <a:off x="5797296" y="4087368"/>
+            <a:ext cx="777240" cy="137160"/>
           </a:xfrm>
           <a:prstGeom prst="rect">
             <a:avLst/>
@@ -5393,8 +5393,8 @@
         </p:nvSpPr>
         <p:spPr>
           <a:xfrm>
-            <a:off x="5751576" y="3959352"/>
-            <a:ext cx="960120" cy="128016"/>
+            <a:off x="5797296" y="4087368"/>
+            <a:ext cx="777240" cy="137160"/>
           </a:xfrm>
           <a:prstGeom prst="rect">
             <a:avLst/>
@@ -5424,8 +5424,8 @@
         </p:nvSpPr>
         <p:spPr>
           <a:xfrm>
-            <a:off x="6775704" y="3886200"/>
-            <a:ext cx="594360" cy="274320"/>
+            <a:off x="6620256" y="3995928"/>
+            <a:ext cx="685800" cy="310896"/>
           </a:xfrm>
           <a:prstGeom prst="rect">
             <a:avLst/>
@@ -5443,7 +5443,7 @@
           <a:p>
             <a:pPr algn="l"/>
             <a:r>
-              <a:rPr lang="en-US" sz="1150" b="1" i="0" dirty="0">
+              <a:rPr lang="en-US" sz="1300" b="1" i="0" dirty="0">
                 <a:solidFill>
                   <a:srgbClr val="0B6E4F"/>
                 </a:solidFill>
@@ -5463,8 +5463,8 @@
         </p:nvSpPr>
         <p:spPr>
           <a:xfrm>
-            <a:off x="4608576" y="4233672"/>
-            <a:ext cx="1143000" cy="274320"/>
+            <a:off x="4608576" y="4398264"/>
+            <a:ext cx="1188720" cy="310896"/>
           </a:xfrm>
           <a:prstGeom prst="rect">
             <a:avLst/>
@@ -5482,7 +5482,7 @@
           <a:p>
             <a:pPr algn="l"/>
             <a:r>
-              <a:rPr lang="en-US" sz="1150" b="0" i="0" dirty="0">
+              <a:rPr lang="en-US" sz="1300" b="0" i="0" dirty="0">
                 <a:solidFill>
                   <a:srgbClr val="1F2328"/>
                 </a:solidFill>
@@ -5502,8 +5502,8 @@
         </p:nvSpPr>
         <p:spPr>
           <a:xfrm>
-            <a:off x="5751576" y="4306824"/>
-            <a:ext cx="960120" cy="128016"/>
+            <a:off x="5797296" y="4489704"/>
+            <a:ext cx="777240" cy="137160"/>
           </a:xfrm>
           <a:prstGeom prst="rect">
             <a:avLst/>
@@ -5533,8 +5533,8 @@
         </p:nvSpPr>
         <p:spPr>
           <a:xfrm>
-            <a:off x="6775704" y="4233672"/>
-            <a:ext cx="594360" cy="274320"/>
+            <a:off x="6620256" y="4398264"/>
+            <a:ext cx="685800" cy="310896"/>
           </a:xfrm>
           <a:prstGeom prst="rect">
             <a:avLst/>
@@ -5552,7 +5552,7 @@
           <a:p>
             <a:pPr algn="l"/>
             <a:r>
-              <a:rPr lang="en-US" sz="1150" b="1" i="0" dirty="0">
+              <a:rPr lang="en-US" sz="1300" b="1" i="0" dirty="0">
                 <a:solidFill>
                   <a:srgbClr val="3A434C"/>
                 </a:solidFill>
@@ -5572,8 +5572,8 @@
         </p:nvSpPr>
         <p:spPr>
           <a:xfrm>
-            <a:off x="4608576" y="4562856"/>
-            <a:ext cx="2697480" cy="201168"/>
+            <a:off x="4608576" y="4800600"/>
+            <a:ext cx="2560320" cy="237744"/>
           </a:xfrm>
           <a:prstGeom prst="rect">
             <a:avLst/>
@@ -5591,7 +5591,7 @@
           <a:p>
             <a:pPr algn="l"/>
             <a:r>
-              <a:rPr lang="en-US" sz="950" b="0" i="1" dirty="0">
+              <a:rPr lang="en-US" sz="1100" b="0" i="1" dirty="0">
                 <a:solidFill>
                   <a:srgbClr val="5B6770"/>
                 </a:solidFill>
@@ -5611,8 +5611,8 @@
         </p:nvSpPr>
         <p:spPr>
           <a:xfrm>
-            <a:off x="4517136" y="4937760"/>
-            <a:ext cx="2880360" cy="640080"/>
+            <a:off x="4517136" y="5102352"/>
+            <a:ext cx="2743200" cy="640080"/>
           </a:xfrm>
           <a:prstGeom prst="roundRect">
             <a:avLst>
@@ -5634,7 +5634,7 @@
           <a:p>
             <a:pPr algn="ctr"/>
             <a:r>
-              <a:rPr lang="en-US" sz="1200" b="1" i="0" dirty="0">
+              <a:rPr lang="en-US" sz="1300" b="1" i="0" dirty="0">
                 <a:solidFill>
                   <a:srgbClr val="0B6E4F"/>
                 </a:solidFill>
@@ -5644,7 +5644,7 @@
               <a:t xml:space="preserve">Not in the documentation: </a:t>
             </a:r>
             <a:r>
-              <a:rPr lang="en-US" sz="1200" b="0" i="0" dirty="0">
+              <a:rPr lang="en-US" sz="1300" b="0" i="0" dirty="0">
                 <a:solidFill>
                   <a:srgbClr val="3A434C"/>
                 </a:solidFill>
@@ -5664,8 +5664,8 @@
         </p:nvSpPr>
         <p:spPr>
           <a:xfrm>
-            <a:off x="7863840" y="2395728"/>
-            <a:ext cx="3520440" cy="3364992"/>
+            <a:off x="7726679" y="2304288"/>
+            <a:ext cx="3657600" cy="3566160"/>
           </a:xfrm>
           <a:prstGeom prst="roundRect">
             <a:avLst>
@@ -5699,8 +5699,8 @@
         </p:nvSpPr>
         <p:spPr>
           <a:xfrm>
-            <a:off x="8092440" y="2560320"/>
-            <a:ext cx="3063240" cy="274320"/>
+            <a:off x="7955279" y="2468880"/>
+            <a:ext cx="3200400" cy="274320"/>
           </a:xfrm>
           <a:prstGeom prst="rect">
             <a:avLst/>
@@ -5738,8 +5738,8 @@
         </p:nvSpPr>
         <p:spPr>
           <a:xfrm>
-            <a:off x="8092440" y="2834640"/>
-            <a:ext cx="3063240" cy="256032"/>
+            <a:off x="7955279" y="2743200"/>
+            <a:ext cx="3200400" cy="256032"/>
           </a:xfrm>
           <a:prstGeom prst="rect">
             <a:avLst/>
@@ -5757,7 +5757,7 @@
           <a:p>
             <a:pPr algn="l"/>
             <a:r>
-              <a:rPr lang="en-US" sz="1150" b="0" i="1" dirty="0">
+              <a:rPr lang="en-US" sz="1250" b="0" i="1" dirty="0">
                 <a:solidFill>
                   <a:srgbClr val="5B6770"/>
                 </a:solidFill>
@@ -5777,8 +5777,8 @@
         </p:nvSpPr>
         <p:spPr>
           <a:xfrm>
-            <a:off x="8001000" y="3200400"/>
-            <a:ext cx="3246120" cy="1691640"/>
+            <a:off x="7863840" y="3108960"/>
+            <a:ext cx="3383280" cy="1979676"/>
           </a:xfrm>
           <a:prstGeom prst="roundRect">
             <a:avLst>
@@ -5812,8 +5812,8 @@
         </p:nvSpPr>
         <p:spPr>
           <a:xfrm>
-            <a:off x="8001000" y="3264408"/>
-            <a:ext cx="3200400" cy="173736"/>
+            <a:off x="7863840" y="3172968"/>
+            <a:ext cx="3337560" cy="205740"/>
           </a:xfrm>
           <a:prstGeom prst="rect">
             <a:avLst/>
@@ -5832,7 +5832,7 @@
               </a:tabLst>
             </a:pPr>
             <a:r>
-              <a:rPr lang="en-US" sz="1000" b="1" i="0" dirty="0">
+              <a:rPr lang="en-US" sz="1100" b="1" i="0" dirty="0">
                 <a:solidFill>
                   <a:srgbClr val="0B6E4F"/>
                 </a:solidFill>
@@ -5842,7 +5842,7 @@
               <a:t xml:space="preserve">Individual:</a:t>
             </a:r>
             <a:r>
-              <a:rPr lang="en-US" sz="1000" b="0" i="0" dirty="0">
+              <a:rPr lang="en-US" sz="1100" b="0" i="0" dirty="0">
                 <a:solidFill>
                   <a:srgbClr val="1F2328"/>
                 </a:solidFill>
@@ -5852,7 +5852,7 @@
               <a:t xml:space="preserve"> </a:t>
             </a:r>
             <a:r>
-              <a:rPr lang="en-US" sz="1000" b="0" i="0" dirty="0">
+              <a:rPr lang="en-US" sz="1100" b="0" i="0" dirty="0">
                 <a:solidFill>
                   <a:srgbClr val="1F2328"/>
                 </a:solidFill>
@@ -5861,7 +5861,7 @@
               </a:rPr>
               <a:t xml:space="preserve">cisplatin_bmdep</a:t>
             </a:r>
-            <a:endParaRPr lang="en-US" sz="1000"/>
+            <a:endParaRPr lang="en-US" sz="1100"/>
           </a:p>
         </p:txBody>
       </p:sp>
@@ -5873,8 +5873,8 @@
         </p:nvSpPr>
         <p:spPr>
           <a:xfrm>
-            <a:off x="8001000" y="3438144"/>
-            <a:ext cx="3200400" cy="173736"/>
+            <a:off x="7863840" y="3378708"/>
+            <a:ext cx="3337560" cy="205740"/>
           </a:xfrm>
           <a:prstGeom prst="rect">
             <a:avLst/>
@@ -5893,7 +5893,7 @@
               </a:tabLst>
             </a:pPr>
             <a:r>
-              <a:rPr lang="en-US" sz="1000" b="0" i="0" dirty="0">
+              <a:rPr lang="en-US" sz="1100" b="0" i="0" dirty="0">
                 <a:solidFill>
                   <a:srgbClr val="1F2328"/>
                 </a:solidFill>
@@ -5903,7 +5903,7 @@
               <a:t xml:space="preserve">  </a:t>
             </a:r>
             <a:r>
-              <a:rPr lang="en-US" sz="1000" b="1" i="0" dirty="0">
+              <a:rPr lang="en-US" sz="1100" b="1" i="0" dirty="0">
                 <a:solidFill>
                   <a:srgbClr val="0B6E4F"/>
                 </a:solidFill>
@@ -5913,7 +5913,7 @@
               <a:t xml:space="preserve">Types:</a:t>
             </a:r>
             <a:r>
-              <a:rPr lang="en-US" sz="1000" b="0" i="0" dirty="0">
+              <a:rPr lang="en-US" sz="1100" b="0" i="0" dirty="0">
                 <a:solidFill>
                   <a:srgbClr val="1F2328"/>
                 </a:solidFill>
@@ -5923,7 +5923,7 @@
               <a:t xml:space="preserve"> </a:t>
             </a:r>
             <a:r>
-              <a:rPr lang="en-US" sz="1000" b="0" i="0" dirty="0">
+              <a:rPr lang="en-US" sz="1100" b="0" i="0" dirty="0">
                 <a:solidFill>
                   <a:srgbClr val="1F2328"/>
                 </a:solidFill>
@@ -5932,7 +5932,7 @@
               </a:rPr>
               <a:t xml:space="preserve">CandidateAssociation</a:t>
             </a:r>
-            <a:endParaRPr lang="en-US" sz="1000"/>
+            <a:endParaRPr lang="en-US" sz="1100"/>
           </a:p>
         </p:txBody>
       </p:sp>
@@ -5944,8 +5944,8 @@
         </p:nvSpPr>
         <p:spPr>
           <a:xfrm>
-            <a:off x="8001000" y="3611879"/>
-            <a:ext cx="3200400" cy="173736"/>
+            <a:off x="7863840" y="3584448"/>
+            <a:ext cx="3337560" cy="205740"/>
           </a:xfrm>
           <a:prstGeom prst="rect">
             <a:avLst/>
@@ -5964,7 +5964,7 @@
               </a:tabLst>
             </a:pPr>
             <a:r>
-              <a:rPr lang="en-US" sz="1000" b="0" i="0" dirty="0">
+              <a:rPr lang="en-US" sz="1100" b="0" i="0" dirty="0">
                 <a:solidFill>
                   <a:srgbClr val="1F2328"/>
                 </a:solidFill>
@@ -5974,7 +5974,7 @@
               <a:t xml:space="preserve">  </a:t>
             </a:r>
             <a:r>
-              <a:rPr lang="en-US" sz="1000" b="1" i="0" dirty="0">
+              <a:rPr lang="en-US" sz="1100" b="1" i="0" dirty="0">
                 <a:solidFill>
                   <a:srgbClr val="0B6E4F"/>
                 </a:solidFill>
@@ -5983,7 +5983,7 @@
               </a:rPr>
               <a:t xml:space="preserve">Facts:</a:t>
             </a:r>
-            <a:endParaRPr lang="en-US" sz="1000"/>
+            <a:endParaRPr lang="en-US" sz="1100"/>
           </a:p>
         </p:txBody>
       </p:sp>
@@ -5995,8 +5995,8 @@
         </p:nvSpPr>
         <p:spPr>
           <a:xfrm>
-            <a:off x="8001000" y="3785615"/>
-            <a:ext cx="3200400" cy="173736"/>
+            <a:off x="7863840" y="3790187"/>
+            <a:ext cx="3337560" cy="205740"/>
           </a:xfrm>
           <a:prstGeom prst="rect">
             <a:avLst/>
@@ -6015,7 +6015,7 @@
               </a:tabLst>
             </a:pPr>
             <a:r>
-              <a:rPr lang="en-US" sz="1000" b="0" i="0" dirty="0">
+              <a:rPr lang="en-US" sz="1100" b="0" i="0" dirty="0">
                 <a:solidFill>
                   <a:srgbClr val="1F2328"/>
                 </a:solidFill>
@@ -6025,7 +6025,7 @@
               <a:t xml:space="preserve">    </a:t>
             </a:r>
             <a:r>
-              <a:rPr lang="en-US" sz="1000" b="0" i="0" dirty="0">
+              <a:rPr lang="en-US" sz="1100" b="0" i="0" dirty="0">
                 <a:solidFill>
                   <a:srgbClr val="1F2328"/>
                 </a:solidFill>
@@ -6035,7 +6035,7 @@
               <a:t xml:space="preserve">hasDrug</a:t>
             </a:r>
             <a:r>
-              <a:rPr lang="en-US" sz="1000" b="0" i="0" dirty="0">
+              <a:rPr lang="en-US" sz="1100" b="0" i="0" dirty="0">
                 <a:solidFill>
                   <a:srgbClr val="1F2328"/>
                 </a:solidFill>
@@ -6045,7 +6045,7 @@
               <a:t xml:space="preserve"> </a:t>
             </a:r>
             <a:r>
-              <a:rPr lang="en-US" sz="1000" b="0" i="0" dirty="0">
+              <a:rPr lang="en-US" sz="1100" b="0" i="0" dirty="0">
                 <a:solidFill>
                   <a:srgbClr val="1F2328"/>
                 </a:solidFill>
@@ -6055,7 +6055,7 @@
               <a:t xml:space="preserve">Cisplatin</a:t>
             </a:r>
             <a:r>
-              <a:rPr lang="en-US" sz="1000" b="0" i="0" dirty="0">
+              <a:rPr lang="en-US" sz="1100" b="0" i="0" dirty="0">
                 <a:solidFill>
                   <a:srgbClr val="1F2328"/>
                 </a:solidFill>
@@ -6064,7 +6064,7 @@
               </a:rPr>
               <a:t xml:space="preserve">,</a:t>
             </a:r>
-            <a:endParaRPr lang="en-US" sz="1000"/>
+            <a:endParaRPr lang="en-US" sz="1100"/>
           </a:p>
         </p:txBody>
       </p:sp>
@@ -6076,8 +6076,8 @@
         </p:nvSpPr>
         <p:spPr>
           <a:xfrm>
-            <a:off x="8001000" y="3959352"/>
-            <a:ext cx="3200400" cy="173736"/>
+            <a:off x="7863840" y="3995928"/>
+            <a:ext cx="3337560" cy="205740"/>
           </a:xfrm>
           <a:prstGeom prst="rect">
             <a:avLst/>
@@ -6096,7 +6096,7 @@
               </a:tabLst>
             </a:pPr>
             <a:r>
-              <a:rPr lang="en-US" sz="1000" b="0" i="0" dirty="0">
+              <a:rPr lang="en-US" sz="1100" b="0" i="0" dirty="0">
                 <a:solidFill>
                   <a:srgbClr val="1F2328"/>
                 </a:solidFill>
@@ -6106,7 +6106,7 @@
               <a:t xml:space="preserve">    </a:t>
             </a:r>
             <a:r>
-              <a:rPr lang="en-US" sz="1000" b="0" i="0" dirty="0">
+              <a:rPr lang="en-US" sz="1100" b="0" i="0" dirty="0">
                 <a:solidFill>
                   <a:srgbClr val="1F2328"/>
                 </a:solidFill>
@@ -6116,7 +6116,7 @@
               <a:t xml:space="preserve">hasCondition</a:t>
             </a:r>
             <a:r>
-              <a:rPr lang="en-US" sz="1000" b="0" i="0" dirty="0">
+              <a:rPr lang="en-US" sz="1100" b="0" i="0" dirty="0">
                 <a:solidFill>
                   <a:srgbClr val="1F2328"/>
                 </a:solidFill>
@@ -6126,7 +6126,7 @@
               <a:t xml:space="preserve"> </a:t>
             </a:r>
             <a:r>
-              <a:rPr lang="en-US" sz="1000" b="0" i="0" dirty="0">
+              <a:rPr lang="en-US" sz="1100" b="0" i="0" dirty="0">
                 <a:solidFill>
                   <a:srgbClr val="1F2328"/>
                 </a:solidFill>
@@ -6136,7 +6136,7 @@
               <a:t xml:space="preserve">BoneMarrowDepression</a:t>
             </a:r>
             <a:r>
-              <a:rPr lang="en-US" sz="1000" b="0" i="0" dirty="0">
+              <a:rPr lang="en-US" sz="1100" b="0" i="0" dirty="0">
                 <a:solidFill>
                   <a:srgbClr val="1F2328"/>
                 </a:solidFill>
@@ -6145,7 +6145,7 @@
               </a:rPr>
               <a:t xml:space="preserve">,</a:t>
             </a:r>
-            <a:endParaRPr lang="en-US" sz="1000"/>
+            <a:endParaRPr lang="en-US" sz="1100"/>
           </a:p>
         </p:txBody>
       </p:sp>
@@ -6157,8 +6157,8 @@
         </p:nvSpPr>
         <p:spPr>
           <a:xfrm>
-            <a:off x="8001000" y="4133087"/>
-            <a:ext cx="3200400" cy="173736"/>
+            <a:off x="7863840" y="4201668"/>
+            <a:ext cx="3337560" cy="205740"/>
           </a:xfrm>
           <a:prstGeom prst="rect">
             <a:avLst/>
@@ -6177,7 +6177,7 @@
               </a:tabLst>
             </a:pPr>
             <a:r>
-              <a:rPr lang="en-US" sz="1000" b="0" i="0" dirty="0">
+              <a:rPr lang="en-US" sz="1100" b="0" i="0" dirty="0">
                 <a:solidFill>
                   <a:srgbClr val="1F2328"/>
                 </a:solidFill>
@@ -6187,7 +6187,7 @@
               <a:t xml:space="preserve">    </a:t>
             </a:r>
             <a:r>
-              <a:rPr lang="en-US" sz="1000" b="0" i="0" dirty="0">
+              <a:rPr lang="en-US" sz="1100" b="0" i="0" dirty="0">
                 <a:solidFill>
                   <a:srgbClr val="1F2328"/>
                 </a:solidFill>
@@ -6197,7 +6197,7 @@
               <a:t xml:space="preserve">status</a:t>
             </a:r>
             <a:r>
-              <a:rPr lang="en-US" sz="1000" b="0" i="0" dirty="0">
+              <a:rPr lang="en-US" sz="1100" b="0" i="0" dirty="0">
                 <a:solidFill>
                   <a:srgbClr val="1F2328"/>
                 </a:solidFill>
@@ -6207,7 +6207,7 @@
               <a:t xml:space="preserve"> </a:t>
             </a:r>
             <a:r>
-              <a:rPr lang="en-US" sz="1000" b="0" i="0" dirty="0">
+              <a:rPr lang="en-US" sz="1100" b="0" i="0" dirty="0">
                 <a:solidFill>
                   <a:srgbClr val="A3401E"/>
                 </a:solidFill>
@@ -6216,7 +6216,7 @@
               </a:rPr>
               <a:t xml:space="preserve">"needs expert review"</a:t>
             </a:r>
-            <a:endParaRPr lang="en-US" sz="1000"/>
+            <a:endParaRPr lang="en-US" sz="1100"/>
           </a:p>
         </p:txBody>
       </p:sp>
@@ -6228,8 +6228,8 @@
         </p:nvSpPr>
         <p:spPr>
           <a:xfrm>
-            <a:off x="8001000" y="4306824"/>
-            <a:ext cx="3200400" cy="173736"/>
+            <a:off x="7863840" y="4407408"/>
+            <a:ext cx="3337560" cy="205740"/>
           </a:xfrm>
           <a:prstGeom prst="rect">
             <a:avLst/>
@@ -6248,7 +6248,7 @@
               </a:tabLst>
             </a:pPr>
             <a:r>
-              <a:rPr lang="en-US" sz="1000" b="0" i="0" dirty="0">
+              <a:rPr lang="en-US" sz="1100" b="0" i="0" dirty="0">
                 <a:solidFill>
                   <a:srgbClr val="1F2328"/>
                 </a:solidFill>
@@ -6258,7 +6258,7 @@
               <a:t xml:space="preserve">  </a:t>
             </a:r>
             <a:r>
-              <a:rPr lang="en-US" sz="1000" b="1" i="0" dirty="0">
+              <a:rPr lang="en-US" sz="1100" b="1" i="0" dirty="0">
                 <a:solidFill>
                   <a:srgbClr val="0B6E4F"/>
                 </a:solidFill>
@@ -6267,7 +6267,7 @@
               </a:rPr>
               <a:t xml:space="preserve">Annotations:</a:t>
             </a:r>
-            <a:endParaRPr lang="en-US" sz="1000"/>
+            <a:endParaRPr lang="en-US" sz="1100"/>
           </a:p>
         </p:txBody>
       </p:sp>
@@ -6279,8 +6279,8 @@
         </p:nvSpPr>
         <p:spPr>
           <a:xfrm>
-            <a:off x="8001000" y="4480560"/>
-            <a:ext cx="3200400" cy="173736"/>
+            <a:off x="7863840" y="4613148"/>
+            <a:ext cx="3337560" cy="205740"/>
           </a:xfrm>
           <a:prstGeom prst="rect">
             <a:avLst/>
@@ -6299,7 +6299,7 @@
               </a:tabLst>
             </a:pPr>
             <a:r>
-              <a:rPr lang="en-US" sz="1000" b="0" i="0" dirty="0">
+              <a:rPr lang="en-US" sz="1100" b="0" i="0" dirty="0">
                 <a:solidFill>
                   <a:srgbClr val="1F2328"/>
                 </a:solidFill>
@@ -6309,7 +6309,7 @@
               <a:t xml:space="preserve">    </a:t>
             </a:r>
             <a:r>
-              <a:rPr lang="en-US" sz="1000" b="0" i="0" dirty="0">
+              <a:rPr lang="en-US" sz="1100" b="0" i="0" dirty="0">
                 <a:solidFill>
                   <a:srgbClr val="5B6770"/>
                 </a:solidFill>
@@ -6319,7 +6319,7 @@
               <a:t xml:space="preserve">prov:wasDerivedFrom</a:t>
             </a:r>
             <a:r>
-              <a:rPr lang="en-US" sz="1000" b="0" i="0" dirty="0">
+              <a:rPr lang="en-US" sz="1100" b="0" i="0" dirty="0">
                 <a:solidFill>
                   <a:srgbClr val="1F2328"/>
                 </a:solidFill>
@@ -6329,7 +6329,7 @@
               <a:t xml:space="preserve"> </a:t>
             </a:r>
             <a:r>
-              <a:rPr lang="en-US" sz="1000" b="0" i="0" dirty="0">
+              <a:rPr lang="en-US" sz="1100" b="0" i="0" dirty="0">
                 <a:solidFill>
                   <a:srgbClr val="2F6B78"/>
                 </a:solidFill>
@@ -6339,7 +6339,7 @@
               <a:t xml:space="preserve">treatment:drug</a:t>
             </a:r>
             <a:r>
-              <a:rPr lang="en-US" sz="1000" b="0" i="0" dirty="0">
+              <a:rPr lang="en-US" sz="1100" b="0" i="0" dirty="0">
                 <a:solidFill>
                   <a:srgbClr val="1F2328"/>
                 </a:solidFill>
@@ -6348,7 +6348,7 @@
               </a:rPr>
               <a:t xml:space="preserve">,</a:t>
             </a:r>
-            <a:endParaRPr lang="en-US" sz="1000"/>
+            <a:endParaRPr lang="en-US" sz="1100"/>
           </a:p>
         </p:txBody>
       </p:sp>
@@ -6360,8 +6360,8 @@
         </p:nvSpPr>
         <p:spPr>
           <a:xfrm>
-            <a:off x="8001000" y="4654296"/>
-            <a:ext cx="3200400" cy="173736"/>
+            <a:off x="7863840" y="4818888"/>
+            <a:ext cx="3337560" cy="205740"/>
           </a:xfrm>
           <a:prstGeom prst="rect">
             <a:avLst/>
@@ -6380,7 +6380,7 @@
               </a:tabLst>
             </a:pPr>
             <a:r>
-              <a:rPr lang="en-US" sz="1000" b="0" i="0" dirty="0">
+              <a:rPr lang="en-US" sz="1100" b="0" i="0" dirty="0">
                 <a:solidFill>
                   <a:srgbClr val="1F2328"/>
                 </a:solidFill>
@@ -6390,7 +6390,7 @@
               <a:t xml:space="preserve">    </a:t>
             </a:r>
             <a:r>
-              <a:rPr lang="en-US" sz="1000" b="0" i="0" dirty="0">
+              <a:rPr lang="en-US" sz="1100" b="0" i="0" dirty="0">
                 <a:solidFill>
                   <a:srgbClr val="5B6770"/>
                 </a:solidFill>
@@ -6400,7 +6400,7 @@
               <a:t xml:space="preserve">prov:wasDerivedFrom</a:t>
             </a:r>
             <a:r>
-              <a:rPr lang="en-US" sz="1000" b="0" i="0" dirty="0">
+              <a:rPr lang="en-US" sz="1100" b="0" i="0" dirty="0">
                 <a:solidFill>
                   <a:srgbClr val="1F2328"/>
                 </a:solidFill>
@@ -6410,7 +6410,7 @@
               <a:t xml:space="preserve"> </a:t>
             </a:r>
             <a:r>
-              <a:rPr lang="en-US" sz="1000" b="0" i="0" dirty="0">
+              <a:rPr lang="en-US" sz="1100" b="0" i="0" dirty="0">
                 <a:solidFill>
                   <a:srgbClr val="2F6B78"/>
                 </a:solidFill>
@@ -6419,7 +6419,7 @@
               </a:rPr>
               <a:t xml:space="preserve">admission:BM_DEP</a:t>
             </a:r>
-            <a:endParaRPr lang="en-US" sz="1000"/>
+            <a:endParaRPr lang="en-US" sz="1100"/>
           </a:p>
         </p:txBody>
       </p:sp>
@@ -6431,8 +6431,8 @@
         </p:nvSpPr>
         <p:spPr>
           <a:xfrm>
-            <a:off x="8001000" y="5065776"/>
-            <a:ext cx="3246120" cy="512064"/>
+            <a:off x="7863840" y="5193792"/>
+            <a:ext cx="3383280" cy="548640"/>
           </a:xfrm>
           <a:prstGeom prst="roundRect">
             <a:avLst>
@@ -6454,7 +6454,7 @@
           <a:p>
             <a:pPr algn="ctr"/>
             <a:r>
-              <a:rPr lang="en-US" sz="1100" b="1" i="0" dirty="0">
+              <a:rPr lang="en-US" sz="1200" b="1" i="0" dirty="0">
                 <a:solidFill>
                   <a:srgbClr val="93600F"/>
                 </a:solidFill>
@@ -6464,7 +6464,7 @@
               <a:t xml:space="preserve">A PATTERN, NOT A CAUSE  </a:t>
             </a:r>
             <a:r>
-              <a:rPr lang="en-US" sz="1150" b="0" i="0" dirty="0">
+              <a:rPr lang="en-US" sz="1250" b="0" i="0" dirty="0">
                 <a:solidFill>
                   <a:srgbClr val="3A434C"/>
                 </a:solidFill>
@@ -6484,7 +6484,7 @@
         </p:nvSpPr>
         <p:spPr>
           <a:xfrm>
-            <a:off x="4078224" y="3913632"/>
+            <a:off x="4078224" y="3922776"/>
             <a:ext cx="274320" cy="329184"/>
           </a:xfrm>
           <a:prstGeom prst="rightArrow">
@@ -6506,7 +6506,7 @@
         </p:nvSpPr>
         <p:spPr>
           <a:xfrm>
-            <a:off x="7562088" y="3913632"/>
+            <a:off x="7424927" y="3922776"/>
             <a:ext cx="274320" cy="329184"/>
           </a:xfrm>
           <a:prstGeom prst="rightArrow">
@@ -6528,7 +6528,7 @@
         </p:nvSpPr>
         <p:spPr>
           <a:xfrm>
-            <a:off x="822960" y="5961888"/>
+            <a:off x="822960" y="5998464"/>
             <a:ext cx="10607040" cy="237744"/>
           </a:xfrm>
           <a:prstGeom prst="rect">

</xml_diff>